<commit_message>
Enlarge surgical video slides to 16:9 and confirm HbA1c wording
</commit_message>
<xml_diff>
--- a/downloads/highst-perioperative-webinar.pptx
+++ b/downloads/highst-perioperative-webinar.pptx
@@ -2,27 +2,27 @@
 <file path=ppt/presentation.xml><?xml version="1.0" encoding="utf-8"?>
 <p:presentation xmlns:p="http://schemas.openxmlformats.org/presentationml/2006/main">
   <p:sldMasterIdLst>
-    <p:sldMasterId xmlns:r="http://schemas.openxmlformats.org/officeDocument/2006/relationships" id="2147483648" r:id="R3ee2d0f966a248e7"/>
+    <p:sldMasterId xmlns:r="http://schemas.openxmlformats.org/officeDocument/2006/relationships" id="2147483648" r:id="Rcc4efa1c288b4ef1"/>
   </p:sldMasterIdLst>
   <p:notesMasterIdLst>
-    <p:notesMasterId xmlns:r="http://schemas.openxmlformats.org/officeDocument/2006/relationships" r:id="R662b736467ee40c6"/>
+    <p:notesMasterId xmlns:r="http://schemas.openxmlformats.org/officeDocument/2006/relationships" r:id="R5b3e87f3e91845dc"/>
   </p:notesMasterIdLst>
   <p:sldIdLst>
-    <p:sldId xmlns:r="http://schemas.openxmlformats.org/officeDocument/2006/relationships" id="256" r:id="R5ae23c2c2cbc4e2c"/>
-    <p:sldId xmlns:r="http://schemas.openxmlformats.org/officeDocument/2006/relationships" id="257" r:id="Rc6519a8fb2c2492d"/>
-    <p:sldId xmlns:r="http://schemas.openxmlformats.org/officeDocument/2006/relationships" id="258" r:id="R80c16b392c344c00"/>
-    <p:sldId xmlns:r="http://schemas.openxmlformats.org/officeDocument/2006/relationships" id="259" r:id="R6a706f3b62e8485e"/>
-    <p:sldId xmlns:r="http://schemas.openxmlformats.org/officeDocument/2006/relationships" id="260" r:id="Rbfc97fb5a5e744ac"/>
-    <p:sldId xmlns:r="http://schemas.openxmlformats.org/officeDocument/2006/relationships" id="261" r:id="R2b21da0f6fb64faa"/>
-    <p:sldId xmlns:r="http://schemas.openxmlformats.org/officeDocument/2006/relationships" id="262" r:id="Rb894b300af5545fe"/>
-    <p:sldId xmlns:r="http://schemas.openxmlformats.org/officeDocument/2006/relationships" id="263" r:id="Ra60f04e9ce5747ea"/>
-    <p:sldId xmlns:r="http://schemas.openxmlformats.org/officeDocument/2006/relationships" id="264" r:id="R8db459d1f1704378"/>
-    <p:sldId xmlns:r="http://schemas.openxmlformats.org/officeDocument/2006/relationships" id="265" r:id="R827d67de1f7d4901"/>
-    <p:sldId xmlns:r="http://schemas.openxmlformats.org/officeDocument/2006/relationships" id="266" r:id="Rad1aa5f85d024365"/>
-    <p:sldId xmlns:r="http://schemas.openxmlformats.org/officeDocument/2006/relationships" id="267" r:id="R9aa08bb171204ccb"/>
-    <p:sldId xmlns:r="http://schemas.openxmlformats.org/officeDocument/2006/relationships" id="268" r:id="R61a426fd01014238"/>
-    <p:sldId xmlns:r="http://schemas.openxmlformats.org/officeDocument/2006/relationships" id="269" r:id="Rbd40dde7d8ed4d55"/>
-    <p:sldId xmlns:r="http://schemas.openxmlformats.org/officeDocument/2006/relationships" id="270" r:id="R0a6981511179472b"/>
+    <p:sldId xmlns:r="http://schemas.openxmlformats.org/officeDocument/2006/relationships" id="256" r:id="R4c25997d9bc44673"/>
+    <p:sldId xmlns:r="http://schemas.openxmlformats.org/officeDocument/2006/relationships" id="257" r:id="Ra34716ee66604145"/>
+    <p:sldId xmlns:r="http://schemas.openxmlformats.org/officeDocument/2006/relationships" id="258" r:id="R1c053f9aed004e46"/>
+    <p:sldId xmlns:r="http://schemas.openxmlformats.org/officeDocument/2006/relationships" id="259" r:id="R5d6be922e3394221"/>
+    <p:sldId xmlns:r="http://schemas.openxmlformats.org/officeDocument/2006/relationships" id="260" r:id="Re071ba049aea43f8"/>
+    <p:sldId xmlns:r="http://schemas.openxmlformats.org/officeDocument/2006/relationships" id="261" r:id="Raff95f084a754c6b"/>
+    <p:sldId xmlns:r="http://schemas.openxmlformats.org/officeDocument/2006/relationships" id="262" r:id="R6e6cfbd7a0c146b1"/>
+    <p:sldId xmlns:r="http://schemas.openxmlformats.org/officeDocument/2006/relationships" id="263" r:id="Rb287d44de0134827"/>
+    <p:sldId xmlns:r="http://schemas.openxmlformats.org/officeDocument/2006/relationships" id="264" r:id="R4372b6e55b2e4f11"/>
+    <p:sldId xmlns:r="http://schemas.openxmlformats.org/officeDocument/2006/relationships" id="265" r:id="R1070a5fd12b24763"/>
+    <p:sldId xmlns:r="http://schemas.openxmlformats.org/officeDocument/2006/relationships" id="266" r:id="Rba9933b85e6141a0"/>
+    <p:sldId xmlns:r="http://schemas.openxmlformats.org/officeDocument/2006/relationships" id="267" r:id="R7f7f84753cc4478c"/>
+    <p:sldId xmlns:r="http://schemas.openxmlformats.org/officeDocument/2006/relationships" id="268" r:id="R938443632cb94a4c"/>
+    <p:sldId xmlns:r="http://schemas.openxmlformats.org/officeDocument/2006/relationships" id="269" r:id="Rfc2ff55228e94e0f"/>
+    <p:sldId xmlns:r="http://schemas.openxmlformats.org/officeDocument/2006/relationships" id="270" r:id="R6be3f0cec11a4ec8"/>
   </p:sldIdLst>
   <p:sldSz cx="12192000" cy="6858000"/>
   <p:notesSz cx="6858000" cy="9144000"/>
@@ -1206,7 +1206,7 @@
           <a:lstStyle xmlns:a="http://schemas.openxmlformats.org/drawingml/2006/main"/>
           <a:p xmlns:a="http://schemas.openxmlformats.org/drawingml/2006/main">
             <a:r>
-              <a:t>The list reflects the preoperative tests provided by HIGHST. Blood glucose and HbA1c are listed separately. HbA1c denotes glycated hemoglobin. HPV and syphilis are separate entries. The slide does not assign a specimen type or testing method to HPV.</a:t>
+              <a:t>Preoperative testing includes blood coagulation tests, complete blood count (CBC), prostate-specific antigen (PSA), blood glucose, glycated hemoglobin (HbA1c), HPV and syphilis testing, urine testing, liver function and inflammatory markers.</a:t>
             </a:r>
           </a:p>
           <a:p xmlns:a="http://schemas.openxmlformats.org/drawingml/2006/main">
@@ -1563,7 +1563,7 @@
           <p:cNvPr id="3" name="Title">
             <a:extLst xmlns:a="http://schemas.openxmlformats.org/drawingml/2006/main">
               <a:ext uri="{FF2B5EF4-FFF2-40B4-BE49-F238E27FC236}">
-                <a16:creationId xmlns:a16="http://schemas.microsoft.com/office/drawing/2014/main" id="{04E1E01B-7363-44BD-B532-825C5E8B50BA}"/>
+                <a16:creationId xmlns:a16="http://schemas.microsoft.com/office/drawing/2014/main" id="{83A30845-1A30-4200-82FE-AAF854C64535}"/>
               </a:ext>
             </a:extLst>
           </p:cNvPr>
@@ -1720,7 +1720,7 @@
           <p:cNvPr id="2" name="Subtitle">
             <a:extLst xmlns:a="http://schemas.openxmlformats.org/drawingml/2006/main">
               <a:ext uri="{FF2B5EF4-FFF2-40B4-BE49-F238E27FC236}">
-                <a16:creationId xmlns:a16="http://schemas.microsoft.com/office/drawing/2014/main" id="{0DB0C217-E39C-4A44-85FA-7689BAF07F8A}"/>
+                <a16:creationId xmlns:a16="http://schemas.microsoft.com/office/drawing/2014/main" id="{51CF4F87-CDD6-45FC-A767-BA911FA802A6}"/>
               </a:ext>
             </a:extLst>
           </p:cNvPr>
@@ -1894,7 +1894,7 @@
           <p:cNvPr id="2" name="Section title">
             <a:extLst xmlns:a="http://schemas.openxmlformats.org/drawingml/2006/main">
               <a:ext uri="{FF2B5EF4-FFF2-40B4-BE49-F238E27FC236}">
-                <a16:creationId xmlns:a16="http://schemas.microsoft.com/office/drawing/2014/main" id="{7EF962CF-EA9B-490C-B2D1-A2C9F7EB71E5}"/>
+                <a16:creationId xmlns:a16="http://schemas.microsoft.com/office/drawing/2014/main" id="{3EA20947-52AE-4F37-9C7A-C837300B0EFE}"/>
               </a:ext>
             </a:extLst>
           </p:cNvPr>
@@ -2068,7 +2068,7 @@
           <p:cNvPr id="3" name="Title">
             <a:extLst xmlns:a="http://schemas.openxmlformats.org/drawingml/2006/main">
               <a:ext uri="{FF2B5EF4-FFF2-40B4-BE49-F238E27FC236}">
-                <a16:creationId xmlns:a16="http://schemas.microsoft.com/office/drawing/2014/main" id="{59F10B97-08C3-4FBE-8102-C3C0A53937B6}"/>
+                <a16:creationId xmlns:a16="http://schemas.microsoft.com/office/drawing/2014/main" id="{1CD33F13-8A6C-43A5-844B-B0637746FEEF}"/>
               </a:ext>
             </a:extLst>
           </p:cNvPr>
@@ -2225,7 +2225,7 @@
           <p:cNvPr id="2" name="Body">
             <a:extLst xmlns:a="http://schemas.openxmlformats.org/drawingml/2006/main">
               <a:ext uri="{FF2B5EF4-FFF2-40B4-BE49-F238E27FC236}">
-                <a16:creationId xmlns:a16="http://schemas.microsoft.com/office/drawing/2014/main" id="{22E19779-C792-4F35-93B5-9C9D449FC4DD}"/>
+                <a16:creationId xmlns:a16="http://schemas.microsoft.com/office/drawing/2014/main" id="{9748D49E-2AC4-484A-B01F-73AC2A95F987}"/>
               </a:ext>
             </a:extLst>
           </p:cNvPr>
@@ -2399,7 +2399,7 @@
           <p:cNvPr id="4" name="Title">
             <a:extLst xmlns:a="http://schemas.openxmlformats.org/drawingml/2006/main">
               <a:ext uri="{FF2B5EF4-FFF2-40B4-BE49-F238E27FC236}">
-                <a16:creationId xmlns:a16="http://schemas.microsoft.com/office/drawing/2014/main" id="{9755860D-6D27-46B1-A619-B13BC637AF1F}"/>
+                <a16:creationId xmlns:a16="http://schemas.microsoft.com/office/drawing/2014/main" id="{74F7C5FD-DA8D-4180-B99C-400D5FDF496D}"/>
               </a:ext>
             </a:extLst>
           </p:cNvPr>
@@ -2556,7 +2556,7 @@
           <p:cNvPr id="2" name="Left column">
             <a:extLst xmlns:a="http://schemas.openxmlformats.org/drawingml/2006/main">
               <a:ext uri="{FF2B5EF4-FFF2-40B4-BE49-F238E27FC236}">
-                <a16:creationId xmlns:a16="http://schemas.microsoft.com/office/drawing/2014/main" id="{2EF09A62-5371-481B-802D-99DB67FD733C}"/>
+                <a16:creationId xmlns:a16="http://schemas.microsoft.com/office/drawing/2014/main" id="{68978989-A2E0-4EE9-92E1-A678E47ADA54}"/>
               </a:ext>
             </a:extLst>
           </p:cNvPr>
@@ -2713,7 +2713,7 @@
           <p:cNvPr id="3" name="Right column">
             <a:extLst xmlns:a="http://schemas.openxmlformats.org/drawingml/2006/main">
               <a:ext uri="{FF2B5EF4-FFF2-40B4-BE49-F238E27FC236}">
-                <a16:creationId xmlns:a16="http://schemas.microsoft.com/office/drawing/2014/main" id="{1A04455C-729E-4417-9DFD-2ADBC8C6FD0F}"/>
+                <a16:creationId xmlns:a16="http://schemas.microsoft.com/office/drawing/2014/main" id="{A2F1F952-AC79-44F5-B140-E319853E1231}"/>
               </a:ext>
             </a:extLst>
           </p:cNvPr>
@@ -2887,7 +2887,7 @@
           <p:cNvPr id="3" name="Title">
             <a:extLst xmlns:a="http://schemas.openxmlformats.org/drawingml/2006/main">
               <a:ext uri="{FF2B5EF4-FFF2-40B4-BE49-F238E27FC236}">
-                <a16:creationId xmlns:a16="http://schemas.microsoft.com/office/drawing/2014/main" id="{6A9B795A-96EC-4BF6-8947-D97B7C52EA9F}"/>
+                <a16:creationId xmlns:a16="http://schemas.microsoft.com/office/drawing/2014/main" id="{20245DB9-B556-4BD0-98E1-229C04B3BCEC}"/>
               </a:ext>
             </a:extLst>
           </p:cNvPr>
@@ -3044,7 +3044,7 @@
           <p:cNvPr id="2" name="Left column">
             <a:extLst xmlns:a="http://schemas.openxmlformats.org/drawingml/2006/main">
               <a:ext uri="{FF2B5EF4-FFF2-40B4-BE49-F238E27FC236}">
-                <a16:creationId xmlns:a16="http://schemas.microsoft.com/office/drawing/2014/main" id="{F2CEF8B2-72F4-49CD-8519-C5362ADA65AA}"/>
+                <a16:creationId xmlns:a16="http://schemas.microsoft.com/office/drawing/2014/main" id="{CD0A0566-3B7E-4505-B0AA-FE1170F845E3}"/>
               </a:ext>
             </a:extLst>
           </p:cNvPr>
@@ -3239,12 +3239,12 @@
   </p:cSld>
   <p:clrMap bg1="lt1" tx1="dk1" bg2="lt2" tx2="dk2" accent1="accent1" accent2="accent2" accent3="accent3" accent4="accent4" accent5="accent5" accent6="accent6" hlink="hlink" folHlink="folHlink"/>
   <p:sldLayoutIdLst>
-    <p:sldLayoutId xmlns:r="http://schemas.openxmlformats.org/officeDocument/2006/relationships" id="2147483649" r:id="Rb344a4b21ece4bae"/>
-    <p:sldLayoutId xmlns:r="http://schemas.openxmlformats.org/officeDocument/2006/relationships" id="2147483650" r:id="Rebb8a7672b6e4f3f"/>
-    <p:sldLayoutId xmlns:r="http://schemas.openxmlformats.org/officeDocument/2006/relationships" id="2147483651" r:id="R093bad8932324621"/>
-    <p:sldLayoutId xmlns:r="http://schemas.openxmlformats.org/officeDocument/2006/relationships" id="2147483652" r:id="R55bc0cd5caa04312"/>
-    <p:sldLayoutId xmlns:r="http://schemas.openxmlformats.org/officeDocument/2006/relationships" id="2147483653" r:id="Rc93deddcb524408a"/>
-    <p:sldLayoutId xmlns:r="http://schemas.openxmlformats.org/officeDocument/2006/relationships" id="2147483654" r:id="R1ed98b9186be40eb"/>
+    <p:sldLayoutId xmlns:r="http://schemas.openxmlformats.org/officeDocument/2006/relationships" id="2147483649" r:id="R5a2cd24448d54d55"/>
+    <p:sldLayoutId xmlns:r="http://schemas.openxmlformats.org/officeDocument/2006/relationships" id="2147483650" r:id="Rc7da571e9a8f45e1"/>
+    <p:sldLayoutId xmlns:r="http://schemas.openxmlformats.org/officeDocument/2006/relationships" id="2147483651" r:id="R3c870f87f4af4ee0"/>
+    <p:sldLayoutId xmlns:r="http://schemas.openxmlformats.org/officeDocument/2006/relationships" id="2147483652" r:id="Raaa64aea0ac1474c"/>
+    <p:sldLayoutId xmlns:r="http://schemas.openxmlformats.org/officeDocument/2006/relationships" id="2147483653" r:id="Reffff0882e434602"/>
+    <p:sldLayoutId xmlns:r="http://schemas.openxmlformats.org/officeDocument/2006/relationships" id="2147483654" r:id="R4f2d406ee2094f4a"/>
   </p:sldLayoutIdLst>
   <p:txStyles>
     <p:titleStyle>
@@ -3795,7 +3795,7 @@
           <p:cNvPr id="12" name="">
             <a:extLst xmlns:a="http://schemas.openxmlformats.org/drawingml/2006/main">
               <a:ext uri="{FF2B5EF4-FFF2-40B4-BE49-F238E27FC236}">
-                <a16:creationId xmlns:a16="http://schemas.microsoft.com/office/drawing/2014/main" id="{60A17C08-0291-4BB8-9CD6-EA7B12570B55}"/>
+                <a16:creationId xmlns:a16="http://schemas.microsoft.com/office/drawing/2014/main" id="{52FC47BC-909A-4676-B5DA-8C08CA5ED106}"/>
               </a:ext>
             </a:extLst>
           </p:cNvPr>
@@ -3825,7 +3825,7 @@
           <p:cNvPr id="2" name="">
             <a:extLst xmlns:a="http://schemas.openxmlformats.org/drawingml/2006/main">
               <a:ext uri="{FF2B5EF4-FFF2-40B4-BE49-F238E27FC236}">
-                <a16:creationId xmlns:a16="http://schemas.microsoft.com/office/drawing/2014/main" id="{E9D60992-BE13-41F4-A4FF-2895FF317E3B}"/>
+                <a16:creationId xmlns:a16="http://schemas.microsoft.com/office/drawing/2014/main" id="{9FFCB69E-8759-404E-8F7D-B5E07788423E}"/>
               </a:ext>
             </a:extLst>
           </p:cNvPr>
@@ -3835,7 +3835,7 @@
           <p:nvPr/>
         </p:nvPicPr>
         <p:blipFill>
-          <a:blip xmlns:r="http://schemas.openxmlformats.org/officeDocument/2006/relationships" xmlns:a="http://schemas.openxmlformats.org/drawingml/2006/main" r:embed="Rcfe4123ce0df497c"/>
+          <a:blip xmlns:r="http://schemas.openxmlformats.org/officeDocument/2006/relationships" xmlns:a="http://schemas.openxmlformats.org/drawingml/2006/main" r:embed="R2896c692362149b9"/>
           <a:stretch xmlns:a="http://schemas.openxmlformats.org/drawingml/2006/main"/>
         </p:blipFill>
         <p:spPr>
@@ -3853,7 +3853,7 @@
           <p:cNvPr id="3" name="">
             <a:extLst xmlns:a="http://schemas.openxmlformats.org/drawingml/2006/main">
               <a:ext uri="{FF2B5EF4-FFF2-40B4-BE49-F238E27FC236}">
-                <a16:creationId xmlns:a16="http://schemas.microsoft.com/office/drawing/2014/main" id="{768CDA7B-AE7B-4661-9687-21736A7E0F2F}"/>
+                <a16:creationId xmlns:a16="http://schemas.microsoft.com/office/drawing/2014/main" id="{ECBEBB88-520D-4540-9CEB-6B52F1FF5F20}"/>
               </a:ext>
             </a:extLst>
           </p:cNvPr>
@@ -3863,7 +3863,7 @@
           <p:nvPr/>
         </p:nvPicPr>
         <p:blipFill>
-          <a:blip xmlns:r="http://schemas.openxmlformats.org/officeDocument/2006/relationships" xmlns:a="http://schemas.openxmlformats.org/drawingml/2006/main" r:embed="R379bd318452e4983"/>
+          <a:blip xmlns:r="http://schemas.openxmlformats.org/officeDocument/2006/relationships" xmlns:a="http://schemas.openxmlformats.org/drawingml/2006/main" r:embed="R26958d57f78d4f77"/>
           <a:stretch xmlns:a="http://schemas.openxmlformats.org/drawingml/2006/main"/>
         </p:blipFill>
         <p:spPr>
@@ -3881,7 +3881,7 @@
           <p:cNvPr id="4" name="">
             <a:extLst xmlns:a="http://schemas.openxmlformats.org/drawingml/2006/main">
               <a:ext uri="{FF2B5EF4-FFF2-40B4-BE49-F238E27FC236}">
-                <a16:creationId xmlns:a16="http://schemas.microsoft.com/office/drawing/2014/main" id="{974C58B9-07FB-4959-BFA5-05853CDE11B5}"/>
+                <a16:creationId xmlns:a16="http://schemas.microsoft.com/office/drawing/2014/main" id="{0DE53793-EECC-42B0-8BC8-371032928C4F}"/>
               </a:ext>
             </a:extLst>
           </p:cNvPr>
@@ -3908,7 +3908,7 @@
             <a:noAutofit/>
           </a:bodyPr>
           <a:lstStyle xmlns:a="http://schemas.openxmlformats.org/drawingml/2006/main">
-            <a:defPPr>
+            <a:defPPr algn="l">
               <a:defRPr sz="1050" b="1">
                 <a:solidFill>
                   <a:srgbClr val="9B7744"/>
@@ -3920,7 +3920,7 @@
             </a:defPPr>
           </a:lstStyle>
           <a:p xmlns:a="http://schemas.openxmlformats.org/drawingml/2006/main">
-            <a:pPr>
+            <a:pPr algn="l">
               <a:defRPr sz="1050" b="1">
                 <a:solidFill>
                   <a:srgbClr val="9B7744"/>
@@ -3949,7 +3949,7 @@
           <p:cNvPr id="5" name="">
             <a:extLst xmlns:a="http://schemas.openxmlformats.org/drawingml/2006/main">
               <a:ext uri="{FF2B5EF4-FFF2-40B4-BE49-F238E27FC236}">
-                <a16:creationId xmlns:a16="http://schemas.microsoft.com/office/drawing/2014/main" id="{700E3104-921D-4B87-A290-4D1CA8E4053A}"/>
+                <a16:creationId xmlns:a16="http://schemas.microsoft.com/office/drawing/2014/main" id="{A656F724-0DFB-46ED-8484-C27E0813AB3E}"/>
               </a:ext>
             </a:extLst>
           </p:cNvPr>
@@ -3976,7 +3976,7 @@
             <a:noAutofit/>
           </a:bodyPr>
           <a:lstStyle xmlns:a="http://schemas.openxmlformats.org/drawingml/2006/main">
-            <a:defPPr>
+            <a:defPPr algn="l">
               <a:defRPr sz="4950" b="1">
                 <a:solidFill>
                   <a:srgbClr val="1B1D19"/>
@@ -3988,7 +3988,7 @@
             </a:defPPr>
           </a:lstStyle>
           <a:p xmlns:a="http://schemas.openxmlformats.org/drawingml/2006/main">
-            <a:pPr>
+            <a:pPr algn="l">
               <a:defRPr sz="4950" b="1">
                 <a:solidFill>
                   <a:srgbClr val="1B1D19"/>
@@ -4011,7 +4011,7 @@
             </a:r>
           </a:p>
           <a:p xmlns:a="http://schemas.openxmlformats.org/drawingml/2006/main">
-            <a:pPr>
+            <a:pPr algn="l">
               <a:defRPr sz="4950" b="1">
                 <a:solidFill>
                   <a:srgbClr val="1B1D19"/>
@@ -4034,7 +4034,7 @@
             </a:r>
           </a:p>
           <a:p xmlns:a="http://schemas.openxmlformats.org/drawingml/2006/main">
-            <a:pPr>
+            <a:pPr algn="l">
               <a:defRPr sz="4950" b="1">
                 <a:solidFill>
                   <a:srgbClr val="1B1D19"/>
@@ -4063,7 +4063,7 @@
           <p:cNvPr id="6" name="">
             <a:extLst xmlns:a="http://schemas.openxmlformats.org/drawingml/2006/main">
               <a:ext uri="{FF2B5EF4-FFF2-40B4-BE49-F238E27FC236}">
-                <a16:creationId xmlns:a16="http://schemas.microsoft.com/office/drawing/2014/main" id="{38AE132E-234C-4572-911D-B9397A9D1DB0}"/>
+                <a16:creationId xmlns:a16="http://schemas.microsoft.com/office/drawing/2014/main" id="{DC1705A2-81B4-4C73-A99F-8B746C38E81D}"/>
               </a:ext>
             </a:extLst>
           </p:cNvPr>
@@ -4090,7 +4090,7 @@
             <a:noAutofit/>
           </a:bodyPr>
           <a:lstStyle xmlns:a="http://schemas.openxmlformats.org/drawingml/2006/main">
-            <a:defPPr>
+            <a:defPPr algn="l">
               <a:defRPr sz="1800" b="0">
                 <a:solidFill>
                   <a:srgbClr val="6B7265"/>
@@ -4102,7 +4102,7 @@
             </a:defPPr>
           </a:lstStyle>
           <a:p xmlns:a="http://schemas.openxmlformats.org/drawingml/2006/main">
-            <a:pPr>
+            <a:pPr algn="l">
               <a:defRPr sz="1800" b="0">
                 <a:solidFill>
                   <a:srgbClr val="6B7265"/>
@@ -4131,7 +4131,7 @@
           <p:cNvPr id="7" name="">
             <a:extLst xmlns:a="http://schemas.openxmlformats.org/drawingml/2006/main">
               <a:ext uri="{FF2B5EF4-FFF2-40B4-BE49-F238E27FC236}">
-                <a16:creationId xmlns:a16="http://schemas.microsoft.com/office/drawing/2014/main" id="{088CEF62-5682-4B76-89B9-094A7A600652}"/>
+                <a16:creationId xmlns:a16="http://schemas.microsoft.com/office/drawing/2014/main" id="{F51C4B22-FC8A-4DB1-B6A8-A3A9E3C4CB36}"/>
               </a:ext>
             </a:extLst>
           </p:cNvPr>
@@ -4161,7 +4161,7 @@
           <p:cNvPr id="8" name="">
             <a:extLst xmlns:a="http://schemas.openxmlformats.org/drawingml/2006/main">
               <a:ext uri="{FF2B5EF4-FFF2-40B4-BE49-F238E27FC236}">
-                <a16:creationId xmlns:a16="http://schemas.microsoft.com/office/drawing/2014/main" id="{87602927-C006-42BD-9425-B280D4F64674}"/>
+                <a16:creationId xmlns:a16="http://schemas.microsoft.com/office/drawing/2014/main" id="{3846B4D2-64EE-43AF-9A2C-20F7EC9F6B6C}"/>
               </a:ext>
             </a:extLst>
           </p:cNvPr>
@@ -4188,7 +4188,7 @@
             <a:noAutofit/>
           </a:bodyPr>
           <a:lstStyle xmlns:a="http://schemas.openxmlformats.org/drawingml/2006/main">
-            <a:defPPr>
+            <a:defPPr algn="l">
               <a:defRPr sz="1800" b="1">
                 <a:solidFill>
                   <a:srgbClr val="1B1D19"/>
@@ -4200,7 +4200,7 @@
             </a:defPPr>
           </a:lstStyle>
           <a:p xmlns:a="http://schemas.openxmlformats.org/drawingml/2006/main">
-            <a:pPr>
+            <a:pPr algn="l">
               <a:defRPr sz="1800" b="1">
                 <a:solidFill>
                   <a:srgbClr val="1B1D19"/>
@@ -4229,7 +4229,7 @@
           <p:cNvPr id="9" name="">
             <a:extLst xmlns:a="http://schemas.openxmlformats.org/drawingml/2006/main">
               <a:ext uri="{FF2B5EF4-FFF2-40B4-BE49-F238E27FC236}">
-                <a16:creationId xmlns:a16="http://schemas.microsoft.com/office/drawing/2014/main" id="{461B9079-3623-40F3-B4BF-0A256C9B39B0}"/>
+                <a16:creationId xmlns:a16="http://schemas.microsoft.com/office/drawing/2014/main" id="{9FE8D573-79AD-4FAA-8BA9-3F68B2FBBCA3}"/>
               </a:ext>
             </a:extLst>
           </p:cNvPr>
@@ -4256,7 +4256,7 @@
             <a:noAutofit/>
           </a:bodyPr>
           <a:lstStyle xmlns:a="http://schemas.openxmlformats.org/drawingml/2006/main">
-            <a:defPPr>
+            <a:defPPr algn="l">
               <a:defRPr sz="1200" b="0">
                 <a:solidFill>
                   <a:srgbClr val="6B7265"/>
@@ -4268,7 +4268,7 @@
             </a:defPPr>
           </a:lstStyle>
           <a:p xmlns:a="http://schemas.openxmlformats.org/drawingml/2006/main">
-            <a:pPr>
+            <a:pPr algn="l">
               <a:defRPr sz="1200" b="0">
                 <a:solidFill>
                   <a:srgbClr val="6B7265"/>
@@ -4297,7 +4297,7 @@
           <p:cNvPr id="10" name="">
             <a:extLst xmlns:a="http://schemas.openxmlformats.org/drawingml/2006/main">
               <a:ext uri="{FF2B5EF4-FFF2-40B4-BE49-F238E27FC236}">
-                <a16:creationId xmlns:a16="http://schemas.microsoft.com/office/drawing/2014/main" id="{7B527F81-49AF-4A38-8077-9DC953FD8AF8}"/>
+                <a16:creationId xmlns:a16="http://schemas.microsoft.com/office/drawing/2014/main" id="{DCCB7398-DC6B-4C10-90EC-75B68A1CFF7D}"/>
               </a:ext>
             </a:extLst>
           </p:cNvPr>
@@ -4324,7 +4324,7 @@
             <a:noAutofit/>
           </a:bodyPr>
           <a:lstStyle xmlns:a="http://schemas.openxmlformats.org/drawingml/2006/main">
-            <a:defPPr>
+            <a:defPPr algn="l">
               <a:defRPr sz="975" b="0">
                 <a:solidFill>
                   <a:srgbClr val="858B7E"/>
@@ -4336,7 +4336,7 @@
             </a:defPPr>
           </a:lstStyle>
           <a:p xmlns:a="http://schemas.openxmlformats.org/drawingml/2006/main">
-            <a:pPr>
+            <a:pPr algn="l">
               <a:defRPr sz="975" b="0">
                 <a:solidFill>
                   <a:srgbClr val="858B7E"/>
@@ -4365,7 +4365,7 @@
           <p:cNvPr id="11" name="">
             <a:extLst xmlns:a="http://schemas.openxmlformats.org/drawingml/2006/main">
               <a:ext uri="{FF2B5EF4-FFF2-40B4-BE49-F238E27FC236}">
-                <a16:creationId xmlns:a16="http://schemas.microsoft.com/office/drawing/2014/main" id="{67A76F45-FBE8-48C3-BDC7-1F569099100E}"/>
+                <a16:creationId xmlns:a16="http://schemas.microsoft.com/office/drawing/2014/main" id="{E4899F88-F611-4927-8576-DA52F50E6009}"/>
               </a:ext>
             </a:extLst>
           </p:cNvPr>
@@ -4392,7 +4392,7 @@
             <a:noAutofit/>
           </a:bodyPr>
           <a:lstStyle xmlns:a="http://schemas.openxmlformats.org/drawingml/2006/main">
-            <a:defPPr>
+            <a:defPPr algn="l">
               <a:defRPr sz="975" b="0">
                 <a:solidFill>
                   <a:srgbClr val="858B7E"/>
@@ -4404,7 +4404,7 @@
             </a:defPPr>
           </a:lstStyle>
           <a:p xmlns:a="http://schemas.openxmlformats.org/drawingml/2006/main">
-            <a:pPr>
+            <a:pPr algn="l">
               <a:defRPr sz="975" b="0">
                 <a:solidFill>
                   <a:srgbClr val="858B7E"/>
@@ -4431,7 +4431,7 @@
     </p:spTree>
     <p:extLst>
       <p:ext uri="{BB962C8B-B14F-4D97-AF65-F5344CB8AC3E}">
-        <p14:creationId xmlns:p14="http://schemas.microsoft.com/office/powerpoint/2010/main" val="723943149"/>
+        <p14:creationId xmlns:p14="http://schemas.microsoft.com/office/powerpoint/2010/main" val="84154455"/>
       </p:ext>
     </p:extLst>
   </p:cSld>
@@ -4459,22 +4459,22 @@
       </p:grpSpPr>
       <p:sp>
         <p:nvSpPr>
-          <p:cNvPr id="7" name="">
-            <a:extLst xmlns:a="http://schemas.openxmlformats.org/drawingml/2006/main">
-              <a:ext uri="{FF2B5EF4-FFF2-40B4-BE49-F238E27FC236}">
-                <a16:creationId xmlns:a16="http://schemas.microsoft.com/office/drawing/2014/main" id="{72BE3D15-ACE0-4D5E-83F1-BDDFEB081C82}"/>
-              </a:ext>
-            </a:extLst>
-          </p:cNvPr>
-          <p:cNvSpPr>
-            <a:spLocks xmlns:a="http://schemas.openxmlformats.org/drawingml/2006/main" noGrp="1"/>
-          </p:cNvSpPr>
-          <p:nvPr/>
-        </p:nvSpPr>
-        <p:spPr>
-          <a:xfrm xmlns:a="http://schemas.openxmlformats.org/drawingml/2006/main">
-            <a:off x="685800" y="619125"/>
-            <a:ext cx="10668000" cy="247650"/>
+          <p:cNvPr id="6" name="">
+            <a:extLst xmlns:a="http://schemas.openxmlformats.org/drawingml/2006/main">
+              <a:ext uri="{FF2B5EF4-FFF2-40B4-BE49-F238E27FC236}">
+                <a16:creationId xmlns:a16="http://schemas.microsoft.com/office/drawing/2014/main" id="{4B3D57BD-51F6-4C5D-A45A-C790EEC67A2C}"/>
+              </a:ext>
+            </a:extLst>
+          </p:cNvPr>
+          <p:cNvSpPr>
+            <a:spLocks xmlns:a="http://schemas.openxmlformats.org/drawingml/2006/main" noGrp="1"/>
+          </p:cNvSpPr>
+          <p:nvPr/>
+        </p:nvSpPr>
+        <p:spPr>
+          <a:xfrm xmlns:a="http://schemas.openxmlformats.org/drawingml/2006/main">
+            <a:off x="914400" y="133350"/>
+            <a:ext cx="10363200" cy="152400"/>
           </a:xfrm>
           <a:prstGeom xmlns:a="http://schemas.openxmlformats.org/drawingml/2006/main" prst="rect">
             <a:avLst/>
@@ -4489,8 +4489,8 @@
             <a:noAutofit/>
           </a:bodyPr>
           <a:lstStyle xmlns:a="http://schemas.openxmlformats.org/drawingml/2006/main">
-            <a:defPPr>
-              <a:defRPr sz="1050" b="1">
+            <a:defPPr algn="l">
+              <a:defRPr sz="825" b="1">
                 <a:solidFill>
                   <a:srgbClr val="9B7744"/>
                 </a:solidFill>
@@ -4501,8 +4501,8 @@
             </a:defPPr>
           </a:lstStyle>
           <a:p xmlns:a="http://schemas.openxmlformats.org/drawingml/2006/main">
-            <a:pPr>
-              <a:defRPr sz="1050" b="1">
+            <a:pPr algn="l">
+              <a:defRPr sz="825" b="1">
                 <a:solidFill>
                   <a:srgbClr val="9B7744"/>
                 </a:solidFill>
@@ -4512,7 +4512,7 @@
               </a:defRPr>
             </a:pPr>
             <a:r>
-              <a:rPr sz="1050" b="1">
+              <a:rPr sz="825" b="1">
                 <a:solidFill>
                   <a:srgbClr val="9B7744"/>
                 </a:solidFill>
@@ -4530,19 +4530,19 @@
           <p:cNvPr id="2" name="">
             <a:extLst xmlns:a="http://schemas.openxmlformats.org/drawingml/2006/main">
               <a:ext uri="{FF2B5EF4-FFF2-40B4-BE49-F238E27FC236}">
-                <a16:creationId xmlns:a16="http://schemas.microsoft.com/office/drawing/2014/main" id="{038D4BD8-41E3-43D0-84A8-6AD3BA001BC3}"/>
-              </a:ext>
-            </a:extLst>
-          </p:cNvPr>
-          <p:cNvSpPr>
-            <a:spLocks xmlns:a="http://schemas.openxmlformats.org/drawingml/2006/main" noGrp="1"/>
-          </p:cNvSpPr>
-          <p:nvPr/>
-        </p:nvSpPr>
-        <p:spPr>
-          <a:xfrm xmlns:a="http://schemas.openxmlformats.org/drawingml/2006/main">
-            <a:off x="685800" y="1047750"/>
-            <a:ext cx="10820400" cy="1085850"/>
+                <a16:creationId xmlns:a16="http://schemas.microsoft.com/office/drawing/2014/main" id="{F82464B3-5E6E-4D7D-82C1-4E265536E151}"/>
+              </a:ext>
+            </a:extLst>
+          </p:cNvPr>
+          <p:cNvSpPr>
+            <a:spLocks xmlns:a="http://schemas.openxmlformats.org/drawingml/2006/main" noGrp="1"/>
+          </p:cNvSpPr>
+          <p:nvPr/>
+        </p:nvSpPr>
+        <p:spPr>
+          <a:xfrm xmlns:a="http://schemas.openxmlformats.org/drawingml/2006/main">
+            <a:off x="914400" y="304800"/>
+            <a:ext cx="10363200" cy="381000"/>
           </a:xfrm>
           <a:prstGeom xmlns:a="http://schemas.openxmlformats.org/drawingml/2006/main" prst="rect">
             <a:avLst/>
@@ -4557,8 +4557,8 @@
             <a:noAutofit/>
           </a:bodyPr>
           <a:lstStyle xmlns:a="http://schemas.openxmlformats.org/drawingml/2006/main">
-            <a:defPPr>
-              <a:defRPr sz="3450" b="1">
+            <a:defPPr algn="l">
+              <a:defRPr sz="2250" b="1">
                 <a:solidFill>
                   <a:srgbClr val="1B1D19"/>
                 </a:solidFill>
@@ -4569,8 +4569,8 @@
             </a:defPPr>
           </a:lstStyle>
           <a:p xmlns:a="http://schemas.openxmlformats.org/drawingml/2006/main">
-            <a:pPr>
-              <a:defRPr sz="3450" b="1">
+            <a:pPr algn="l">
+              <a:defRPr sz="2250" b="1">
                 <a:solidFill>
                   <a:srgbClr val="1B1D19"/>
                 </a:solidFill>
@@ -4580,7 +4580,7 @@
               </a:defRPr>
             </a:pPr>
             <a:r>
-              <a:rPr sz="3450" b="1">
+              <a:rPr sz="2250" b="1">
                 <a:solidFill>
                   <a:srgbClr val="1B1D19"/>
                 </a:solidFill>
@@ -4598,25 +4598,25 @@
           <p:cNvPr id="3" name="">
             <a:extLst xmlns:a="http://schemas.openxmlformats.org/drawingml/2006/main">
               <a:ext uri="{FF2B5EF4-FFF2-40B4-BE49-F238E27FC236}">
-                <a16:creationId xmlns:a16="http://schemas.microsoft.com/office/drawing/2014/main" id="{B8D191B4-66E3-4D73-A05E-38C10DFF53FF}"/>
-              </a:ext>
-            </a:extLst>
-          </p:cNvPr>
-          <p:cNvSpPr>
-            <a:spLocks xmlns:a="http://schemas.openxmlformats.org/drawingml/2006/main" noGrp="1"/>
-          </p:cNvSpPr>
-          <p:nvPr/>
-        </p:nvSpPr>
-        <p:spPr>
-          <a:xfrm xmlns:a="http://schemas.openxmlformats.org/drawingml/2006/main">
-            <a:off x="685800" y="2476500"/>
-            <a:ext cx="10820400" cy="3524250"/>
+                <a16:creationId xmlns:a16="http://schemas.microsoft.com/office/drawing/2014/main" id="{D4F6AB68-7854-4E4F-97B8-F030DA168BDB}"/>
+              </a:ext>
+            </a:extLst>
+          </p:cNvPr>
+          <p:cNvSpPr>
+            <a:spLocks xmlns:a="http://schemas.openxmlformats.org/drawingml/2006/main" noGrp="1"/>
+          </p:cNvSpPr>
+          <p:nvPr/>
+        </p:nvSpPr>
+        <p:spPr>
+          <a:xfrm xmlns:a="http://schemas.openxmlformats.org/drawingml/2006/main">
+            <a:off x="914400" y="723900"/>
+            <a:ext cx="10363200" cy="5829300"/>
           </a:xfrm>
           <a:prstGeom xmlns:a="http://schemas.openxmlformats.org/drawingml/2006/main" prst="rect">
             <a:avLst/>
           </a:prstGeom>
           <a:solidFill xmlns:a="http://schemas.openxmlformats.org/drawingml/2006/main">
-            <a:srgbClr val="F7F7F3"/>
+            <a:srgbClr val="F4F3EE"/>
           </a:solidFill>
           <a:ln xmlns:a="http://schemas.openxmlformats.org/drawingml/2006/main" w="0">
             <a:noFill/>
@@ -4628,49 +4628,19 @@
           <p:cNvPr id="4" name="">
             <a:extLst xmlns:a="http://schemas.openxmlformats.org/drawingml/2006/main">
               <a:ext uri="{FF2B5EF4-FFF2-40B4-BE49-F238E27FC236}">
-                <a16:creationId xmlns:a16="http://schemas.microsoft.com/office/drawing/2014/main" id="{15C9CFD1-0437-4E56-812E-2435E8CE7B25}"/>
-              </a:ext>
-            </a:extLst>
-          </p:cNvPr>
-          <p:cNvSpPr>
-            <a:spLocks xmlns:a="http://schemas.openxmlformats.org/drawingml/2006/main" noGrp="1"/>
-          </p:cNvSpPr>
-          <p:nvPr/>
-        </p:nvSpPr>
-        <p:spPr>
-          <a:xfrm xmlns:a="http://schemas.openxmlformats.org/drawingml/2006/main">
-            <a:off x="685800" y="2476500"/>
-            <a:ext cx="10820400" cy="9525"/>
-          </a:xfrm>
-          <a:prstGeom xmlns:a="http://schemas.openxmlformats.org/drawingml/2006/main" prst="rect">
-            <a:avLst/>
-          </a:prstGeom>
-          <a:solidFill xmlns:a="http://schemas.openxmlformats.org/drawingml/2006/main">
-            <a:srgbClr val="DEDFD6"/>
-          </a:solidFill>
-          <a:ln xmlns:a="http://schemas.openxmlformats.org/drawingml/2006/main" w="0">
-            <a:noFill/>
-          </a:ln>
-        </p:spPr>
-      </p:sp>
-      <p:sp>
-        <p:nvSpPr>
-          <p:cNvPr id="5" name="">
-            <a:extLst xmlns:a="http://schemas.openxmlformats.org/drawingml/2006/main">
-              <a:ext uri="{FF2B5EF4-FFF2-40B4-BE49-F238E27FC236}">
-                <a16:creationId xmlns:a16="http://schemas.microsoft.com/office/drawing/2014/main" id="{260AC76E-F290-41E4-A8D1-986817883B4E}"/>
-              </a:ext>
-            </a:extLst>
-          </p:cNvPr>
-          <p:cNvSpPr>
-            <a:spLocks xmlns:a="http://schemas.openxmlformats.org/drawingml/2006/main" noGrp="1"/>
-          </p:cNvSpPr>
-          <p:nvPr/>
-        </p:nvSpPr>
-        <p:spPr>
-          <a:xfrm xmlns:a="http://schemas.openxmlformats.org/drawingml/2006/main">
-            <a:off x="685800" y="6448425"/>
-            <a:ext cx="10191750" cy="228600"/>
+                <a16:creationId xmlns:a16="http://schemas.microsoft.com/office/drawing/2014/main" id="{E629B1D3-DE24-4EC4-9B99-9EED144C6D93}"/>
+              </a:ext>
+            </a:extLst>
+          </p:cNvPr>
+          <p:cNvSpPr>
+            <a:spLocks xmlns:a="http://schemas.openxmlformats.org/drawingml/2006/main" noGrp="1"/>
+          </p:cNvSpPr>
+          <p:nvPr/>
+        </p:nvSpPr>
+        <p:spPr>
+          <a:xfrm xmlns:a="http://schemas.openxmlformats.org/drawingml/2006/main">
+            <a:off x="914400" y="6667500"/>
+            <a:ext cx="9525000" cy="152400"/>
           </a:xfrm>
           <a:prstGeom xmlns:a="http://schemas.openxmlformats.org/drawingml/2006/main" prst="rect">
             <a:avLst/>
@@ -4685,8 +4655,8 @@
             <a:noAutofit/>
           </a:bodyPr>
           <a:lstStyle xmlns:a="http://schemas.openxmlformats.org/drawingml/2006/main">
-            <a:defPPr>
-              <a:defRPr sz="975" b="0">
+            <a:defPPr algn="l">
+              <a:defRPr sz="825" b="0">
                 <a:solidFill>
                   <a:srgbClr val="858B7E"/>
                 </a:solidFill>
@@ -4697,8 +4667,8 @@
             </a:defPPr>
           </a:lstStyle>
           <a:p xmlns:a="http://schemas.openxmlformats.org/drawingml/2006/main">
-            <a:pPr>
-              <a:defRPr sz="975" b="0">
+            <a:pPr algn="l">
+              <a:defRPr sz="825" b="0">
                 <a:solidFill>
                   <a:srgbClr val="858B7E"/>
                 </a:solidFill>
@@ -4708,7 +4678,7 @@
               </a:defRPr>
             </a:pPr>
             <a:r>
-              <a:rPr sz="975" b="0">
+              <a:rPr sz="825" b="0">
                 <a:solidFill>
                   <a:srgbClr val="858B7E"/>
                 </a:solidFill>
@@ -4723,22 +4693,22 @@
       </p:sp>
       <p:sp>
         <p:nvSpPr>
-          <p:cNvPr id="6" name="">
-            <a:extLst xmlns:a="http://schemas.openxmlformats.org/drawingml/2006/main">
-              <a:ext uri="{FF2B5EF4-FFF2-40B4-BE49-F238E27FC236}">
-                <a16:creationId xmlns:a16="http://schemas.microsoft.com/office/drawing/2014/main" id="{F8B96786-0866-4819-BC45-45632059886B}"/>
-              </a:ext>
-            </a:extLst>
-          </p:cNvPr>
-          <p:cNvSpPr>
-            <a:spLocks xmlns:a="http://schemas.openxmlformats.org/drawingml/2006/main" noGrp="1"/>
-          </p:cNvSpPr>
-          <p:nvPr/>
-        </p:nvSpPr>
-        <p:spPr>
-          <a:xfrm xmlns:a="http://schemas.openxmlformats.org/drawingml/2006/main">
-            <a:off x="11134725" y="6448425"/>
-            <a:ext cx="371475" cy="228600"/>
+          <p:cNvPr id="5" name="">
+            <a:extLst xmlns:a="http://schemas.openxmlformats.org/drawingml/2006/main">
+              <a:ext uri="{FF2B5EF4-FFF2-40B4-BE49-F238E27FC236}">
+                <a16:creationId xmlns:a16="http://schemas.microsoft.com/office/drawing/2014/main" id="{09CC2E0A-5DD9-47E6-9500-E3DA3DE4227C}"/>
+              </a:ext>
+            </a:extLst>
+          </p:cNvPr>
+          <p:cNvSpPr>
+            <a:spLocks xmlns:a="http://schemas.openxmlformats.org/drawingml/2006/main" noGrp="1"/>
+          </p:cNvSpPr>
+          <p:nvPr/>
+        </p:nvSpPr>
+        <p:spPr>
+          <a:xfrm xmlns:a="http://schemas.openxmlformats.org/drawingml/2006/main">
+            <a:off x="11049000" y="6667500"/>
+            <a:ext cx="228600" cy="152400"/>
           </a:xfrm>
           <a:prstGeom xmlns:a="http://schemas.openxmlformats.org/drawingml/2006/main" prst="rect">
             <a:avLst/>
@@ -4753,8 +4723,8 @@
             <a:noAutofit/>
           </a:bodyPr>
           <a:lstStyle xmlns:a="http://schemas.openxmlformats.org/drawingml/2006/main">
-            <a:defPPr>
-              <a:defRPr sz="975" b="0">
+            <a:defPPr algn="l">
+              <a:defRPr sz="825" b="0">
                 <a:solidFill>
                   <a:srgbClr val="858B7E"/>
                 </a:solidFill>
@@ -4765,8 +4735,8 @@
             </a:defPPr>
           </a:lstStyle>
           <a:p xmlns:a="http://schemas.openxmlformats.org/drawingml/2006/main">
-            <a:pPr>
-              <a:defRPr sz="975" b="0">
+            <a:pPr algn="l">
+              <a:defRPr sz="825" b="0">
                 <a:solidFill>
                   <a:srgbClr val="858B7E"/>
                 </a:solidFill>
@@ -4776,7 +4746,7 @@
               </a:defRPr>
             </a:pPr>
             <a:r>
-              <a:rPr sz="975" b="0">
+              <a:rPr sz="825" b="0">
                 <a:solidFill>
                   <a:srgbClr val="858B7E"/>
                 </a:solidFill>
@@ -4792,7 +4762,7 @@
     </p:spTree>
     <p:extLst>
       <p:ext uri="{BB962C8B-B14F-4D97-AF65-F5344CB8AC3E}">
-        <p14:creationId xmlns:p14="http://schemas.microsoft.com/office/powerpoint/2010/main" val="658523851"/>
+        <p14:creationId xmlns:p14="http://schemas.microsoft.com/office/powerpoint/2010/main" val="913285162"/>
       </p:ext>
     </p:extLst>
   </p:cSld>
@@ -4820,22 +4790,22 @@
       </p:grpSpPr>
       <p:sp>
         <p:nvSpPr>
-          <p:cNvPr id="7" name="">
-            <a:extLst xmlns:a="http://schemas.openxmlformats.org/drawingml/2006/main">
-              <a:ext uri="{FF2B5EF4-FFF2-40B4-BE49-F238E27FC236}">
-                <a16:creationId xmlns:a16="http://schemas.microsoft.com/office/drawing/2014/main" id="{975012B8-D0FF-494A-8DCD-81F0BF8AB51A}"/>
-              </a:ext>
-            </a:extLst>
-          </p:cNvPr>
-          <p:cNvSpPr>
-            <a:spLocks xmlns:a="http://schemas.openxmlformats.org/drawingml/2006/main" noGrp="1"/>
-          </p:cNvSpPr>
-          <p:nvPr/>
-        </p:nvSpPr>
-        <p:spPr>
-          <a:xfrm xmlns:a="http://schemas.openxmlformats.org/drawingml/2006/main">
-            <a:off x="685800" y="619125"/>
-            <a:ext cx="10668000" cy="247650"/>
+          <p:cNvPr id="6" name="">
+            <a:extLst xmlns:a="http://schemas.openxmlformats.org/drawingml/2006/main">
+              <a:ext uri="{FF2B5EF4-FFF2-40B4-BE49-F238E27FC236}">
+                <a16:creationId xmlns:a16="http://schemas.microsoft.com/office/drawing/2014/main" id="{B948F76B-13AF-4998-A6EB-DE7EF5FC1BF5}"/>
+              </a:ext>
+            </a:extLst>
+          </p:cNvPr>
+          <p:cNvSpPr>
+            <a:spLocks xmlns:a="http://schemas.openxmlformats.org/drawingml/2006/main" noGrp="1"/>
+          </p:cNvSpPr>
+          <p:nvPr/>
+        </p:nvSpPr>
+        <p:spPr>
+          <a:xfrm xmlns:a="http://schemas.openxmlformats.org/drawingml/2006/main">
+            <a:off x="914400" y="133350"/>
+            <a:ext cx="10363200" cy="152400"/>
           </a:xfrm>
           <a:prstGeom xmlns:a="http://schemas.openxmlformats.org/drawingml/2006/main" prst="rect">
             <a:avLst/>
@@ -4850,8 +4820,8 @@
             <a:noAutofit/>
           </a:bodyPr>
           <a:lstStyle xmlns:a="http://schemas.openxmlformats.org/drawingml/2006/main">
-            <a:defPPr>
-              <a:defRPr sz="1050" b="1">
+            <a:defPPr algn="l">
+              <a:defRPr sz="825" b="1">
                 <a:solidFill>
                   <a:srgbClr val="9B7744"/>
                 </a:solidFill>
@@ -4862,8 +4832,8 @@
             </a:defPPr>
           </a:lstStyle>
           <a:p xmlns:a="http://schemas.openxmlformats.org/drawingml/2006/main">
-            <a:pPr>
-              <a:defRPr sz="1050" b="1">
+            <a:pPr algn="l">
+              <a:defRPr sz="825" b="1">
                 <a:solidFill>
                   <a:srgbClr val="9B7744"/>
                 </a:solidFill>
@@ -4873,7 +4843,7 @@
               </a:defRPr>
             </a:pPr>
             <a:r>
-              <a:rPr sz="1050" b="1">
+              <a:rPr sz="825" b="1">
                 <a:solidFill>
                   <a:srgbClr val="9B7744"/>
                 </a:solidFill>
@@ -4891,19 +4861,19 @@
           <p:cNvPr id="2" name="">
             <a:extLst xmlns:a="http://schemas.openxmlformats.org/drawingml/2006/main">
               <a:ext uri="{FF2B5EF4-FFF2-40B4-BE49-F238E27FC236}">
-                <a16:creationId xmlns:a16="http://schemas.microsoft.com/office/drawing/2014/main" id="{E1C36471-6E9B-4FD8-B72E-9D39D714D517}"/>
-              </a:ext>
-            </a:extLst>
-          </p:cNvPr>
-          <p:cNvSpPr>
-            <a:spLocks xmlns:a="http://schemas.openxmlformats.org/drawingml/2006/main" noGrp="1"/>
-          </p:cNvSpPr>
-          <p:nvPr/>
-        </p:nvSpPr>
-        <p:spPr>
-          <a:xfrm xmlns:a="http://schemas.openxmlformats.org/drawingml/2006/main">
-            <a:off x="685800" y="1047750"/>
-            <a:ext cx="10820400" cy="1085850"/>
+                <a16:creationId xmlns:a16="http://schemas.microsoft.com/office/drawing/2014/main" id="{617B11E6-112E-4B64-8EA0-59E36EAF4231}"/>
+              </a:ext>
+            </a:extLst>
+          </p:cNvPr>
+          <p:cNvSpPr>
+            <a:spLocks xmlns:a="http://schemas.openxmlformats.org/drawingml/2006/main" noGrp="1"/>
+          </p:cNvSpPr>
+          <p:nvPr/>
+        </p:nvSpPr>
+        <p:spPr>
+          <a:xfrm xmlns:a="http://schemas.openxmlformats.org/drawingml/2006/main">
+            <a:off x="914400" y="304800"/>
+            <a:ext cx="10363200" cy="381000"/>
           </a:xfrm>
           <a:prstGeom xmlns:a="http://schemas.openxmlformats.org/drawingml/2006/main" prst="rect">
             <a:avLst/>
@@ -4918,8 +4888,8 @@
             <a:noAutofit/>
           </a:bodyPr>
           <a:lstStyle xmlns:a="http://schemas.openxmlformats.org/drawingml/2006/main">
-            <a:defPPr>
-              <a:defRPr sz="3450" b="1">
+            <a:defPPr algn="l">
+              <a:defRPr sz="2250" b="1">
                 <a:solidFill>
                   <a:srgbClr val="1B1D19"/>
                 </a:solidFill>
@@ -4930,8 +4900,8 @@
             </a:defPPr>
           </a:lstStyle>
           <a:p xmlns:a="http://schemas.openxmlformats.org/drawingml/2006/main">
-            <a:pPr>
-              <a:defRPr sz="3450" b="1">
+            <a:pPr algn="l">
+              <a:defRPr sz="2250" b="1">
                 <a:solidFill>
                   <a:srgbClr val="1B1D19"/>
                 </a:solidFill>
@@ -4941,7 +4911,7 @@
               </a:defRPr>
             </a:pPr>
             <a:r>
-              <a:rPr sz="3450" b="1">
+              <a:rPr sz="2250" b="1">
                 <a:solidFill>
                   <a:srgbClr val="1B1D19"/>
                 </a:solidFill>
@@ -4959,25 +4929,25 @@
           <p:cNvPr id="3" name="">
             <a:extLst xmlns:a="http://schemas.openxmlformats.org/drawingml/2006/main">
               <a:ext uri="{FF2B5EF4-FFF2-40B4-BE49-F238E27FC236}">
-                <a16:creationId xmlns:a16="http://schemas.microsoft.com/office/drawing/2014/main" id="{2EDDAC19-9688-4730-B9E6-337892C56B41}"/>
-              </a:ext>
-            </a:extLst>
-          </p:cNvPr>
-          <p:cNvSpPr>
-            <a:spLocks xmlns:a="http://schemas.openxmlformats.org/drawingml/2006/main" noGrp="1"/>
-          </p:cNvSpPr>
-          <p:nvPr/>
-        </p:nvSpPr>
-        <p:spPr>
-          <a:xfrm xmlns:a="http://schemas.openxmlformats.org/drawingml/2006/main">
-            <a:off x="685800" y="2476500"/>
-            <a:ext cx="10820400" cy="3524250"/>
+                <a16:creationId xmlns:a16="http://schemas.microsoft.com/office/drawing/2014/main" id="{C011A6B2-BEF1-47E5-8362-4588107CA265}"/>
+              </a:ext>
+            </a:extLst>
+          </p:cNvPr>
+          <p:cNvSpPr>
+            <a:spLocks xmlns:a="http://schemas.openxmlformats.org/drawingml/2006/main" noGrp="1"/>
+          </p:cNvSpPr>
+          <p:nvPr/>
+        </p:nvSpPr>
+        <p:spPr>
+          <a:xfrm xmlns:a="http://schemas.openxmlformats.org/drawingml/2006/main">
+            <a:off x="914400" y="723900"/>
+            <a:ext cx="10363200" cy="5829300"/>
           </a:xfrm>
           <a:prstGeom xmlns:a="http://schemas.openxmlformats.org/drawingml/2006/main" prst="rect">
             <a:avLst/>
           </a:prstGeom>
           <a:solidFill xmlns:a="http://schemas.openxmlformats.org/drawingml/2006/main">
-            <a:srgbClr val="F7F7F3"/>
+            <a:srgbClr val="F4F3EE"/>
           </a:solidFill>
           <a:ln xmlns:a="http://schemas.openxmlformats.org/drawingml/2006/main" w="0">
             <a:noFill/>
@@ -4989,49 +4959,19 @@
           <p:cNvPr id="4" name="">
             <a:extLst xmlns:a="http://schemas.openxmlformats.org/drawingml/2006/main">
               <a:ext uri="{FF2B5EF4-FFF2-40B4-BE49-F238E27FC236}">
-                <a16:creationId xmlns:a16="http://schemas.microsoft.com/office/drawing/2014/main" id="{BF0A7C99-99DE-42BB-947A-4A271945DB81}"/>
-              </a:ext>
-            </a:extLst>
-          </p:cNvPr>
-          <p:cNvSpPr>
-            <a:spLocks xmlns:a="http://schemas.openxmlformats.org/drawingml/2006/main" noGrp="1"/>
-          </p:cNvSpPr>
-          <p:nvPr/>
-        </p:nvSpPr>
-        <p:spPr>
-          <a:xfrm xmlns:a="http://schemas.openxmlformats.org/drawingml/2006/main">
-            <a:off x="685800" y="2476500"/>
-            <a:ext cx="10820400" cy="9525"/>
-          </a:xfrm>
-          <a:prstGeom xmlns:a="http://schemas.openxmlformats.org/drawingml/2006/main" prst="rect">
-            <a:avLst/>
-          </a:prstGeom>
-          <a:solidFill xmlns:a="http://schemas.openxmlformats.org/drawingml/2006/main">
-            <a:srgbClr val="DEDFD6"/>
-          </a:solidFill>
-          <a:ln xmlns:a="http://schemas.openxmlformats.org/drawingml/2006/main" w="0">
-            <a:noFill/>
-          </a:ln>
-        </p:spPr>
-      </p:sp>
-      <p:sp>
-        <p:nvSpPr>
-          <p:cNvPr id="5" name="">
-            <a:extLst xmlns:a="http://schemas.openxmlformats.org/drawingml/2006/main">
-              <a:ext uri="{FF2B5EF4-FFF2-40B4-BE49-F238E27FC236}">
-                <a16:creationId xmlns:a16="http://schemas.microsoft.com/office/drawing/2014/main" id="{DDF221EA-67D9-4240-8407-80A5B3485F04}"/>
-              </a:ext>
-            </a:extLst>
-          </p:cNvPr>
-          <p:cNvSpPr>
-            <a:spLocks xmlns:a="http://schemas.openxmlformats.org/drawingml/2006/main" noGrp="1"/>
-          </p:cNvSpPr>
-          <p:nvPr/>
-        </p:nvSpPr>
-        <p:spPr>
-          <a:xfrm xmlns:a="http://schemas.openxmlformats.org/drawingml/2006/main">
-            <a:off x="685800" y="6448425"/>
-            <a:ext cx="10191750" cy="228600"/>
+                <a16:creationId xmlns:a16="http://schemas.microsoft.com/office/drawing/2014/main" id="{CD4B71A4-92B3-47EF-810F-4E7A62655147}"/>
+              </a:ext>
+            </a:extLst>
+          </p:cNvPr>
+          <p:cNvSpPr>
+            <a:spLocks xmlns:a="http://schemas.openxmlformats.org/drawingml/2006/main" noGrp="1"/>
+          </p:cNvSpPr>
+          <p:nvPr/>
+        </p:nvSpPr>
+        <p:spPr>
+          <a:xfrm xmlns:a="http://schemas.openxmlformats.org/drawingml/2006/main">
+            <a:off x="914400" y="6667500"/>
+            <a:ext cx="9525000" cy="152400"/>
           </a:xfrm>
           <a:prstGeom xmlns:a="http://schemas.openxmlformats.org/drawingml/2006/main" prst="rect">
             <a:avLst/>
@@ -5046,8 +4986,8 @@
             <a:noAutofit/>
           </a:bodyPr>
           <a:lstStyle xmlns:a="http://schemas.openxmlformats.org/drawingml/2006/main">
-            <a:defPPr>
-              <a:defRPr sz="975" b="0">
+            <a:defPPr algn="l">
+              <a:defRPr sz="825" b="0">
                 <a:solidFill>
                   <a:srgbClr val="858B7E"/>
                 </a:solidFill>
@@ -5058,8 +4998,8 @@
             </a:defPPr>
           </a:lstStyle>
           <a:p xmlns:a="http://schemas.openxmlformats.org/drawingml/2006/main">
-            <a:pPr>
-              <a:defRPr sz="975" b="0">
+            <a:pPr algn="l">
+              <a:defRPr sz="825" b="0">
                 <a:solidFill>
                   <a:srgbClr val="858B7E"/>
                 </a:solidFill>
@@ -5069,7 +5009,7 @@
               </a:defRPr>
             </a:pPr>
             <a:r>
-              <a:rPr sz="975" b="0">
+              <a:rPr sz="825" b="0">
                 <a:solidFill>
                   <a:srgbClr val="858B7E"/>
                 </a:solidFill>
@@ -5084,22 +5024,22 @@
       </p:sp>
       <p:sp>
         <p:nvSpPr>
-          <p:cNvPr id="6" name="">
-            <a:extLst xmlns:a="http://schemas.openxmlformats.org/drawingml/2006/main">
-              <a:ext uri="{FF2B5EF4-FFF2-40B4-BE49-F238E27FC236}">
-                <a16:creationId xmlns:a16="http://schemas.microsoft.com/office/drawing/2014/main" id="{0946B173-3BD1-433E-B28E-A94B36D16DA3}"/>
-              </a:ext>
-            </a:extLst>
-          </p:cNvPr>
-          <p:cNvSpPr>
-            <a:spLocks xmlns:a="http://schemas.openxmlformats.org/drawingml/2006/main" noGrp="1"/>
-          </p:cNvSpPr>
-          <p:nvPr/>
-        </p:nvSpPr>
-        <p:spPr>
-          <a:xfrm xmlns:a="http://schemas.openxmlformats.org/drawingml/2006/main">
-            <a:off x="11134725" y="6448425"/>
-            <a:ext cx="371475" cy="228600"/>
+          <p:cNvPr id="5" name="">
+            <a:extLst xmlns:a="http://schemas.openxmlformats.org/drawingml/2006/main">
+              <a:ext uri="{FF2B5EF4-FFF2-40B4-BE49-F238E27FC236}">
+                <a16:creationId xmlns:a16="http://schemas.microsoft.com/office/drawing/2014/main" id="{3C235B60-DDBB-4B18-B185-B4F5DAEAB8B0}"/>
+              </a:ext>
+            </a:extLst>
+          </p:cNvPr>
+          <p:cNvSpPr>
+            <a:spLocks xmlns:a="http://schemas.openxmlformats.org/drawingml/2006/main" noGrp="1"/>
+          </p:cNvSpPr>
+          <p:nvPr/>
+        </p:nvSpPr>
+        <p:spPr>
+          <a:xfrm xmlns:a="http://schemas.openxmlformats.org/drawingml/2006/main">
+            <a:off x="11049000" y="6667500"/>
+            <a:ext cx="228600" cy="152400"/>
           </a:xfrm>
           <a:prstGeom xmlns:a="http://schemas.openxmlformats.org/drawingml/2006/main" prst="rect">
             <a:avLst/>
@@ -5114,8 +5054,8 @@
             <a:noAutofit/>
           </a:bodyPr>
           <a:lstStyle xmlns:a="http://schemas.openxmlformats.org/drawingml/2006/main">
-            <a:defPPr>
-              <a:defRPr sz="975" b="0">
+            <a:defPPr algn="l">
+              <a:defRPr sz="825" b="0">
                 <a:solidFill>
                   <a:srgbClr val="858B7E"/>
                 </a:solidFill>
@@ -5126,8 +5066,8 @@
             </a:defPPr>
           </a:lstStyle>
           <a:p xmlns:a="http://schemas.openxmlformats.org/drawingml/2006/main">
-            <a:pPr>
-              <a:defRPr sz="975" b="0">
+            <a:pPr algn="l">
+              <a:defRPr sz="825" b="0">
                 <a:solidFill>
                   <a:srgbClr val="858B7E"/>
                 </a:solidFill>
@@ -5137,7 +5077,7 @@
               </a:defRPr>
             </a:pPr>
             <a:r>
-              <a:rPr sz="975" b="0">
+              <a:rPr sz="825" b="0">
                 <a:solidFill>
                   <a:srgbClr val="858B7E"/>
                 </a:solidFill>
@@ -5153,7 +5093,7 @@
     </p:spTree>
     <p:extLst>
       <p:ext uri="{BB962C8B-B14F-4D97-AF65-F5344CB8AC3E}">
-        <p14:creationId xmlns:p14="http://schemas.microsoft.com/office/powerpoint/2010/main" val="21090931"/>
+        <p14:creationId xmlns:p14="http://schemas.microsoft.com/office/powerpoint/2010/main" val="384130213"/>
       </p:ext>
     </p:extLst>
   </p:cSld>
@@ -5181,22 +5121,22 @@
       </p:grpSpPr>
       <p:sp>
         <p:nvSpPr>
-          <p:cNvPr id="7" name="">
-            <a:extLst xmlns:a="http://schemas.openxmlformats.org/drawingml/2006/main">
-              <a:ext uri="{FF2B5EF4-FFF2-40B4-BE49-F238E27FC236}">
-                <a16:creationId xmlns:a16="http://schemas.microsoft.com/office/drawing/2014/main" id="{46D3BBE8-0691-430C-8DAD-A4EB5A105E29}"/>
-              </a:ext>
-            </a:extLst>
-          </p:cNvPr>
-          <p:cNvSpPr>
-            <a:spLocks xmlns:a="http://schemas.openxmlformats.org/drawingml/2006/main" noGrp="1"/>
-          </p:cNvSpPr>
-          <p:nvPr/>
-        </p:nvSpPr>
-        <p:spPr>
-          <a:xfrm xmlns:a="http://schemas.openxmlformats.org/drawingml/2006/main">
-            <a:off x="685800" y="619125"/>
-            <a:ext cx="10668000" cy="247650"/>
+          <p:cNvPr id="6" name="">
+            <a:extLst xmlns:a="http://schemas.openxmlformats.org/drawingml/2006/main">
+              <a:ext uri="{FF2B5EF4-FFF2-40B4-BE49-F238E27FC236}">
+                <a16:creationId xmlns:a16="http://schemas.microsoft.com/office/drawing/2014/main" id="{DDB168A0-DD97-4756-9201-9A459B89C2F2}"/>
+              </a:ext>
+            </a:extLst>
+          </p:cNvPr>
+          <p:cNvSpPr>
+            <a:spLocks xmlns:a="http://schemas.openxmlformats.org/drawingml/2006/main" noGrp="1"/>
+          </p:cNvSpPr>
+          <p:nvPr/>
+        </p:nvSpPr>
+        <p:spPr>
+          <a:xfrm xmlns:a="http://schemas.openxmlformats.org/drawingml/2006/main">
+            <a:off x="914400" y="133350"/>
+            <a:ext cx="10363200" cy="152400"/>
           </a:xfrm>
           <a:prstGeom xmlns:a="http://schemas.openxmlformats.org/drawingml/2006/main" prst="rect">
             <a:avLst/>
@@ -5211,8 +5151,8 @@
             <a:noAutofit/>
           </a:bodyPr>
           <a:lstStyle xmlns:a="http://schemas.openxmlformats.org/drawingml/2006/main">
-            <a:defPPr>
-              <a:defRPr sz="1050" b="1">
+            <a:defPPr algn="l">
+              <a:defRPr sz="825" b="1">
                 <a:solidFill>
                   <a:srgbClr val="9B7744"/>
                 </a:solidFill>
@@ -5223,8 +5163,8 @@
             </a:defPPr>
           </a:lstStyle>
           <a:p xmlns:a="http://schemas.openxmlformats.org/drawingml/2006/main">
-            <a:pPr>
-              <a:defRPr sz="1050" b="1">
+            <a:pPr algn="l">
+              <a:defRPr sz="825" b="1">
                 <a:solidFill>
                   <a:srgbClr val="9B7744"/>
                 </a:solidFill>
@@ -5234,7 +5174,7 @@
               </a:defRPr>
             </a:pPr>
             <a:r>
-              <a:rPr sz="1050" b="1">
+              <a:rPr sz="825" b="1">
                 <a:solidFill>
                   <a:srgbClr val="9B7744"/>
                 </a:solidFill>
@@ -5252,19 +5192,19 @@
           <p:cNvPr id="2" name="">
             <a:extLst xmlns:a="http://schemas.openxmlformats.org/drawingml/2006/main">
               <a:ext uri="{FF2B5EF4-FFF2-40B4-BE49-F238E27FC236}">
-                <a16:creationId xmlns:a16="http://schemas.microsoft.com/office/drawing/2014/main" id="{5A3B2B39-9BAE-43D7-AAD1-8FF71D5B148A}"/>
-              </a:ext>
-            </a:extLst>
-          </p:cNvPr>
-          <p:cNvSpPr>
-            <a:spLocks xmlns:a="http://schemas.openxmlformats.org/drawingml/2006/main" noGrp="1"/>
-          </p:cNvSpPr>
-          <p:nvPr/>
-        </p:nvSpPr>
-        <p:spPr>
-          <a:xfrm xmlns:a="http://schemas.openxmlformats.org/drawingml/2006/main">
-            <a:off x="685800" y="1047750"/>
-            <a:ext cx="10820400" cy="1085850"/>
+                <a16:creationId xmlns:a16="http://schemas.microsoft.com/office/drawing/2014/main" id="{C7F8D385-9418-4980-B60A-251723390303}"/>
+              </a:ext>
+            </a:extLst>
+          </p:cNvPr>
+          <p:cNvSpPr>
+            <a:spLocks xmlns:a="http://schemas.openxmlformats.org/drawingml/2006/main" noGrp="1"/>
+          </p:cNvSpPr>
+          <p:nvPr/>
+        </p:nvSpPr>
+        <p:spPr>
+          <a:xfrm xmlns:a="http://schemas.openxmlformats.org/drawingml/2006/main">
+            <a:off x="914400" y="304800"/>
+            <a:ext cx="10363200" cy="381000"/>
           </a:xfrm>
           <a:prstGeom xmlns:a="http://schemas.openxmlformats.org/drawingml/2006/main" prst="rect">
             <a:avLst/>
@@ -5279,8 +5219,8 @@
             <a:noAutofit/>
           </a:bodyPr>
           <a:lstStyle xmlns:a="http://schemas.openxmlformats.org/drawingml/2006/main">
-            <a:defPPr>
-              <a:defRPr sz="3450" b="1">
+            <a:defPPr algn="l">
+              <a:defRPr sz="2250" b="1">
                 <a:solidFill>
                   <a:srgbClr val="1B1D19"/>
                 </a:solidFill>
@@ -5291,8 +5231,8 @@
             </a:defPPr>
           </a:lstStyle>
           <a:p xmlns:a="http://schemas.openxmlformats.org/drawingml/2006/main">
-            <a:pPr>
-              <a:defRPr sz="3450" b="1">
+            <a:pPr algn="l">
+              <a:defRPr sz="2250" b="1">
                 <a:solidFill>
                   <a:srgbClr val="1B1D19"/>
                 </a:solidFill>
@@ -5302,7 +5242,7 @@
               </a:defRPr>
             </a:pPr>
             <a:r>
-              <a:rPr sz="3450" b="1">
+              <a:rPr sz="2250" b="1">
                 <a:solidFill>
                   <a:srgbClr val="1B1D19"/>
                 </a:solidFill>
@@ -5320,25 +5260,25 @@
           <p:cNvPr id="3" name="">
             <a:extLst xmlns:a="http://schemas.openxmlformats.org/drawingml/2006/main">
               <a:ext uri="{FF2B5EF4-FFF2-40B4-BE49-F238E27FC236}">
-                <a16:creationId xmlns:a16="http://schemas.microsoft.com/office/drawing/2014/main" id="{79FE073C-10FA-4C5D-B24D-1F2D1F74E221}"/>
-              </a:ext>
-            </a:extLst>
-          </p:cNvPr>
-          <p:cNvSpPr>
-            <a:spLocks xmlns:a="http://schemas.openxmlformats.org/drawingml/2006/main" noGrp="1"/>
-          </p:cNvSpPr>
-          <p:nvPr/>
-        </p:nvSpPr>
-        <p:spPr>
-          <a:xfrm xmlns:a="http://schemas.openxmlformats.org/drawingml/2006/main">
-            <a:off x="685800" y="2476500"/>
-            <a:ext cx="10820400" cy="3524250"/>
+                <a16:creationId xmlns:a16="http://schemas.microsoft.com/office/drawing/2014/main" id="{B204A2F5-FB8D-4536-9078-E12CC311D752}"/>
+              </a:ext>
+            </a:extLst>
+          </p:cNvPr>
+          <p:cNvSpPr>
+            <a:spLocks xmlns:a="http://schemas.openxmlformats.org/drawingml/2006/main" noGrp="1"/>
+          </p:cNvSpPr>
+          <p:nvPr/>
+        </p:nvSpPr>
+        <p:spPr>
+          <a:xfrm xmlns:a="http://schemas.openxmlformats.org/drawingml/2006/main">
+            <a:off x="914400" y="723900"/>
+            <a:ext cx="10363200" cy="5829300"/>
           </a:xfrm>
           <a:prstGeom xmlns:a="http://schemas.openxmlformats.org/drawingml/2006/main" prst="rect">
             <a:avLst/>
           </a:prstGeom>
           <a:solidFill xmlns:a="http://schemas.openxmlformats.org/drawingml/2006/main">
-            <a:srgbClr val="F7F7F3"/>
+            <a:srgbClr val="F4F3EE"/>
           </a:solidFill>
           <a:ln xmlns:a="http://schemas.openxmlformats.org/drawingml/2006/main" w="0">
             <a:noFill/>
@@ -5350,49 +5290,19 @@
           <p:cNvPr id="4" name="">
             <a:extLst xmlns:a="http://schemas.openxmlformats.org/drawingml/2006/main">
               <a:ext uri="{FF2B5EF4-FFF2-40B4-BE49-F238E27FC236}">
-                <a16:creationId xmlns:a16="http://schemas.microsoft.com/office/drawing/2014/main" id="{9B816346-CD9B-4996-95B4-F4EA5AA96839}"/>
-              </a:ext>
-            </a:extLst>
-          </p:cNvPr>
-          <p:cNvSpPr>
-            <a:spLocks xmlns:a="http://schemas.openxmlformats.org/drawingml/2006/main" noGrp="1"/>
-          </p:cNvSpPr>
-          <p:nvPr/>
-        </p:nvSpPr>
-        <p:spPr>
-          <a:xfrm xmlns:a="http://schemas.openxmlformats.org/drawingml/2006/main">
-            <a:off x="685800" y="2476500"/>
-            <a:ext cx="10820400" cy="9525"/>
-          </a:xfrm>
-          <a:prstGeom xmlns:a="http://schemas.openxmlformats.org/drawingml/2006/main" prst="rect">
-            <a:avLst/>
-          </a:prstGeom>
-          <a:solidFill xmlns:a="http://schemas.openxmlformats.org/drawingml/2006/main">
-            <a:srgbClr val="DEDFD6"/>
-          </a:solidFill>
-          <a:ln xmlns:a="http://schemas.openxmlformats.org/drawingml/2006/main" w="0">
-            <a:noFill/>
-          </a:ln>
-        </p:spPr>
-      </p:sp>
-      <p:sp>
-        <p:nvSpPr>
-          <p:cNvPr id="5" name="">
-            <a:extLst xmlns:a="http://schemas.openxmlformats.org/drawingml/2006/main">
-              <a:ext uri="{FF2B5EF4-FFF2-40B4-BE49-F238E27FC236}">
-                <a16:creationId xmlns:a16="http://schemas.microsoft.com/office/drawing/2014/main" id="{76C54E36-AABC-4246-BF3A-9827C766718D}"/>
-              </a:ext>
-            </a:extLst>
-          </p:cNvPr>
-          <p:cNvSpPr>
-            <a:spLocks xmlns:a="http://schemas.openxmlformats.org/drawingml/2006/main" noGrp="1"/>
-          </p:cNvSpPr>
-          <p:nvPr/>
-        </p:nvSpPr>
-        <p:spPr>
-          <a:xfrm xmlns:a="http://schemas.openxmlformats.org/drawingml/2006/main">
-            <a:off x="685800" y="6448425"/>
-            <a:ext cx="10191750" cy="228600"/>
+                <a16:creationId xmlns:a16="http://schemas.microsoft.com/office/drawing/2014/main" id="{62EB008C-B53B-4AD4-B7BE-5E6CB45CFFE4}"/>
+              </a:ext>
+            </a:extLst>
+          </p:cNvPr>
+          <p:cNvSpPr>
+            <a:spLocks xmlns:a="http://schemas.openxmlformats.org/drawingml/2006/main" noGrp="1"/>
+          </p:cNvSpPr>
+          <p:nvPr/>
+        </p:nvSpPr>
+        <p:spPr>
+          <a:xfrm xmlns:a="http://schemas.openxmlformats.org/drawingml/2006/main">
+            <a:off x="914400" y="6667500"/>
+            <a:ext cx="9525000" cy="152400"/>
           </a:xfrm>
           <a:prstGeom xmlns:a="http://schemas.openxmlformats.org/drawingml/2006/main" prst="rect">
             <a:avLst/>
@@ -5407,8 +5317,8 @@
             <a:noAutofit/>
           </a:bodyPr>
           <a:lstStyle xmlns:a="http://schemas.openxmlformats.org/drawingml/2006/main">
-            <a:defPPr>
-              <a:defRPr sz="975" b="0">
+            <a:defPPr algn="l">
+              <a:defRPr sz="825" b="0">
                 <a:solidFill>
                   <a:srgbClr val="858B7E"/>
                 </a:solidFill>
@@ -5419,8 +5329,8 @@
             </a:defPPr>
           </a:lstStyle>
           <a:p xmlns:a="http://schemas.openxmlformats.org/drawingml/2006/main">
-            <a:pPr>
-              <a:defRPr sz="975" b="0">
+            <a:pPr algn="l">
+              <a:defRPr sz="825" b="0">
                 <a:solidFill>
                   <a:srgbClr val="858B7E"/>
                 </a:solidFill>
@@ -5430,7 +5340,7 @@
               </a:defRPr>
             </a:pPr>
             <a:r>
-              <a:rPr sz="975" b="0">
+              <a:rPr sz="825" b="0">
                 <a:solidFill>
                   <a:srgbClr val="858B7E"/>
                 </a:solidFill>
@@ -5445,22 +5355,22 @@
       </p:sp>
       <p:sp>
         <p:nvSpPr>
-          <p:cNvPr id="6" name="">
-            <a:extLst xmlns:a="http://schemas.openxmlformats.org/drawingml/2006/main">
-              <a:ext uri="{FF2B5EF4-FFF2-40B4-BE49-F238E27FC236}">
-                <a16:creationId xmlns:a16="http://schemas.microsoft.com/office/drawing/2014/main" id="{8BEE52B9-8E31-42EE-954A-FD2DDA19A5AB}"/>
-              </a:ext>
-            </a:extLst>
-          </p:cNvPr>
-          <p:cNvSpPr>
-            <a:spLocks xmlns:a="http://schemas.openxmlformats.org/drawingml/2006/main" noGrp="1"/>
-          </p:cNvSpPr>
-          <p:nvPr/>
-        </p:nvSpPr>
-        <p:spPr>
-          <a:xfrm xmlns:a="http://schemas.openxmlformats.org/drawingml/2006/main">
-            <a:off x="11134725" y="6448425"/>
-            <a:ext cx="371475" cy="228600"/>
+          <p:cNvPr id="5" name="">
+            <a:extLst xmlns:a="http://schemas.openxmlformats.org/drawingml/2006/main">
+              <a:ext uri="{FF2B5EF4-FFF2-40B4-BE49-F238E27FC236}">
+                <a16:creationId xmlns:a16="http://schemas.microsoft.com/office/drawing/2014/main" id="{6196C79B-91D5-43E8-B155-1B9D9C3718E7}"/>
+              </a:ext>
+            </a:extLst>
+          </p:cNvPr>
+          <p:cNvSpPr>
+            <a:spLocks xmlns:a="http://schemas.openxmlformats.org/drawingml/2006/main" noGrp="1"/>
+          </p:cNvSpPr>
+          <p:nvPr/>
+        </p:nvSpPr>
+        <p:spPr>
+          <a:xfrm xmlns:a="http://schemas.openxmlformats.org/drawingml/2006/main">
+            <a:off x="11049000" y="6667500"/>
+            <a:ext cx="228600" cy="152400"/>
           </a:xfrm>
           <a:prstGeom xmlns:a="http://schemas.openxmlformats.org/drawingml/2006/main" prst="rect">
             <a:avLst/>
@@ -5475,8 +5385,8 @@
             <a:noAutofit/>
           </a:bodyPr>
           <a:lstStyle xmlns:a="http://schemas.openxmlformats.org/drawingml/2006/main">
-            <a:defPPr>
-              <a:defRPr sz="975" b="0">
+            <a:defPPr algn="l">
+              <a:defRPr sz="825" b="0">
                 <a:solidFill>
                   <a:srgbClr val="858B7E"/>
                 </a:solidFill>
@@ -5487,8 +5397,8 @@
             </a:defPPr>
           </a:lstStyle>
           <a:p xmlns:a="http://schemas.openxmlformats.org/drawingml/2006/main">
-            <a:pPr>
-              <a:defRPr sz="975" b="0">
+            <a:pPr algn="l">
+              <a:defRPr sz="825" b="0">
                 <a:solidFill>
                   <a:srgbClr val="858B7E"/>
                 </a:solidFill>
@@ -5498,7 +5408,7 @@
               </a:defRPr>
             </a:pPr>
             <a:r>
-              <a:rPr sz="975" b="0">
+              <a:rPr sz="825" b="0">
                 <a:solidFill>
                   <a:srgbClr val="858B7E"/>
                 </a:solidFill>
@@ -5514,7 +5424,7 @@
     </p:spTree>
     <p:extLst>
       <p:ext uri="{BB962C8B-B14F-4D97-AF65-F5344CB8AC3E}">
-        <p14:creationId xmlns:p14="http://schemas.microsoft.com/office/powerpoint/2010/main" val="1564626933"/>
+        <p14:creationId xmlns:p14="http://schemas.microsoft.com/office/powerpoint/2010/main" val="247606364"/>
       </p:ext>
     </p:extLst>
   </p:cSld>
@@ -5545,7 +5455,7 @@
           <p:cNvPr id="18" name="">
             <a:extLst xmlns:a="http://schemas.openxmlformats.org/drawingml/2006/main">
               <a:ext uri="{FF2B5EF4-FFF2-40B4-BE49-F238E27FC236}">
-                <a16:creationId xmlns:a16="http://schemas.microsoft.com/office/drawing/2014/main" id="{A5DCA6E4-2AB0-4C7A-A319-EC32C74DC3EA}"/>
+                <a16:creationId xmlns:a16="http://schemas.microsoft.com/office/drawing/2014/main" id="{9F51E3ED-C361-49AD-AF9A-C2B4D40E5DDA}"/>
               </a:ext>
             </a:extLst>
           </p:cNvPr>
@@ -5572,7 +5482,7 @@
             <a:noAutofit/>
           </a:bodyPr>
           <a:lstStyle xmlns:a="http://schemas.openxmlformats.org/drawingml/2006/main">
-            <a:defPPr>
+            <a:defPPr algn="l">
               <a:defRPr sz="1050" b="1">
                 <a:solidFill>
                   <a:srgbClr val="9B7744"/>
@@ -5584,7 +5494,7 @@
             </a:defPPr>
           </a:lstStyle>
           <a:p xmlns:a="http://schemas.openxmlformats.org/drawingml/2006/main">
-            <a:pPr>
+            <a:pPr algn="l">
               <a:defRPr sz="1050" b="1">
                 <a:solidFill>
                   <a:srgbClr val="9B7744"/>
@@ -5613,7 +5523,7 @@
           <p:cNvPr id="2" name="">
             <a:extLst xmlns:a="http://schemas.openxmlformats.org/drawingml/2006/main">
               <a:ext uri="{FF2B5EF4-FFF2-40B4-BE49-F238E27FC236}">
-                <a16:creationId xmlns:a16="http://schemas.microsoft.com/office/drawing/2014/main" id="{BF605903-5514-4286-AA0F-5C11F8450573}"/>
+                <a16:creationId xmlns:a16="http://schemas.microsoft.com/office/drawing/2014/main" id="{50DA7D65-89F1-4DB8-AA5D-73483259F3FF}"/>
               </a:ext>
             </a:extLst>
           </p:cNvPr>
@@ -5640,7 +5550,7 @@
             <a:noAutofit/>
           </a:bodyPr>
           <a:lstStyle xmlns:a="http://schemas.openxmlformats.org/drawingml/2006/main">
-            <a:defPPr>
+            <a:defPPr algn="l">
               <a:defRPr sz="3450" b="1">
                 <a:solidFill>
                   <a:srgbClr val="1B1D19"/>
@@ -5652,7 +5562,7 @@
             </a:defPPr>
           </a:lstStyle>
           <a:p xmlns:a="http://schemas.openxmlformats.org/drawingml/2006/main">
-            <a:pPr>
+            <a:pPr algn="l">
               <a:defRPr sz="3450" b="1">
                 <a:solidFill>
                   <a:srgbClr val="1B1D19"/>
@@ -5681,7 +5591,7 @@
           <p:cNvPr id="3" name="">
             <a:extLst xmlns:a="http://schemas.openxmlformats.org/drawingml/2006/main">
               <a:ext uri="{FF2B5EF4-FFF2-40B4-BE49-F238E27FC236}">
-                <a16:creationId xmlns:a16="http://schemas.microsoft.com/office/drawing/2014/main" id="{92E1628D-96B8-4ED4-8180-B5F9FCDB0C2B}"/>
+                <a16:creationId xmlns:a16="http://schemas.microsoft.com/office/drawing/2014/main" id="{DFAF3D75-F055-453A-B058-A7CC4D3CE0CE}"/>
               </a:ext>
             </a:extLst>
           </p:cNvPr>
@@ -5711,7 +5621,7 @@
           <p:cNvPr id="4" name="">
             <a:extLst xmlns:a="http://schemas.openxmlformats.org/drawingml/2006/main">
               <a:ext uri="{FF2B5EF4-FFF2-40B4-BE49-F238E27FC236}">
-                <a16:creationId xmlns:a16="http://schemas.microsoft.com/office/drawing/2014/main" id="{DB395F9D-2789-44D9-AD31-C8428FA6107D}"/>
+                <a16:creationId xmlns:a16="http://schemas.microsoft.com/office/drawing/2014/main" id="{E51E0B5D-4BDF-4E9A-9B7A-4CF06B5E439B}"/>
               </a:ext>
             </a:extLst>
           </p:cNvPr>
@@ -5738,7 +5648,7 @@
             <a:noAutofit/>
           </a:bodyPr>
           <a:lstStyle xmlns:a="http://schemas.openxmlformats.org/drawingml/2006/main">
-            <a:defPPr>
+            <a:defPPr algn="l">
               <a:defRPr sz="1125" b="0">
                 <a:solidFill>
                   <a:srgbClr val="9B7744"/>
@@ -5750,7 +5660,7 @@
             </a:defPPr>
           </a:lstStyle>
           <a:p xmlns:a="http://schemas.openxmlformats.org/drawingml/2006/main">
-            <a:pPr>
+            <a:pPr algn="l">
               <a:defRPr sz="1125" b="0">
                 <a:solidFill>
                   <a:srgbClr val="9B7744"/>
@@ -5779,7 +5689,7 @@
           <p:cNvPr id="5" name="">
             <a:extLst xmlns:a="http://schemas.openxmlformats.org/drawingml/2006/main">
               <a:ext uri="{FF2B5EF4-FFF2-40B4-BE49-F238E27FC236}">
-                <a16:creationId xmlns:a16="http://schemas.microsoft.com/office/drawing/2014/main" id="{033D9895-CF7B-4E28-B62D-5D27A7F865E2}"/>
+                <a16:creationId xmlns:a16="http://schemas.microsoft.com/office/drawing/2014/main" id="{CEF8BB61-C838-4230-A0D2-3FB76F295B35}"/>
               </a:ext>
             </a:extLst>
           </p:cNvPr>
@@ -5806,7 +5716,7 @@
             <a:noAutofit/>
           </a:bodyPr>
           <a:lstStyle xmlns:a="http://schemas.openxmlformats.org/drawingml/2006/main">
-            <a:defPPr>
+            <a:defPPr algn="l">
               <a:defRPr sz="2175" b="1">
                 <a:solidFill>
                   <a:srgbClr val="1B1D19"/>
@@ -5818,7 +5728,7 @@
             </a:defPPr>
           </a:lstStyle>
           <a:p xmlns:a="http://schemas.openxmlformats.org/drawingml/2006/main">
-            <a:pPr>
+            <a:pPr algn="l">
               <a:defRPr sz="2175" b="1">
                 <a:solidFill>
                   <a:srgbClr val="1B1D19"/>
@@ -5847,7 +5757,7 @@
           <p:cNvPr id="6" name="">
             <a:extLst xmlns:a="http://schemas.openxmlformats.org/drawingml/2006/main">
               <a:ext uri="{FF2B5EF4-FFF2-40B4-BE49-F238E27FC236}">
-                <a16:creationId xmlns:a16="http://schemas.microsoft.com/office/drawing/2014/main" id="{1CFC48B3-28A6-42E1-9D3B-8D3644AC3791}"/>
+                <a16:creationId xmlns:a16="http://schemas.microsoft.com/office/drawing/2014/main" id="{546264C7-82C6-4786-A1DB-4954E4E9C0D8}"/>
               </a:ext>
             </a:extLst>
           </p:cNvPr>
@@ -5874,7 +5784,7 @@
             <a:noAutofit/>
           </a:bodyPr>
           <a:lstStyle xmlns:a="http://schemas.openxmlformats.org/drawingml/2006/main">
-            <a:defPPr>
+            <a:defPPr algn="l">
               <a:defRPr sz="1725" b="0">
                 <a:solidFill>
                   <a:srgbClr val="6B7265"/>
@@ -5886,7 +5796,7 @@
             </a:defPPr>
           </a:lstStyle>
           <a:p xmlns:a="http://schemas.openxmlformats.org/drawingml/2006/main">
-            <a:pPr>
+            <a:pPr algn="l">
               <a:defRPr sz="1725" b="0">
                 <a:solidFill>
                   <a:srgbClr val="6B7265"/>
@@ -5915,7 +5825,7 @@
           <p:cNvPr id="7" name="">
             <a:extLst xmlns:a="http://schemas.openxmlformats.org/drawingml/2006/main">
               <a:ext uri="{FF2B5EF4-FFF2-40B4-BE49-F238E27FC236}">
-                <a16:creationId xmlns:a16="http://schemas.microsoft.com/office/drawing/2014/main" id="{D33755AD-F2E2-4076-982E-367B3666F250}"/>
+                <a16:creationId xmlns:a16="http://schemas.microsoft.com/office/drawing/2014/main" id="{B4DEEF72-8D33-440E-BA15-B91BF8A5F9AC}"/>
               </a:ext>
             </a:extLst>
           </p:cNvPr>
@@ -5945,7 +5855,7 @@
           <p:cNvPr id="8" name="">
             <a:extLst xmlns:a="http://schemas.openxmlformats.org/drawingml/2006/main">
               <a:ext uri="{FF2B5EF4-FFF2-40B4-BE49-F238E27FC236}">
-                <a16:creationId xmlns:a16="http://schemas.microsoft.com/office/drawing/2014/main" id="{5EAA12F6-5B84-4D21-9CBF-0FCBDB83BE05}"/>
+                <a16:creationId xmlns:a16="http://schemas.microsoft.com/office/drawing/2014/main" id="{B528790F-E96E-48F2-B7B7-44B7E1E4059D}"/>
               </a:ext>
             </a:extLst>
           </p:cNvPr>
@@ -5972,7 +5882,7 @@
             <a:noAutofit/>
           </a:bodyPr>
           <a:lstStyle xmlns:a="http://schemas.openxmlformats.org/drawingml/2006/main">
-            <a:defPPr>
+            <a:defPPr algn="l">
               <a:defRPr sz="1125" b="0">
                 <a:solidFill>
                   <a:srgbClr val="9B7744"/>
@@ -5984,7 +5894,7 @@
             </a:defPPr>
           </a:lstStyle>
           <a:p xmlns:a="http://schemas.openxmlformats.org/drawingml/2006/main">
-            <a:pPr>
+            <a:pPr algn="l">
               <a:defRPr sz="1125" b="0">
                 <a:solidFill>
                   <a:srgbClr val="9B7744"/>
@@ -6013,7 +5923,7 @@
           <p:cNvPr id="9" name="">
             <a:extLst xmlns:a="http://schemas.openxmlformats.org/drawingml/2006/main">
               <a:ext uri="{FF2B5EF4-FFF2-40B4-BE49-F238E27FC236}">
-                <a16:creationId xmlns:a16="http://schemas.microsoft.com/office/drawing/2014/main" id="{502C18D5-152B-446B-9D27-B6547693ACC0}"/>
+                <a16:creationId xmlns:a16="http://schemas.microsoft.com/office/drawing/2014/main" id="{2B63B1EE-6768-43E8-B348-BA6A8E6024A7}"/>
               </a:ext>
             </a:extLst>
           </p:cNvPr>
@@ -6040,7 +5950,7 @@
             <a:noAutofit/>
           </a:bodyPr>
           <a:lstStyle xmlns:a="http://schemas.openxmlformats.org/drawingml/2006/main">
-            <a:defPPr>
+            <a:defPPr algn="l">
               <a:defRPr sz="2175" b="1">
                 <a:solidFill>
                   <a:srgbClr val="1B1D19"/>
@@ -6052,7 +5962,7 @@
             </a:defPPr>
           </a:lstStyle>
           <a:p xmlns:a="http://schemas.openxmlformats.org/drawingml/2006/main">
-            <a:pPr>
+            <a:pPr algn="l">
               <a:defRPr sz="2175" b="1">
                 <a:solidFill>
                   <a:srgbClr val="1B1D19"/>
@@ -6081,7 +5991,7 @@
           <p:cNvPr id="10" name="">
             <a:extLst xmlns:a="http://schemas.openxmlformats.org/drawingml/2006/main">
               <a:ext uri="{FF2B5EF4-FFF2-40B4-BE49-F238E27FC236}">
-                <a16:creationId xmlns:a16="http://schemas.microsoft.com/office/drawing/2014/main" id="{6904878B-BAD9-4999-861F-2DA7AE862BA8}"/>
+                <a16:creationId xmlns:a16="http://schemas.microsoft.com/office/drawing/2014/main" id="{32BA2BFD-DD1C-4FAE-A279-1B7369E429E8}"/>
               </a:ext>
             </a:extLst>
           </p:cNvPr>
@@ -6108,7 +6018,7 @@
             <a:noAutofit/>
           </a:bodyPr>
           <a:lstStyle xmlns:a="http://schemas.openxmlformats.org/drawingml/2006/main">
-            <a:defPPr>
+            <a:defPPr algn="l">
               <a:defRPr sz="1725" b="0">
                 <a:solidFill>
                   <a:srgbClr val="6B7265"/>
@@ -6120,7 +6030,7 @@
             </a:defPPr>
           </a:lstStyle>
           <a:p xmlns:a="http://schemas.openxmlformats.org/drawingml/2006/main">
-            <a:pPr>
+            <a:pPr algn="l">
               <a:defRPr sz="1725" b="0">
                 <a:solidFill>
                   <a:srgbClr val="6B7265"/>
@@ -6149,7 +6059,7 @@
           <p:cNvPr id="11" name="">
             <a:extLst xmlns:a="http://schemas.openxmlformats.org/drawingml/2006/main">
               <a:ext uri="{FF2B5EF4-FFF2-40B4-BE49-F238E27FC236}">
-                <a16:creationId xmlns:a16="http://schemas.microsoft.com/office/drawing/2014/main" id="{3F2BFF73-E5EE-47FC-844E-442AEA305DB0}"/>
+                <a16:creationId xmlns:a16="http://schemas.microsoft.com/office/drawing/2014/main" id="{96517E87-A4FF-4A03-B7AB-1316B1481CBA}"/>
               </a:ext>
             </a:extLst>
           </p:cNvPr>
@@ -6179,7 +6089,7 @@
           <p:cNvPr id="12" name="">
             <a:extLst xmlns:a="http://schemas.openxmlformats.org/drawingml/2006/main">
               <a:ext uri="{FF2B5EF4-FFF2-40B4-BE49-F238E27FC236}">
-                <a16:creationId xmlns:a16="http://schemas.microsoft.com/office/drawing/2014/main" id="{2DCAB5F1-CAD5-415F-A4A3-DEFC1E2C17BB}"/>
+                <a16:creationId xmlns:a16="http://schemas.microsoft.com/office/drawing/2014/main" id="{E0DFB6FB-B0FA-4D3B-A474-D79685090E9F}"/>
               </a:ext>
             </a:extLst>
           </p:cNvPr>
@@ -6206,7 +6116,7 @@
             <a:noAutofit/>
           </a:bodyPr>
           <a:lstStyle xmlns:a="http://schemas.openxmlformats.org/drawingml/2006/main">
-            <a:defPPr>
+            <a:defPPr algn="l">
               <a:defRPr sz="1125" b="0">
                 <a:solidFill>
                   <a:srgbClr val="9B7744"/>
@@ -6218,7 +6128,7 @@
             </a:defPPr>
           </a:lstStyle>
           <a:p xmlns:a="http://schemas.openxmlformats.org/drawingml/2006/main">
-            <a:pPr>
+            <a:pPr algn="l">
               <a:defRPr sz="1125" b="0">
                 <a:solidFill>
                   <a:srgbClr val="9B7744"/>
@@ -6247,7 +6157,7 @@
           <p:cNvPr id="13" name="">
             <a:extLst xmlns:a="http://schemas.openxmlformats.org/drawingml/2006/main">
               <a:ext uri="{FF2B5EF4-FFF2-40B4-BE49-F238E27FC236}">
-                <a16:creationId xmlns:a16="http://schemas.microsoft.com/office/drawing/2014/main" id="{F97726D7-C57F-4CBE-AFCE-620A30C08B85}"/>
+                <a16:creationId xmlns:a16="http://schemas.microsoft.com/office/drawing/2014/main" id="{7C7097B9-6682-4C38-8690-DE412DCE9A6A}"/>
               </a:ext>
             </a:extLst>
           </p:cNvPr>
@@ -6274,7 +6184,7 @@
             <a:noAutofit/>
           </a:bodyPr>
           <a:lstStyle xmlns:a="http://schemas.openxmlformats.org/drawingml/2006/main">
-            <a:defPPr>
+            <a:defPPr algn="l">
               <a:defRPr sz="2175" b="1">
                 <a:solidFill>
                   <a:srgbClr val="1B1D19"/>
@@ -6286,7 +6196,7 @@
             </a:defPPr>
           </a:lstStyle>
           <a:p xmlns:a="http://schemas.openxmlformats.org/drawingml/2006/main">
-            <a:pPr>
+            <a:pPr algn="l">
               <a:defRPr sz="2175" b="1">
                 <a:solidFill>
                   <a:srgbClr val="1B1D19"/>
@@ -6315,7 +6225,7 @@
           <p:cNvPr id="14" name="">
             <a:extLst xmlns:a="http://schemas.openxmlformats.org/drawingml/2006/main">
               <a:ext uri="{FF2B5EF4-FFF2-40B4-BE49-F238E27FC236}">
-                <a16:creationId xmlns:a16="http://schemas.microsoft.com/office/drawing/2014/main" id="{BD2AED3E-11A3-4C73-A42B-679179875424}"/>
+                <a16:creationId xmlns:a16="http://schemas.microsoft.com/office/drawing/2014/main" id="{513E2E82-7767-466B-8639-D664F71363CD}"/>
               </a:ext>
             </a:extLst>
           </p:cNvPr>
@@ -6342,7 +6252,7 @@
             <a:noAutofit/>
           </a:bodyPr>
           <a:lstStyle xmlns:a="http://schemas.openxmlformats.org/drawingml/2006/main">
-            <a:defPPr>
+            <a:defPPr algn="l">
               <a:defRPr sz="1725" b="0">
                 <a:solidFill>
                   <a:srgbClr val="6B7265"/>
@@ -6354,7 +6264,7 @@
             </a:defPPr>
           </a:lstStyle>
           <a:p xmlns:a="http://schemas.openxmlformats.org/drawingml/2006/main">
-            <a:pPr>
+            <a:pPr algn="l">
               <a:defRPr sz="1725" b="0">
                 <a:solidFill>
                   <a:srgbClr val="6B7265"/>
@@ -6383,7 +6293,7 @@
           <p:cNvPr id="15" name="">
             <a:extLst xmlns:a="http://schemas.openxmlformats.org/drawingml/2006/main">
               <a:ext uri="{FF2B5EF4-FFF2-40B4-BE49-F238E27FC236}">
-                <a16:creationId xmlns:a16="http://schemas.microsoft.com/office/drawing/2014/main" id="{B185C07A-A5FF-4BEE-82E6-20FD29B7E84F}"/>
+                <a16:creationId xmlns:a16="http://schemas.microsoft.com/office/drawing/2014/main" id="{DB3425C6-2B53-4370-B744-4E38CCD26C9B}"/>
               </a:ext>
             </a:extLst>
           </p:cNvPr>
@@ -6410,7 +6320,7 @@
             <a:noAutofit/>
           </a:bodyPr>
           <a:lstStyle xmlns:a="http://schemas.openxmlformats.org/drawingml/2006/main">
-            <a:defPPr>
+            <a:defPPr algn="l">
               <a:defRPr sz="1050" b="0">
                 <a:solidFill>
                   <a:srgbClr val="6B7265"/>
@@ -6422,7 +6332,7 @@
             </a:defPPr>
           </a:lstStyle>
           <a:p xmlns:a="http://schemas.openxmlformats.org/drawingml/2006/main">
-            <a:pPr>
+            <a:pPr algn="l">
               <a:defRPr sz="1050" b="0">
                 <a:solidFill>
                   <a:srgbClr val="6B7265"/>
@@ -6451,7 +6361,7 @@
           <p:cNvPr id="16" name="">
             <a:extLst xmlns:a="http://schemas.openxmlformats.org/drawingml/2006/main">
               <a:ext uri="{FF2B5EF4-FFF2-40B4-BE49-F238E27FC236}">
-                <a16:creationId xmlns:a16="http://schemas.microsoft.com/office/drawing/2014/main" id="{C9EECA77-8E8E-434B-B51A-EB9463AFE1D7}"/>
+                <a16:creationId xmlns:a16="http://schemas.microsoft.com/office/drawing/2014/main" id="{9D5B83D9-EAFC-4665-9E59-0312427DBB71}"/>
               </a:ext>
             </a:extLst>
           </p:cNvPr>
@@ -6478,7 +6388,7 @@
             <a:noAutofit/>
           </a:bodyPr>
           <a:lstStyle xmlns:a="http://schemas.openxmlformats.org/drawingml/2006/main">
-            <a:defPPr>
+            <a:defPPr algn="l">
               <a:defRPr sz="975" b="0">
                 <a:solidFill>
                   <a:srgbClr val="858B7E"/>
@@ -6490,7 +6400,7 @@
             </a:defPPr>
           </a:lstStyle>
           <a:p xmlns:a="http://schemas.openxmlformats.org/drawingml/2006/main">
-            <a:pPr>
+            <a:pPr algn="l">
               <a:defRPr sz="975" b="0">
                 <a:solidFill>
                   <a:srgbClr val="858B7E"/>
@@ -6519,7 +6429,7 @@
           <p:cNvPr id="17" name="">
             <a:extLst xmlns:a="http://schemas.openxmlformats.org/drawingml/2006/main">
               <a:ext uri="{FF2B5EF4-FFF2-40B4-BE49-F238E27FC236}">
-                <a16:creationId xmlns:a16="http://schemas.microsoft.com/office/drawing/2014/main" id="{B6B2BCDE-283D-4A54-8CCF-B18D1DDB78DE}"/>
+                <a16:creationId xmlns:a16="http://schemas.microsoft.com/office/drawing/2014/main" id="{D6685A5A-49EA-4695-B4FE-28BBA3369A81}"/>
               </a:ext>
             </a:extLst>
           </p:cNvPr>
@@ -6546,7 +6456,7 @@
             <a:noAutofit/>
           </a:bodyPr>
           <a:lstStyle xmlns:a="http://schemas.openxmlformats.org/drawingml/2006/main">
-            <a:defPPr>
+            <a:defPPr algn="l">
               <a:defRPr sz="975" b="0">
                 <a:solidFill>
                   <a:srgbClr val="858B7E"/>
@@ -6558,7 +6468,7 @@
             </a:defPPr>
           </a:lstStyle>
           <a:p xmlns:a="http://schemas.openxmlformats.org/drawingml/2006/main">
-            <a:pPr>
+            <a:pPr algn="l">
               <a:defRPr sz="975" b="0">
                 <a:solidFill>
                   <a:srgbClr val="858B7E"/>
@@ -6585,7 +6495,7 @@
     </p:spTree>
     <p:extLst>
       <p:ext uri="{BB962C8B-B14F-4D97-AF65-F5344CB8AC3E}">
-        <p14:creationId xmlns:p14="http://schemas.microsoft.com/office/powerpoint/2010/main" val="2044230986"/>
+        <p14:creationId xmlns:p14="http://schemas.microsoft.com/office/powerpoint/2010/main" val="1731940605"/>
       </p:ext>
     </p:extLst>
   </p:cSld>
@@ -6616,7 +6526,7 @@
           <p:cNvPr id="11" name="">
             <a:extLst xmlns:a="http://schemas.openxmlformats.org/drawingml/2006/main">
               <a:ext uri="{FF2B5EF4-FFF2-40B4-BE49-F238E27FC236}">
-                <a16:creationId xmlns:a16="http://schemas.microsoft.com/office/drawing/2014/main" id="{3FF51C7C-6406-4559-B95F-016B541D15BC}"/>
+                <a16:creationId xmlns:a16="http://schemas.microsoft.com/office/drawing/2014/main" id="{A1123E88-B70D-4A4B-86F5-B7AC43968DD4}"/>
               </a:ext>
             </a:extLst>
           </p:cNvPr>
@@ -6643,7 +6553,7 @@
             <a:noAutofit/>
           </a:bodyPr>
           <a:lstStyle xmlns:a="http://schemas.openxmlformats.org/drawingml/2006/main">
-            <a:defPPr>
+            <a:defPPr algn="l">
               <a:defRPr sz="1050" b="1">
                 <a:solidFill>
                   <a:srgbClr val="9B7744"/>
@@ -6655,7 +6565,7 @@
             </a:defPPr>
           </a:lstStyle>
           <a:p xmlns:a="http://schemas.openxmlformats.org/drawingml/2006/main">
-            <a:pPr>
+            <a:pPr algn="l">
               <a:defRPr sz="1050" b="1">
                 <a:solidFill>
                   <a:srgbClr val="9B7744"/>
@@ -6684,7 +6594,7 @@
           <p:cNvPr id="2" name="">
             <a:extLst xmlns:a="http://schemas.openxmlformats.org/drawingml/2006/main">
               <a:ext uri="{FF2B5EF4-FFF2-40B4-BE49-F238E27FC236}">
-                <a16:creationId xmlns:a16="http://schemas.microsoft.com/office/drawing/2014/main" id="{ABBAD620-ECCC-4B6C-A7D0-456170308BE5}"/>
+                <a16:creationId xmlns:a16="http://schemas.microsoft.com/office/drawing/2014/main" id="{F1DAB37F-E3BA-4966-AA0E-92EDF6FCED7F}"/>
               </a:ext>
             </a:extLst>
           </p:cNvPr>
@@ -6711,7 +6621,7 @@
             <a:noAutofit/>
           </a:bodyPr>
           <a:lstStyle xmlns:a="http://schemas.openxmlformats.org/drawingml/2006/main">
-            <a:defPPr>
+            <a:defPPr algn="l">
               <a:defRPr sz="3450" b="1">
                 <a:solidFill>
                   <a:srgbClr val="1B1D19"/>
@@ -6723,7 +6633,7 @@
             </a:defPPr>
           </a:lstStyle>
           <a:p xmlns:a="http://schemas.openxmlformats.org/drawingml/2006/main">
-            <a:pPr>
+            <a:pPr algn="l">
               <a:defRPr sz="3450" b="1">
                 <a:solidFill>
                   <a:srgbClr val="1B1D19"/>
@@ -6752,7 +6662,7 @@
           <p:cNvPr id="3" name="">
             <a:extLst xmlns:a="http://schemas.openxmlformats.org/drawingml/2006/main">
               <a:ext uri="{FF2B5EF4-FFF2-40B4-BE49-F238E27FC236}">
-                <a16:creationId xmlns:a16="http://schemas.microsoft.com/office/drawing/2014/main" id="{E1843804-A0DC-432F-BCA4-C16480447B6A}"/>
+                <a16:creationId xmlns:a16="http://schemas.microsoft.com/office/drawing/2014/main" id="{D8ABB487-3AC7-41AA-99BE-D6D296552729}"/>
               </a:ext>
             </a:extLst>
           </p:cNvPr>
@@ -6782,7 +6692,7 @@
           <p:cNvPr id="4" name="">
             <a:extLst xmlns:a="http://schemas.openxmlformats.org/drawingml/2006/main">
               <a:ext uri="{FF2B5EF4-FFF2-40B4-BE49-F238E27FC236}">
-                <a16:creationId xmlns:a16="http://schemas.microsoft.com/office/drawing/2014/main" id="{FA5D9517-56AE-4F43-99F2-9FD5A0B09B33}"/>
+                <a16:creationId xmlns:a16="http://schemas.microsoft.com/office/drawing/2014/main" id="{9D4844CD-6DDF-43B7-A819-E204A13C9D04}"/>
               </a:ext>
             </a:extLst>
           </p:cNvPr>
@@ -6809,7 +6719,7 @@
             <a:noAutofit/>
           </a:bodyPr>
           <a:lstStyle xmlns:a="http://schemas.openxmlformats.org/drawingml/2006/main">
-            <a:defPPr>
+            <a:defPPr algn="l">
               <a:defRPr sz="2325" b="1">
                 <a:solidFill>
                   <a:srgbClr val="1B1D19"/>
@@ -6821,7 +6731,7 @@
             </a:defPPr>
           </a:lstStyle>
           <a:p xmlns:a="http://schemas.openxmlformats.org/drawingml/2006/main">
-            <a:pPr>
+            <a:pPr algn="l">
               <a:defRPr sz="2325" b="1">
                 <a:solidFill>
                   <a:srgbClr val="1B1D19"/>
@@ -6850,7 +6760,7 @@
           <p:cNvPr id="5" name="">
             <a:extLst xmlns:a="http://schemas.openxmlformats.org/drawingml/2006/main">
               <a:ext uri="{FF2B5EF4-FFF2-40B4-BE49-F238E27FC236}">
-                <a16:creationId xmlns:a16="http://schemas.microsoft.com/office/drawing/2014/main" id="{63110DCB-7D14-4213-A564-A1B3880538DD}"/>
+                <a16:creationId xmlns:a16="http://schemas.microsoft.com/office/drawing/2014/main" id="{F0D0F480-55F0-4892-8818-B904556AA0B1}"/>
               </a:ext>
             </a:extLst>
           </p:cNvPr>
@@ -6880,7 +6790,7 @@
           <p:cNvPr id="6" name="">
             <a:extLst xmlns:a="http://schemas.openxmlformats.org/drawingml/2006/main">
               <a:ext uri="{FF2B5EF4-FFF2-40B4-BE49-F238E27FC236}">
-                <a16:creationId xmlns:a16="http://schemas.microsoft.com/office/drawing/2014/main" id="{54CE1670-956B-4E96-9580-93F866411493}"/>
+                <a16:creationId xmlns:a16="http://schemas.microsoft.com/office/drawing/2014/main" id="{456334D7-46A8-4A0F-9697-87A4AC685A05}"/>
               </a:ext>
             </a:extLst>
           </p:cNvPr>
@@ -6910,7 +6820,7 @@
           <p:cNvPr id="7" name="">
             <a:extLst xmlns:a="http://schemas.openxmlformats.org/drawingml/2006/main">
               <a:ext uri="{FF2B5EF4-FFF2-40B4-BE49-F238E27FC236}">
-                <a16:creationId xmlns:a16="http://schemas.microsoft.com/office/drawing/2014/main" id="{001C981B-FF0D-4333-B79A-0AE0C0DAE421}"/>
+                <a16:creationId xmlns:a16="http://schemas.microsoft.com/office/drawing/2014/main" id="{AE75F113-CE2D-48FC-9652-78865A925DF8}"/>
               </a:ext>
             </a:extLst>
           </p:cNvPr>
@@ -6937,7 +6847,7 @@
             <a:noAutofit/>
           </a:bodyPr>
           <a:lstStyle xmlns:a="http://schemas.openxmlformats.org/drawingml/2006/main">
-            <a:defPPr>
+            <a:defPPr algn="l">
               <a:defRPr sz="2325" b="1">
                 <a:solidFill>
                   <a:srgbClr val="1B1D19"/>
@@ -6949,7 +6859,7 @@
             </a:defPPr>
           </a:lstStyle>
           <a:p xmlns:a="http://schemas.openxmlformats.org/drawingml/2006/main">
-            <a:pPr>
+            <a:pPr algn="l">
               <a:defRPr sz="2325" b="1">
                 <a:solidFill>
                   <a:srgbClr val="1B1D19"/>
@@ -6978,7 +6888,7 @@
           <p:cNvPr id="8" name="">
             <a:extLst xmlns:a="http://schemas.openxmlformats.org/drawingml/2006/main">
               <a:ext uri="{FF2B5EF4-FFF2-40B4-BE49-F238E27FC236}">
-                <a16:creationId xmlns:a16="http://schemas.microsoft.com/office/drawing/2014/main" id="{AD648BDA-3AE7-4061-B8B1-96EB13575E94}"/>
+                <a16:creationId xmlns:a16="http://schemas.microsoft.com/office/drawing/2014/main" id="{8F72D158-5B30-4584-B6CA-DDB96FC89495}"/>
               </a:ext>
             </a:extLst>
           </p:cNvPr>
@@ -7008,7 +6918,7 @@
           <p:cNvPr id="9" name="">
             <a:extLst xmlns:a="http://schemas.openxmlformats.org/drawingml/2006/main">
               <a:ext uri="{FF2B5EF4-FFF2-40B4-BE49-F238E27FC236}">
-                <a16:creationId xmlns:a16="http://schemas.microsoft.com/office/drawing/2014/main" id="{51B1AEAD-A70F-4EDB-A71C-719905B60DE5}"/>
+                <a16:creationId xmlns:a16="http://schemas.microsoft.com/office/drawing/2014/main" id="{64995B6F-4E0F-4524-84D9-D20BA40CABB8}"/>
               </a:ext>
             </a:extLst>
           </p:cNvPr>
@@ -7035,7 +6945,7 @@
             <a:noAutofit/>
           </a:bodyPr>
           <a:lstStyle xmlns:a="http://schemas.openxmlformats.org/drawingml/2006/main">
-            <a:defPPr>
+            <a:defPPr algn="l">
               <a:defRPr sz="975" b="0">
                 <a:solidFill>
                   <a:srgbClr val="858B7E"/>
@@ -7047,7 +6957,7 @@
             </a:defPPr>
           </a:lstStyle>
           <a:p xmlns:a="http://schemas.openxmlformats.org/drawingml/2006/main">
-            <a:pPr>
+            <a:pPr algn="l">
               <a:defRPr sz="975" b="0">
                 <a:solidFill>
                   <a:srgbClr val="858B7E"/>
@@ -7076,7 +6986,7 @@
           <p:cNvPr id="10" name="">
             <a:extLst xmlns:a="http://schemas.openxmlformats.org/drawingml/2006/main">
               <a:ext uri="{FF2B5EF4-FFF2-40B4-BE49-F238E27FC236}">
-                <a16:creationId xmlns:a16="http://schemas.microsoft.com/office/drawing/2014/main" id="{2CE470A4-0C84-431B-BA1B-61801899B70F}"/>
+                <a16:creationId xmlns:a16="http://schemas.microsoft.com/office/drawing/2014/main" id="{1EF514B7-4835-4769-9464-F3D4C5368C0E}"/>
               </a:ext>
             </a:extLst>
           </p:cNvPr>
@@ -7103,7 +7013,7 @@
             <a:noAutofit/>
           </a:bodyPr>
           <a:lstStyle xmlns:a="http://schemas.openxmlformats.org/drawingml/2006/main">
-            <a:defPPr>
+            <a:defPPr algn="l">
               <a:defRPr sz="975" b="0">
                 <a:solidFill>
                   <a:srgbClr val="858B7E"/>
@@ -7115,7 +7025,7 @@
             </a:defPPr>
           </a:lstStyle>
           <a:p xmlns:a="http://schemas.openxmlformats.org/drawingml/2006/main">
-            <a:pPr>
+            <a:pPr algn="l">
               <a:defRPr sz="975" b="0">
                 <a:solidFill>
                   <a:srgbClr val="858B7E"/>
@@ -7142,7 +7052,7 @@
     </p:spTree>
     <p:extLst>
       <p:ext uri="{BB962C8B-B14F-4D97-AF65-F5344CB8AC3E}">
-        <p14:creationId xmlns:p14="http://schemas.microsoft.com/office/powerpoint/2010/main" val="113398340"/>
+        <p14:creationId xmlns:p14="http://schemas.microsoft.com/office/powerpoint/2010/main" val="2136088364"/>
       </p:ext>
     </p:extLst>
   </p:cSld>
@@ -7173,7 +7083,7 @@
           <p:cNvPr id="6" name="">
             <a:extLst xmlns:a="http://schemas.openxmlformats.org/drawingml/2006/main">
               <a:ext uri="{FF2B5EF4-FFF2-40B4-BE49-F238E27FC236}">
-                <a16:creationId xmlns:a16="http://schemas.microsoft.com/office/drawing/2014/main" id="{1B440F8E-C75A-41C4-A47C-A54B61A4E405}"/>
+                <a16:creationId xmlns:a16="http://schemas.microsoft.com/office/drawing/2014/main" id="{86D8B6E4-D899-463D-9BEC-1929FCFA89B8}"/>
               </a:ext>
             </a:extLst>
           </p:cNvPr>
@@ -7200,7 +7110,7 @@
             <a:noAutofit/>
           </a:bodyPr>
           <a:lstStyle xmlns:a="http://schemas.openxmlformats.org/drawingml/2006/main">
-            <a:defPPr>
+            <a:defPPr algn="l">
               <a:defRPr sz="1050" b="1">
                 <a:solidFill>
                   <a:srgbClr val="9B7744"/>
@@ -7212,7 +7122,7 @@
             </a:defPPr>
           </a:lstStyle>
           <a:p xmlns:a="http://schemas.openxmlformats.org/drawingml/2006/main">
-            <a:pPr>
+            <a:pPr algn="l">
               <a:defRPr sz="1050" b="1">
                 <a:solidFill>
                   <a:srgbClr val="9B7744"/>
@@ -7241,7 +7151,7 @@
           <p:cNvPr id="2" name="">
             <a:extLst xmlns:a="http://schemas.openxmlformats.org/drawingml/2006/main">
               <a:ext uri="{FF2B5EF4-FFF2-40B4-BE49-F238E27FC236}">
-                <a16:creationId xmlns:a16="http://schemas.microsoft.com/office/drawing/2014/main" id="{2E6249D1-F19E-439F-B358-B9642C1D3209}"/>
+                <a16:creationId xmlns:a16="http://schemas.microsoft.com/office/drawing/2014/main" id="{EDF8CBBD-9CFE-4220-8F6B-1C192CB43CEC}"/>
               </a:ext>
             </a:extLst>
           </p:cNvPr>
@@ -7268,7 +7178,7 @@
             <a:noAutofit/>
           </a:bodyPr>
           <a:lstStyle xmlns:a="http://schemas.openxmlformats.org/drawingml/2006/main">
-            <a:defPPr>
+            <a:defPPr algn="l">
               <a:defRPr sz="3450" b="1">
                 <a:solidFill>
                   <a:srgbClr val="1B1D19"/>
@@ -7280,7 +7190,7 @@
             </a:defPPr>
           </a:lstStyle>
           <a:p xmlns:a="http://schemas.openxmlformats.org/drawingml/2006/main">
-            <a:pPr>
+            <a:pPr algn="l">
               <a:defRPr sz="3450" b="1">
                 <a:solidFill>
                   <a:srgbClr val="1B1D19"/>
@@ -7309,7 +7219,7 @@
           <p:cNvPr id="3" name="">
             <a:extLst xmlns:a="http://schemas.openxmlformats.org/drawingml/2006/main">
               <a:ext uri="{FF2B5EF4-FFF2-40B4-BE49-F238E27FC236}">
-                <a16:creationId xmlns:a16="http://schemas.microsoft.com/office/drawing/2014/main" id="{49DDCC07-55B4-4FF3-ADCD-1FE699A74A67}"/>
+                <a16:creationId xmlns:a16="http://schemas.microsoft.com/office/drawing/2014/main" id="{4A396832-6E4C-45D7-85DA-E4315156AFB2}"/>
               </a:ext>
             </a:extLst>
           </p:cNvPr>
@@ -7336,7 +7246,7 @@
             <a:noAutofit/>
           </a:bodyPr>
           <a:lstStyle xmlns:a="http://schemas.openxmlformats.org/drawingml/2006/main">
-            <a:defPPr>
+            <a:defPPr algn="l">
               <a:defRPr sz="3225" b="0">
                 <a:solidFill>
                   <a:srgbClr val="6B7265"/>
@@ -7348,7 +7258,7 @@
             </a:defPPr>
           </a:lstStyle>
           <a:p xmlns:a="http://schemas.openxmlformats.org/drawingml/2006/main">
-            <a:pPr>
+            <a:pPr algn="l">
               <a:defRPr sz="3225" b="0">
                 <a:solidFill>
                   <a:srgbClr val="6B7265"/>
@@ -7377,7 +7287,7 @@
           <p:cNvPr id="4" name="">
             <a:extLst xmlns:a="http://schemas.openxmlformats.org/drawingml/2006/main">
               <a:ext uri="{FF2B5EF4-FFF2-40B4-BE49-F238E27FC236}">
-                <a16:creationId xmlns:a16="http://schemas.microsoft.com/office/drawing/2014/main" id="{8F4DDEDD-616D-4046-9D44-02B58CB10F01}"/>
+                <a16:creationId xmlns:a16="http://schemas.microsoft.com/office/drawing/2014/main" id="{050D5ACB-4128-4C59-A1F6-EBBCB66F7AD9}"/>
               </a:ext>
             </a:extLst>
           </p:cNvPr>
@@ -7404,7 +7314,7 @@
             <a:noAutofit/>
           </a:bodyPr>
           <a:lstStyle xmlns:a="http://schemas.openxmlformats.org/drawingml/2006/main">
-            <a:defPPr>
+            <a:defPPr algn="l">
               <a:defRPr sz="975" b="0">
                 <a:solidFill>
                   <a:srgbClr val="858B7E"/>
@@ -7416,7 +7326,7 @@
             </a:defPPr>
           </a:lstStyle>
           <a:p xmlns:a="http://schemas.openxmlformats.org/drawingml/2006/main">
-            <a:pPr>
+            <a:pPr algn="l">
               <a:defRPr sz="975" b="0">
                 <a:solidFill>
                   <a:srgbClr val="858B7E"/>
@@ -7445,7 +7355,7 @@
           <p:cNvPr id="5" name="">
             <a:extLst xmlns:a="http://schemas.openxmlformats.org/drawingml/2006/main">
               <a:ext uri="{FF2B5EF4-FFF2-40B4-BE49-F238E27FC236}">
-                <a16:creationId xmlns:a16="http://schemas.microsoft.com/office/drawing/2014/main" id="{FF0733FA-C7AC-49AD-9C49-F0BEAEEEBA4C}"/>
+                <a16:creationId xmlns:a16="http://schemas.microsoft.com/office/drawing/2014/main" id="{EC9C5626-B4DA-452D-A2CC-C536A0B6EEBE}"/>
               </a:ext>
             </a:extLst>
           </p:cNvPr>
@@ -7472,7 +7382,7 @@
             <a:noAutofit/>
           </a:bodyPr>
           <a:lstStyle xmlns:a="http://schemas.openxmlformats.org/drawingml/2006/main">
-            <a:defPPr>
+            <a:defPPr algn="l">
               <a:defRPr sz="975" b="0">
                 <a:solidFill>
                   <a:srgbClr val="858B7E"/>
@@ -7484,7 +7394,7 @@
             </a:defPPr>
           </a:lstStyle>
           <a:p xmlns:a="http://schemas.openxmlformats.org/drawingml/2006/main">
-            <a:pPr>
+            <a:pPr algn="l">
               <a:defRPr sz="975" b="0">
                 <a:solidFill>
                   <a:srgbClr val="858B7E"/>
@@ -7511,7 +7421,7 @@
     </p:spTree>
     <p:extLst>
       <p:ext uri="{BB962C8B-B14F-4D97-AF65-F5344CB8AC3E}">
-        <p14:creationId xmlns:p14="http://schemas.microsoft.com/office/powerpoint/2010/main" val="1409525333"/>
+        <p14:creationId xmlns:p14="http://schemas.microsoft.com/office/powerpoint/2010/main" val="728180069"/>
       </p:ext>
     </p:extLst>
   </p:cSld>
@@ -7542,7 +7452,7 @@
           <p:cNvPr id="7" name="">
             <a:extLst xmlns:a="http://schemas.openxmlformats.org/drawingml/2006/main">
               <a:ext uri="{FF2B5EF4-FFF2-40B4-BE49-F238E27FC236}">
-                <a16:creationId xmlns:a16="http://schemas.microsoft.com/office/drawing/2014/main" id="{2A21CD0C-3CCC-4814-B1D2-483FBAE9E1E4}"/>
+                <a16:creationId xmlns:a16="http://schemas.microsoft.com/office/drawing/2014/main" id="{4BE6C08D-6C82-403E-ACC9-6BC583AE4C76}"/>
               </a:ext>
             </a:extLst>
           </p:cNvPr>
@@ -7569,7 +7479,7 @@
             <a:noAutofit/>
           </a:bodyPr>
           <a:lstStyle xmlns:a="http://schemas.openxmlformats.org/drawingml/2006/main">
-            <a:defPPr>
+            <a:defPPr algn="l">
               <a:defRPr sz="1050" b="1">
                 <a:solidFill>
                   <a:srgbClr val="9B7744"/>
@@ -7581,7 +7491,7 @@
             </a:defPPr>
           </a:lstStyle>
           <a:p xmlns:a="http://schemas.openxmlformats.org/drawingml/2006/main">
-            <a:pPr>
+            <a:pPr algn="l">
               <a:defRPr sz="1050" b="1">
                 <a:solidFill>
                   <a:srgbClr val="9B7744"/>
@@ -7610,7 +7520,7 @@
           <p:cNvPr id="2" name="">
             <a:extLst xmlns:a="http://schemas.openxmlformats.org/drawingml/2006/main">
               <a:ext uri="{FF2B5EF4-FFF2-40B4-BE49-F238E27FC236}">
-                <a16:creationId xmlns:a16="http://schemas.microsoft.com/office/drawing/2014/main" id="{24707496-FD04-40A8-BB45-F195CB0A5AB2}"/>
+                <a16:creationId xmlns:a16="http://schemas.microsoft.com/office/drawing/2014/main" id="{2B099948-80AF-4755-BC9D-66D15834077E}"/>
               </a:ext>
             </a:extLst>
           </p:cNvPr>
@@ -7637,7 +7547,7 @@
             <a:noAutofit/>
           </a:bodyPr>
           <a:lstStyle xmlns:a="http://schemas.openxmlformats.org/drawingml/2006/main">
-            <a:defPPr>
+            <a:defPPr algn="l">
               <a:defRPr sz="3450" b="1">
                 <a:solidFill>
                   <a:srgbClr val="1B1D19"/>
@@ -7649,7 +7559,7 @@
             </a:defPPr>
           </a:lstStyle>
           <a:p xmlns:a="http://schemas.openxmlformats.org/drawingml/2006/main">
-            <a:pPr>
+            <a:pPr algn="l">
               <a:defRPr sz="3450" b="1">
                 <a:solidFill>
                   <a:srgbClr val="1B1D19"/>
@@ -7678,7 +7588,7 @@
           <p:cNvPr id="3" name="">
             <a:extLst xmlns:a="http://schemas.openxmlformats.org/drawingml/2006/main">
               <a:ext uri="{FF2B5EF4-FFF2-40B4-BE49-F238E27FC236}">
-                <a16:creationId xmlns:a16="http://schemas.microsoft.com/office/drawing/2014/main" id="{2F7920E3-5D01-42BD-A53F-4C91B38700EF}"/>
+                <a16:creationId xmlns:a16="http://schemas.microsoft.com/office/drawing/2014/main" id="{6CEFE01A-78CA-410F-8C5F-0481E1475EEC}"/>
               </a:ext>
             </a:extLst>
           </p:cNvPr>
@@ -7705,7 +7615,7 @@
             <a:noAutofit/>
           </a:bodyPr>
           <a:lstStyle xmlns:a="http://schemas.openxmlformats.org/drawingml/2006/main">
-            <a:defPPr>
+            <a:defPPr algn="l">
               <a:defRPr sz="2550" b="0">
                 <a:solidFill>
                   <a:srgbClr val="6B7265"/>
@@ -7717,7 +7627,7 @@
             </a:defPPr>
           </a:lstStyle>
           <a:p xmlns:a="http://schemas.openxmlformats.org/drawingml/2006/main">
-            <a:pPr>
+            <a:pPr algn="l">
               <a:defRPr sz="2550" b="0">
                 <a:solidFill>
                   <a:srgbClr val="6B7265"/>
@@ -7746,7 +7656,7 @@
           <p:cNvPr id="4" name="">
             <a:extLst xmlns:a="http://schemas.openxmlformats.org/drawingml/2006/main">
               <a:ext uri="{FF2B5EF4-FFF2-40B4-BE49-F238E27FC236}">
-                <a16:creationId xmlns:a16="http://schemas.microsoft.com/office/drawing/2014/main" id="{FFA248D5-4D0E-44ED-9AB3-3120CBBB30C1}"/>
+                <a16:creationId xmlns:a16="http://schemas.microsoft.com/office/drawing/2014/main" id="{2259E8F4-6E42-43BC-8118-97B6128680FD}"/>
               </a:ext>
             </a:extLst>
           </p:cNvPr>
@@ -7756,7 +7666,7 @@
           <p:nvPr/>
         </p:nvPicPr>
         <p:blipFill>
-          <a:blip xmlns:r="http://schemas.openxmlformats.org/officeDocument/2006/relationships" xmlns:a="http://schemas.openxmlformats.org/drawingml/2006/main" r:embed="R8653044f626d465b"/>
+          <a:blip xmlns:r="http://schemas.openxmlformats.org/officeDocument/2006/relationships" xmlns:a="http://schemas.openxmlformats.org/drawingml/2006/main" r:embed="R52df518727ce49a0"/>
           <a:stretch xmlns:a="http://schemas.openxmlformats.org/drawingml/2006/main"/>
         </p:blipFill>
         <p:spPr>
@@ -7774,7 +7684,7 @@
           <p:cNvPr id="5" name="">
             <a:extLst xmlns:a="http://schemas.openxmlformats.org/drawingml/2006/main">
               <a:ext uri="{FF2B5EF4-FFF2-40B4-BE49-F238E27FC236}">
-                <a16:creationId xmlns:a16="http://schemas.microsoft.com/office/drawing/2014/main" id="{26648A6C-5704-4F70-A9F7-06A133198D6A}"/>
+                <a16:creationId xmlns:a16="http://schemas.microsoft.com/office/drawing/2014/main" id="{087CD8BF-47F1-438E-9CF4-618BDE953733}"/>
               </a:ext>
             </a:extLst>
           </p:cNvPr>
@@ -7801,7 +7711,7 @@
             <a:noAutofit/>
           </a:bodyPr>
           <a:lstStyle xmlns:a="http://schemas.openxmlformats.org/drawingml/2006/main">
-            <a:defPPr>
+            <a:defPPr algn="l">
               <a:defRPr sz="975" b="0">
                 <a:solidFill>
                   <a:srgbClr val="858B7E"/>
@@ -7813,7 +7723,7 @@
             </a:defPPr>
           </a:lstStyle>
           <a:p xmlns:a="http://schemas.openxmlformats.org/drawingml/2006/main">
-            <a:pPr>
+            <a:pPr algn="l">
               <a:defRPr sz="975" b="0">
                 <a:solidFill>
                   <a:srgbClr val="858B7E"/>
@@ -7842,7 +7752,7 @@
           <p:cNvPr id="6" name="">
             <a:extLst xmlns:a="http://schemas.openxmlformats.org/drawingml/2006/main">
               <a:ext uri="{FF2B5EF4-FFF2-40B4-BE49-F238E27FC236}">
-                <a16:creationId xmlns:a16="http://schemas.microsoft.com/office/drawing/2014/main" id="{632CB211-003D-46BC-922F-AA1723E2056D}"/>
+                <a16:creationId xmlns:a16="http://schemas.microsoft.com/office/drawing/2014/main" id="{C843C27F-B039-4F74-9515-AAC8F080CF78}"/>
               </a:ext>
             </a:extLst>
           </p:cNvPr>
@@ -7869,7 +7779,7 @@
             <a:noAutofit/>
           </a:bodyPr>
           <a:lstStyle xmlns:a="http://schemas.openxmlformats.org/drawingml/2006/main">
-            <a:defPPr>
+            <a:defPPr algn="l">
               <a:defRPr sz="975" b="0">
                 <a:solidFill>
                   <a:srgbClr val="858B7E"/>
@@ -7881,7 +7791,7 @@
             </a:defPPr>
           </a:lstStyle>
           <a:p xmlns:a="http://schemas.openxmlformats.org/drawingml/2006/main">
-            <a:pPr>
+            <a:pPr algn="l">
               <a:defRPr sz="975" b="0">
                 <a:solidFill>
                   <a:srgbClr val="858B7E"/>
@@ -7908,7 +7818,7 @@
     </p:spTree>
     <p:extLst>
       <p:ext uri="{BB962C8B-B14F-4D97-AF65-F5344CB8AC3E}">
-        <p14:creationId xmlns:p14="http://schemas.microsoft.com/office/powerpoint/2010/main" val="329523382"/>
+        <p14:creationId xmlns:p14="http://schemas.microsoft.com/office/powerpoint/2010/main" val="504326415"/>
       </p:ext>
     </p:extLst>
   </p:cSld>
@@ -7939,7 +7849,7 @@
           <p:cNvPr id="14" name="">
             <a:extLst xmlns:a="http://schemas.openxmlformats.org/drawingml/2006/main">
               <a:ext uri="{FF2B5EF4-FFF2-40B4-BE49-F238E27FC236}">
-                <a16:creationId xmlns:a16="http://schemas.microsoft.com/office/drawing/2014/main" id="{7B5BE419-D4C8-4892-8EAC-69CF0B0E6E4F}"/>
+                <a16:creationId xmlns:a16="http://schemas.microsoft.com/office/drawing/2014/main" id="{38E66460-D960-4FD6-AF1A-05FD27E62860}"/>
               </a:ext>
             </a:extLst>
           </p:cNvPr>
@@ -7966,7 +7876,7 @@
             <a:noAutofit/>
           </a:bodyPr>
           <a:lstStyle xmlns:a="http://schemas.openxmlformats.org/drawingml/2006/main">
-            <a:defPPr>
+            <a:defPPr algn="l">
               <a:defRPr sz="1050" b="1">
                 <a:solidFill>
                   <a:srgbClr val="9B7744"/>
@@ -7978,7 +7888,7 @@
             </a:defPPr>
           </a:lstStyle>
           <a:p xmlns:a="http://schemas.openxmlformats.org/drawingml/2006/main">
-            <a:pPr>
+            <a:pPr algn="l">
               <a:defRPr sz="1050" b="1">
                 <a:solidFill>
                   <a:srgbClr val="9B7744"/>
@@ -8007,7 +7917,7 @@
           <p:cNvPr id="2" name="">
             <a:extLst xmlns:a="http://schemas.openxmlformats.org/drawingml/2006/main">
               <a:ext uri="{FF2B5EF4-FFF2-40B4-BE49-F238E27FC236}">
-                <a16:creationId xmlns:a16="http://schemas.microsoft.com/office/drawing/2014/main" id="{5A19D2AA-F309-45C1-8584-EED4502AFFC3}"/>
+                <a16:creationId xmlns:a16="http://schemas.microsoft.com/office/drawing/2014/main" id="{053D07E6-0D77-49D4-8655-A5D66DC726AF}"/>
               </a:ext>
             </a:extLst>
           </p:cNvPr>
@@ -8034,7 +7944,7 @@
             <a:noAutofit/>
           </a:bodyPr>
           <a:lstStyle xmlns:a="http://schemas.openxmlformats.org/drawingml/2006/main">
-            <a:defPPr>
+            <a:defPPr algn="l">
               <a:defRPr sz="3450" b="1">
                 <a:solidFill>
                   <a:srgbClr val="1B1D19"/>
@@ -8046,7 +7956,7 @@
             </a:defPPr>
           </a:lstStyle>
           <a:p xmlns:a="http://schemas.openxmlformats.org/drawingml/2006/main">
-            <a:pPr>
+            <a:pPr algn="l">
               <a:defRPr sz="3450" b="1">
                 <a:solidFill>
                   <a:srgbClr val="1B1D19"/>
@@ -8075,7 +7985,7 @@
           <p:cNvPr id="3" name="">
             <a:extLst xmlns:a="http://schemas.openxmlformats.org/drawingml/2006/main">
               <a:ext uri="{FF2B5EF4-FFF2-40B4-BE49-F238E27FC236}">
-                <a16:creationId xmlns:a16="http://schemas.microsoft.com/office/drawing/2014/main" id="{F2BD37C9-D41A-4CB4-886E-9BDBA28DAED6}"/>
+                <a16:creationId xmlns:a16="http://schemas.microsoft.com/office/drawing/2014/main" id="{D5120603-2723-4CCF-B04D-A738B462EED0}"/>
               </a:ext>
             </a:extLst>
           </p:cNvPr>
@@ -8105,7 +8015,7 @@
           <p:cNvPr id="4" name="">
             <a:extLst xmlns:a="http://schemas.openxmlformats.org/drawingml/2006/main">
               <a:ext uri="{FF2B5EF4-FFF2-40B4-BE49-F238E27FC236}">
-                <a16:creationId xmlns:a16="http://schemas.microsoft.com/office/drawing/2014/main" id="{4448458E-C1A9-4748-A06C-4DE5850D9212}"/>
+                <a16:creationId xmlns:a16="http://schemas.microsoft.com/office/drawing/2014/main" id="{4AF922A0-9D52-4444-AE5B-62F1FF85F75E}"/>
               </a:ext>
             </a:extLst>
           </p:cNvPr>
@@ -8132,7 +8042,7 @@
             <a:noAutofit/>
           </a:bodyPr>
           <a:lstStyle xmlns:a="http://schemas.openxmlformats.org/drawingml/2006/main">
-            <a:defPPr>
+            <a:defPPr algn="l">
               <a:defRPr sz="2475" b="1">
                 <a:solidFill>
                   <a:srgbClr val="1B1D19"/>
@@ -8144,7 +8054,7 @@
             </a:defPPr>
           </a:lstStyle>
           <a:p xmlns:a="http://schemas.openxmlformats.org/drawingml/2006/main">
-            <a:pPr>
+            <a:pPr algn="l">
               <a:defRPr sz="2475" b="1">
                 <a:solidFill>
                   <a:srgbClr val="1B1D19"/>
@@ -8173,7 +8083,7 @@
           <p:cNvPr id="5" name="">
             <a:extLst xmlns:a="http://schemas.openxmlformats.org/drawingml/2006/main">
               <a:ext uri="{FF2B5EF4-FFF2-40B4-BE49-F238E27FC236}">
-                <a16:creationId xmlns:a16="http://schemas.microsoft.com/office/drawing/2014/main" id="{2F10588E-CA5D-4B7C-BECD-CB8EBDA9E02F}"/>
+                <a16:creationId xmlns:a16="http://schemas.microsoft.com/office/drawing/2014/main" id="{B9F66F0B-7F03-4279-97E6-FD6FD5BC5A29}"/>
               </a:ext>
             </a:extLst>
           </p:cNvPr>
@@ -8200,7 +8110,7 @@
             <a:noAutofit/>
           </a:bodyPr>
           <a:lstStyle xmlns:a="http://schemas.openxmlformats.org/drawingml/2006/main">
-            <a:defPPr>
+            <a:defPPr algn="l">
               <a:defRPr sz="1800" b="0">
                 <a:solidFill>
                   <a:srgbClr val="6B7265"/>
@@ -8212,7 +8122,7 @@
             </a:defPPr>
           </a:lstStyle>
           <a:p xmlns:a="http://schemas.openxmlformats.org/drawingml/2006/main">
-            <a:pPr>
+            <a:pPr algn="l">
               <a:defRPr sz="1800" b="0">
                 <a:solidFill>
                   <a:srgbClr val="6B7265"/>
@@ -8235,7 +8145,7 @@
             </a:r>
           </a:p>
           <a:p xmlns:a="http://schemas.openxmlformats.org/drawingml/2006/main">
-            <a:pPr>
+            <a:pPr algn="l">
               <a:defRPr sz="1800" b="0">
                 <a:solidFill>
                   <a:srgbClr val="6B7265"/>
@@ -8264,7 +8174,7 @@
           <p:cNvPr id="6" name="">
             <a:extLst xmlns:a="http://schemas.openxmlformats.org/drawingml/2006/main">
               <a:ext uri="{FF2B5EF4-FFF2-40B4-BE49-F238E27FC236}">
-                <a16:creationId xmlns:a16="http://schemas.microsoft.com/office/drawing/2014/main" id="{A0A2583C-6021-4D84-A077-6DAC2F194B4F}"/>
+                <a16:creationId xmlns:a16="http://schemas.microsoft.com/office/drawing/2014/main" id="{C131F9FB-CB2C-4346-87ED-A2E80064C4C4}"/>
               </a:ext>
             </a:extLst>
           </p:cNvPr>
@@ -8294,7 +8204,7 @@
           <p:cNvPr id="7" name="">
             <a:extLst xmlns:a="http://schemas.openxmlformats.org/drawingml/2006/main">
               <a:ext uri="{FF2B5EF4-FFF2-40B4-BE49-F238E27FC236}">
-                <a16:creationId xmlns:a16="http://schemas.microsoft.com/office/drawing/2014/main" id="{5EDE8503-3D98-4A06-8012-C1FA64AB56DF}"/>
+                <a16:creationId xmlns:a16="http://schemas.microsoft.com/office/drawing/2014/main" id="{518BED8B-31C9-4E32-9DEF-BD91F7171781}"/>
               </a:ext>
             </a:extLst>
           </p:cNvPr>
@@ -8321,7 +8231,7 @@
             <a:noAutofit/>
           </a:bodyPr>
           <a:lstStyle xmlns:a="http://schemas.openxmlformats.org/drawingml/2006/main">
-            <a:defPPr>
+            <a:defPPr algn="l">
               <a:defRPr sz="2475" b="1">
                 <a:solidFill>
                   <a:srgbClr val="1B1D19"/>
@@ -8333,7 +8243,7 @@
             </a:defPPr>
           </a:lstStyle>
           <a:p xmlns:a="http://schemas.openxmlformats.org/drawingml/2006/main">
-            <a:pPr>
+            <a:pPr algn="l">
               <a:defRPr sz="2475" b="1">
                 <a:solidFill>
                   <a:srgbClr val="1B1D19"/>
@@ -8362,7 +8272,7 @@
           <p:cNvPr id="8" name="">
             <a:extLst xmlns:a="http://schemas.openxmlformats.org/drawingml/2006/main">
               <a:ext uri="{FF2B5EF4-FFF2-40B4-BE49-F238E27FC236}">
-                <a16:creationId xmlns:a16="http://schemas.microsoft.com/office/drawing/2014/main" id="{785503D1-CB32-4F1A-AEA1-D641502C045C}"/>
+                <a16:creationId xmlns:a16="http://schemas.microsoft.com/office/drawing/2014/main" id="{592B5856-E657-46D5-9AF8-8700A9968C0E}"/>
               </a:ext>
             </a:extLst>
           </p:cNvPr>
@@ -8389,7 +8299,7 @@
             <a:noAutofit/>
           </a:bodyPr>
           <a:lstStyle xmlns:a="http://schemas.openxmlformats.org/drawingml/2006/main">
-            <a:defPPr>
+            <a:defPPr algn="l">
               <a:defRPr sz="1800" b="0">
                 <a:solidFill>
                   <a:srgbClr val="6B7265"/>
@@ -8401,7 +8311,7 @@
             </a:defPPr>
           </a:lstStyle>
           <a:p xmlns:a="http://schemas.openxmlformats.org/drawingml/2006/main">
-            <a:pPr>
+            <a:pPr algn="l">
               <a:defRPr sz="1800" b="0">
                 <a:solidFill>
                   <a:srgbClr val="6B7265"/>
@@ -8430,7 +8340,7 @@
           <p:cNvPr id="9" name="">
             <a:extLst xmlns:a="http://schemas.openxmlformats.org/drawingml/2006/main">
               <a:ext uri="{FF2B5EF4-FFF2-40B4-BE49-F238E27FC236}">
-                <a16:creationId xmlns:a16="http://schemas.microsoft.com/office/drawing/2014/main" id="{D4BA40E3-F0DE-4448-B9DE-5809182C49E7}"/>
+                <a16:creationId xmlns:a16="http://schemas.microsoft.com/office/drawing/2014/main" id="{D691A902-89BE-4757-900D-DFA32AC03D3F}"/>
               </a:ext>
             </a:extLst>
           </p:cNvPr>
@@ -8460,7 +8370,7 @@
           <p:cNvPr id="10" name="">
             <a:extLst xmlns:a="http://schemas.openxmlformats.org/drawingml/2006/main">
               <a:ext uri="{FF2B5EF4-FFF2-40B4-BE49-F238E27FC236}">
-                <a16:creationId xmlns:a16="http://schemas.microsoft.com/office/drawing/2014/main" id="{8108C06A-191A-4E36-9373-41FE0A14318A}"/>
+                <a16:creationId xmlns:a16="http://schemas.microsoft.com/office/drawing/2014/main" id="{D0B7B565-9841-4E4F-BCFD-57FB11A3C35B}"/>
               </a:ext>
             </a:extLst>
           </p:cNvPr>
@@ -8470,7 +8380,7 @@
           <p:nvPr/>
         </p:nvPicPr>
         <p:blipFill>
-          <a:blip xmlns:r="http://schemas.openxmlformats.org/officeDocument/2006/relationships" xmlns:a="http://schemas.openxmlformats.org/drawingml/2006/main" r:embed="R83ae52e145c84415"/>
+          <a:blip xmlns:r="http://schemas.openxmlformats.org/officeDocument/2006/relationships" xmlns:a="http://schemas.openxmlformats.org/drawingml/2006/main" r:embed="R385b817c7b724199"/>
           <a:stretch xmlns:a="http://schemas.openxmlformats.org/drawingml/2006/main"/>
         </p:blipFill>
         <p:spPr>
@@ -8488,7 +8398,7 @@
           <p:cNvPr id="11" name="">
             <a:extLst xmlns:a="http://schemas.openxmlformats.org/drawingml/2006/main">
               <a:ext uri="{FF2B5EF4-FFF2-40B4-BE49-F238E27FC236}">
-                <a16:creationId xmlns:a16="http://schemas.microsoft.com/office/drawing/2014/main" id="{3474C657-2D64-416C-8D2F-41F002551EDE}"/>
+                <a16:creationId xmlns:a16="http://schemas.microsoft.com/office/drawing/2014/main" id="{E0097F5D-3031-4628-A6FA-45208EDECCF4}"/>
               </a:ext>
             </a:extLst>
           </p:cNvPr>
@@ -8515,7 +8425,7 @@
             <a:noAutofit/>
           </a:bodyPr>
           <a:lstStyle xmlns:a="http://schemas.openxmlformats.org/drawingml/2006/main">
-            <a:defPPr>
+            <a:defPPr algn="l">
               <a:defRPr sz="1050" b="0">
                 <a:solidFill>
                   <a:srgbClr val="6B7265"/>
@@ -8527,7 +8437,7 @@
             </a:defPPr>
           </a:lstStyle>
           <a:p xmlns:a="http://schemas.openxmlformats.org/drawingml/2006/main">
-            <a:pPr>
+            <a:pPr algn="l">
               <a:defRPr sz="1050" b="0">
                 <a:solidFill>
                   <a:srgbClr val="6B7265"/>
@@ -8556,7 +8466,7 @@
           <p:cNvPr id="12" name="">
             <a:extLst xmlns:a="http://schemas.openxmlformats.org/drawingml/2006/main">
               <a:ext uri="{FF2B5EF4-FFF2-40B4-BE49-F238E27FC236}">
-                <a16:creationId xmlns:a16="http://schemas.microsoft.com/office/drawing/2014/main" id="{F928B746-5265-4566-A7F8-F5B97EC7070B}"/>
+                <a16:creationId xmlns:a16="http://schemas.microsoft.com/office/drawing/2014/main" id="{99B51878-C20E-4EFA-A0A7-FDAA7EA65E10}"/>
               </a:ext>
             </a:extLst>
           </p:cNvPr>
@@ -8583,7 +8493,7 @@
             <a:noAutofit/>
           </a:bodyPr>
           <a:lstStyle xmlns:a="http://schemas.openxmlformats.org/drawingml/2006/main">
-            <a:defPPr>
+            <a:defPPr algn="l">
               <a:defRPr sz="975" b="0">
                 <a:solidFill>
                   <a:srgbClr val="858B7E"/>
@@ -8595,7 +8505,7 @@
             </a:defPPr>
           </a:lstStyle>
           <a:p xmlns:a="http://schemas.openxmlformats.org/drawingml/2006/main">
-            <a:pPr>
+            <a:pPr algn="l">
               <a:defRPr sz="975" b="0">
                 <a:solidFill>
                   <a:srgbClr val="858B7E"/>
@@ -8624,7 +8534,7 @@
           <p:cNvPr id="13" name="">
             <a:extLst xmlns:a="http://schemas.openxmlformats.org/drawingml/2006/main">
               <a:ext uri="{FF2B5EF4-FFF2-40B4-BE49-F238E27FC236}">
-                <a16:creationId xmlns:a16="http://schemas.microsoft.com/office/drawing/2014/main" id="{99294542-5840-44B2-A5CC-9A2A65DC892C}"/>
+                <a16:creationId xmlns:a16="http://schemas.microsoft.com/office/drawing/2014/main" id="{98461DB2-7223-4414-8994-D8CFC6F0DD27}"/>
               </a:ext>
             </a:extLst>
           </p:cNvPr>
@@ -8651,7 +8561,7 @@
             <a:noAutofit/>
           </a:bodyPr>
           <a:lstStyle xmlns:a="http://schemas.openxmlformats.org/drawingml/2006/main">
-            <a:defPPr>
+            <a:defPPr algn="l">
               <a:defRPr sz="975" b="0">
                 <a:solidFill>
                   <a:srgbClr val="858B7E"/>
@@ -8663,7 +8573,7 @@
             </a:defPPr>
           </a:lstStyle>
           <a:p xmlns:a="http://schemas.openxmlformats.org/drawingml/2006/main">
-            <a:pPr>
+            <a:pPr algn="l">
               <a:defRPr sz="975" b="0">
                 <a:solidFill>
                   <a:srgbClr val="858B7E"/>
@@ -8690,7 +8600,7 @@
     </p:spTree>
     <p:extLst>
       <p:ext uri="{BB962C8B-B14F-4D97-AF65-F5344CB8AC3E}">
-        <p14:creationId xmlns:p14="http://schemas.microsoft.com/office/powerpoint/2010/main" val="1348005585"/>
+        <p14:creationId xmlns:p14="http://schemas.microsoft.com/office/powerpoint/2010/main" val="1037200205"/>
       </p:ext>
     </p:extLst>
   </p:cSld>
@@ -8721,7 +8631,7 @@
           <p:cNvPr id="11" name="">
             <a:extLst xmlns:a="http://schemas.openxmlformats.org/drawingml/2006/main">
               <a:ext uri="{FF2B5EF4-FFF2-40B4-BE49-F238E27FC236}">
-                <a16:creationId xmlns:a16="http://schemas.microsoft.com/office/drawing/2014/main" id="{45F5C1FA-C9BD-4BEC-BEA6-46D2B26D6FA6}"/>
+                <a16:creationId xmlns:a16="http://schemas.microsoft.com/office/drawing/2014/main" id="{97088DFC-491C-4C1B-B12F-9897868B5D5F}"/>
               </a:ext>
             </a:extLst>
           </p:cNvPr>
@@ -8748,7 +8658,7 @@
             <a:noAutofit/>
           </a:bodyPr>
           <a:lstStyle xmlns:a="http://schemas.openxmlformats.org/drawingml/2006/main">
-            <a:defPPr>
+            <a:defPPr algn="l">
               <a:defRPr sz="1050" b="1">
                 <a:solidFill>
                   <a:srgbClr val="9B7744"/>
@@ -8760,7 +8670,7 @@
             </a:defPPr>
           </a:lstStyle>
           <a:p xmlns:a="http://schemas.openxmlformats.org/drawingml/2006/main">
-            <a:pPr>
+            <a:pPr algn="l">
               <a:defRPr sz="1050" b="1">
                 <a:solidFill>
                   <a:srgbClr val="9B7744"/>
@@ -8789,7 +8699,7 @@
           <p:cNvPr id="2" name="">
             <a:extLst xmlns:a="http://schemas.openxmlformats.org/drawingml/2006/main">
               <a:ext uri="{FF2B5EF4-FFF2-40B4-BE49-F238E27FC236}">
-                <a16:creationId xmlns:a16="http://schemas.microsoft.com/office/drawing/2014/main" id="{04E0CFBE-2B10-4520-B9C1-63DCA71D1F20}"/>
+                <a16:creationId xmlns:a16="http://schemas.microsoft.com/office/drawing/2014/main" id="{8B1E144D-E2E1-4FA7-9C94-DF7F3DB9192A}"/>
               </a:ext>
             </a:extLst>
           </p:cNvPr>
@@ -8816,7 +8726,7 @@
             <a:noAutofit/>
           </a:bodyPr>
           <a:lstStyle xmlns:a="http://schemas.openxmlformats.org/drawingml/2006/main">
-            <a:defPPr>
+            <a:defPPr algn="l">
               <a:defRPr sz="3450" b="1">
                 <a:solidFill>
                   <a:srgbClr val="1B1D19"/>
@@ -8828,7 +8738,7 @@
             </a:defPPr>
           </a:lstStyle>
           <a:p xmlns:a="http://schemas.openxmlformats.org/drawingml/2006/main">
-            <a:pPr>
+            <a:pPr algn="l">
               <a:defRPr sz="3450" b="1">
                 <a:solidFill>
                   <a:srgbClr val="1B1D19"/>
@@ -8857,7 +8767,7 @@
           <p:cNvPr id="3" name="">
             <a:extLst xmlns:a="http://schemas.openxmlformats.org/drawingml/2006/main">
               <a:ext uri="{FF2B5EF4-FFF2-40B4-BE49-F238E27FC236}">
-                <a16:creationId xmlns:a16="http://schemas.microsoft.com/office/drawing/2014/main" id="{5258DF64-27C3-4B5B-BE98-82C4B2FAC97F}"/>
+                <a16:creationId xmlns:a16="http://schemas.microsoft.com/office/drawing/2014/main" id="{13922CD8-6E45-4E8B-A6C6-65A49CE65506}"/>
               </a:ext>
             </a:extLst>
           </p:cNvPr>
@@ -8887,7 +8797,7 @@
           <p:cNvPr id="4" name="">
             <a:extLst xmlns:a="http://schemas.openxmlformats.org/drawingml/2006/main">
               <a:ext uri="{FF2B5EF4-FFF2-40B4-BE49-F238E27FC236}">
-                <a16:creationId xmlns:a16="http://schemas.microsoft.com/office/drawing/2014/main" id="{FBAD99DC-EFF8-4799-86CE-0AFA8FF88EDD}"/>
+                <a16:creationId xmlns:a16="http://schemas.microsoft.com/office/drawing/2014/main" id="{27B2692C-CF11-4478-AF4B-07E94610A8BD}"/>
               </a:ext>
             </a:extLst>
           </p:cNvPr>
@@ -8914,7 +8824,7 @@
             <a:noAutofit/>
           </a:bodyPr>
           <a:lstStyle xmlns:a="http://schemas.openxmlformats.org/drawingml/2006/main">
-            <a:defPPr>
+            <a:defPPr algn="l">
               <a:defRPr sz="2325" b="1">
                 <a:solidFill>
                   <a:srgbClr val="1B1D19"/>
@@ -8926,7 +8836,7 @@
             </a:defPPr>
           </a:lstStyle>
           <a:p xmlns:a="http://schemas.openxmlformats.org/drawingml/2006/main">
-            <a:pPr>
+            <a:pPr algn="l">
               <a:defRPr sz="2325" b="1">
                 <a:solidFill>
                   <a:srgbClr val="1B1D19"/>
@@ -8955,7 +8865,7 @@
           <p:cNvPr id="5" name="">
             <a:extLst xmlns:a="http://schemas.openxmlformats.org/drawingml/2006/main">
               <a:ext uri="{FF2B5EF4-FFF2-40B4-BE49-F238E27FC236}">
-                <a16:creationId xmlns:a16="http://schemas.microsoft.com/office/drawing/2014/main" id="{B2D73DAB-9676-4220-A18F-E7D75FD2455E}"/>
+                <a16:creationId xmlns:a16="http://schemas.microsoft.com/office/drawing/2014/main" id="{3D0A9FC0-BF32-46B2-8E32-C8A284B1D5A4}"/>
               </a:ext>
             </a:extLst>
           </p:cNvPr>
@@ -8982,7 +8892,7 @@
             <a:noAutofit/>
           </a:bodyPr>
           <a:lstStyle xmlns:a="http://schemas.openxmlformats.org/drawingml/2006/main">
-            <a:defPPr>
+            <a:defPPr algn="l">
               <a:defRPr sz="2025" b="0">
                 <a:solidFill>
                   <a:srgbClr val="6B7265"/>
@@ -8994,7 +8904,7 @@
             </a:defPPr>
           </a:lstStyle>
           <a:p xmlns:a="http://schemas.openxmlformats.org/drawingml/2006/main">
-            <a:pPr>
+            <a:pPr algn="l">
               <a:defRPr sz="2025" b="0">
                 <a:solidFill>
                   <a:srgbClr val="6B7265"/>
@@ -9017,7 +8927,7 @@
             </a:r>
           </a:p>
           <a:p xmlns:a="http://schemas.openxmlformats.org/drawingml/2006/main">
-            <a:pPr>
+            <a:pPr algn="l">
               <a:defRPr sz="2025" b="0">
                 <a:solidFill>
                   <a:srgbClr val="6B7265"/>
@@ -9046,7 +8956,7 @@
           <p:cNvPr id="6" name="">
             <a:extLst xmlns:a="http://schemas.openxmlformats.org/drawingml/2006/main">
               <a:ext uri="{FF2B5EF4-FFF2-40B4-BE49-F238E27FC236}">
-                <a16:creationId xmlns:a16="http://schemas.microsoft.com/office/drawing/2014/main" id="{E53EA957-DD2F-4A4A-B16D-4D2229E33E0B}"/>
+                <a16:creationId xmlns:a16="http://schemas.microsoft.com/office/drawing/2014/main" id="{1E185101-9405-4936-94C9-4B5E90C08E1E}"/>
               </a:ext>
             </a:extLst>
           </p:cNvPr>
@@ -9076,7 +8986,7 @@
           <p:cNvPr id="7" name="">
             <a:extLst xmlns:a="http://schemas.openxmlformats.org/drawingml/2006/main">
               <a:ext uri="{FF2B5EF4-FFF2-40B4-BE49-F238E27FC236}">
-                <a16:creationId xmlns:a16="http://schemas.microsoft.com/office/drawing/2014/main" id="{358CCED7-97FA-4997-86D9-1E9E89087E0C}"/>
+                <a16:creationId xmlns:a16="http://schemas.microsoft.com/office/drawing/2014/main" id="{69D63C35-20E5-40F0-A997-AD988FE80E1D}"/>
               </a:ext>
             </a:extLst>
           </p:cNvPr>
@@ -9103,7 +9013,7 @@
             <a:noAutofit/>
           </a:bodyPr>
           <a:lstStyle xmlns:a="http://schemas.openxmlformats.org/drawingml/2006/main">
-            <a:defPPr>
+            <a:defPPr algn="l">
               <a:defRPr sz="2325" b="1">
                 <a:solidFill>
                   <a:srgbClr val="1B1D19"/>
@@ -9115,7 +9025,7 @@
             </a:defPPr>
           </a:lstStyle>
           <a:p xmlns:a="http://schemas.openxmlformats.org/drawingml/2006/main">
-            <a:pPr>
+            <a:pPr algn="l">
               <a:defRPr sz="2325" b="1">
                 <a:solidFill>
                   <a:srgbClr val="1B1D19"/>
@@ -9144,7 +9054,7 @@
           <p:cNvPr id="8" name="">
             <a:extLst xmlns:a="http://schemas.openxmlformats.org/drawingml/2006/main">
               <a:ext uri="{FF2B5EF4-FFF2-40B4-BE49-F238E27FC236}">
-                <a16:creationId xmlns:a16="http://schemas.microsoft.com/office/drawing/2014/main" id="{1CE2ED1A-C06B-473D-B0F2-53C9397C6A4E}"/>
+                <a16:creationId xmlns:a16="http://schemas.microsoft.com/office/drawing/2014/main" id="{FEEDFAC1-6D15-4661-8DEF-C181E89B8F4C}"/>
               </a:ext>
             </a:extLst>
           </p:cNvPr>
@@ -9171,7 +9081,7 @@
             <a:noAutofit/>
           </a:bodyPr>
           <a:lstStyle xmlns:a="http://schemas.openxmlformats.org/drawingml/2006/main">
-            <a:defPPr>
+            <a:defPPr algn="l">
               <a:defRPr sz="2025" b="0">
                 <a:solidFill>
                   <a:srgbClr val="6B7265"/>
@@ -9183,7 +9093,7 @@
             </a:defPPr>
           </a:lstStyle>
           <a:p xmlns:a="http://schemas.openxmlformats.org/drawingml/2006/main">
-            <a:pPr>
+            <a:pPr algn="l">
               <a:defRPr sz="2025" b="0">
                 <a:solidFill>
                   <a:srgbClr val="6B7265"/>
@@ -9206,7 +9116,7 @@
             </a:r>
           </a:p>
           <a:p xmlns:a="http://schemas.openxmlformats.org/drawingml/2006/main">
-            <a:pPr>
+            <a:pPr algn="l">
               <a:defRPr sz="2025" b="0">
                 <a:solidFill>
                   <a:srgbClr val="6B7265"/>
@@ -9235,7 +9145,7 @@
           <p:cNvPr id="9" name="">
             <a:extLst xmlns:a="http://schemas.openxmlformats.org/drawingml/2006/main">
               <a:ext uri="{FF2B5EF4-FFF2-40B4-BE49-F238E27FC236}">
-                <a16:creationId xmlns:a16="http://schemas.microsoft.com/office/drawing/2014/main" id="{658B2F2C-8078-4395-A961-D4641AAF4D9E}"/>
+                <a16:creationId xmlns:a16="http://schemas.microsoft.com/office/drawing/2014/main" id="{453DB956-B5BE-4DA2-9DA0-EB4C25C1097B}"/>
               </a:ext>
             </a:extLst>
           </p:cNvPr>
@@ -9262,7 +9172,7 @@
             <a:noAutofit/>
           </a:bodyPr>
           <a:lstStyle xmlns:a="http://schemas.openxmlformats.org/drawingml/2006/main">
-            <a:defPPr>
+            <a:defPPr algn="l">
               <a:defRPr sz="975" b="0">
                 <a:solidFill>
                   <a:srgbClr val="858B7E"/>
@@ -9274,7 +9184,7 @@
             </a:defPPr>
           </a:lstStyle>
           <a:p xmlns:a="http://schemas.openxmlformats.org/drawingml/2006/main">
-            <a:pPr>
+            <a:pPr algn="l">
               <a:defRPr sz="975" b="0">
                 <a:solidFill>
                   <a:srgbClr val="858B7E"/>
@@ -9303,7 +9213,7 @@
           <p:cNvPr id="10" name="">
             <a:extLst xmlns:a="http://schemas.openxmlformats.org/drawingml/2006/main">
               <a:ext uri="{FF2B5EF4-FFF2-40B4-BE49-F238E27FC236}">
-                <a16:creationId xmlns:a16="http://schemas.microsoft.com/office/drawing/2014/main" id="{93B7FDB5-7333-4128-9FA8-3EEDECE0D3FF}"/>
+                <a16:creationId xmlns:a16="http://schemas.microsoft.com/office/drawing/2014/main" id="{450CA4F0-900B-463A-AD44-E21062968233}"/>
               </a:ext>
             </a:extLst>
           </p:cNvPr>
@@ -9330,7 +9240,7 @@
             <a:noAutofit/>
           </a:bodyPr>
           <a:lstStyle xmlns:a="http://schemas.openxmlformats.org/drawingml/2006/main">
-            <a:defPPr>
+            <a:defPPr algn="l">
               <a:defRPr sz="975" b="0">
                 <a:solidFill>
                   <a:srgbClr val="858B7E"/>
@@ -9342,7 +9252,7 @@
             </a:defPPr>
           </a:lstStyle>
           <a:p xmlns:a="http://schemas.openxmlformats.org/drawingml/2006/main">
-            <a:pPr>
+            <a:pPr algn="l">
               <a:defRPr sz="975" b="0">
                 <a:solidFill>
                   <a:srgbClr val="858B7E"/>
@@ -9369,7 +9279,7 @@
     </p:spTree>
     <p:extLst>
       <p:ext uri="{BB962C8B-B14F-4D97-AF65-F5344CB8AC3E}">
-        <p14:creationId xmlns:p14="http://schemas.microsoft.com/office/powerpoint/2010/main" val="1850138458"/>
+        <p14:creationId xmlns:p14="http://schemas.microsoft.com/office/powerpoint/2010/main" val="1012824638"/>
       </p:ext>
     </p:extLst>
   </p:cSld>
@@ -9400,7 +9310,7 @@
           <p:cNvPr id="11" name="">
             <a:extLst xmlns:a="http://schemas.openxmlformats.org/drawingml/2006/main">
               <a:ext uri="{FF2B5EF4-FFF2-40B4-BE49-F238E27FC236}">
-                <a16:creationId xmlns:a16="http://schemas.microsoft.com/office/drawing/2014/main" id="{C8EBCD9F-2ED8-4215-B12E-397822845202}"/>
+                <a16:creationId xmlns:a16="http://schemas.microsoft.com/office/drawing/2014/main" id="{6D91DBC3-70DD-45FB-BCE9-AC98EB1A4FD2}"/>
               </a:ext>
             </a:extLst>
           </p:cNvPr>
@@ -9427,7 +9337,7 @@
             <a:noAutofit/>
           </a:bodyPr>
           <a:lstStyle xmlns:a="http://schemas.openxmlformats.org/drawingml/2006/main">
-            <a:defPPr>
+            <a:defPPr algn="l">
               <a:defRPr sz="1050" b="1">
                 <a:solidFill>
                   <a:srgbClr val="9B7744"/>
@@ -9439,7 +9349,7 @@
             </a:defPPr>
           </a:lstStyle>
           <a:p xmlns:a="http://schemas.openxmlformats.org/drawingml/2006/main">
-            <a:pPr>
+            <a:pPr algn="l">
               <a:defRPr sz="1050" b="1">
                 <a:solidFill>
                   <a:srgbClr val="9B7744"/>
@@ -9468,7 +9378,7 @@
           <p:cNvPr id="2" name="">
             <a:extLst xmlns:a="http://schemas.openxmlformats.org/drawingml/2006/main">
               <a:ext uri="{FF2B5EF4-FFF2-40B4-BE49-F238E27FC236}">
-                <a16:creationId xmlns:a16="http://schemas.microsoft.com/office/drawing/2014/main" id="{52CDAA3B-7677-45C1-A057-9A5B9DFF40D3}"/>
+                <a16:creationId xmlns:a16="http://schemas.microsoft.com/office/drawing/2014/main" id="{66B622D6-7B65-4B56-846E-BC495CB377CB}"/>
               </a:ext>
             </a:extLst>
           </p:cNvPr>
@@ -9495,7 +9405,7 @@
             <a:noAutofit/>
           </a:bodyPr>
           <a:lstStyle xmlns:a="http://schemas.openxmlformats.org/drawingml/2006/main">
-            <a:defPPr>
+            <a:defPPr algn="l">
               <a:defRPr sz="3450" b="1">
                 <a:solidFill>
                   <a:srgbClr val="1B1D19"/>
@@ -9507,7 +9417,7 @@
             </a:defPPr>
           </a:lstStyle>
           <a:p xmlns:a="http://schemas.openxmlformats.org/drawingml/2006/main">
-            <a:pPr>
+            <a:pPr algn="l">
               <a:defRPr sz="3450" b="1">
                 <a:solidFill>
                   <a:srgbClr val="1B1D19"/>
@@ -9536,7 +9446,7 @@
           <p:cNvPr id="3" name="">
             <a:extLst xmlns:a="http://schemas.openxmlformats.org/drawingml/2006/main">
               <a:ext uri="{FF2B5EF4-FFF2-40B4-BE49-F238E27FC236}">
-                <a16:creationId xmlns:a16="http://schemas.microsoft.com/office/drawing/2014/main" id="{2D616E45-7D06-4057-A9B6-CCC9CBDE9193}"/>
+                <a16:creationId xmlns:a16="http://schemas.microsoft.com/office/drawing/2014/main" id="{F8570920-3805-4AD8-A614-5E1B6C1061E1}"/>
               </a:ext>
             </a:extLst>
           </p:cNvPr>
@@ -9566,7 +9476,7 @@
           <p:cNvPr id="4" name="">
             <a:extLst xmlns:a="http://schemas.openxmlformats.org/drawingml/2006/main">
               <a:ext uri="{FF2B5EF4-FFF2-40B4-BE49-F238E27FC236}">
-                <a16:creationId xmlns:a16="http://schemas.microsoft.com/office/drawing/2014/main" id="{0B285D62-AE7E-4569-95FA-CF896AAD45AA}"/>
+                <a16:creationId xmlns:a16="http://schemas.microsoft.com/office/drawing/2014/main" id="{33ECA283-7AFF-40EB-9ECF-2FE06D45B665}"/>
               </a:ext>
             </a:extLst>
           </p:cNvPr>
@@ -9593,7 +9503,7 @@
             <a:noAutofit/>
           </a:bodyPr>
           <a:lstStyle xmlns:a="http://schemas.openxmlformats.org/drawingml/2006/main">
-            <a:defPPr>
+            <a:defPPr algn="l">
               <a:defRPr sz="2325" b="1">
                 <a:solidFill>
                   <a:srgbClr val="1B1D19"/>
@@ -9605,7 +9515,7 @@
             </a:defPPr>
           </a:lstStyle>
           <a:p xmlns:a="http://schemas.openxmlformats.org/drawingml/2006/main">
-            <a:pPr>
+            <a:pPr algn="l">
               <a:defRPr sz="2325" b="1">
                 <a:solidFill>
                   <a:srgbClr val="1B1D19"/>
@@ -9634,7 +9544,7 @@
           <p:cNvPr id="5" name="">
             <a:extLst xmlns:a="http://schemas.openxmlformats.org/drawingml/2006/main">
               <a:ext uri="{FF2B5EF4-FFF2-40B4-BE49-F238E27FC236}">
-                <a16:creationId xmlns:a16="http://schemas.microsoft.com/office/drawing/2014/main" id="{A29E4B90-374D-449F-A42D-C9BCFCD621E0}"/>
+                <a16:creationId xmlns:a16="http://schemas.microsoft.com/office/drawing/2014/main" id="{A48954D0-F98C-4EAC-826C-272FC162DFC1}"/>
               </a:ext>
             </a:extLst>
           </p:cNvPr>
@@ -9661,7 +9571,7 @@
             <a:noAutofit/>
           </a:bodyPr>
           <a:lstStyle xmlns:a="http://schemas.openxmlformats.org/drawingml/2006/main">
-            <a:defPPr>
+            <a:defPPr algn="l">
               <a:defRPr sz="2025" b="0">
                 <a:solidFill>
                   <a:srgbClr val="6B7265"/>
@@ -9673,7 +9583,7 @@
             </a:defPPr>
           </a:lstStyle>
           <a:p xmlns:a="http://schemas.openxmlformats.org/drawingml/2006/main">
-            <a:pPr>
+            <a:pPr algn="l">
               <a:defRPr sz="2025" b="0">
                 <a:solidFill>
                   <a:srgbClr val="6B7265"/>
@@ -9696,7 +9606,7 @@
             </a:r>
           </a:p>
           <a:p xmlns:a="http://schemas.openxmlformats.org/drawingml/2006/main">
-            <a:pPr>
+            <a:pPr algn="l">
               <a:defRPr sz="2025" b="0">
                 <a:solidFill>
                   <a:srgbClr val="6B7265"/>
@@ -9719,7 +9629,7 @@
             </a:r>
           </a:p>
           <a:p xmlns:a="http://schemas.openxmlformats.org/drawingml/2006/main">
-            <a:pPr>
+            <a:pPr algn="l">
               <a:defRPr sz="2025" b="0">
                 <a:solidFill>
                   <a:srgbClr val="6B7265"/>
@@ -9742,7 +9652,7 @@
             </a:r>
           </a:p>
           <a:p xmlns:a="http://schemas.openxmlformats.org/drawingml/2006/main">
-            <a:pPr>
+            <a:pPr algn="l">
               <a:defRPr sz="2025" b="0">
                 <a:solidFill>
                   <a:srgbClr val="6B7265"/>
@@ -9765,7 +9675,7 @@
             </a:r>
           </a:p>
           <a:p xmlns:a="http://schemas.openxmlformats.org/drawingml/2006/main">
-            <a:pPr>
+            <a:pPr algn="l">
               <a:defRPr sz="2025" b="0">
                 <a:solidFill>
                   <a:srgbClr val="6B7265"/>
@@ -9794,7 +9704,7 @@
           <p:cNvPr id="6" name="">
             <a:extLst xmlns:a="http://schemas.openxmlformats.org/drawingml/2006/main">
               <a:ext uri="{FF2B5EF4-FFF2-40B4-BE49-F238E27FC236}">
-                <a16:creationId xmlns:a16="http://schemas.microsoft.com/office/drawing/2014/main" id="{967778B0-6A49-4F7E-AD2E-E83A2213A4ED}"/>
+                <a16:creationId xmlns:a16="http://schemas.microsoft.com/office/drawing/2014/main" id="{2D922D43-6C29-4B84-A89F-F1ADCDCB7603}"/>
               </a:ext>
             </a:extLst>
           </p:cNvPr>
@@ -9824,7 +9734,7 @@
           <p:cNvPr id="7" name="">
             <a:extLst xmlns:a="http://schemas.openxmlformats.org/drawingml/2006/main">
               <a:ext uri="{FF2B5EF4-FFF2-40B4-BE49-F238E27FC236}">
-                <a16:creationId xmlns:a16="http://schemas.microsoft.com/office/drawing/2014/main" id="{38EA2078-2D58-4F8F-AF1C-EE34DDFF9A24}"/>
+                <a16:creationId xmlns:a16="http://schemas.microsoft.com/office/drawing/2014/main" id="{C0CF020E-7E4D-4792-AEC8-DC9CF0FEA54E}"/>
               </a:ext>
             </a:extLst>
           </p:cNvPr>
@@ -9851,7 +9761,7 @@
             <a:noAutofit/>
           </a:bodyPr>
           <a:lstStyle xmlns:a="http://schemas.openxmlformats.org/drawingml/2006/main">
-            <a:defPPr>
+            <a:defPPr algn="l">
               <a:defRPr sz="2325" b="1">
                 <a:solidFill>
                   <a:srgbClr val="1B1D19"/>
@@ -9863,7 +9773,7 @@
             </a:defPPr>
           </a:lstStyle>
           <a:p xmlns:a="http://schemas.openxmlformats.org/drawingml/2006/main">
-            <a:pPr>
+            <a:pPr algn="l">
               <a:defRPr sz="2325" b="1">
                 <a:solidFill>
                   <a:srgbClr val="1B1D19"/>
@@ -9892,7 +9802,7 @@
           <p:cNvPr id="8" name="">
             <a:extLst xmlns:a="http://schemas.openxmlformats.org/drawingml/2006/main">
               <a:ext uri="{FF2B5EF4-FFF2-40B4-BE49-F238E27FC236}">
-                <a16:creationId xmlns:a16="http://schemas.microsoft.com/office/drawing/2014/main" id="{9E0AC341-9617-42C7-A62B-709B114E118B}"/>
+                <a16:creationId xmlns:a16="http://schemas.microsoft.com/office/drawing/2014/main" id="{DE4C9B48-39E8-4779-9661-1410F751C791}"/>
               </a:ext>
             </a:extLst>
           </p:cNvPr>
@@ -9919,7 +9829,7 @@
             <a:noAutofit/>
           </a:bodyPr>
           <a:lstStyle xmlns:a="http://schemas.openxmlformats.org/drawingml/2006/main">
-            <a:defPPr>
+            <a:defPPr algn="l">
               <a:defRPr sz="2025" b="0">
                 <a:solidFill>
                   <a:srgbClr val="6B7265"/>
@@ -9931,7 +9841,7 @@
             </a:defPPr>
           </a:lstStyle>
           <a:p xmlns:a="http://schemas.openxmlformats.org/drawingml/2006/main">
-            <a:pPr>
+            <a:pPr algn="l">
               <a:defRPr sz="2025" b="0">
                 <a:solidFill>
                   <a:srgbClr val="6B7265"/>
@@ -9954,7 +9864,7 @@
             </a:r>
           </a:p>
           <a:p xmlns:a="http://schemas.openxmlformats.org/drawingml/2006/main">
-            <a:pPr>
+            <a:pPr algn="l">
               <a:defRPr sz="2025" b="0">
                 <a:solidFill>
                   <a:srgbClr val="6B7265"/>
@@ -9977,7 +9887,7 @@
             </a:r>
           </a:p>
           <a:p xmlns:a="http://schemas.openxmlformats.org/drawingml/2006/main">
-            <a:pPr>
+            <a:pPr algn="l">
               <a:defRPr sz="2025" b="0">
                 <a:solidFill>
                   <a:srgbClr val="6B7265"/>
@@ -10000,7 +9910,7 @@
             </a:r>
           </a:p>
           <a:p xmlns:a="http://schemas.openxmlformats.org/drawingml/2006/main">
-            <a:pPr>
+            <a:pPr algn="l">
               <a:defRPr sz="2025" b="0">
                 <a:solidFill>
                   <a:srgbClr val="6B7265"/>
@@ -10023,7 +9933,7 @@
             </a:r>
           </a:p>
           <a:p xmlns:a="http://schemas.openxmlformats.org/drawingml/2006/main">
-            <a:pPr>
+            <a:pPr algn="l">
               <a:defRPr sz="2025" b="0">
                 <a:solidFill>
                   <a:srgbClr val="6B7265"/>
@@ -10052,7 +9962,7 @@
           <p:cNvPr id="9" name="">
             <a:extLst xmlns:a="http://schemas.openxmlformats.org/drawingml/2006/main">
               <a:ext uri="{FF2B5EF4-FFF2-40B4-BE49-F238E27FC236}">
-                <a16:creationId xmlns:a16="http://schemas.microsoft.com/office/drawing/2014/main" id="{E84E5F96-52C6-4ED9-AAFC-06C89511FECD}"/>
+                <a16:creationId xmlns:a16="http://schemas.microsoft.com/office/drawing/2014/main" id="{1E5FD6B3-4CB6-4B2C-8988-3924317E7CAB}"/>
               </a:ext>
             </a:extLst>
           </p:cNvPr>
@@ -10079,7 +9989,7 @@
             <a:noAutofit/>
           </a:bodyPr>
           <a:lstStyle xmlns:a="http://schemas.openxmlformats.org/drawingml/2006/main">
-            <a:defPPr>
+            <a:defPPr algn="l">
               <a:defRPr sz="975" b="0">
                 <a:solidFill>
                   <a:srgbClr val="858B7E"/>
@@ -10091,7 +10001,7 @@
             </a:defPPr>
           </a:lstStyle>
           <a:p xmlns:a="http://schemas.openxmlformats.org/drawingml/2006/main">
-            <a:pPr>
+            <a:pPr algn="l">
               <a:defRPr sz="975" b="0">
                 <a:solidFill>
                   <a:srgbClr val="858B7E"/>
@@ -10120,7 +10030,7 @@
           <p:cNvPr id="10" name="">
             <a:extLst xmlns:a="http://schemas.openxmlformats.org/drawingml/2006/main">
               <a:ext uri="{FF2B5EF4-FFF2-40B4-BE49-F238E27FC236}">
-                <a16:creationId xmlns:a16="http://schemas.microsoft.com/office/drawing/2014/main" id="{5138FC81-1ECC-46E1-A12B-FC02F519110C}"/>
+                <a16:creationId xmlns:a16="http://schemas.microsoft.com/office/drawing/2014/main" id="{CA0DE3B4-DB18-4FAF-BB8A-5BB8894744C0}"/>
               </a:ext>
             </a:extLst>
           </p:cNvPr>
@@ -10147,7 +10057,7 @@
             <a:noAutofit/>
           </a:bodyPr>
           <a:lstStyle xmlns:a="http://schemas.openxmlformats.org/drawingml/2006/main">
-            <a:defPPr>
+            <a:defPPr algn="l">
               <a:defRPr sz="975" b="0">
                 <a:solidFill>
                   <a:srgbClr val="858B7E"/>
@@ -10159,7 +10069,7 @@
             </a:defPPr>
           </a:lstStyle>
           <a:p xmlns:a="http://schemas.openxmlformats.org/drawingml/2006/main">
-            <a:pPr>
+            <a:pPr algn="l">
               <a:defRPr sz="975" b="0">
                 <a:solidFill>
                   <a:srgbClr val="858B7E"/>
@@ -10186,7 +10096,7 @@
     </p:spTree>
     <p:extLst>
       <p:ext uri="{BB962C8B-B14F-4D97-AF65-F5344CB8AC3E}">
-        <p14:creationId xmlns:p14="http://schemas.microsoft.com/office/powerpoint/2010/main" val="1086705405"/>
+        <p14:creationId xmlns:p14="http://schemas.microsoft.com/office/powerpoint/2010/main" val="146394642"/>
       </p:ext>
     </p:extLst>
   </p:cSld>
@@ -10217,7 +10127,7 @@
           <p:cNvPr id="11" name="">
             <a:extLst xmlns:a="http://schemas.openxmlformats.org/drawingml/2006/main">
               <a:ext uri="{FF2B5EF4-FFF2-40B4-BE49-F238E27FC236}">
-                <a16:creationId xmlns:a16="http://schemas.microsoft.com/office/drawing/2014/main" id="{747A4D98-DABD-4C34-8447-840D20477763}"/>
+                <a16:creationId xmlns:a16="http://schemas.microsoft.com/office/drawing/2014/main" id="{480108A2-7549-4524-AFF7-A9A6E7B6655B}"/>
               </a:ext>
             </a:extLst>
           </p:cNvPr>
@@ -10244,7 +10154,7 @@
             <a:noAutofit/>
           </a:bodyPr>
           <a:lstStyle xmlns:a="http://schemas.openxmlformats.org/drawingml/2006/main">
-            <a:defPPr>
+            <a:defPPr algn="l">
               <a:defRPr sz="1050" b="1">
                 <a:solidFill>
                   <a:srgbClr val="9B7744"/>
@@ -10256,7 +10166,7 @@
             </a:defPPr>
           </a:lstStyle>
           <a:p xmlns:a="http://schemas.openxmlformats.org/drawingml/2006/main">
-            <a:pPr>
+            <a:pPr algn="l">
               <a:defRPr sz="1050" b="1">
                 <a:solidFill>
                   <a:srgbClr val="9B7744"/>
@@ -10285,7 +10195,7 @@
           <p:cNvPr id="2" name="">
             <a:extLst xmlns:a="http://schemas.openxmlformats.org/drawingml/2006/main">
               <a:ext uri="{FF2B5EF4-FFF2-40B4-BE49-F238E27FC236}">
-                <a16:creationId xmlns:a16="http://schemas.microsoft.com/office/drawing/2014/main" id="{2885118C-1C0D-49BA-9F77-B07F503FCBE6}"/>
+                <a16:creationId xmlns:a16="http://schemas.microsoft.com/office/drawing/2014/main" id="{698EB9C9-C471-4F33-A1DC-AE9DB1520AE6}"/>
               </a:ext>
             </a:extLst>
           </p:cNvPr>
@@ -10312,7 +10222,7 @@
             <a:noAutofit/>
           </a:bodyPr>
           <a:lstStyle xmlns:a="http://schemas.openxmlformats.org/drawingml/2006/main">
-            <a:defPPr>
+            <a:defPPr algn="l">
               <a:defRPr sz="3450" b="1">
                 <a:solidFill>
                   <a:srgbClr val="1B1D19"/>
@@ -10324,7 +10234,7 @@
             </a:defPPr>
           </a:lstStyle>
           <a:p xmlns:a="http://schemas.openxmlformats.org/drawingml/2006/main">
-            <a:pPr>
+            <a:pPr algn="l">
               <a:defRPr sz="3450" b="1">
                 <a:solidFill>
                   <a:srgbClr val="1B1D19"/>
@@ -10353,7 +10263,7 @@
           <p:cNvPr id="3" name="">
             <a:extLst xmlns:a="http://schemas.openxmlformats.org/drawingml/2006/main">
               <a:ext uri="{FF2B5EF4-FFF2-40B4-BE49-F238E27FC236}">
-                <a16:creationId xmlns:a16="http://schemas.microsoft.com/office/drawing/2014/main" id="{99141F39-792F-4224-AF93-11A48237D807}"/>
+                <a16:creationId xmlns:a16="http://schemas.microsoft.com/office/drawing/2014/main" id="{B8C2AFC0-E7E2-43CF-82C5-BC06D00B4933}"/>
               </a:ext>
             </a:extLst>
           </p:cNvPr>
@@ -10383,7 +10293,7 @@
           <p:cNvPr id="4" name="">
             <a:extLst xmlns:a="http://schemas.openxmlformats.org/drawingml/2006/main">
               <a:ext uri="{FF2B5EF4-FFF2-40B4-BE49-F238E27FC236}">
-                <a16:creationId xmlns:a16="http://schemas.microsoft.com/office/drawing/2014/main" id="{A3041062-A39F-499B-97A9-CB0C267EC7E4}"/>
+                <a16:creationId xmlns:a16="http://schemas.microsoft.com/office/drawing/2014/main" id="{DFC190D2-5FCE-4557-A51C-11399A2DE072}"/>
               </a:ext>
             </a:extLst>
           </p:cNvPr>
@@ -10410,7 +10320,7 @@
             <a:noAutofit/>
           </a:bodyPr>
           <a:lstStyle xmlns:a="http://schemas.openxmlformats.org/drawingml/2006/main">
-            <a:defPPr>
+            <a:defPPr algn="l">
               <a:defRPr sz="2325" b="1">
                 <a:solidFill>
                   <a:srgbClr val="1B1D19"/>
@@ -10422,7 +10332,7 @@
             </a:defPPr>
           </a:lstStyle>
           <a:p xmlns:a="http://schemas.openxmlformats.org/drawingml/2006/main">
-            <a:pPr>
+            <a:pPr algn="l">
               <a:defRPr sz="2325" b="1">
                 <a:solidFill>
                   <a:srgbClr val="1B1D19"/>
@@ -10451,7 +10361,7 @@
           <p:cNvPr id="5" name="">
             <a:extLst xmlns:a="http://schemas.openxmlformats.org/drawingml/2006/main">
               <a:ext uri="{FF2B5EF4-FFF2-40B4-BE49-F238E27FC236}">
-                <a16:creationId xmlns:a16="http://schemas.microsoft.com/office/drawing/2014/main" id="{E96C56F6-A6DE-415A-B921-EF0E68A0111B}"/>
+                <a16:creationId xmlns:a16="http://schemas.microsoft.com/office/drawing/2014/main" id="{5D98D46A-C831-4456-AB42-B7A411BC6F66}"/>
               </a:ext>
             </a:extLst>
           </p:cNvPr>
@@ -10478,7 +10388,7 @@
             <a:noAutofit/>
           </a:bodyPr>
           <a:lstStyle xmlns:a="http://schemas.openxmlformats.org/drawingml/2006/main">
-            <a:defPPr>
+            <a:defPPr algn="l">
               <a:defRPr sz="2025" b="0">
                 <a:solidFill>
                   <a:srgbClr val="6B7265"/>
@@ -10490,7 +10400,7 @@
             </a:defPPr>
           </a:lstStyle>
           <a:p xmlns:a="http://schemas.openxmlformats.org/drawingml/2006/main">
-            <a:pPr>
+            <a:pPr algn="l">
               <a:defRPr sz="2025" b="0">
                 <a:solidFill>
                   <a:srgbClr val="6B7265"/>
@@ -10513,7 +10423,7 @@
             </a:r>
           </a:p>
           <a:p xmlns:a="http://schemas.openxmlformats.org/drawingml/2006/main">
-            <a:pPr>
+            <a:pPr algn="l">
               <a:defRPr sz="2025" b="0">
                 <a:solidFill>
                   <a:srgbClr val="6B7265"/>
@@ -10542,7 +10452,7 @@
           <p:cNvPr id="6" name="">
             <a:extLst xmlns:a="http://schemas.openxmlformats.org/drawingml/2006/main">
               <a:ext uri="{FF2B5EF4-FFF2-40B4-BE49-F238E27FC236}">
-                <a16:creationId xmlns:a16="http://schemas.microsoft.com/office/drawing/2014/main" id="{410B884D-F818-4D1B-90D6-B7D3CAB08AFA}"/>
+                <a16:creationId xmlns:a16="http://schemas.microsoft.com/office/drawing/2014/main" id="{2E98EC5C-4B3B-4F23-9E67-F1CD2BFA7C2A}"/>
               </a:ext>
             </a:extLst>
           </p:cNvPr>
@@ -10572,7 +10482,7 @@
           <p:cNvPr id="7" name="">
             <a:extLst xmlns:a="http://schemas.openxmlformats.org/drawingml/2006/main">
               <a:ext uri="{FF2B5EF4-FFF2-40B4-BE49-F238E27FC236}">
-                <a16:creationId xmlns:a16="http://schemas.microsoft.com/office/drawing/2014/main" id="{A85A6D49-4DBA-4DC9-9FE5-91816415E5F3}"/>
+                <a16:creationId xmlns:a16="http://schemas.microsoft.com/office/drawing/2014/main" id="{7D934AD7-ACBD-4487-8D6E-2F46CCE2DB1A}"/>
               </a:ext>
             </a:extLst>
           </p:cNvPr>
@@ -10599,7 +10509,7 @@
             <a:noAutofit/>
           </a:bodyPr>
           <a:lstStyle xmlns:a="http://schemas.openxmlformats.org/drawingml/2006/main">
-            <a:defPPr>
+            <a:defPPr algn="l">
               <a:defRPr sz="2325" b="1">
                 <a:solidFill>
                   <a:srgbClr val="1B1D19"/>
@@ -10611,7 +10521,7 @@
             </a:defPPr>
           </a:lstStyle>
           <a:p xmlns:a="http://schemas.openxmlformats.org/drawingml/2006/main">
-            <a:pPr>
+            <a:pPr algn="l">
               <a:defRPr sz="2325" b="1">
                 <a:solidFill>
                   <a:srgbClr val="1B1D19"/>
@@ -10640,7 +10550,7 @@
           <p:cNvPr id="8" name="">
             <a:extLst xmlns:a="http://schemas.openxmlformats.org/drawingml/2006/main">
               <a:ext uri="{FF2B5EF4-FFF2-40B4-BE49-F238E27FC236}">
-                <a16:creationId xmlns:a16="http://schemas.microsoft.com/office/drawing/2014/main" id="{3C1C009A-CFDD-4D70-81AB-7399AEFBDB59}"/>
+                <a16:creationId xmlns:a16="http://schemas.microsoft.com/office/drawing/2014/main" id="{B135813E-7B2E-4BB9-84C7-A293A04DE123}"/>
               </a:ext>
             </a:extLst>
           </p:cNvPr>
@@ -10667,7 +10577,7 @@
             <a:noAutofit/>
           </a:bodyPr>
           <a:lstStyle xmlns:a="http://schemas.openxmlformats.org/drawingml/2006/main">
-            <a:defPPr>
+            <a:defPPr algn="l">
               <a:defRPr sz="2025" b="0">
                 <a:solidFill>
                   <a:srgbClr val="6B7265"/>
@@ -10679,7 +10589,7 @@
             </a:defPPr>
           </a:lstStyle>
           <a:p xmlns:a="http://schemas.openxmlformats.org/drawingml/2006/main">
-            <a:pPr>
+            <a:pPr algn="l">
               <a:defRPr sz="2025" b="0">
                 <a:solidFill>
                   <a:srgbClr val="6B7265"/>
@@ -10702,7 +10612,7 @@
             </a:r>
           </a:p>
           <a:p xmlns:a="http://schemas.openxmlformats.org/drawingml/2006/main">
-            <a:pPr>
+            <a:pPr algn="l">
               <a:defRPr sz="2025" b="0">
                 <a:solidFill>
                   <a:srgbClr val="6B7265"/>
@@ -10731,7 +10641,7 @@
           <p:cNvPr id="9" name="">
             <a:extLst xmlns:a="http://schemas.openxmlformats.org/drawingml/2006/main">
               <a:ext uri="{FF2B5EF4-FFF2-40B4-BE49-F238E27FC236}">
-                <a16:creationId xmlns:a16="http://schemas.microsoft.com/office/drawing/2014/main" id="{0431776F-2570-4FBE-8133-1D5DDB06CB81}"/>
+                <a16:creationId xmlns:a16="http://schemas.microsoft.com/office/drawing/2014/main" id="{3817BD7F-11FB-46DF-ABBB-7E2DA8B28941}"/>
               </a:ext>
             </a:extLst>
           </p:cNvPr>
@@ -10758,7 +10668,7 @@
             <a:noAutofit/>
           </a:bodyPr>
           <a:lstStyle xmlns:a="http://schemas.openxmlformats.org/drawingml/2006/main">
-            <a:defPPr>
+            <a:defPPr algn="l">
               <a:defRPr sz="975" b="0">
                 <a:solidFill>
                   <a:srgbClr val="858B7E"/>
@@ -10770,7 +10680,7 @@
             </a:defPPr>
           </a:lstStyle>
           <a:p xmlns:a="http://schemas.openxmlformats.org/drawingml/2006/main">
-            <a:pPr>
+            <a:pPr algn="l">
               <a:defRPr sz="975" b="0">
                 <a:solidFill>
                   <a:srgbClr val="858B7E"/>
@@ -10799,7 +10709,7 @@
           <p:cNvPr id="10" name="">
             <a:extLst xmlns:a="http://schemas.openxmlformats.org/drawingml/2006/main">
               <a:ext uri="{FF2B5EF4-FFF2-40B4-BE49-F238E27FC236}">
-                <a16:creationId xmlns:a16="http://schemas.microsoft.com/office/drawing/2014/main" id="{87916EE4-6C36-42B8-8427-F0CB45660A15}"/>
+                <a16:creationId xmlns:a16="http://schemas.microsoft.com/office/drawing/2014/main" id="{259A88A0-EF09-431F-9748-68D2EA2F8E3A}"/>
               </a:ext>
             </a:extLst>
           </p:cNvPr>
@@ -10826,7 +10736,7 @@
             <a:noAutofit/>
           </a:bodyPr>
           <a:lstStyle xmlns:a="http://schemas.openxmlformats.org/drawingml/2006/main">
-            <a:defPPr>
+            <a:defPPr algn="l">
               <a:defRPr sz="975" b="0">
                 <a:solidFill>
                   <a:srgbClr val="858B7E"/>
@@ -10838,7 +10748,7 @@
             </a:defPPr>
           </a:lstStyle>
           <a:p xmlns:a="http://schemas.openxmlformats.org/drawingml/2006/main">
-            <a:pPr>
+            <a:pPr algn="l">
               <a:defRPr sz="975" b="0">
                 <a:solidFill>
                   <a:srgbClr val="858B7E"/>
@@ -10865,7 +10775,7 @@
     </p:spTree>
     <p:extLst>
       <p:ext uri="{BB962C8B-B14F-4D97-AF65-F5344CB8AC3E}">
-        <p14:creationId xmlns:p14="http://schemas.microsoft.com/office/powerpoint/2010/main" val="236622401"/>
+        <p14:creationId xmlns:p14="http://schemas.microsoft.com/office/powerpoint/2010/main" val="2085656208"/>
       </p:ext>
     </p:extLst>
   </p:cSld>
@@ -10893,22 +10803,22 @@
       </p:grpSpPr>
       <p:sp>
         <p:nvSpPr>
-          <p:cNvPr id="8" name="">
-            <a:extLst xmlns:a="http://schemas.openxmlformats.org/drawingml/2006/main">
-              <a:ext uri="{FF2B5EF4-FFF2-40B4-BE49-F238E27FC236}">
-                <a16:creationId xmlns:a16="http://schemas.microsoft.com/office/drawing/2014/main" id="{8CE9A5A0-C847-494F-BBB8-31AB0FC0D892}"/>
-              </a:ext>
-            </a:extLst>
-          </p:cNvPr>
-          <p:cNvSpPr>
-            <a:spLocks xmlns:a="http://schemas.openxmlformats.org/drawingml/2006/main" noGrp="1"/>
-          </p:cNvSpPr>
-          <p:nvPr/>
-        </p:nvSpPr>
-        <p:spPr>
-          <a:xfrm xmlns:a="http://schemas.openxmlformats.org/drawingml/2006/main">
-            <a:off x="685800" y="619125"/>
-            <a:ext cx="10668000" cy="247650"/>
+          <p:cNvPr id="7" name="">
+            <a:extLst xmlns:a="http://schemas.openxmlformats.org/drawingml/2006/main">
+              <a:ext uri="{FF2B5EF4-FFF2-40B4-BE49-F238E27FC236}">
+                <a16:creationId xmlns:a16="http://schemas.microsoft.com/office/drawing/2014/main" id="{4837E0D5-B8BB-4876-8F42-CE56396E24EE}"/>
+              </a:ext>
+            </a:extLst>
+          </p:cNvPr>
+          <p:cNvSpPr>
+            <a:spLocks xmlns:a="http://schemas.openxmlformats.org/drawingml/2006/main" noGrp="1"/>
+          </p:cNvSpPr>
+          <p:nvPr/>
+        </p:nvSpPr>
+        <p:spPr>
+          <a:xfrm xmlns:a="http://schemas.openxmlformats.org/drawingml/2006/main">
+            <a:off x="914400" y="133350"/>
+            <a:ext cx="10363200" cy="152400"/>
           </a:xfrm>
           <a:prstGeom xmlns:a="http://schemas.openxmlformats.org/drawingml/2006/main" prst="rect">
             <a:avLst/>
@@ -10923,8 +10833,8 @@
             <a:noAutofit/>
           </a:bodyPr>
           <a:lstStyle xmlns:a="http://schemas.openxmlformats.org/drawingml/2006/main">
-            <a:defPPr>
-              <a:defRPr sz="1050" b="1">
+            <a:defPPr algn="l">
+              <a:defRPr sz="825" b="1">
                 <a:solidFill>
                   <a:srgbClr val="9B7744"/>
                 </a:solidFill>
@@ -10935,8 +10845,8 @@
             </a:defPPr>
           </a:lstStyle>
           <a:p xmlns:a="http://schemas.openxmlformats.org/drawingml/2006/main">
-            <a:pPr>
-              <a:defRPr sz="1050" b="1">
+            <a:pPr algn="l">
+              <a:defRPr sz="825" b="1">
                 <a:solidFill>
                   <a:srgbClr val="9B7744"/>
                 </a:solidFill>
@@ -10946,7 +10856,7 @@
               </a:defRPr>
             </a:pPr>
             <a:r>
-              <a:rPr sz="1050" b="1">
+              <a:rPr sz="825" b="1">
                 <a:solidFill>
                   <a:srgbClr val="9B7744"/>
                 </a:solidFill>
@@ -10964,19 +10874,19 @@
           <p:cNvPr id="2" name="">
             <a:extLst xmlns:a="http://schemas.openxmlformats.org/drawingml/2006/main">
               <a:ext uri="{FF2B5EF4-FFF2-40B4-BE49-F238E27FC236}">
-                <a16:creationId xmlns:a16="http://schemas.microsoft.com/office/drawing/2014/main" id="{95D00165-6D68-494A-A980-DF1181E81F5F}"/>
-              </a:ext>
-            </a:extLst>
-          </p:cNvPr>
-          <p:cNvSpPr>
-            <a:spLocks xmlns:a="http://schemas.openxmlformats.org/drawingml/2006/main" noGrp="1"/>
-          </p:cNvSpPr>
-          <p:nvPr/>
-        </p:nvSpPr>
-        <p:spPr>
-          <a:xfrm xmlns:a="http://schemas.openxmlformats.org/drawingml/2006/main">
-            <a:off x="685800" y="1047750"/>
-            <a:ext cx="10820400" cy="1085850"/>
+                <a16:creationId xmlns:a16="http://schemas.microsoft.com/office/drawing/2014/main" id="{ABB2C8B8-8AB4-487D-94D8-B44A3FE793A9}"/>
+              </a:ext>
+            </a:extLst>
+          </p:cNvPr>
+          <p:cNvSpPr>
+            <a:spLocks xmlns:a="http://schemas.openxmlformats.org/drawingml/2006/main" noGrp="1"/>
+          </p:cNvSpPr>
+          <p:nvPr/>
+        </p:nvSpPr>
+        <p:spPr>
+          <a:xfrm xmlns:a="http://schemas.openxmlformats.org/drawingml/2006/main">
+            <a:off x="914400" y="304800"/>
+            <a:ext cx="10363200" cy="381000"/>
           </a:xfrm>
           <a:prstGeom xmlns:a="http://schemas.openxmlformats.org/drawingml/2006/main" prst="rect">
             <a:avLst/>
@@ -10991,8 +10901,8 @@
             <a:noAutofit/>
           </a:bodyPr>
           <a:lstStyle xmlns:a="http://schemas.openxmlformats.org/drawingml/2006/main">
-            <a:defPPr>
-              <a:defRPr sz="3450" b="1">
+            <a:defPPr algn="l">
+              <a:defRPr sz="2250" b="1">
                 <a:solidFill>
                   <a:srgbClr val="1B1D19"/>
                 </a:solidFill>
@@ -11003,8 +10913,8 @@
             </a:defPPr>
           </a:lstStyle>
           <a:p xmlns:a="http://schemas.openxmlformats.org/drawingml/2006/main">
-            <a:pPr>
-              <a:defRPr sz="3450" b="1">
+            <a:pPr algn="l">
+              <a:defRPr sz="2250" b="1">
                 <a:solidFill>
                   <a:srgbClr val="1B1D19"/>
                 </a:solidFill>
@@ -11014,7 +10924,7 @@
               </a:defRPr>
             </a:pPr>
             <a:r>
-              <a:rPr sz="3450" b="1">
+              <a:rPr sz="2250" b="1">
                 <a:solidFill>
                   <a:srgbClr val="1B1D19"/>
                 </a:solidFill>
@@ -11032,19 +10942,19 @@
           <p:cNvPr id="3" name="">
             <a:extLst xmlns:a="http://schemas.openxmlformats.org/drawingml/2006/main">
               <a:ext uri="{FF2B5EF4-FFF2-40B4-BE49-F238E27FC236}">
-                <a16:creationId xmlns:a16="http://schemas.microsoft.com/office/drawing/2014/main" id="{FB106567-E7FB-4BC2-B194-4712F8924CE8}"/>
-              </a:ext>
-            </a:extLst>
-          </p:cNvPr>
-          <p:cNvSpPr>
-            <a:spLocks xmlns:a="http://schemas.openxmlformats.org/drawingml/2006/main" noGrp="1"/>
-          </p:cNvSpPr>
-          <p:nvPr/>
-        </p:nvSpPr>
-        <p:spPr>
-          <a:xfrm xmlns:a="http://schemas.openxmlformats.org/drawingml/2006/main">
-            <a:off x="685800" y="1905000"/>
-            <a:ext cx="10820400" cy="438150"/>
+                <a16:creationId xmlns:a16="http://schemas.microsoft.com/office/drawing/2014/main" id="{55D1910B-8D13-496C-9DF2-6C29A628566D}"/>
+              </a:ext>
+            </a:extLst>
+          </p:cNvPr>
+          <p:cNvSpPr>
+            <a:spLocks xmlns:a="http://schemas.openxmlformats.org/drawingml/2006/main" noGrp="1"/>
+          </p:cNvSpPr>
+          <p:nvPr/>
+        </p:nvSpPr>
+        <p:spPr>
+          <a:xfrm xmlns:a="http://schemas.openxmlformats.org/drawingml/2006/main">
+            <a:off x="8039100" y="371475"/>
+            <a:ext cx="3238500" cy="266700"/>
           </a:xfrm>
           <a:prstGeom xmlns:a="http://schemas.openxmlformats.org/drawingml/2006/main" prst="rect">
             <a:avLst/>
@@ -11059,8 +10969,8 @@
             <a:noAutofit/>
           </a:bodyPr>
           <a:lstStyle xmlns:a="http://schemas.openxmlformats.org/drawingml/2006/main">
-            <a:defPPr>
-              <a:defRPr sz="2025" b="0">
+            <a:defPPr algn="r">
+              <a:defRPr sz="1350" b="0">
                 <a:solidFill>
                   <a:srgbClr val="6B7265"/>
                 </a:solidFill>
@@ -11071,8 +10981,8 @@
             </a:defPPr>
           </a:lstStyle>
           <a:p xmlns:a="http://schemas.openxmlformats.org/drawingml/2006/main">
-            <a:pPr>
-              <a:defRPr sz="2025" b="0">
+            <a:pPr algn="r">
+              <a:defRPr sz="1350" b="0">
                 <a:solidFill>
                   <a:srgbClr val="6B7265"/>
                 </a:solidFill>
@@ -11082,7 +10992,7 @@
               </a:defRPr>
             </a:pPr>
             <a:r>
-              <a:rPr sz="2025" b="0">
+              <a:rPr sz="1350" b="0">
                 <a:solidFill>
                   <a:srgbClr val="6B7265"/>
                 </a:solidFill>
@@ -11100,25 +11010,25 @@
           <p:cNvPr id="4" name="">
             <a:extLst xmlns:a="http://schemas.openxmlformats.org/drawingml/2006/main">
               <a:ext uri="{FF2B5EF4-FFF2-40B4-BE49-F238E27FC236}">
-                <a16:creationId xmlns:a16="http://schemas.microsoft.com/office/drawing/2014/main" id="{D2096399-3272-4D35-B8EC-4E1F47A8A6D7}"/>
-              </a:ext>
-            </a:extLst>
-          </p:cNvPr>
-          <p:cNvSpPr>
-            <a:spLocks xmlns:a="http://schemas.openxmlformats.org/drawingml/2006/main" noGrp="1"/>
-          </p:cNvSpPr>
-          <p:nvPr/>
-        </p:nvSpPr>
-        <p:spPr>
-          <a:xfrm xmlns:a="http://schemas.openxmlformats.org/drawingml/2006/main">
-            <a:off x="685800" y="2476500"/>
-            <a:ext cx="10820400" cy="3524250"/>
+                <a16:creationId xmlns:a16="http://schemas.microsoft.com/office/drawing/2014/main" id="{6FC27F45-32AF-4CE2-AD4B-6124173DBECF}"/>
+              </a:ext>
+            </a:extLst>
+          </p:cNvPr>
+          <p:cNvSpPr>
+            <a:spLocks xmlns:a="http://schemas.openxmlformats.org/drawingml/2006/main" noGrp="1"/>
+          </p:cNvSpPr>
+          <p:nvPr/>
+        </p:nvSpPr>
+        <p:spPr>
+          <a:xfrm xmlns:a="http://schemas.openxmlformats.org/drawingml/2006/main">
+            <a:off x="914400" y="723900"/>
+            <a:ext cx="10363200" cy="5829300"/>
           </a:xfrm>
           <a:prstGeom xmlns:a="http://schemas.openxmlformats.org/drawingml/2006/main" prst="rect">
             <a:avLst/>
           </a:prstGeom>
           <a:solidFill xmlns:a="http://schemas.openxmlformats.org/drawingml/2006/main">
-            <a:srgbClr val="F7F7F3"/>
+            <a:srgbClr val="F4F3EE"/>
           </a:solidFill>
           <a:ln xmlns:a="http://schemas.openxmlformats.org/drawingml/2006/main" w="0">
             <a:noFill/>
@@ -11130,49 +11040,19 @@
           <p:cNvPr id="5" name="">
             <a:extLst xmlns:a="http://schemas.openxmlformats.org/drawingml/2006/main">
               <a:ext uri="{FF2B5EF4-FFF2-40B4-BE49-F238E27FC236}">
-                <a16:creationId xmlns:a16="http://schemas.microsoft.com/office/drawing/2014/main" id="{1292C0A0-3EFC-465A-B81C-2B248048DB48}"/>
-              </a:ext>
-            </a:extLst>
-          </p:cNvPr>
-          <p:cNvSpPr>
-            <a:spLocks xmlns:a="http://schemas.openxmlformats.org/drawingml/2006/main" noGrp="1"/>
-          </p:cNvSpPr>
-          <p:nvPr/>
-        </p:nvSpPr>
-        <p:spPr>
-          <a:xfrm xmlns:a="http://schemas.openxmlformats.org/drawingml/2006/main">
-            <a:off x="685800" y="2476500"/>
-            <a:ext cx="10820400" cy="9525"/>
-          </a:xfrm>
-          <a:prstGeom xmlns:a="http://schemas.openxmlformats.org/drawingml/2006/main" prst="rect">
-            <a:avLst/>
-          </a:prstGeom>
-          <a:solidFill xmlns:a="http://schemas.openxmlformats.org/drawingml/2006/main">
-            <a:srgbClr val="DEDFD6"/>
-          </a:solidFill>
-          <a:ln xmlns:a="http://schemas.openxmlformats.org/drawingml/2006/main" w="0">
-            <a:noFill/>
-          </a:ln>
-        </p:spPr>
-      </p:sp>
-      <p:sp>
-        <p:nvSpPr>
-          <p:cNvPr id="6" name="">
-            <a:extLst xmlns:a="http://schemas.openxmlformats.org/drawingml/2006/main">
-              <a:ext uri="{FF2B5EF4-FFF2-40B4-BE49-F238E27FC236}">
-                <a16:creationId xmlns:a16="http://schemas.microsoft.com/office/drawing/2014/main" id="{516B356D-D8B3-40CC-B0FF-DAB12EF044BC}"/>
-              </a:ext>
-            </a:extLst>
-          </p:cNvPr>
-          <p:cNvSpPr>
-            <a:spLocks xmlns:a="http://schemas.openxmlformats.org/drawingml/2006/main" noGrp="1"/>
-          </p:cNvSpPr>
-          <p:nvPr/>
-        </p:nvSpPr>
-        <p:spPr>
-          <a:xfrm xmlns:a="http://schemas.openxmlformats.org/drawingml/2006/main">
-            <a:off x="685800" y="6448425"/>
-            <a:ext cx="10191750" cy="228600"/>
+                <a16:creationId xmlns:a16="http://schemas.microsoft.com/office/drawing/2014/main" id="{61C14C0D-0191-4F5F-B578-208910C2A4A1}"/>
+              </a:ext>
+            </a:extLst>
+          </p:cNvPr>
+          <p:cNvSpPr>
+            <a:spLocks xmlns:a="http://schemas.openxmlformats.org/drawingml/2006/main" noGrp="1"/>
+          </p:cNvSpPr>
+          <p:nvPr/>
+        </p:nvSpPr>
+        <p:spPr>
+          <a:xfrm xmlns:a="http://schemas.openxmlformats.org/drawingml/2006/main">
+            <a:off x="914400" y="6667500"/>
+            <a:ext cx="9525000" cy="152400"/>
           </a:xfrm>
           <a:prstGeom xmlns:a="http://schemas.openxmlformats.org/drawingml/2006/main" prst="rect">
             <a:avLst/>
@@ -11187,8 +11067,8 @@
             <a:noAutofit/>
           </a:bodyPr>
           <a:lstStyle xmlns:a="http://schemas.openxmlformats.org/drawingml/2006/main">
-            <a:defPPr>
-              <a:defRPr sz="975" b="0">
+            <a:defPPr algn="l">
+              <a:defRPr sz="825" b="0">
                 <a:solidFill>
                   <a:srgbClr val="858B7E"/>
                 </a:solidFill>
@@ -11199,8 +11079,8 @@
             </a:defPPr>
           </a:lstStyle>
           <a:p xmlns:a="http://schemas.openxmlformats.org/drawingml/2006/main">
-            <a:pPr>
-              <a:defRPr sz="975" b="0">
+            <a:pPr algn="l">
+              <a:defRPr sz="825" b="0">
                 <a:solidFill>
                   <a:srgbClr val="858B7E"/>
                 </a:solidFill>
@@ -11210,7 +11090,7 @@
               </a:defRPr>
             </a:pPr>
             <a:r>
-              <a:rPr sz="975" b="0">
+              <a:rPr sz="825" b="0">
                 <a:solidFill>
                   <a:srgbClr val="858B7E"/>
                 </a:solidFill>
@@ -11225,22 +11105,22 @@
       </p:sp>
       <p:sp>
         <p:nvSpPr>
-          <p:cNvPr id="7" name="">
-            <a:extLst xmlns:a="http://schemas.openxmlformats.org/drawingml/2006/main">
-              <a:ext uri="{FF2B5EF4-FFF2-40B4-BE49-F238E27FC236}">
-                <a16:creationId xmlns:a16="http://schemas.microsoft.com/office/drawing/2014/main" id="{A3FE2D87-F399-462E-8053-1B60C9B20371}"/>
-              </a:ext>
-            </a:extLst>
-          </p:cNvPr>
-          <p:cNvSpPr>
-            <a:spLocks xmlns:a="http://schemas.openxmlformats.org/drawingml/2006/main" noGrp="1"/>
-          </p:cNvSpPr>
-          <p:nvPr/>
-        </p:nvSpPr>
-        <p:spPr>
-          <a:xfrm xmlns:a="http://schemas.openxmlformats.org/drawingml/2006/main">
-            <a:off x="11134725" y="6448425"/>
-            <a:ext cx="371475" cy="228600"/>
+          <p:cNvPr id="6" name="">
+            <a:extLst xmlns:a="http://schemas.openxmlformats.org/drawingml/2006/main">
+              <a:ext uri="{FF2B5EF4-FFF2-40B4-BE49-F238E27FC236}">
+                <a16:creationId xmlns:a16="http://schemas.microsoft.com/office/drawing/2014/main" id="{AC33F3E4-8241-4FB4-A2BF-B543F0828B85}"/>
+              </a:ext>
+            </a:extLst>
+          </p:cNvPr>
+          <p:cNvSpPr>
+            <a:spLocks xmlns:a="http://schemas.openxmlformats.org/drawingml/2006/main" noGrp="1"/>
+          </p:cNvSpPr>
+          <p:nvPr/>
+        </p:nvSpPr>
+        <p:spPr>
+          <a:xfrm xmlns:a="http://schemas.openxmlformats.org/drawingml/2006/main">
+            <a:off x="11049000" y="6667500"/>
+            <a:ext cx="228600" cy="152400"/>
           </a:xfrm>
           <a:prstGeom xmlns:a="http://schemas.openxmlformats.org/drawingml/2006/main" prst="rect">
             <a:avLst/>
@@ -11255,8 +11135,8 @@
             <a:noAutofit/>
           </a:bodyPr>
           <a:lstStyle xmlns:a="http://schemas.openxmlformats.org/drawingml/2006/main">
-            <a:defPPr>
-              <a:defRPr sz="975" b="0">
+            <a:defPPr algn="l">
+              <a:defRPr sz="825" b="0">
                 <a:solidFill>
                   <a:srgbClr val="858B7E"/>
                 </a:solidFill>
@@ -11267,8 +11147,8 @@
             </a:defPPr>
           </a:lstStyle>
           <a:p xmlns:a="http://schemas.openxmlformats.org/drawingml/2006/main">
-            <a:pPr>
-              <a:defRPr sz="975" b="0">
+            <a:pPr algn="l">
+              <a:defRPr sz="825" b="0">
                 <a:solidFill>
                   <a:srgbClr val="858B7E"/>
                 </a:solidFill>
@@ -11278,7 +11158,7 @@
               </a:defRPr>
             </a:pPr>
             <a:r>
-              <a:rPr sz="975" b="0">
+              <a:rPr sz="825" b="0">
                 <a:solidFill>
                   <a:srgbClr val="858B7E"/>
                 </a:solidFill>
@@ -11294,7 +11174,7 @@
     </p:spTree>
     <p:extLst>
       <p:ext uri="{BB962C8B-B14F-4D97-AF65-F5344CB8AC3E}">
-        <p14:creationId xmlns:p14="http://schemas.microsoft.com/office/powerpoint/2010/main" val="2143185249"/>
+        <p14:creationId xmlns:p14="http://schemas.microsoft.com/office/powerpoint/2010/main" val="1335954805"/>
       </p:ext>
     </p:extLst>
   </p:cSld>
@@ -11322,22 +11202,22 @@
       </p:grpSpPr>
       <p:sp>
         <p:nvSpPr>
-          <p:cNvPr id="7" name="">
-            <a:extLst xmlns:a="http://schemas.openxmlformats.org/drawingml/2006/main">
-              <a:ext uri="{FF2B5EF4-FFF2-40B4-BE49-F238E27FC236}">
-                <a16:creationId xmlns:a16="http://schemas.microsoft.com/office/drawing/2014/main" id="{7C99248E-09AA-410A-B19C-E79EF6B3C388}"/>
-              </a:ext>
-            </a:extLst>
-          </p:cNvPr>
-          <p:cNvSpPr>
-            <a:spLocks xmlns:a="http://schemas.openxmlformats.org/drawingml/2006/main" noGrp="1"/>
-          </p:cNvSpPr>
-          <p:nvPr/>
-        </p:nvSpPr>
-        <p:spPr>
-          <a:xfrm xmlns:a="http://schemas.openxmlformats.org/drawingml/2006/main">
-            <a:off x="685800" y="619125"/>
-            <a:ext cx="10668000" cy="247650"/>
+          <p:cNvPr id="6" name="">
+            <a:extLst xmlns:a="http://schemas.openxmlformats.org/drawingml/2006/main">
+              <a:ext uri="{FF2B5EF4-FFF2-40B4-BE49-F238E27FC236}">
+                <a16:creationId xmlns:a16="http://schemas.microsoft.com/office/drawing/2014/main" id="{15E5453A-74CD-47C7-A5D9-A570EB39C765}"/>
+              </a:ext>
+            </a:extLst>
+          </p:cNvPr>
+          <p:cNvSpPr>
+            <a:spLocks xmlns:a="http://schemas.openxmlformats.org/drawingml/2006/main" noGrp="1"/>
+          </p:cNvSpPr>
+          <p:nvPr/>
+        </p:nvSpPr>
+        <p:spPr>
+          <a:xfrm xmlns:a="http://schemas.openxmlformats.org/drawingml/2006/main">
+            <a:off x="914400" y="133350"/>
+            <a:ext cx="10363200" cy="152400"/>
           </a:xfrm>
           <a:prstGeom xmlns:a="http://schemas.openxmlformats.org/drawingml/2006/main" prst="rect">
             <a:avLst/>
@@ -11352,8 +11232,8 @@
             <a:noAutofit/>
           </a:bodyPr>
           <a:lstStyle xmlns:a="http://schemas.openxmlformats.org/drawingml/2006/main">
-            <a:defPPr>
-              <a:defRPr sz="1050" b="1">
+            <a:defPPr algn="l">
+              <a:defRPr sz="825" b="1">
                 <a:solidFill>
                   <a:srgbClr val="9B7744"/>
                 </a:solidFill>
@@ -11364,8 +11244,8 @@
             </a:defPPr>
           </a:lstStyle>
           <a:p xmlns:a="http://schemas.openxmlformats.org/drawingml/2006/main">
-            <a:pPr>
-              <a:defRPr sz="1050" b="1">
+            <a:pPr algn="l">
+              <a:defRPr sz="825" b="1">
                 <a:solidFill>
                   <a:srgbClr val="9B7744"/>
                 </a:solidFill>
@@ -11375,7 +11255,7 @@
               </a:defRPr>
             </a:pPr>
             <a:r>
-              <a:rPr sz="1050" b="1">
+              <a:rPr sz="825" b="1">
                 <a:solidFill>
                   <a:srgbClr val="9B7744"/>
                 </a:solidFill>
@@ -11393,19 +11273,19 @@
           <p:cNvPr id="2" name="">
             <a:extLst xmlns:a="http://schemas.openxmlformats.org/drawingml/2006/main">
               <a:ext uri="{FF2B5EF4-FFF2-40B4-BE49-F238E27FC236}">
-                <a16:creationId xmlns:a16="http://schemas.microsoft.com/office/drawing/2014/main" id="{FE6E7A5B-691A-4104-B374-8C0977151C77}"/>
-              </a:ext>
-            </a:extLst>
-          </p:cNvPr>
-          <p:cNvSpPr>
-            <a:spLocks xmlns:a="http://schemas.openxmlformats.org/drawingml/2006/main" noGrp="1"/>
-          </p:cNvSpPr>
-          <p:nvPr/>
-        </p:nvSpPr>
-        <p:spPr>
-          <a:xfrm xmlns:a="http://schemas.openxmlformats.org/drawingml/2006/main">
-            <a:off x="685800" y="1047750"/>
-            <a:ext cx="10820400" cy="1085850"/>
+                <a16:creationId xmlns:a16="http://schemas.microsoft.com/office/drawing/2014/main" id="{0C629D3C-F077-4085-9AF6-CCED921E85B2}"/>
+              </a:ext>
+            </a:extLst>
+          </p:cNvPr>
+          <p:cNvSpPr>
+            <a:spLocks xmlns:a="http://schemas.openxmlformats.org/drawingml/2006/main" noGrp="1"/>
+          </p:cNvSpPr>
+          <p:nvPr/>
+        </p:nvSpPr>
+        <p:spPr>
+          <a:xfrm xmlns:a="http://schemas.openxmlformats.org/drawingml/2006/main">
+            <a:off x="914400" y="304800"/>
+            <a:ext cx="10363200" cy="381000"/>
           </a:xfrm>
           <a:prstGeom xmlns:a="http://schemas.openxmlformats.org/drawingml/2006/main" prst="rect">
             <a:avLst/>
@@ -11420,8 +11300,8 @@
             <a:noAutofit/>
           </a:bodyPr>
           <a:lstStyle xmlns:a="http://schemas.openxmlformats.org/drawingml/2006/main">
-            <a:defPPr>
-              <a:defRPr sz="3450" b="1">
+            <a:defPPr algn="l">
+              <a:defRPr sz="2250" b="1">
                 <a:solidFill>
                   <a:srgbClr val="1B1D19"/>
                 </a:solidFill>
@@ -11432,8 +11312,8 @@
             </a:defPPr>
           </a:lstStyle>
           <a:p xmlns:a="http://schemas.openxmlformats.org/drawingml/2006/main">
-            <a:pPr>
-              <a:defRPr sz="3450" b="1">
+            <a:pPr algn="l">
+              <a:defRPr sz="2250" b="1">
                 <a:solidFill>
                   <a:srgbClr val="1B1D19"/>
                 </a:solidFill>
@@ -11443,7 +11323,7 @@
               </a:defRPr>
             </a:pPr>
             <a:r>
-              <a:rPr sz="3450" b="1">
+              <a:rPr sz="2250" b="1">
                 <a:solidFill>
                   <a:srgbClr val="1B1D19"/>
                 </a:solidFill>
@@ -11461,25 +11341,25 @@
           <p:cNvPr id="3" name="">
             <a:extLst xmlns:a="http://schemas.openxmlformats.org/drawingml/2006/main">
               <a:ext uri="{FF2B5EF4-FFF2-40B4-BE49-F238E27FC236}">
-                <a16:creationId xmlns:a16="http://schemas.microsoft.com/office/drawing/2014/main" id="{FBD50AA4-1686-4523-80E6-AACCAA787376}"/>
-              </a:ext>
-            </a:extLst>
-          </p:cNvPr>
-          <p:cNvSpPr>
-            <a:spLocks xmlns:a="http://schemas.openxmlformats.org/drawingml/2006/main" noGrp="1"/>
-          </p:cNvSpPr>
-          <p:nvPr/>
-        </p:nvSpPr>
-        <p:spPr>
-          <a:xfrm xmlns:a="http://schemas.openxmlformats.org/drawingml/2006/main">
-            <a:off x="685800" y="2476500"/>
-            <a:ext cx="10820400" cy="3524250"/>
+                <a16:creationId xmlns:a16="http://schemas.microsoft.com/office/drawing/2014/main" id="{1C835A2E-7974-4597-8652-AB10E2FD0840}"/>
+              </a:ext>
+            </a:extLst>
+          </p:cNvPr>
+          <p:cNvSpPr>
+            <a:spLocks xmlns:a="http://schemas.openxmlformats.org/drawingml/2006/main" noGrp="1"/>
+          </p:cNvSpPr>
+          <p:nvPr/>
+        </p:nvSpPr>
+        <p:spPr>
+          <a:xfrm xmlns:a="http://schemas.openxmlformats.org/drawingml/2006/main">
+            <a:off x="914400" y="723900"/>
+            <a:ext cx="10363200" cy="5829300"/>
           </a:xfrm>
           <a:prstGeom xmlns:a="http://schemas.openxmlformats.org/drawingml/2006/main" prst="rect">
             <a:avLst/>
           </a:prstGeom>
           <a:solidFill xmlns:a="http://schemas.openxmlformats.org/drawingml/2006/main">
-            <a:srgbClr val="F7F7F3"/>
+            <a:srgbClr val="F4F3EE"/>
           </a:solidFill>
           <a:ln xmlns:a="http://schemas.openxmlformats.org/drawingml/2006/main" w="0">
             <a:noFill/>
@@ -11491,49 +11371,19 @@
           <p:cNvPr id="4" name="">
             <a:extLst xmlns:a="http://schemas.openxmlformats.org/drawingml/2006/main">
               <a:ext uri="{FF2B5EF4-FFF2-40B4-BE49-F238E27FC236}">
-                <a16:creationId xmlns:a16="http://schemas.microsoft.com/office/drawing/2014/main" id="{BC20EA18-3AE7-4C10-BE6B-B15781DAD9C6}"/>
-              </a:ext>
-            </a:extLst>
-          </p:cNvPr>
-          <p:cNvSpPr>
-            <a:spLocks xmlns:a="http://schemas.openxmlformats.org/drawingml/2006/main" noGrp="1"/>
-          </p:cNvSpPr>
-          <p:nvPr/>
-        </p:nvSpPr>
-        <p:spPr>
-          <a:xfrm xmlns:a="http://schemas.openxmlformats.org/drawingml/2006/main">
-            <a:off x="685800" y="2476500"/>
-            <a:ext cx="10820400" cy="9525"/>
-          </a:xfrm>
-          <a:prstGeom xmlns:a="http://schemas.openxmlformats.org/drawingml/2006/main" prst="rect">
-            <a:avLst/>
-          </a:prstGeom>
-          <a:solidFill xmlns:a="http://schemas.openxmlformats.org/drawingml/2006/main">
-            <a:srgbClr val="DEDFD6"/>
-          </a:solidFill>
-          <a:ln xmlns:a="http://schemas.openxmlformats.org/drawingml/2006/main" w="0">
-            <a:noFill/>
-          </a:ln>
-        </p:spPr>
-      </p:sp>
-      <p:sp>
-        <p:nvSpPr>
-          <p:cNvPr id="5" name="">
-            <a:extLst xmlns:a="http://schemas.openxmlformats.org/drawingml/2006/main">
-              <a:ext uri="{FF2B5EF4-FFF2-40B4-BE49-F238E27FC236}">
-                <a16:creationId xmlns:a16="http://schemas.microsoft.com/office/drawing/2014/main" id="{B45BE914-8DEF-4C3A-8475-EF10D7393F60}"/>
-              </a:ext>
-            </a:extLst>
-          </p:cNvPr>
-          <p:cNvSpPr>
-            <a:spLocks xmlns:a="http://schemas.openxmlformats.org/drawingml/2006/main" noGrp="1"/>
-          </p:cNvSpPr>
-          <p:nvPr/>
-        </p:nvSpPr>
-        <p:spPr>
-          <a:xfrm xmlns:a="http://schemas.openxmlformats.org/drawingml/2006/main">
-            <a:off x="685800" y="6448425"/>
-            <a:ext cx="10191750" cy="228600"/>
+                <a16:creationId xmlns:a16="http://schemas.microsoft.com/office/drawing/2014/main" id="{DC36C5BE-7D2A-4FD6-9F59-054D2A039D79}"/>
+              </a:ext>
+            </a:extLst>
+          </p:cNvPr>
+          <p:cNvSpPr>
+            <a:spLocks xmlns:a="http://schemas.openxmlformats.org/drawingml/2006/main" noGrp="1"/>
+          </p:cNvSpPr>
+          <p:nvPr/>
+        </p:nvSpPr>
+        <p:spPr>
+          <a:xfrm xmlns:a="http://schemas.openxmlformats.org/drawingml/2006/main">
+            <a:off x="914400" y="6667500"/>
+            <a:ext cx="9525000" cy="152400"/>
           </a:xfrm>
           <a:prstGeom xmlns:a="http://schemas.openxmlformats.org/drawingml/2006/main" prst="rect">
             <a:avLst/>
@@ -11548,8 +11398,8 @@
             <a:noAutofit/>
           </a:bodyPr>
           <a:lstStyle xmlns:a="http://schemas.openxmlformats.org/drawingml/2006/main">
-            <a:defPPr>
-              <a:defRPr sz="975" b="0">
+            <a:defPPr algn="l">
+              <a:defRPr sz="825" b="0">
                 <a:solidFill>
                   <a:srgbClr val="858B7E"/>
                 </a:solidFill>
@@ -11560,8 +11410,8 @@
             </a:defPPr>
           </a:lstStyle>
           <a:p xmlns:a="http://schemas.openxmlformats.org/drawingml/2006/main">
-            <a:pPr>
-              <a:defRPr sz="975" b="0">
+            <a:pPr algn="l">
+              <a:defRPr sz="825" b="0">
                 <a:solidFill>
                   <a:srgbClr val="858B7E"/>
                 </a:solidFill>
@@ -11571,7 +11421,7 @@
               </a:defRPr>
             </a:pPr>
             <a:r>
-              <a:rPr sz="975" b="0">
+              <a:rPr sz="825" b="0">
                 <a:solidFill>
                   <a:srgbClr val="858B7E"/>
                 </a:solidFill>
@@ -11586,22 +11436,22 @@
       </p:sp>
       <p:sp>
         <p:nvSpPr>
-          <p:cNvPr id="6" name="">
-            <a:extLst xmlns:a="http://schemas.openxmlformats.org/drawingml/2006/main">
-              <a:ext uri="{FF2B5EF4-FFF2-40B4-BE49-F238E27FC236}">
-                <a16:creationId xmlns:a16="http://schemas.microsoft.com/office/drawing/2014/main" id="{27861A6D-A58F-4794-BCCF-A177E16B717B}"/>
-              </a:ext>
-            </a:extLst>
-          </p:cNvPr>
-          <p:cNvSpPr>
-            <a:spLocks xmlns:a="http://schemas.openxmlformats.org/drawingml/2006/main" noGrp="1"/>
-          </p:cNvSpPr>
-          <p:nvPr/>
-        </p:nvSpPr>
-        <p:spPr>
-          <a:xfrm xmlns:a="http://schemas.openxmlformats.org/drawingml/2006/main">
-            <a:off x="11134725" y="6448425"/>
-            <a:ext cx="371475" cy="228600"/>
+          <p:cNvPr id="5" name="">
+            <a:extLst xmlns:a="http://schemas.openxmlformats.org/drawingml/2006/main">
+              <a:ext uri="{FF2B5EF4-FFF2-40B4-BE49-F238E27FC236}">
+                <a16:creationId xmlns:a16="http://schemas.microsoft.com/office/drawing/2014/main" id="{BCFFFD73-AB2E-4DA2-944E-9CE28C1275EE}"/>
+              </a:ext>
+            </a:extLst>
+          </p:cNvPr>
+          <p:cNvSpPr>
+            <a:spLocks xmlns:a="http://schemas.openxmlformats.org/drawingml/2006/main" noGrp="1"/>
+          </p:cNvSpPr>
+          <p:nvPr/>
+        </p:nvSpPr>
+        <p:spPr>
+          <a:xfrm xmlns:a="http://schemas.openxmlformats.org/drawingml/2006/main">
+            <a:off x="11049000" y="6667500"/>
+            <a:ext cx="228600" cy="152400"/>
           </a:xfrm>
           <a:prstGeom xmlns:a="http://schemas.openxmlformats.org/drawingml/2006/main" prst="rect">
             <a:avLst/>
@@ -11616,8 +11466,8 @@
             <a:noAutofit/>
           </a:bodyPr>
           <a:lstStyle xmlns:a="http://schemas.openxmlformats.org/drawingml/2006/main">
-            <a:defPPr>
-              <a:defRPr sz="975" b="0">
+            <a:defPPr algn="l">
+              <a:defRPr sz="825" b="0">
                 <a:solidFill>
                   <a:srgbClr val="858B7E"/>
                 </a:solidFill>
@@ -11628,8 +11478,8 @@
             </a:defPPr>
           </a:lstStyle>
           <a:p xmlns:a="http://schemas.openxmlformats.org/drawingml/2006/main">
-            <a:pPr>
-              <a:defRPr sz="975" b="0">
+            <a:pPr algn="l">
+              <a:defRPr sz="825" b="0">
                 <a:solidFill>
                   <a:srgbClr val="858B7E"/>
                 </a:solidFill>
@@ -11639,7 +11489,7 @@
               </a:defRPr>
             </a:pPr>
             <a:r>
-              <a:rPr sz="975" b="0">
+              <a:rPr sz="825" b="0">
                 <a:solidFill>
                   <a:srgbClr val="858B7E"/>
                 </a:solidFill>
@@ -11655,7 +11505,7 @@
     </p:spTree>
     <p:extLst>
       <p:ext uri="{BB962C8B-B14F-4D97-AF65-F5344CB8AC3E}">
-        <p14:creationId xmlns:p14="http://schemas.microsoft.com/office/powerpoint/2010/main" val="1564799833"/>
+        <p14:creationId xmlns:p14="http://schemas.microsoft.com/office/powerpoint/2010/main" val="1374361539"/>
       </p:ext>
     </p:extLst>
   </p:cSld>
@@ -11683,22 +11533,22 @@
       </p:grpSpPr>
       <p:sp>
         <p:nvSpPr>
-          <p:cNvPr id="7" name="">
-            <a:extLst xmlns:a="http://schemas.openxmlformats.org/drawingml/2006/main">
-              <a:ext uri="{FF2B5EF4-FFF2-40B4-BE49-F238E27FC236}">
-                <a16:creationId xmlns:a16="http://schemas.microsoft.com/office/drawing/2014/main" id="{EDA3E417-F6F1-4190-AC1C-C4F691BA177D}"/>
-              </a:ext>
-            </a:extLst>
-          </p:cNvPr>
-          <p:cNvSpPr>
-            <a:spLocks xmlns:a="http://schemas.openxmlformats.org/drawingml/2006/main" noGrp="1"/>
-          </p:cNvSpPr>
-          <p:nvPr/>
-        </p:nvSpPr>
-        <p:spPr>
-          <a:xfrm xmlns:a="http://schemas.openxmlformats.org/drawingml/2006/main">
-            <a:off x="685800" y="619125"/>
-            <a:ext cx="10668000" cy="247650"/>
+          <p:cNvPr id="6" name="">
+            <a:extLst xmlns:a="http://schemas.openxmlformats.org/drawingml/2006/main">
+              <a:ext uri="{FF2B5EF4-FFF2-40B4-BE49-F238E27FC236}">
+                <a16:creationId xmlns:a16="http://schemas.microsoft.com/office/drawing/2014/main" id="{C8BD1FF4-16E7-47E8-A9F5-3A3A7A711A50}"/>
+              </a:ext>
+            </a:extLst>
+          </p:cNvPr>
+          <p:cNvSpPr>
+            <a:spLocks xmlns:a="http://schemas.openxmlformats.org/drawingml/2006/main" noGrp="1"/>
+          </p:cNvSpPr>
+          <p:nvPr/>
+        </p:nvSpPr>
+        <p:spPr>
+          <a:xfrm xmlns:a="http://schemas.openxmlformats.org/drawingml/2006/main">
+            <a:off x="914400" y="133350"/>
+            <a:ext cx="10363200" cy="152400"/>
           </a:xfrm>
           <a:prstGeom xmlns:a="http://schemas.openxmlformats.org/drawingml/2006/main" prst="rect">
             <a:avLst/>
@@ -11713,8 +11563,8 @@
             <a:noAutofit/>
           </a:bodyPr>
           <a:lstStyle xmlns:a="http://schemas.openxmlformats.org/drawingml/2006/main">
-            <a:defPPr>
-              <a:defRPr sz="1050" b="1">
+            <a:defPPr algn="l">
+              <a:defRPr sz="825" b="1">
                 <a:solidFill>
                   <a:srgbClr val="9B7744"/>
                 </a:solidFill>
@@ -11725,8 +11575,8 @@
             </a:defPPr>
           </a:lstStyle>
           <a:p xmlns:a="http://schemas.openxmlformats.org/drawingml/2006/main">
-            <a:pPr>
-              <a:defRPr sz="1050" b="1">
+            <a:pPr algn="l">
+              <a:defRPr sz="825" b="1">
                 <a:solidFill>
                   <a:srgbClr val="9B7744"/>
                 </a:solidFill>
@@ -11736,7 +11586,7 @@
               </a:defRPr>
             </a:pPr>
             <a:r>
-              <a:rPr sz="1050" b="1">
+              <a:rPr sz="825" b="1">
                 <a:solidFill>
                   <a:srgbClr val="9B7744"/>
                 </a:solidFill>
@@ -11754,19 +11604,19 @@
           <p:cNvPr id="2" name="">
             <a:extLst xmlns:a="http://schemas.openxmlformats.org/drawingml/2006/main">
               <a:ext uri="{FF2B5EF4-FFF2-40B4-BE49-F238E27FC236}">
-                <a16:creationId xmlns:a16="http://schemas.microsoft.com/office/drawing/2014/main" id="{D77CD645-0E07-4C93-B31E-717B65F5E591}"/>
-              </a:ext>
-            </a:extLst>
-          </p:cNvPr>
-          <p:cNvSpPr>
-            <a:spLocks xmlns:a="http://schemas.openxmlformats.org/drawingml/2006/main" noGrp="1"/>
-          </p:cNvSpPr>
-          <p:nvPr/>
-        </p:nvSpPr>
-        <p:spPr>
-          <a:xfrm xmlns:a="http://schemas.openxmlformats.org/drawingml/2006/main">
-            <a:off x="685800" y="1047750"/>
-            <a:ext cx="10820400" cy="1085850"/>
+                <a16:creationId xmlns:a16="http://schemas.microsoft.com/office/drawing/2014/main" id="{B116C21E-C437-46A1-B87D-D52C8C765964}"/>
+              </a:ext>
+            </a:extLst>
+          </p:cNvPr>
+          <p:cNvSpPr>
+            <a:spLocks xmlns:a="http://schemas.openxmlformats.org/drawingml/2006/main" noGrp="1"/>
+          </p:cNvSpPr>
+          <p:nvPr/>
+        </p:nvSpPr>
+        <p:spPr>
+          <a:xfrm xmlns:a="http://schemas.openxmlformats.org/drawingml/2006/main">
+            <a:off x="914400" y="304800"/>
+            <a:ext cx="10363200" cy="381000"/>
           </a:xfrm>
           <a:prstGeom xmlns:a="http://schemas.openxmlformats.org/drawingml/2006/main" prst="rect">
             <a:avLst/>
@@ -11781,8 +11631,8 @@
             <a:noAutofit/>
           </a:bodyPr>
           <a:lstStyle xmlns:a="http://schemas.openxmlformats.org/drawingml/2006/main">
-            <a:defPPr>
-              <a:defRPr sz="3450" b="1">
+            <a:defPPr algn="l">
+              <a:defRPr sz="2250" b="1">
                 <a:solidFill>
                   <a:srgbClr val="1B1D19"/>
                 </a:solidFill>
@@ -11793,8 +11643,8 @@
             </a:defPPr>
           </a:lstStyle>
           <a:p xmlns:a="http://schemas.openxmlformats.org/drawingml/2006/main">
-            <a:pPr>
-              <a:defRPr sz="3450" b="1">
+            <a:pPr algn="l">
+              <a:defRPr sz="2250" b="1">
                 <a:solidFill>
                   <a:srgbClr val="1B1D19"/>
                 </a:solidFill>
@@ -11804,7 +11654,7 @@
               </a:defRPr>
             </a:pPr>
             <a:r>
-              <a:rPr sz="3450" b="1">
+              <a:rPr sz="2250" b="1">
                 <a:solidFill>
                   <a:srgbClr val="1B1D19"/>
                 </a:solidFill>
@@ -11822,25 +11672,25 @@
           <p:cNvPr id="3" name="">
             <a:extLst xmlns:a="http://schemas.openxmlformats.org/drawingml/2006/main">
               <a:ext uri="{FF2B5EF4-FFF2-40B4-BE49-F238E27FC236}">
-                <a16:creationId xmlns:a16="http://schemas.microsoft.com/office/drawing/2014/main" id="{9E326510-E311-4A5E-B0C9-1E786FCCF01A}"/>
-              </a:ext>
-            </a:extLst>
-          </p:cNvPr>
-          <p:cNvSpPr>
-            <a:spLocks xmlns:a="http://schemas.openxmlformats.org/drawingml/2006/main" noGrp="1"/>
-          </p:cNvSpPr>
-          <p:nvPr/>
-        </p:nvSpPr>
-        <p:spPr>
-          <a:xfrm xmlns:a="http://schemas.openxmlformats.org/drawingml/2006/main">
-            <a:off x="685800" y="2476500"/>
-            <a:ext cx="10820400" cy="3524250"/>
+                <a16:creationId xmlns:a16="http://schemas.microsoft.com/office/drawing/2014/main" id="{058CF802-5BD1-40C2-AA19-87DFEBF933CC}"/>
+              </a:ext>
+            </a:extLst>
+          </p:cNvPr>
+          <p:cNvSpPr>
+            <a:spLocks xmlns:a="http://schemas.openxmlformats.org/drawingml/2006/main" noGrp="1"/>
+          </p:cNvSpPr>
+          <p:nvPr/>
+        </p:nvSpPr>
+        <p:spPr>
+          <a:xfrm xmlns:a="http://schemas.openxmlformats.org/drawingml/2006/main">
+            <a:off x="914400" y="723900"/>
+            <a:ext cx="10363200" cy="5829300"/>
           </a:xfrm>
           <a:prstGeom xmlns:a="http://schemas.openxmlformats.org/drawingml/2006/main" prst="rect">
             <a:avLst/>
           </a:prstGeom>
           <a:solidFill xmlns:a="http://schemas.openxmlformats.org/drawingml/2006/main">
-            <a:srgbClr val="F7F7F3"/>
+            <a:srgbClr val="F4F3EE"/>
           </a:solidFill>
           <a:ln xmlns:a="http://schemas.openxmlformats.org/drawingml/2006/main" w="0">
             <a:noFill/>
@@ -11852,49 +11702,19 @@
           <p:cNvPr id="4" name="">
             <a:extLst xmlns:a="http://schemas.openxmlformats.org/drawingml/2006/main">
               <a:ext uri="{FF2B5EF4-FFF2-40B4-BE49-F238E27FC236}">
-                <a16:creationId xmlns:a16="http://schemas.microsoft.com/office/drawing/2014/main" id="{1DFF8C5B-1466-4933-A2A9-ADFDE69401FC}"/>
-              </a:ext>
-            </a:extLst>
-          </p:cNvPr>
-          <p:cNvSpPr>
-            <a:spLocks xmlns:a="http://schemas.openxmlformats.org/drawingml/2006/main" noGrp="1"/>
-          </p:cNvSpPr>
-          <p:nvPr/>
-        </p:nvSpPr>
-        <p:spPr>
-          <a:xfrm xmlns:a="http://schemas.openxmlformats.org/drawingml/2006/main">
-            <a:off x="685800" y="2476500"/>
-            <a:ext cx="10820400" cy="9525"/>
-          </a:xfrm>
-          <a:prstGeom xmlns:a="http://schemas.openxmlformats.org/drawingml/2006/main" prst="rect">
-            <a:avLst/>
-          </a:prstGeom>
-          <a:solidFill xmlns:a="http://schemas.openxmlformats.org/drawingml/2006/main">
-            <a:srgbClr val="DEDFD6"/>
-          </a:solidFill>
-          <a:ln xmlns:a="http://schemas.openxmlformats.org/drawingml/2006/main" w="0">
-            <a:noFill/>
-          </a:ln>
-        </p:spPr>
-      </p:sp>
-      <p:sp>
-        <p:nvSpPr>
-          <p:cNvPr id="5" name="">
-            <a:extLst xmlns:a="http://schemas.openxmlformats.org/drawingml/2006/main">
-              <a:ext uri="{FF2B5EF4-FFF2-40B4-BE49-F238E27FC236}">
-                <a16:creationId xmlns:a16="http://schemas.microsoft.com/office/drawing/2014/main" id="{E725F7F3-79A2-4338-B6A7-5CAEE0200A5C}"/>
-              </a:ext>
-            </a:extLst>
-          </p:cNvPr>
-          <p:cNvSpPr>
-            <a:spLocks xmlns:a="http://schemas.openxmlformats.org/drawingml/2006/main" noGrp="1"/>
-          </p:cNvSpPr>
-          <p:nvPr/>
-        </p:nvSpPr>
-        <p:spPr>
-          <a:xfrm xmlns:a="http://schemas.openxmlformats.org/drawingml/2006/main">
-            <a:off x="685800" y="6448425"/>
-            <a:ext cx="10191750" cy="228600"/>
+                <a16:creationId xmlns:a16="http://schemas.microsoft.com/office/drawing/2014/main" id="{3E623818-FD7C-478E-8CA3-82F2F6D73D9A}"/>
+              </a:ext>
+            </a:extLst>
+          </p:cNvPr>
+          <p:cNvSpPr>
+            <a:spLocks xmlns:a="http://schemas.openxmlformats.org/drawingml/2006/main" noGrp="1"/>
+          </p:cNvSpPr>
+          <p:nvPr/>
+        </p:nvSpPr>
+        <p:spPr>
+          <a:xfrm xmlns:a="http://schemas.openxmlformats.org/drawingml/2006/main">
+            <a:off x="914400" y="6667500"/>
+            <a:ext cx="9525000" cy="152400"/>
           </a:xfrm>
           <a:prstGeom xmlns:a="http://schemas.openxmlformats.org/drawingml/2006/main" prst="rect">
             <a:avLst/>
@@ -11909,8 +11729,8 @@
             <a:noAutofit/>
           </a:bodyPr>
           <a:lstStyle xmlns:a="http://schemas.openxmlformats.org/drawingml/2006/main">
-            <a:defPPr>
-              <a:defRPr sz="975" b="0">
+            <a:defPPr algn="l">
+              <a:defRPr sz="825" b="0">
                 <a:solidFill>
                   <a:srgbClr val="858B7E"/>
                 </a:solidFill>
@@ -11921,8 +11741,8 @@
             </a:defPPr>
           </a:lstStyle>
           <a:p xmlns:a="http://schemas.openxmlformats.org/drawingml/2006/main">
-            <a:pPr>
-              <a:defRPr sz="975" b="0">
+            <a:pPr algn="l">
+              <a:defRPr sz="825" b="0">
                 <a:solidFill>
                   <a:srgbClr val="858B7E"/>
                 </a:solidFill>
@@ -11932,7 +11752,7 @@
               </a:defRPr>
             </a:pPr>
             <a:r>
-              <a:rPr sz="975" b="0">
+              <a:rPr sz="825" b="0">
                 <a:solidFill>
                   <a:srgbClr val="858B7E"/>
                 </a:solidFill>
@@ -11947,22 +11767,22 @@
       </p:sp>
       <p:sp>
         <p:nvSpPr>
-          <p:cNvPr id="6" name="">
-            <a:extLst xmlns:a="http://schemas.openxmlformats.org/drawingml/2006/main">
-              <a:ext uri="{FF2B5EF4-FFF2-40B4-BE49-F238E27FC236}">
-                <a16:creationId xmlns:a16="http://schemas.microsoft.com/office/drawing/2014/main" id="{3622CEBA-BEA1-4D94-9BA4-EE0D6E5F941C}"/>
-              </a:ext>
-            </a:extLst>
-          </p:cNvPr>
-          <p:cNvSpPr>
-            <a:spLocks xmlns:a="http://schemas.openxmlformats.org/drawingml/2006/main" noGrp="1"/>
-          </p:cNvSpPr>
-          <p:nvPr/>
-        </p:nvSpPr>
-        <p:spPr>
-          <a:xfrm xmlns:a="http://schemas.openxmlformats.org/drawingml/2006/main">
-            <a:off x="11134725" y="6448425"/>
-            <a:ext cx="371475" cy="228600"/>
+          <p:cNvPr id="5" name="">
+            <a:extLst xmlns:a="http://schemas.openxmlformats.org/drawingml/2006/main">
+              <a:ext uri="{FF2B5EF4-FFF2-40B4-BE49-F238E27FC236}">
+                <a16:creationId xmlns:a16="http://schemas.microsoft.com/office/drawing/2014/main" id="{41CBFFE8-9C63-4959-BE72-9A9DDEF23BC2}"/>
+              </a:ext>
+            </a:extLst>
+          </p:cNvPr>
+          <p:cNvSpPr>
+            <a:spLocks xmlns:a="http://schemas.openxmlformats.org/drawingml/2006/main" noGrp="1"/>
+          </p:cNvSpPr>
+          <p:nvPr/>
+        </p:nvSpPr>
+        <p:spPr>
+          <a:xfrm xmlns:a="http://schemas.openxmlformats.org/drawingml/2006/main">
+            <a:off x="11049000" y="6667500"/>
+            <a:ext cx="228600" cy="152400"/>
           </a:xfrm>
           <a:prstGeom xmlns:a="http://schemas.openxmlformats.org/drawingml/2006/main" prst="rect">
             <a:avLst/>
@@ -11977,8 +11797,8 @@
             <a:noAutofit/>
           </a:bodyPr>
           <a:lstStyle xmlns:a="http://schemas.openxmlformats.org/drawingml/2006/main">
-            <a:defPPr>
-              <a:defRPr sz="975" b="0">
+            <a:defPPr algn="l">
+              <a:defRPr sz="825" b="0">
                 <a:solidFill>
                   <a:srgbClr val="858B7E"/>
                 </a:solidFill>
@@ -11989,8 +11809,8 @@
             </a:defPPr>
           </a:lstStyle>
           <a:p xmlns:a="http://schemas.openxmlformats.org/drawingml/2006/main">
-            <a:pPr>
-              <a:defRPr sz="975" b="0">
+            <a:pPr algn="l">
+              <a:defRPr sz="825" b="0">
                 <a:solidFill>
                   <a:srgbClr val="858B7E"/>
                 </a:solidFill>
@@ -12000,7 +11820,7 @@
               </a:defRPr>
             </a:pPr>
             <a:r>
-              <a:rPr sz="975" b="0">
+              <a:rPr sz="825" b="0">
                 <a:solidFill>
                   <a:srgbClr val="858B7E"/>
                 </a:solidFill>
@@ -12016,7 +11836,7 @@
     </p:spTree>
     <p:extLst>
       <p:ext uri="{BB962C8B-B14F-4D97-AF65-F5344CB8AC3E}">
-        <p14:creationId xmlns:p14="http://schemas.microsoft.com/office/powerpoint/2010/main" val="534160250"/>
+        <p14:creationId xmlns:p14="http://schemas.microsoft.com/office/powerpoint/2010/main" val="1916071384"/>
       </p:ext>
     </p:extLst>
   </p:cSld>

</xml_diff>

<commit_message>
Restore breathing room around 16:9 surgical videos
</commit_message>
<xml_diff>
--- a/downloads/highst-perioperative-webinar.pptx
+++ b/downloads/highst-perioperative-webinar.pptx
@@ -2,27 +2,27 @@
 <file path=ppt/presentation.xml><?xml version="1.0" encoding="utf-8"?>
 <p:presentation xmlns:p="http://schemas.openxmlformats.org/presentationml/2006/main">
   <p:sldMasterIdLst>
-    <p:sldMasterId xmlns:r="http://schemas.openxmlformats.org/officeDocument/2006/relationships" id="2147483648" r:id="Rcc4efa1c288b4ef1"/>
+    <p:sldMasterId xmlns:r="http://schemas.openxmlformats.org/officeDocument/2006/relationships" id="2147483648" r:id="R7adf33d2b9084b6d"/>
   </p:sldMasterIdLst>
   <p:notesMasterIdLst>
-    <p:notesMasterId xmlns:r="http://schemas.openxmlformats.org/officeDocument/2006/relationships" r:id="R5b3e87f3e91845dc"/>
+    <p:notesMasterId xmlns:r="http://schemas.openxmlformats.org/officeDocument/2006/relationships" r:id="R32832b0067714240"/>
   </p:notesMasterIdLst>
   <p:sldIdLst>
-    <p:sldId xmlns:r="http://schemas.openxmlformats.org/officeDocument/2006/relationships" id="256" r:id="R4c25997d9bc44673"/>
-    <p:sldId xmlns:r="http://schemas.openxmlformats.org/officeDocument/2006/relationships" id="257" r:id="Ra34716ee66604145"/>
-    <p:sldId xmlns:r="http://schemas.openxmlformats.org/officeDocument/2006/relationships" id="258" r:id="R1c053f9aed004e46"/>
-    <p:sldId xmlns:r="http://schemas.openxmlformats.org/officeDocument/2006/relationships" id="259" r:id="R5d6be922e3394221"/>
-    <p:sldId xmlns:r="http://schemas.openxmlformats.org/officeDocument/2006/relationships" id="260" r:id="Re071ba049aea43f8"/>
-    <p:sldId xmlns:r="http://schemas.openxmlformats.org/officeDocument/2006/relationships" id="261" r:id="Raff95f084a754c6b"/>
-    <p:sldId xmlns:r="http://schemas.openxmlformats.org/officeDocument/2006/relationships" id="262" r:id="R6e6cfbd7a0c146b1"/>
-    <p:sldId xmlns:r="http://schemas.openxmlformats.org/officeDocument/2006/relationships" id="263" r:id="Rb287d44de0134827"/>
-    <p:sldId xmlns:r="http://schemas.openxmlformats.org/officeDocument/2006/relationships" id="264" r:id="R4372b6e55b2e4f11"/>
-    <p:sldId xmlns:r="http://schemas.openxmlformats.org/officeDocument/2006/relationships" id="265" r:id="R1070a5fd12b24763"/>
-    <p:sldId xmlns:r="http://schemas.openxmlformats.org/officeDocument/2006/relationships" id="266" r:id="Rba9933b85e6141a0"/>
-    <p:sldId xmlns:r="http://schemas.openxmlformats.org/officeDocument/2006/relationships" id="267" r:id="R7f7f84753cc4478c"/>
-    <p:sldId xmlns:r="http://schemas.openxmlformats.org/officeDocument/2006/relationships" id="268" r:id="R938443632cb94a4c"/>
-    <p:sldId xmlns:r="http://schemas.openxmlformats.org/officeDocument/2006/relationships" id="269" r:id="Rfc2ff55228e94e0f"/>
-    <p:sldId xmlns:r="http://schemas.openxmlformats.org/officeDocument/2006/relationships" id="270" r:id="R6be3f0cec11a4ec8"/>
+    <p:sldId xmlns:r="http://schemas.openxmlformats.org/officeDocument/2006/relationships" id="256" r:id="R026351cf90b848db"/>
+    <p:sldId xmlns:r="http://schemas.openxmlformats.org/officeDocument/2006/relationships" id="257" r:id="R2ba4f477345640be"/>
+    <p:sldId xmlns:r="http://schemas.openxmlformats.org/officeDocument/2006/relationships" id="258" r:id="R849c71373cfc4f01"/>
+    <p:sldId xmlns:r="http://schemas.openxmlformats.org/officeDocument/2006/relationships" id="259" r:id="R026ca8a0feb64d5b"/>
+    <p:sldId xmlns:r="http://schemas.openxmlformats.org/officeDocument/2006/relationships" id="260" r:id="R2c24d6288f8646a1"/>
+    <p:sldId xmlns:r="http://schemas.openxmlformats.org/officeDocument/2006/relationships" id="261" r:id="R086e8a57d976493a"/>
+    <p:sldId xmlns:r="http://schemas.openxmlformats.org/officeDocument/2006/relationships" id="262" r:id="Ref8de98a8414493a"/>
+    <p:sldId xmlns:r="http://schemas.openxmlformats.org/officeDocument/2006/relationships" id="263" r:id="Ra831c697b7a14b4b"/>
+    <p:sldId xmlns:r="http://schemas.openxmlformats.org/officeDocument/2006/relationships" id="264" r:id="R59f9326457b94172"/>
+    <p:sldId xmlns:r="http://schemas.openxmlformats.org/officeDocument/2006/relationships" id="265" r:id="R7d93610b44cf47c6"/>
+    <p:sldId xmlns:r="http://schemas.openxmlformats.org/officeDocument/2006/relationships" id="266" r:id="R39f889f1428c4b38"/>
+    <p:sldId xmlns:r="http://schemas.openxmlformats.org/officeDocument/2006/relationships" id="267" r:id="Rbf6a6f596ae54cfb"/>
+    <p:sldId xmlns:r="http://schemas.openxmlformats.org/officeDocument/2006/relationships" id="268" r:id="R22b11c31379c488c"/>
+    <p:sldId xmlns:r="http://schemas.openxmlformats.org/officeDocument/2006/relationships" id="269" r:id="R8d39ac556d3a43ba"/>
+    <p:sldId xmlns:r="http://schemas.openxmlformats.org/officeDocument/2006/relationships" id="270" r:id="R9400b852d2d24d0a"/>
   </p:sldIdLst>
   <p:sldSz cx="12192000" cy="6858000"/>
   <p:notesSz cx="6858000" cy="9144000"/>
@@ -1563,7 +1563,7 @@
           <p:cNvPr id="3" name="Title">
             <a:extLst xmlns:a="http://schemas.openxmlformats.org/drawingml/2006/main">
               <a:ext uri="{FF2B5EF4-FFF2-40B4-BE49-F238E27FC236}">
-                <a16:creationId xmlns:a16="http://schemas.microsoft.com/office/drawing/2014/main" id="{83A30845-1A30-4200-82FE-AAF854C64535}"/>
+                <a16:creationId xmlns:a16="http://schemas.microsoft.com/office/drawing/2014/main" id="{9839395D-D49D-4CD3-97C4-9622F24AEAED}"/>
               </a:ext>
             </a:extLst>
           </p:cNvPr>
@@ -1720,7 +1720,7 @@
           <p:cNvPr id="2" name="Subtitle">
             <a:extLst xmlns:a="http://schemas.openxmlformats.org/drawingml/2006/main">
               <a:ext uri="{FF2B5EF4-FFF2-40B4-BE49-F238E27FC236}">
-                <a16:creationId xmlns:a16="http://schemas.microsoft.com/office/drawing/2014/main" id="{51CF4F87-CDD6-45FC-A767-BA911FA802A6}"/>
+                <a16:creationId xmlns:a16="http://schemas.microsoft.com/office/drawing/2014/main" id="{92E6F663-1D3D-4F6A-BE43-0FC99250FE0D}"/>
               </a:ext>
             </a:extLst>
           </p:cNvPr>
@@ -1894,7 +1894,7 @@
           <p:cNvPr id="2" name="Section title">
             <a:extLst xmlns:a="http://schemas.openxmlformats.org/drawingml/2006/main">
               <a:ext uri="{FF2B5EF4-FFF2-40B4-BE49-F238E27FC236}">
-                <a16:creationId xmlns:a16="http://schemas.microsoft.com/office/drawing/2014/main" id="{3EA20947-52AE-4F37-9C7A-C837300B0EFE}"/>
+                <a16:creationId xmlns:a16="http://schemas.microsoft.com/office/drawing/2014/main" id="{E7954647-92D0-46E4-9EBC-D7F2CCD370CA}"/>
               </a:ext>
             </a:extLst>
           </p:cNvPr>
@@ -2068,7 +2068,7 @@
           <p:cNvPr id="3" name="Title">
             <a:extLst xmlns:a="http://schemas.openxmlformats.org/drawingml/2006/main">
               <a:ext uri="{FF2B5EF4-FFF2-40B4-BE49-F238E27FC236}">
-                <a16:creationId xmlns:a16="http://schemas.microsoft.com/office/drawing/2014/main" id="{1CD33F13-8A6C-43A5-844B-B0637746FEEF}"/>
+                <a16:creationId xmlns:a16="http://schemas.microsoft.com/office/drawing/2014/main" id="{605A7C10-F321-428F-A91A-295881A16DB5}"/>
               </a:ext>
             </a:extLst>
           </p:cNvPr>
@@ -2225,7 +2225,7 @@
           <p:cNvPr id="2" name="Body">
             <a:extLst xmlns:a="http://schemas.openxmlformats.org/drawingml/2006/main">
               <a:ext uri="{FF2B5EF4-FFF2-40B4-BE49-F238E27FC236}">
-                <a16:creationId xmlns:a16="http://schemas.microsoft.com/office/drawing/2014/main" id="{9748D49E-2AC4-484A-B01F-73AC2A95F987}"/>
+                <a16:creationId xmlns:a16="http://schemas.microsoft.com/office/drawing/2014/main" id="{4F2B1A68-0AD3-4772-A201-73BCF1479D42}"/>
               </a:ext>
             </a:extLst>
           </p:cNvPr>
@@ -2399,7 +2399,7 @@
           <p:cNvPr id="4" name="Title">
             <a:extLst xmlns:a="http://schemas.openxmlformats.org/drawingml/2006/main">
               <a:ext uri="{FF2B5EF4-FFF2-40B4-BE49-F238E27FC236}">
-                <a16:creationId xmlns:a16="http://schemas.microsoft.com/office/drawing/2014/main" id="{74F7C5FD-DA8D-4180-B99C-400D5FDF496D}"/>
+                <a16:creationId xmlns:a16="http://schemas.microsoft.com/office/drawing/2014/main" id="{5DD94B3F-52F6-4421-BF32-6C9AB3E5905B}"/>
               </a:ext>
             </a:extLst>
           </p:cNvPr>
@@ -2556,7 +2556,7 @@
           <p:cNvPr id="2" name="Left column">
             <a:extLst xmlns:a="http://schemas.openxmlformats.org/drawingml/2006/main">
               <a:ext uri="{FF2B5EF4-FFF2-40B4-BE49-F238E27FC236}">
-                <a16:creationId xmlns:a16="http://schemas.microsoft.com/office/drawing/2014/main" id="{68978989-A2E0-4EE9-92E1-A678E47ADA54}"/>
+                <a16:creationId xmlns:a16="http://schemas.microsoft.com/office/drawing/2014/main" id="{C17E2B0D-B345-41AC-9918-44B23EC2D290}"/>
               </a:ext>
             </a:extLst>
           </p:cNvPr>
@@ -2713,7 +2713,7 @@
           <p:cNvPr id="3" name="Right column">
             <a:extLst xmlns:a="http://schemas.openxmlformats.org/drawingml/2006/main">
               <a:ext uri="{FF2B5EF4-FFF2-40B4-BE49-F238E27FC236}">
-                <a16:creationId xmlns:a16="http://schemas.microsoft.com/office/drawing/2014/main" id="{A2F1F952-AC79-44F5-B140-E319853E1231}"/>
+                <a16:creationId xmlns:a16="http://schemas.microsoft.com/office/drawing/2014/main" id="{2361EDBA-A20A-421C-9157-908B6887C91F}"/>
               </a:ext>
             </a:extLst>
           </p:cNvPr>
@@ -2887,7 +2887,7 @@
           <p:cNvPr id="3" name="Title">
             <a:extLst xmlns:a="http://schemas.openxmlformats.org/drawingml/2006/main">
               <a:ext uri="{FF2B5EF4-FFF2-40B4-BE49-F238E27FC236}">
-                <a16:creationId xmlns:a16="http://schemas.microsoft.com/office/drawing/2014/main" id="{20245DB9-B556-4BD0-98E1-229C04B3BCEC}"/>
+                <a16:creationId xmlns:a16="http://schemas.microsoft.com/office/drawing/2014/main" id="{73391B42-6979-4628-8A95-69C0A8EF9818}"/>
               </a:ext>
             </a:extLst>
           </p:cNvPr>
@@ -3044,7 +3044,7 @@
           <p:cNvPr id="2" name="Left column">
             <a:extLst xmlns:a="http://schemas.openxmlformats.org/drawingml/2006/main">
               <a:ext uri="{FF2B5EF4-FFF2-40B4-BE49-F238E27FC236}">
-                <a16:creationId xmlns:a16="http://schemas.microsoft.com/office/drawing/2014/main" id="{CD0A0566-3B7E-4505-B0AA-FE1170F845E3}"/>
+                <a16:creationId xmlns:a16="http://schemas.microsoft.com/office/drawing/2014/main" id="{9651E31C-FE02-4C81-BFB2-8EC6DAD34B56}"/>
               </a:ext>
             </a:extLst>
           </p:cNvPr>
@@ -3239,12 +3239,12 @@
   </p:cSld>
   <p:clrMap bg1="lt1" tx1="dk1" bg2="lt2" tx2="dk2" accent1="accent1" accent2="accent2" accent3="accent3" accent4="accent4" accent5="accent5" accent6="accent6" hlink="hlink" folHlink="folHlink"/>
   <p:sldLayoutIdLst>
-    <p:sldLayoutId xmlns:r="http://schemas.openxmlformats.org/officeDocument/2006/relationships" id="2147483649" r:id="R5a2cd24448d54d55"/>
-    <p:sldLayoutId xmlns:r="http://schemas.openxmlformats.org/officeDocument/2006/relationships" id="2147483650" r:id="Rc7da571e9a8f45e1"/>
-    <p:sldLayoutId xmlns:r="http://schemas.openxmlformats.org/officeDocument/2006/relationships" id="2147483651" r:id="R3c870f87f4af4ee0"/>
-    <p:sldLayoutId xmlns:r="http://schemas.openxmlformats.org/officeDocument/2006/relationships" id="2147483652" r:id="Raaa64aea0ac1474c"/>
-    <p:sldLayoutId xmlns:r="http://schemas.openxmlformats.org/officeDocument/2006/relationships" id="2147483653" r:id="Reffff0882e434602"/>
-    <p:sldLayoutId xmlns:r="http://schemas.openxmlformats.org/officeDocument/2006/relationships" id="2147483654" r:id="R4f2d406ee2094f4a"/>
+    <p:sldLayoutId xmlns:r="http://schemas.openxmlformats.org/officeDocument/2006/relationships" id="2147483649" r:id="Ra86812ddddac4343"/>
+    <p:sldLayoutId xmlns:r="http://schemas.openxmlformats.org/officeDocument/2006/relationships" id="2147483650" r:id="R45fe544984204e36"/>
+    <p:sldLayoutId xmlns:r="http://schemas.openxmlformats.org/officeDocument/2006/relationships" id="2147483651" r:id="Rcff55ebd45e14879"/>
+    <p:sldLayoutId xmlns:r="http://schemas.openxmlformats.org/officeDocument/2006/relationships" id="2147483652" r:id="R89f22632ce334507"/>
+    <p:sldLayoutId xmlns:r="http://schemas.openxmlformats.org/officeDocument/2006/relationships" id="2147483653" r:id="R583c59f8679d4173"/>
+    <p:sldLayoutId xmlns:r="http://schemas.openxmlformats.org/officeDocument/2006/relationships" id="2147483654" r:id="R9b7025596a7a4fd8"/>
   </p:sldLayoutIdLst>
   <p:txStyles>
     <p:titleStyle>
@@ -3795,7 +3795,7 @@
           <p:cNvPr id="12" name="">
             <a:extLst xmlns:a="http://schemas.openxmlformats.org/drawingml/2006/main">
               <a:ext uri="{FF2B5EF4-FFF2-40B4-BE49-F238E27FC236}">
-                <a16:creationId xmlns:a16="http://schemas.microsoft.com/office/drawing/2014/main" id="{52FC47BC-909A-4676-B5DA-8C08CA5ED106}"/>
+                <a16:creationId xmlns:a16="http://schemas.microsoft.com/office/drawing/2014/main" id="{05648C0B-73C9-41D7-8E50-9557313C1FA6}"/>
               </a:ext>
             </a:extLst>
           </p:cNvPr>
@@ -3825,7 +3825,7 @@
           <p:cNvPr id="2" name="">
             <a:extLst xmlns:a="http://schemas.openxmlformats.org/drawingml/2006/main">
               <a:ext uri="{FF2B5EF4-FFF2-40B4-BE49-F238E27FC236}">
-                <a16:creationId xmlns:a16="http://schemas.microsoft.com/office/drawing/2014/main" id="{9FFCB69E-8759-404E-8F7D-B5E07788423E}"/>
+                <a16:creationId xmlns:a16="http://schemas.microsoft.com/office/drawing/2014/main" id="{7D8F41BB-F309-43DF-BA41-FEF7B012F2BA}"/>
               </a:ext>
             </a:extLst>
           </p:cNvPr>
@@ -3835,7 +3835,7 @@
           <p:nvPr/>
         </p:nvPicPr>
         <p:blipFill>
-          <a:blip xmlns:r="http://schemas.openxmlformats.org/officeDocument/2006/relationships" xmlns:a="http://schemas.openxmlformats.org/drawingml/2006/main" r:embed="R2896c692362149b9"/>
+          <a:blip xmlns:r="http://schemas.openxmlformats.org/officeDocument/2006/relationships" xmlns:a="http://schemas.openxmlformats.org/drawingml/2006/main" r:embed="R793aad6c0231431e"/>
           <a:stretch xmlns:a="http://schemas.openxmlformats.org/drawingml/2006/main"/>
         </p:blipFill>
         <p:spPr>
@@ -3853,7 +3853,7 @@
           <p:cNvPr id="3" name="">
             <a:extLst xmlns:a="http://schemas.openxmlformats.org/drawingml/2006/main">
               <a:ext uri="{FF2B5EF4-FFF2-40B4-BE49-F238E27FC236}">
-                <a16:creationId xmlns:a16="http://schemas.microsoft.com/office/drawing/2014/main" id="{ECBEBB88-520D-4540-9CEB-6B52F1FF5F20}"/>
+                <a16:creationId xmlns:a16="http://schemas.microsoft.com/office/drawing/2014/main" id="{E74AEEA2-C8D0-4A6D-8ECA-DD8C6ACCF611}"/>
               </a:ext>
             </a:extLst>
           </p:cNvPr>
@@ -3863,7 +3863,7 @@
           <p:nvPr/>
         </p:nvPicPr>
         <p:blipFill>
-          <a:blip xmlns:r="http://schemas.openxmlformats.org/officeDocument/2006/relationships" xmlns:a="http://schemas.openxmlformats.org/drawingml/2006/main" r:embed="R26958d57f78d4f77"/>
+          <a:blip xmlns:r="http://schemas.openxmlformats.org/officeDocument/2006/relationships" xmlns:a="http://schemas.openxmlformats.org/drawingml/2006/main" r:embed="Rf6629f945fff4372"/>
           <a:stretch xmlns:a="http://schemas.openxmlformats.org/drawingml/2006/main"/>
         </p:blipFill>
         <p:spPr>
@@ -3881,7 +3881,7 @@
           <p:cNvPr id="4" name="">
             <a:extLst xmlns:a="http://schemas.openxmlformats.org/drawingml/2006/main">
               <a:ext uri="{FF2B5EF4-FFF2-40B4-BE49-F238E27FC236}">
-                <a16:creationId xmlns:a16="http://schemas.microsoft.com/office/drawing/2014/main" id="{0DE53793-EECC-42B0-8BC8-371032928C4F}"/>
+                <a16:creationId xmlns:a16="http://schemas.microsoft.com/office/drawing/2014/main" id="{41714A62-4565-4D7D-87D1-EE7C95647458}"/>
               </a:ext>
             </a:extLst>
           </p:cNvPr>
@@ -3949,7 +3949,7 @@
           <p:cNvPr id="5" name="">
             <a:extLst xmlns:a="http://schemas.openxmlformats.org/drawingml/2006/main">
               <a:ext uri="{FF2B5EF4-FFF2-40B4-BE49-F238E27FC236}">
-                <a16:creationId xmlns:a16="http://schemas.microsoft.com/office/drawing/2014/main" id="{A656F724-0DFB-46ED-8484-C27E0813AB3E}"/>
+                <a16:creationId xmlns:a16="http://schemas.microsoft.com/office/drawing/2014/main" id="{D6E7EEA2-078F-44A7-B345-7E494E497CF5}"/>
               </a:ext>
             </a:extLst>
           </p:cNvPr>
@@ -4063,7 +4063,7 @@
           <p:cNvPr id="6" name="">
             <a:extLst xmlns:a="http://schemas.openxmlformats.org/drawingml/2006/main">
               <a:ext uri="{FF2B5EF4-FFF2-40B4-BE49-F238E27FC236}">
-                <a16:creationId xmlns:a16="http://schemas.microsoft.com/office/drawing/2014/main" id="{DC1705A2-81B4-4C73-A99F-8B746C38E81D}"/>
+                <a16:creationId xmlns:a16="http://schemas.microsoft.com/office/drawing/2014/main" id="{CB5D89F8-0F42-4160-ACF7-48E1E14A5814}"/>
               </a:ext>
             </a:extLst>
           </p:cNvPr>
@@ -4131,7 +4131,7 @@
           <p:cNvPr id="7" name="">
             <a:extLst xmlns:a="http://schemas.openxmlformats.org/drawingml/2006/main">
               <a:ext uri="{FF2B5EF4-FFF2-40B4-BE49-F238E27FC236}">
-                <a16:creationId xmlns:a16="http://schemas.microsoft.com/office/drawing/2014/main" id="{F51C4B22-FC8A-4DB1-B6A8-A3A9E3C4CB36}"/>
+                <a16:creationId xmlns:a16="http://schemas.microsoft.com/office/drawing/2014/main" id="{F119921F-8C67-40A8-93E4-A04ED39B6A00}"/>
               </a:ext>
             </a:extLst>
           </p:cNvPr>
@@ -4161,7 +4161,7 @@
           <p:cNvPr id="8" name="">
             <a:extLst xmlns:a="http://schemas.openxmlformats.org/drawingml/2006/main">
               <a:ext uri="{FF2B5EF4-FFF2-40B4-BE49-F238E27FC236}">
-                <a16:creationId xmlns:a16="http://schemas.microsoft.com/office/drawing/2014/main" id="{3846B4D2-64EE-43AF-9A2C-20F7EC9F6B6C}"/>
+                <a16:creationId xmlns:a16="http://schemas.microsoft.com/office/drawing/2014/main" id="{415DCA50-1D17-4164-A5D4-AEAF3182BF88}"/>
               </a:ext>
             </a:extLst>
           </p:cNvPr>
@@ -4229,7 +4229,7 @@
           <p:cNvPr id="9" name="">
             <a:extLst xmlns:a="http://schemas.openxmlformats.org/drawingml/2006/main">
               <a:ext uri="{FF2B5EF4-FFF2-40B4-BE49-F238E27FC236}">
-                <a16:creationId xmlns:a16="http://schemas.microsoft.com/office/drawing/2014/main" id="{9FE8D573-79AD-4FAA-8BA9-3F68B2FBBCA3}"/>
+                <a16:creationId xmlns:a16="http://schemas.microsoft.com/office/drawing/2014/main" id="{81581D27-EAA7-4846-9BBD-15D43954981A}"/>
               </a:ext>
             </a:extLst>
           </p:cNvPr>
@@ -4297,7 +4297,7 @@
           <p:cNvPr id="10" name="">
             <a:extLst xmlns:a="http://schemas.openxmlformats.org/drawingml/2006/main">
               <a:ext uri="{FF2B5EF4-FFF2-40B4-BE49-F238E27FC236}">
-                <a16:creationId xmlns:a16="http://schemas.microsoft.com/office/drawing/2014/main" id="{DCCB7398-DC6B-4C10-90EC-75B68A1CFF7D}"/>
+                <a16:creationId xmlns:a16="http://schemas.microsoft.com/office/drawing/2014/main" id="{77DD0E79-2AF2-4795-83B6-9490720B69AE}"/>
               </a:ext>
             </a:extLst>
           </p:cNvPr>
@@ -4365,7 +4365,7 @@
           <p:cNvPr id="11" name="">
             <a:extLst xmlns:a="http://schemas.openxmlformats.org/drawingml/2006/main">
               <a:ext uri="{FF2B5EF4-FFF2-40B4-BE49-F238E27FC236}">
-                <a16:creationId xmlns:a16="http://schemas.microsoft.com/office/drawing/2014/main" id="{E4899F88-F611-4927-8576-DA52F50E6009}"/>
+                <a16:creationId xmlns:a16="http://schemas.microsoft.com/office/drawing/2014/main" id="{85E7A65D-8EE3-461B-B311-A16BDCDEA202}"/>
               </a:ext>
             </a:extLst>
           </p:cNvPr>
@@ -4431,7 +4431,7 @@
     </p:spTree>
     <p:extLst>
       <p:ext uri="{BB962C8B-B14F-4D97-AF65-F5344CB8AC3E}">
-        <p14:creationId xmlns:p14="http://schemas.microsoft.com/office/powerpoint/2010/main" val="84154455"/>
+        <p14:creationId xmlns:p14="http://schemas.microsoft.com/office/powerpoint/2010/main" val="1053574814"/>
       </p:ext>
     </p:extLst>
   </p:cSld>
@@ -4462,19 +4462,19 @@
           <p:cNvPr id="6" name="">
             <a:extLst xmlns:a="http://schemas.openxmlformats.org/drawingml/2006/main">
               <a:ext uri="{FF2B5EF4-FFF2-40B4-BE49-F238E27FC236}">
-                <a16:creationId xmlns:a16="http://schemas.microsoft.com/office/drawing/2014/main" id="{4B3D57BD-51F6-4C5D-A45A-C790EEC67A2C}"/>
-              </a:ext>
-            </a:extLst>
-          </p:cNvPr>
-          <p:cNvSpPr>
-            <a:spLocks xmlns:a="http://schemas.openxmlformats.org/drawingml/2006/main" noGrp="1"/>
-          </p:cNvSpPr>
-          <p:nvPr/>
-        </p:nvSpPr>
-        <p:spPr>
-          <a:xfrm xmlns:a="http://schemas.openxmlformats.org/drawingml/2006/main">
-            <a:off x="914400" y="133350"/>
-            <a:ext cx="10363200" cy="152400"/>
+                <a16:creationId xmlns:a16="http://schemas.microsoft.com/office/drawing/2014/main" id="{4E1FF944-C150-4032-8750-5E3E7B817BB9}"/>
+              </a:ext>
+            </a:extLst>
+          </p:cNvPr>
+          <p:cNvSpPr>
+            <a:spLocks xmlns:a="http://schemas.openxmlformats.org/drawingml/2006/main" noGrp="1"/>
+          </p:cNvSpPr>
+          <p:nvPr/>
+        </p:nvSpPr>
+        <p:spPr>
+          <a:xfrm xmlns:a="http://schemas.openxmlformats.org/drawingml/2006/main">
+            <a:off x="1828800" y="457200"/>
+            <a:ext cx="8534400" cy="171450"/>
           </a:xfrm>
           <a:prstGeom xmlns:a="http://schemas.openxmlformats.org/drawingml/2006/main" prst="rect">
             <a:avLst/>
@@ -4490,7 +4490,7 @@
           </a:bodyPr>
           <a:lstStyle xmlns:a="http://schemas.openxmlformats.org/drawingml/2006/main">
             <a:defPPr algn="l">
-              <a:defRPr sz="825" b="1">
+              <a:defRPr sz="900" b="1">
                 <a:solidFill>
                   <a:srgbClr val="9B7744"/>
                 </a:solidFill>
@@ -4502,7 +4502,7 @@
           </a:lstStyle>
           <a:p xmlns:a="http://schemas.openxmlformats.org/drawingml/2006/main">
             <a:pPr algn="l">
-              <a:defRPr sz="825" b="1">
+              <a:defRPr sz="900" b="1">
                 <a:solidFill>
                   <a:srgbClr val="9B7744"/>
                 </a:solidFill>
@@ -4512,7 +4512,7 @@
               </a:defRPr>
             </a:pPr>
             <a:r>
-              <a:rPr sz="825" b="1">
+              <a:rPr sz="900" b="1">
                 <a:solidFill>
                   <a:srgbClr val="9B7744"/>
                 </a:solidFill>
@@ -4530,19 +4530,19 @@
           <p:cNvPr id="2" name="">
             <a:extLst xmlns:a="http://schemas.openxmlformats.org/drawingml/2006/main">
               <a:ext uri="{FF2B5EF4-FFF2-40B4-BE49-F238E27FC236}">
-                <a16:creationId xmlns:a16="http://schemas.microsoft.com/office/drawing/2014/main" id="{F82464B3-5E6E-4D7D-82C1-4E265536E151}"/>
-              </a:ext>
-            </a:extLst>
-          </p:cNvPr>
-          <p:cNvSpPr>
-            <a:spLocks xmlns:a="http://schemas.openxmlformats.org/drawingml/2006/main" noGrp="1"/>
-          </p:cNvSpPr>
-          <p:nvPr/>
-        </p:nvSpPr>
-        <p:spPr>
-          <a:xfrm xmlns:a="http://schemas.openxmlformats.org/drawingml/2006/main">
-            <a:off x="914400" y="304800"/>
-            <a:ext cx="10363200" cy="381000"/>
+                <a16:creationId xmlns:a16="http://schemas.microsoft.com/office/drawing/2014/main" id="{F9830F39-BB8F-4AD4-8CF1-E2911FD39A04}"/>
+              </a:ext>
+            </a:extLst>
+          </p:cNvPr>
+          <p:cNvSpPr>
+            <a:spLocks xmlns:a="http://schemas.openxmlformats.org/drawingml/2006/main" noGrp="1"/>
+          </p:cNvSpPr>
+          <p:nvPr/>
+        </p:nvSpPr>
+        <p:spPr>
+          <a:xfrm xmlns:a="http://schemas.openxmlformats.org/drawingml/2006/main">
+            <a:off x="1828800" y="723900"/>
+            <a:ext cx="8534400" cy="419100"/>
           </a:xfrm>
           <a:prstGeom xmlns:a="http://schemas.openxmlformats.org/drawingml/2006/main" prst="rect">
             <a:avLst/>
@@ -4558,7 +4558,7 @@
           </a:bodyPr>
           <a:lstStyle xmlns:a="http://schemas.openxmlformats.org/drawingml/2006/main">
             <a:defPPr algn="l">
-              <a:defRPr sz="2250" b="1">
+              <a:defRPr sz="2550" b="1">
                 <a:solidFill>
                   <a:srgbClr val="1B1D19"/>
                 </a:solidFill>
@@ -4570,7 +4570,7 @@
           </a:lstStyle>
           <a:p xmlns:a="http://schemas.openxmlformats.org/drawingml/2006/main">
             <a:pPr algn="l">
-              <a:defRPr sz="2250" b="1">
+              <a:defRPr sz="2550" b="1">
                 <a:solidFill>
                   <a:srgbClr val="1B1D19"/>
                 </a:solidFill>
@@ -4580,7 +4580,7 @@
               </a:defRPr>
             </a:pPr>
             <a:r>
-              <a:rPr sz="2250" b="1">
+              <a:rPr sz="2550" b="1">
                 <a:solidFill>
                   <a:srgbClr val="1B1D19"/>
                 </a:solidFill>
@@ -4598,19 +4598,19 @@
           <p:cNvPr id="3" name="">
             <a:extLst xmlns:a="http://schemas.openxmlformats.org/drawingml/2006/main">
               <a:ext uri="{FF2B5EF4-FFF2-40B4-BE49-F238E27FC236}">
-                <a16:creationId xmlns:a16="http://schemas.microsoft.com/office/drawing/2014/main" id="{D4F6AB68-7854-4E4F-97B8-F030DA168BDB}"/>
-              </a:ext>
-            </a:extLst>
-          </p:cNvPr>
-          <p:cNvSpPr>
-            <a:spLocks xmlns:a="http://schemas.openxmlformats.org/drawingml/2006/main" noGrp="1"/>
-          </p:cNvSpPr>
-          <p:nvPr/>
-        </p:nvSpPr>
-        <p:spPr>
-          <a:xfrm xmlns:a="http://schemas.openxmlformats.org/drawingml/2006/main">
-            <a:off x="914400" y="723900"/>
-            <a:ext cx="10363200" cy="5829300"/>
+                <a16:creationId xmlns:a16="http://schemas.microsoft.com/office/drawing/2014/main" id="{DA0D1F8E-9251-4DD2-A93F-41685FCE51DA}"/>
+              </a:ext>
+            </a:extLst>
+          </p:cNvPr>
+          <p:cNvSpPr>
+            <a:spLocks xmlns:a="http://schemas.openxmlformats.org/drawingml/2006/main" noGrp="1"/>
+          </p:cNvSpPr>
+          <p:nvPr/>
+        </p:nvSpPr>
+        <p:spPr>
+          <a:xfrm xmlns:a="http://schemas.openxmlformats.org/drawingml/2006/main">
+            <a:off x="1828800" y="1333500"/>
+            <a:ext cx="8534400" cy="4800600"/>
           </a:xfrm>
           <a:prstGeom xmlns:a="http://schemas.openxmlformats.org/drawingml/2006/main" prst="rect">
             <a:avLst/>
@@ -4628,19 +4628,19 @@
           <p:cNvPr id="4" name="">
             <a:extLst xmlns:a="http://schemas.openxmlformats.org/drawingml/2006/main">
               <a:ext uri="{FF2B5EF4-FFF2-40B4-BE49-F238E27FC236}">
-                <a16:creationId xmlns:a16="http://schemas.microsoft.com/office/drawing/2014/main" id="{E629B1D3-DE24-4EC4-9B99-9EED144C6D93}"/>
-              </a:ext>
-            </a:extLst>
-          </p:cNvPr>
-          <p:cNvSpPr>
-            <a:spLocks xmlns:a="http://schemas.openxmlformats.org/drawingml/2006/main" noGrp="1"/>
-          </p:cNvSpPr>
-          <p:nvPr/>
-        </p:nvSpPr>
-        <p:spPr>
-          <a:xfrm xmlns:a="http://schemas.openxmlformats.org/drawingml/2006/main">
-            <a:off x="914400" y="6667500"/>
-            <a:ext cx="9525000" cy="152400"/>
+                <a16:creationId xmlns:a16="http://schemas.microsoft.com/office/drawing/2014/main" id="{4E35F0B8-7E56-4545-A9F0-1597A635C8F4}"/>
+              </a:ext>
+            </a:extLst>
+          </p:cNvPr>
+          <p:cNvSpPr>
+            <a:spLocks xmlns:a="http://schemas.openxmlformats.org/drawingml/2006/main" noGrp="1"/>
+          </p:cNvSpPr>
+          <p:nvPr/>
+        </p:nvSpPr>
+        <p:spPr>
+          <a:xfrm xmlns:a="http://schemas.openxmlformats.org/drawingml/2006/main">
+            <a:off x="1828800" y="6429375"/>
+            <a:ext cx="7620000" cy="190500"/>
           </a:xfrm>
           <a:prstGeom xmlns:a="http://schemas.openxmlformats.org/drawingml/2006/main" prst="rect">
             <a:avLst/>
@@ -4656,7 +4656,7 @@
           </a:bodyPr>
           <a:lstStyle xmlns:a="http://schemas.openxmlformats.org/drawingml/2006/main">
             <a:defPPr algn="l">
-              <a:defRPr sz="825" b="0">
+              <a:defRPr sz="900" b="0">
                 <a:solidFill>
                   <a:srgbClr val="858B7E"/>
                 </a:solidFill>
@@ -4668,7 +4668,7 @@
           </a:lstStyle>
           <a:p xmlns:a="http://schemas.openxmlformats.org/drawingml/2006/main">
             <a:pPr algn="l">
-              <a:defRPr sz="825" b="0">
+              <a:defRPr sz="900" b="0">
                 <a:solidFill>
                   <a:srgbClr val="858B7E"/>
                 </a:solidFill>
@@ -4678,7 +4678,7 @@
               </a:defRPr>
             </a:pPr>
             <a:r>
-              <a:rPr sz="825" b="0">
+              <a:rPr sz="900" b="0">
                 <a:solidFill>
                   <a:srgbClr val="858B7E"/>
                 </a:solidFill>
@@ -4696,19 +4696,19 @@
           <p:cNvPr id="5" name="">
             <a:extLst xmlns:a="http://schemas.openxmlformats.org/drawingml/2006/main">
               <a:ext uri="{FF2B5EF4-FFF2-40B4-BE49-F238E27FC236}">
-                <a16:creationId xmlns:a16="http://schemas.microsoft.com/office/drawing/2014/main" id="{09CC2E0A-5DD9-47E6-9500-E3DA3DE4227C}"/>
-              </a:ext>
-            </a:extLst>
-          </p:cNvPr>
-          <p:cNvSpPr>
-            <a:spLocks xmlns:a="http://schemas.openxmlformats.org/drawingml/2006/main" noGrp="1"/>
-          </p:cNvSpPr>
-          <p:nvPr/>
-        </p:nvSpPr>
-        <p:spPr>
-          <a:xfrm xmlns:a="http://schemas.openxmlformats.org/drawingml/2006/main">
-            <a:off x="11049000" y="6667500"/>
-            <a:ext cx="228600" cy="152400"/>
+                <a16:creationId xmlns:a16="http://schemas.microsoft.com/office/drawing/2014/main" id="{3FC86206-42D1-46C3-894D-E261C5F7BF09}"/>
+              </a:ext>
+            </a:extLst>
+          </p:cNvPr>
+          <p:cNvSpPr>
+            <a:spLocks xmlns:a="http://schemas.openxmlformats.org/drawingml/2006/main" noGrp="1"/>
+          </p:cNvSpPr>
+          <p:nvPr/>
+        </p:nvSpPr>
+        <p:spPr>
+          <a:xfrm xmlns:a="http://schemas.openxmlformats.org/drawingml/2006/main">
+            <a:off x="10134600" y="6429375"/>
+            <a:ext cx="228600" cy="190500"/>
           </a:xfrm>
           <a:prstGeom xmlns:a="http://schemas.openxmlformats.org/drawingml/2006/main" prst="rect">
             <a:avLst/>
@@ -4724,7 +4724,7 @@
           </a:bodyPr>
           <a:lstStyle xmlns:a="http://schemas.openxmlformats.org/drawingml/2006/main">
             <a:defPPr algn="l">
-              <a:defRPr sz="825" b="0">
+              <a:defRPr sz="900" b="0">
                 <a:solidFill>
                   <a:srgbClr val="858B7E"/>
                 </a:solidFill>
@@ -4736,7 +4736,7 @@
           </a:lstStyle>
           <a:p xmlns:a="http://schemas.openxmlformats.org/drawingml/2006/main">
             <a:pPr algn="l">
-              <a:defRPr sz="825" b="0">
+              <a:defRPr sz="900" b="0">
                 <a:solidFill>
                   <a:srgbClr val="858B7E"/>
                 </a:solidFill>
@@ -4746,7 +4746,7 @@
               </a:defRPr>
             </a:pPr>
             <a:r>
-              <a:rPr sz="825" b="0">
+              <a:rPr sz="900" b="0">
                 <a:solidFill>
                   <a:srgbClr val="858B7E"/>
                 </a:solidFill>
@@ -4762,7 +4762,7 @@
     </p:spTree>
     <p:extLst>
       <p:ext uri="{BB962C8B-B14F-4D97-AF65-F5344CB8AC3E}">
-        <p14:creationId xmlns:p14="http://schemas.microsoft.com/office/powerpoint/2010/main" val="913285162"/>
+        <p14:creationId xmlns:p14="http://schemas.microsoft.com/office/powerpoint/2010/main" val="636751631"/>
       </p:ext>
     </p:extLst>
   </p:cSld>
@@ -4793,19 +4793,19 @@
           <p:cNvPr id="6" name="">
             <a:extLst xmlns:a="http://schemas.openxmlformats.org/drawingml/2006/main">
               <a:ext uri="{FF2B5EF4-FFF2-40B4-BE49-F238E27FC236}">
-                <a16:creationId xmlns:a16="http://schemas.microsoft.com/office/drawing/2014/main" id="{B948F76B-13AF-4998-A6EB-DE7EF5FC1BF5}"/>
-              </a:ext>
-            </a:extLst>
-          </p:cNvPr>
-          <p:cNvSpPr>
-            <a:spLocks xmlns:a="http://schemas.openxmlformats.org/drawingml/2006/main" noGrp="1"/>
-          </p:cNvSpPr>
-          <p:nvPr/>
-        </p:nvSpPr>
-        <p:spPr>
-          <a:xfrm xmlns:a="http://schemas.openxmlformats.org/drawingml/2006/main">
-            <a:off x="914400" y="133350"/>
-            <a:ext cx="10363200" cy="152400"/>
+                <a16:creationId xmlns:a16="http://schemas.microsoft.com/office/drawing/2014/main" id="{6EBB6511-BCB9-4EDB-902C-D14E5D0A9D3E}"/>
+              </a:ext>
+            </a:extLst>
+          </p:cNvPr>
+          <p:cNvSpPr>
+            <a:spLocks xmlns:a="http://schemas.openxmlformats.org/drawingml/2006/main" noGrp="1"/>
+          </p:cNvSpPr>
+          <p:nvPr/>
+        </p:nvSpPr>
+        <p:spPr>
+          <a:xfrm xmlns:a="http://schemas.openxmlformats.org/drawingml/2006/main">
+            <a:off x="1828800" y="457200"/>
+            <a:ext cx="8534400" cy="171450"/>
           </a:xfrm>
           <a:prstGeom xmlns:a="http://schemas.openxmlformats.org/drawingml/2006/main" prst="rect">
             <a:avLst/>
@@ -4821,7 +4821,7 @@
           </a:bodyPr>
           <a:lstStyle xmlns:a="http://schemas.openxmlformats.org/drawingml/2006/main">
             <a:defPPr algn="l">
-              <a:defRPr sz="825" b="1">
+              <a:defRPr sz="900" b="1">
                 <a:solidFill>
                   <a:srgbClr val="9B7744"/>
                 </a:solidFill>
@@ -4833,7 +4833,7 @@
           </a:lstStyle>
           <a:p xmlns:a="http://schemas.openxmlformats.org/drawingml/2006/main">
             <a:pPr algn="l">
-              <a:defRPr sz="825" b="1">
+              <a:defRPr sz="900" b="1">
                 <a:solidFill>
                   <a:srgbClr val="9B7744"/>
                 </a:solidFill>
@@ -4843,7 +4843,7 @@
               </a:defRPr>
             </a:pPr>
             <a:r>
-              <a:rPr sz="825" b="1">
+              <a:rPr sz="900" b="1">
                 <a:solidFill>
                   <a:srgbClr val="9B7744"/>
                 </a:solidFill>
@@ -4861,19 +4861,19 @@
           <p:cNvPr id="2" name="">
             <a:extLst xmlns:a="http://schemas.openxmlformats.org/drawingml/2006/main">
               <a:ext uri="{FF2B5EF4-FFF2-40B4-BE49-F238E27FC236}">
-                <a16:creationId xmlns:a16="http://schemas.microsoft.com/office/drawing/2014/main" id="{617B11E6-112E-4B64-8EA0-59E36EAF4231}"/>
-              </a:ext>
-            </a:extLst>
-          </p:cNvPr>
-          <p:cNvSpPr>
-            <a:spLocks xmlns:a="http://schemas.openxmlformats.org/drawingml/2006/main" noGrp="1"/>
-          </p:cNvSpPr>
-          <p:nvPr/>
-        </p:nvSpPr>
-        <p:spPr>
-          <a:xfrm xmlns:a="http://schemas.openxmlformats.org/drawingml/2006/main">
-            <a:off x="914400" y="304800"/>
-            <a:ext cx="10363200" cy="381000"/>
+                <a16:creationId xmlns:a16="http://schemas.microsoft.com/office/drawing/2014/main" id="{25EB2940-CDF5-4C77-BB07-D8CF9F00A207}"/>
+              </a:ext>
+            </a:extLst>
+          </p:cNvPr>
+          <p:cNvSpPr>
+            <a:spLocks xmlns:a="http://schemas.openxmlformats.org/drawingml/2006/main" noGrp="1"/>
+          </p:cNvSpPr>
+          <p:nvPr/>
+        </p:nvSpPr>
+        <p:spPr>
+          <a:xfrm xmlns:a="http://schemas.openxmlformats.org/drawingml/2006/main">
+            <a:off x="1828800" y="723900"/>
+            <a:ext cx="8534400" cy="419100"/>
           </a:xfrm>
           <a:prstGeom xmlns:a="http://schemas.openxmlformats.org/drawingml/2006/main" prst="rect">
             <a:avLst/>
@@ -4889,7 +4889,7 @@
           </a:bodyPr>
           <a:lstStyle xmlns:a="http://schemas.openxmlformats.org/drawingml/2006/main">
             <a:defPPr algn="l">
-              <a:defRPr sz="2250" b="1">
+              <a:defRPr sz="2550" b="1">
                 <a:solidFill>
                   <a:srgbClr val="1B1D19"/>
                 </a:solidFill>
@@ -4901,7 +4901,7 @@
           </a:lstStyle>
           <a:p xmlns:a="http://schemas.openxmlformats.org/drawingml/2006/main">
             <a:pPr algn="l">
-              <a:defRPr sz="2250" b="1">
+              <a:defRPr sz="2550" b="1">
                 <a:solidFill>
                   <a:srgbClr val="1B1D19"/>
                 </a:solidFill>
@@ -4911,7 +4911,7 @@
               </a:defRPr>
             </a:pPr>
             <a:r>
-              <a:rPr sz="2250" b="1">
+              <a:rPr sz="2550" b="1">
                 <a:solidFill>
                   <a:srgbClr val="1B1D19"/>
                 </a:solidFill>
@@ -4929,19 +4929,19 @@
           <p:cNvPr id="3" name="">
             <a:extLst xmlns:a="http://schemas.openxmlformats.org/drawingml/2006/main">
               <a:ext uri="{FF2B5EF4-FFF2-40B4-BE49-F238E27FC236}">
-                <a16:creationId xmlns:a16="http://schemas.microsoft.com/office/drawing/2014/main" id="{C011A6B2-BEF1-47E5-8362-4588107CA265}"/>
-              </a:ext>
-            </a:extLst>
-          </p:cNvPr>
-          <p:cNvSpPr>
-            <a:spLocks xmlns:a="http://schemas.openxmlformats.org/drawingml/2006/main" noGrp="1"/>
-          </p:cNvSpPr>
-          <p:nvPr/>
-        </p:nvSpPr>
-        <p:spPr>
-          <a:xfrm xmlns:a="http://schemas.openxmlformats.org/drawingml/2006/main">
-            <a:off x="914400" y="723900"/>
-            <a:ext cx="10363200" cy="5829300"/>
+                <a16:creationId xmlns:a16="http://schemas.microsoft.com/office/drawing/2014/main" id="{CD5FD943-5ECD-4EB3-8138-DD53114645D2}"/>
+              </a:ext>
+            </a:extLst>
+          </p:cNvPr>
+          <p:cNvSpPr>
+            <a:spLocks xmlns:a="http://schemas.openxmlformats.org/drawingml/2006/main" noGrp="1"/>
+          </p:cNvSpPr>
+          <p:nvPr/>
+        </p:nvSpPr>
+        <p:spPr>
+          <a:xfrm xmlns:a="http://schemas.openxmlformats.org/drawingml/2006/main">
+            <a:off x="1828800" y="1333500"/>
+            <a:ext cx="8534400" cy="4800600"/>
           </a:xfrm>
           <a:prstGeom xmlns:a="http://schemas.openxmlformats.org/drawingml/2006/main" prst="rect">
             <a:avLst/>
@@ -4959,19 +4959,19 @@
           <p:cNvPr id="4" name="">
             <a:extLst xmlns:a="http://schemas.openxmlformats.org/drawingml/2006/main">
               <a:ext uri="{FF2B5EF4-FFF2-40B4-BE49-F238E27FC236}">
-                <a16:creationId xmlns:a16="http://schemas.microsoft.com/office/drawing/2014/main" id="{CD4B71A4-92B3-47EF-810F-4E7A62655147}"/>
-              </a:ext>
-            </a:extLst>
-          </p:cNvPr>
-          <p:cNvSpPr>
-            <a:spLocks xmlns:a="http://schemas.openxmlformats.org/drawingml/2006/main" noGrp="1"/>
-          </p:cNvSpPr>
-          <p:nvPr/>
-        </p:nvSpPr>
-        <p:spPr>
-          <a:xfrm xmlns:a="http://schemas.openxmlformats.org/drawingml/2006/main">
-            <a:off x="914400" y="6667500"/>
-            <a:ext cx="9525000" cy="152400"/>
+                <a16:creationId xmlns:a16="http://schemas.microsoft.com/office/drawing/2014/main" id="{1AFA3163-787F-4F12-B0EC-CAB2F610479B}"/>
+              </a:ext>
+            </a:extLst>
+          </p:cNvPr>
+          <p:cNvSpPr>
+            <a:spLocks xmlns:a="http://schemas.openxmlformats.org/drawingml/2006/main" noGrp="1"/>
+          </p:cNvSpPr>
+          <p:nvPr/>
+        </p:nvSpPr>
+        <p:spPr>
+          <a:xfrm xmlns:a="http://schemas.openxmlformats.org/drawingml/2006/main">
+            <a:off x="1828800" y="6429375"/>
+            <a:ext cx="7620000" cy="190500"/>
           </a:xfrm>
           <a:prstGeom xmlns:a="http://schemas.openxmlformats.org/drawingml/2006/main" prst="rect">
             <a:avLst/>
@@ -4987,7 +4987,7 @@
           </a:bodyPr>
           <a:lstStyle xmlns:a="http://schemas.openxmlformats.org/drawingml/2006/main">
             <a:defPPr algn="l">
-              <a:defRPr sz="825" b="0">
+              <a:defRPr sz="900" b="0">
                 <a:solidFill>
                   <a:srgbClr val="858B7E"/>
                 </a:solidFill>
@@ -4999,7 +4999,7 @@
           </a:lstStyle>
           <a:p xmlns:a="http://schemas.openxmlformats.org/drawingml/2006/main">
             <a:pPr algn="l">
-              <a:defRPr sz="825" b="0">
+              <a:defRPr sz="900" b="0">
                 <a:solidFill>
                   <a:srgbClr val="858B7E"/>
                 </a:solidFill>
@@ -5009,7 +5009,7 @@
               </a:defRPr>
             </a:pPr>
             <a:r>
-              <a:rPr sz="825" b="0">
+              <a:rPr sz="900" b="0">
                 <a:solidFill>
                   <a:srgbClr val="858B7E"/>
                 </a:solidFill>
@@ -5027,19 +5027,19 @@
           <p:cNvPr id="5" name="">
             <a:extLst xmlns:a="http://schemas.openxmlformats.org/drawingml/2006/main">
               <a:ext uri="{FF2B5EF4-FFF2-40B4-BE49-F238E27FC236}">
-                <a16:creationId xmlns:a16="http://schemas.microsoft.com/office/drawing/2014/main" id="{3C235B60-DDBB-4B18-B185-B4F5DAEAB8B0}"/>
-              </a:ext>
-            </a:extLst>
-          </p:cNvPr>
-          <p:cNvSpPr>
-            <a:spLocks xmlns:a="http://schemas.openxmlformats.org/drawingml/2006/main" noGrp="1"/>
-          </p:cNvSpPr>
-          <p:nvPr/>
-        </p:nvSpPr>
-        <p:spPr>
-          <a:xfrm xmlns:a="http://schemas.openxmlformats.org/drawingml/2006/main">
-            <a:off x="11049000" y="6667500"/>
-            <a:ext cx="228600" cy="152400"/>
+                <a16:creationId xmlns:a16="http://schemas.microsoft.com/office/drawing/2014/main" id="{59091480-189B-412B-BF8C-967625C344E7}"/>
+              </a:ext>
+            </a:extLst>
+          </p:cNvPr>
+          <p:cNvSpPr>
+            <a:spLocks xmlns:a="http://schemas.openxmlformats.org/drawingml/2006/main" noGrp="1"/>
+          </p:cNvSpPr>
+          <p:nvPr/>
+        </p:nvSpPr>
+        <p:spPr>
+          <a:xfrm xmlns:a="http://schemas.openxmlformats.org/drawingml/2006/main">
+            <a:off x="10134600" y="6429375"/>
+            <a:ext cx="228600" cy="190500"/>
           </a:xfrm>
           <a:prstGeom xmlns:a="http://schemas.openxmlformats.org/drawingml/2006/main" prst="rect">
             <a:avLst/>
@@ -5055,7 +5055,7 @@
           </a:bodyPr>
           <a:lstStyle xmlns:a="http://schemas.openxmlformats.org/drawingml/2006/main">
             <a:defPPr algn="l">
-              <a:defRPr sz="825" b="0">
+              <a:defRPr sz="900" b="0">
                 <a:solidFill>
                   <a:srgbClr val="858B7E"/>
                 </a:solidFill>
@@ -5067,7 +5067,7 @@
           </a:lstStyle>
           <a:p xmlns:a="http://schemas.openxmlformats.org/drawingml/2006/main">
             <a:pPr algn="l">
-              <a:defRPr sz="825" b="0">
+              <a:defRPr sz="900" b="0">
                 <a:solidFill>
                   <a:srgbClr val="858B7E"/>
                 </a:solidFill>
@@ -5077,7 +5077,7 @@
               </a:defRPr>
             </a:pPr>
             <a:r>
-              <a:rPr sz="825" b="0">
+              <a:rPr sz="900" b="0">
                 <a:solidFill>
                   <a:srgbClr val="858B7E"/>
                 </a:solidFill>
@@ -5093,7 +5093,7 @@
     </p:spTree>
     <p:extLst>
       <p:ext uri="{BB962C8B-B14F-4D97-AF65-F5344CB8AC3E}">
-        <p14:creationId xmlns:p14="http://schemas.microsoft.com/office/powerpoint/2010/main" val="384130213"/>
+        <p14:creationId xmlns:p14="http://schemas.microsoft.com/office/powerpoint/2010/main" val="95319808"/>
       </p:ext>
     </p:extLst>
   </p:cSld>
@@ -5124,19 +5124,19 @@
           <p:cNvPr id="6" name="">
             <a:extLst xmlns:a="http://schemas.openxmlformats.org/drawingml/2006/main">
               <a:ext uri="{FF2B5EF4-FFF2-40B4-BE49-F238E27FC236}">
-                <a16:creationId xmlns:a16="http://schemas.microsoft.com/office/drawing/2014/main" id="{DDB168A0-DD97-4756-9201-9A459B89C2F2}"/>
-              </a:ext>
-            </a:extLst>
-          </p:cNvPr>
-          <p:cNvSpPr>
-            <a:spLocks xmlns:a="http://schemas.openxmlformats.org/drawingml/2006/main" noGrp="1"/>
-          </p:cNvSpPr>
-          <p:nvPr/>
-        </p:nvSpPr>
-        <p:spPr>
-          <a:xfrm xmlns:a="http://schemas.openxmlformats.org/drawingml/2006/main">
-            <a:off x="914400" y="133350"/>
-            <a:ext cx="10363200" cy="152400"/>
+                <a16:creationId xmlns:a16="http://schemas.microsoft.com/office/drawing/2014/main" id="{74B2A987-EE4F-45DB-8C6E-90EB2C79B4E5}"/>
+              </a:ext>
+            </a:extLst>
+          </p:cNvPr>
+          <p:cNvSpPr>
+            <a:spLocks xmlns:a="http://schemas.openxmlformats.org/drawingml/2006/main" noGrp="1"/>
+          </p:cNvSpPr>
+          <p:nvPr/>
+        </p:nvSpPr>
+        <p:spPr>
+          <a:xfrm xmlns:a="http://schemas.openxmlformats.org/drawingml/2006/main">
+            <a:off x="1828800" y="457200"/>
+            <a:ext cx="8534400" cy="171450"/>
           </a:xfrm>
           <a:prstGeom xmlns:a="http://schemas.openxmlformats.org/drawingml/2006/main" prst="rect">
             <a:avLst/>
@@ -5152,7 +5152,7 @@
           </a:bodyPr>
           <a:lstStyle xmlns:a="http://schemas.openxmlformats.org/drawingml/2006/main">
             <a:defPPr algn="l">
-              <a:defRPr sz="825" b="1">
+              <a:defRPr sz="900" b="1">
                 <a:solidFill>
                   <a:srgbClr val="9B7744"/>
                 </a:solidFill>
@@ -5164,7 +5164,7 @@
           </a:lstStyle>
           <a:p xmlns:a="http://schemas.openxmlformats.org/drawingml/2006/main">
             <a:pPr algn="l">
-              <a:defRPr sz="825" b="1">
+              <a:defRPr sz="900" b="1">
                 <a:solidFill>
                   <a:srgbClr val="9B7744"/>
                 </a:solidFill>
@@ -5174,7 +5174,7 @@
               </a:defRPr>
             </a:pPr>
             <a:r>
-              <a:rPr sz="825" b="1">
+              <a:rPr sz="900" b="1">
                 <a:solidFill>
                   <a:srgbClr val="9B7744"/>
                 </a:solidFill>
@@ -5192,19 +5192,19 @@
           <p:cNvPr id="2" name="">
             <a:extLst xmlns:a="http://schemas.openxmlformats.org/drawingml/2006/main">
               <a:ext uri="{FF2B5EF4-FFF2-40B4-BE49-F238E27FC236}">
-                <a16:creationId xmlns:a16="http://schemas.microsoft.com/office/drawing/2014/main" id="{C7F8D385-9418-4980-B60A-251723390303}"/>
-              </a:ext>
-            </a:extLst>
-          </p:cNvPr>
-          <p:cNvSpPr>
-            <a:spLocks xmlns:a="http://schemas.openxmlformats.org/drawingml/2006/main" noGrp="1"/>
-          </p:cNvSpPr>
-          <p:nvPr/>
-        </p:nvSpPr>
-        <p:spPr>
-          <a:xfrm xmlns:a="http://schemas.openxmlformats.org/drawingml/2006/main">
-            <a:off x="914400" y="304800"/>
-            <a:ext cx="10363200" cy="381000"/>
+                <a16:creationId xmlns:a16="http://schemas.microsoft.com/office/drawing/2014/main" id="{DB0AA016-F50C-4944-97EA-00E5CCDD7467}"/>
+              </a:ext>
+            </a:extLst>
+          </p:cNvPr>
+          <p:cNvSpPr>
+            <a:spLocks xmlns:a="http://schemas.openxmlformats.org/drawingml/2006/main" noGrp="1"/>
+          </p:cNvSpPr>
+          <p:nvPr/>
+        </p:nvSpPr>
+        <p:spPr>
+          <a:xfrm xmlns:a="http://schemas.openxmlformats.org/drawingml/2006/main">
+            <a:off x="1828800" y="723900"/>
+            <a:ext cx="8534400" cy="419100"/>
           </a:xfrm>
           <a:prstGeom xmlns:a="http://schemas.openxmlformats.org/drawingml/2006/main" prst="rect">
             <a:avLst/>
@@ -5220,7 +5220,7 @@
           </a:bodyPr>
           <a:lstStyle xmlns:a="http://schemas.openxmlformats.org/drawingml/2006/main">
             <a:defPPr algn="l">
-              <a:defRPr sz="2250" b="1">
+              <a:defRPr sz="2550" b="1">
                 <a:solidFill>
                   <a:srgbClr val="1B1D19"/>
                 </a:solidFill>
@@ -5232,7 +5232,7 @@
           </a:lstStyle>
           <a:p xmlns:a="http://schemas.openxmlformats.org/drawingml/2006/main">
             <a:pPr algn="l">
-              <a:defRPr sz="2250" b="1">
+              <a:defRPr sz="2550" b="1">
                 <a:solidFill>
                   <a:srgbClr val="1B1D19"/>
                 </a:solidFill>
@@ -5242,7 +5242,7 @@
               </a:defRPr>
             </a:pPr>
             <a:r>
-              <a:rPr sz="2250" b="1">
+              <a:rPr sz="2550" b="1">
                 <a:solidFill>
                   <a:srgbClr val="1B1D19"/>
                 </a:solidFill>
@@ -5260,19 +5260,19 @@
           <p:cNvPr id="3" name="">
             <a:extLst xmlns:a="http://schemas.openxmlformats.org/drawingml/2006/main">
               <a:ext uri="{FF2B5EF4-FFF2-40B4-BE49-F238E27FC236}">
-                <a16:creationId xmlns:a16="http://schemas.microsoft.com/office/drawing/2014/main" id="{B204A2F5-FB8D-4536-9078-E12CC311D752}"/>
-              </a:ext>
-            </a:extLst>
-          </p:cNvPr>
-          <p:cNvSpPr>
-            <a:spLocks xmlns:a="http://schemas.openxmlformats.org/drawingml/2006/main" noGrp="1"/>
-          </p:cNvSpPr>
-          <p:nvPr/>
-        </p:nvSpPr>
-        <p:spPr>
-          <a:xfrm xmlns:a="http://schemas.openxmlformats.org/drawingml/2006/main">
-            <a:off x="914400" y="723900"/>
-            <a:ext cx="10363200" cy="5829300"/>
+                <a16:creationId xmlns:a16="http://schemas.microsoft.com/office/drawing/2014/main" id="{24073A16-2AD2-46E9-B8AA-D33D14D48564}"/>
+              </a:ext>
+            </a:extLst>
+          </p:cNvPr>
+          <p:cNvSpPr>
+            <a:spLocks xmlns:a="http://schemas.openxmlformats.org/drawingml/2006/main" noGrp="1"/>
+          </p:cNvSpPr>
+          <p:nvPr/>
+        </p:nvSpPr>
+        <p:spPr>
+          <a:xfrm xmlns:a="http://schemas.openxmlformats.org/drawingml/2006/main">
+            <a:off x="1828800" y="1333500"/>
+            <a:ext cx="8534400" cy="4800600"/>
           </a:xfrm>
           <a:prstGeom xmlns:a="http://schemas.openxmlformats.org/drawingml/2006/main" prst="rect">
             <a:avLst/>
@@ -5290,19 +5290,19 @@
           <p:cNvPr id="4" name="">
             <a:extLst xmlns:a="http://schemas.openxmlformats.org/drawingml/2006/main">
               <a:ext uri="{FF2B5EF4-FFF2-40B4-BE49-F238E27FC236}">
-                <a16:creationId xmlns:a16="http://schemas.microsoft.com/office/drawing/2014/main" id="{62EB008C-B53B-4AD4-B7BE-5E6CB45CFFE4}"/>
-              </a:ext>
-            </a:extLst>
-          </p:cNvPr>
-          <p:cNvSpPr>
-            <a:spLocks xmlns:a="http://schemas.openxmlformats.org/drawingml/2006/main" noGrp="1"/>
-          </p:cNvSpPr>
-          <p:nvPr/>
-        </p:nvSpPr>
-        <p:spPr>
-          <a:xfrm xmlns:a="http://schemas.openxmlformats.org/drawingml/2006/main">
-            <a:off x="914400" y="6667500"/>
-            <a:ext cx="9525000" cy="152400"/>
+                <a16:creationId xmlns:a16="http://schemas.microsoft.com/office/drawing/2014/main" id="{FE38BE1E-6866-4976-8DC4-E79F2EB56B93}"/>
+              </a:ext>
+            </a:extLst>
+          </p:cNvPr>
+          <p:cNvSpPr>
+            <a:spLocks xmlns:a="http://schemas.openxmlformats.org/drawingml/2006/main" noGrp="1"/>
+          </p:cNvSpPr>
+          <p:nvPr/>
+        </p:nvSpPr>
+        <p:spPr>
+          <a:xfrm xmlns:a="http://schemas.openxmlformats.org/drawingml/2006/main">
+            <a:off x="1828800" y="6429375"/>
+            <a:ext cx="7620000" cy="190500"/>
           </a:xfrm>
           <a:prstGeom xmlns:a="http://schemas.openxmlformats.org/drawingml/2006/main" prst="rect">
             <a:avLst/>
@@ -5318,7 +5318,7 @@
           </a:bodyPr>
           <a:lstStyle xmlns:a="http://schemas.openxmlformats.org/drawingml/2006/main">
             <a:defPPr algn="l">
-              <a:defRPr sz="825" b="0">
+              <a:defRPr sz="900" b="0">
                 <a:solidFill>
                   <a:srgbClr val="858B7E"/>
                 </a:solidFill>
@@ -5330,7 +5330,7 @@
           </a:lstStyle>
           <a:p xmlns:a="http://schemas.openxmlformats.org/drawingml/2006/main">
             <a:pPr algn="l">
-              <a:defRPr sz="825" b="0">
+              <a:defRPr sz="900" b="0">
                 <a:solidFill>
                   <a:srgbClr val="858B7E"/>
                 </a:solidFill>
@@ -5340,7 +5340,7 @@
               </a:defRPr>
             </a:pPr>
             <a:r>
-              <a:rPr sz="825" b="0">
+              <a:rPr sz="900" b="0">
                 <a:solidFill>
                   <a:srgbClr val="858B7E"/>
                 </a:solidFill>
@@ -5358,19 +5358,19 @@
           <p:cNvPr id="5" name="">
             <a:extLst xmlns:a="http://schemas.openxmlformats.org/drawingml/2006/main">
               <a:ext uri="{FF2B5EF4-FFF2-40B4-BE49-F238E27FC236}">
-                <a16:creationId xmlns:a16="http://schemas.microsoft.com/office/drawing/2014/main" id="{6196C79B-91D5-43E8-B155-1B9D9C3718E7}"/>
-              </a:ext>
-            </a:extLst>
-          </p:cNvPr>
-          <p:cNvSpPr>
-            <a:spLocks xmlns:a="http://schemas.openxmlformats.org/drawingml/2006/main" noGrp="1"/>
-          </p:cNvSpPr>
-          <p:nvPr/>
-        </p:nvSpPr>
-        <p:spPr>
-          <a:xfrm xmlns:a="http://schemas.openxmlformats.org/drawingml/2006/main">
-            <a:off x="11049000" y="6667500"/>
-            <a:ext cx="228600" cy="152400"/>
+                <a16:creationId xmlns:a16="http://schemas.microsoft.com/office/drawing/2014/main" id="{F31726C8-ACF6-408C-8D3C-9C1F74766A6C}"/>
+              </a:ext>
+            </a:extLst>
+          </p:cNvPr>
+          <p:cNvSpPr>
+            <a:spLocks xmlns:a="http://schemas.openxmlformats.org/drawingml/2006/main" noGrp="1"/>
+          </p:cNvSpPr>
+          <p:nvPr/>
+        </p:nvSpPr>
+        <p:spPr>
+          <a:xfrm xmlns:a="http://schemas.openxmlformats.org/drawingml/2006/main">
+            <a:off x="10134600" y="6429375"/>
+            <a:ext cx="228600" cy="190500"/>
           </a:xfrm>
           <a:prstGeom xmlns:a="http://schemas.openxmlformats.org/drawingml/2006/main" prst="rect">
             <a:avLst/>
@@ -5386,7 +5386,7 @@
           </a:bodyPr>
           <a:lstStyle xmlns:a="http://schemas.openxmlformats.org/drawingml/2006/main">
             <a:defPPr algn="l">
-              <a:defRPr sz="825" b="0">
+              <a:defRPr sz="900" b="0">
                 <a:solidFill>
                   <a:srgbClr val="858B7E"/>
                 </a:solidFill>
@@ -5398,7 +5398,7 @@
           </a:lstStyle>
           <a:p xmlns:a="http://schemas.openxmlformats.org/drawingml/2006/main">
             <a:pPr algn="l">
-              <a:defRPr sz="825" b="0">
+              <a:defRPr sz="900" b="0">
                 <a:solidFill>
                   <a:srgbClr val="858B7E"/>
                 </a:solidFill>
@@ -5408,7 +5408,7 @@
               </a:defRPr>
             </a:pPr>
             <a:r>
-              <a:rPr sz="825" b="0">
+              <a:rPr sz="900" b="0">
                 <a:solidFill>
                   <a:srgbClr val="858B7E"/>
                 </a:solidFill>
@@ -5424,7 +5424,7 @@
     </p:spTree>
     <p:extLst>
       <p:ext uri="{BB962C8B-B14F-4D97-AF65-F5344CB8AC3E}">
-        <p14:creationId xmlns:p14="http://schemas.microsoft.com/office/powerpoint/2010/main" val="247606364"/>
+        <p14:creationId xmlns:p14="http://schemas.microsoft.com/office/powerpoint/2010/main" val="804000031"/>
       </p:ext>
     </p:extLst>
   </p:cSld>
@@ -5455,7 +5455,7 @@
           <p:cNvPr id="18" name="">
             <a:extLst xmlns:a="http://schemas.openxmlformats.org/drawingml/2006/main">
               <a:ext uri="{FF2B5EF4-FFF2-40B4-BE49-F238E27FC236}">
-                <a16:creationId xmlns:a16="http://schemas.microsoft.com/office/drawing/2014/main" id="{9F51E3ED-C361-49AD-AF9A-C2B4D40E5DDA}"/>
+                <a16:creationId xmlns:a16="http://schemas.microsoft.com/office/drawing/2014/main" id="{8E2E191D-7336-4DB9-B268-B7216A0A02AC}"/>
               </a:ext>
             </a:extLst>
           </p:cNvPr>
@@ -5523,7 +5523,7 @@
           <p:cNvPr id="2" name="">
             <a:extLst xmlns:a="http://schemas.openxmlformats.org/drawingml/2006/main">
               <a:ext uri="{FF2B5EF4-FFF2-40B4-BE49-F238E27FC236}">
-                <a16:creationId xmlns:a16="http://schemas.microsoft.com/office/drawing/2014/main" id="{50DA7D65-89F1-4DB8-AA5D-73483259F3FF}"/>
+                <a16:creationId xmlns:a16="http://schemas.microsoft.com/office/drawing/2014/main" id="{00F0782A-E1B0-4BF8-855C-18CF3C04CBF4}"/>
               </a:ext>
             </a:extLst>
           </p:cNvPr>
@@ -5591,7 +5591,7 @@
           <p:cNvPr id="3" name="">
             <a:extLst xmlns:a="http://schemas.openxmlformats.org/drawingml/2006/main">
               <a:ext uri="{FF2B5EF4-FFF2-40B4-BE49-F238E27FC236}">
-                <a16:creationId xmlns:a16="http://schemas.microsoft.com/office/drawing/2014/main" id="{DFAF3D75-F055-453A-B058-A7CC4D3CE0CE}"/>
+                <a16:creationId xmlns:a16="http://schemas.microsoft.com/office/drawing/2014/main" id="{7A44F1F8-80BE-4563-B110-6098E2C7FEC9}"/>
               </a:ext>
             </a:extLst>
           </p:cNvPr>
@@ -5621,7 +5621,7 @@
           <p:cNvPr id="4" name="">
             <a:extLst xmlns:a="http://schemas.openxmlformats.org/drawingml/2006/main">
               <a:ext uri="{FF2B5EF4-FFF2-40B4-BE49-F238E27FC236}">
-                <a16:creationId xmlns:a16="http://schemas.microsoft.com/office/drawing/2014/main" id="{E51E0B5D-4BDF-4E9A-9B7A-4CF06B5E439B}"/>
+                <a16:creationId xmlns:a16="http://schemas.microsoft.com/office/drawing/2014/main" id="{52A107B3-7E94-4B2E-8028-FEA1C35375C2}"/>
               </a:ext>
             </a:extLst>
           </p:cNvPr>
@@ -5689,7 +5689,7 @@
           <p:cNvPr id="5" name="">
             <a:extLst xmlns:a="http://schemas.openxmlformats.org/drawingml/2006/main">
               <a:ext uri="{FF2B5EF4-FFF2-40B4-BE49-F238E27FC236}">
-                <a16:creationId xmlns:a16="http://schemas.microsoft.com/office/drawing/2014/main" id="{CEF8BB61-C838-4230-A0D2-3FB76F295B35}"/>
+                <a16:creationId xmlns:a16="http://schemas.microsoft.com/office/drawing/2014/main" id="{F2DD27E2-F500-4ED8-9505-D276EBED520F}"/>
               </a:ext>
             </a:extLst>
           </p:cNvPr>
@@ -5757,7 +5757,7 @@
           <p:cNvPr id="6" name="">
             <a:extLst xmlns:a="http://schemas.openxmlformats.org/drawingml/2006/main">
               <a:ext uri="{FF2B5EF4-FFF2-40B4-BE49-F238E27FC236}">
-                <a16:creationId xmlns:a16="http://schemas.microsoft.com/office/drawing/2014/main" id="{546264C7-82C6-4786-A1DB-4954E4E9C0D8}"/>
+                <a16:creationId xmlns:a16="http://schemas.microsoft.com/office/drawing/2014/main" id="{CAD8330C-0DD1-4ABE-B4EE-6E3337FD0532}"/>
               </a:ext>
             </a:extLst>
           </p:cNvPr>
@@ -5825,7 +5825,7 @@
           <p:cNvPr id="7" name="">
             <a:extLst xmlns:a="http://schemas.openxmlformats.org/drawingml/2006/main">
               <a:ext uri="{FF2B5EF4-FFF2-40B4-BE49-F238E27FC236}">
-                <a16:creationId xmlns:a16="http://schemas.microsoft.com/office/drawing/2014/main" id="{B4DEEF72-8D33-440E-BA15-B91BF8A5F9AC}"/>
+                <a16:creationId xmlns:a16="http://schemas.microsoft.com/office/drawing/2014/main" id="{95508963-195E-4724-88B5-109A29C127E8}"/>
               </a:ext>
             </a:extLst>
           </p:cNvPr>
@@ -5855,7 +5855,7 @@
           <p:cNvPr id="8" name="">
             <a:extLst xmlns:a="http://schemas.openxmlformats.org/drawingml/2006/main">
               <a:ext uri="{FF2B5EF4-FFF2-40B4-BE49-F238E27FC236}">
-                <a16:creationId xmlns:a16="http://schemas.microsoft.com/office/drawing/2014/main" id="{B528790F-E96E-48F2-B7B7-44B7E1E4059D}"/>
+                <a16:creationId xmlns:a16="http://schemas.microsoft.com/office/drawing/2014/main" id="{4CD120B8-024B-4F3F-8E96-0D14CD03A244}"/>
               </a:ext>
             </a:extLst>
           </p:cNvPr>
@@ -5923,7 +5923,7 @@
           <p:cNvPr id="9" name="">
             <a:extLst xmlns:a="http://schemas.openxmlformats.org/drawingml/2006/main">
               <a:ext uri="{FF2B5EF4-FFF2-40B4-BE49-F238E27FC236}">
-                <a16:creationId xmlns:a16="http://schemas.microsoft.com/office/drawing/2014/main" id="{2B63B1EE-6768-43E8-B348-BA6A8E6024A7}"/>
+                <a16:creationId xmlns:a16="http://schemas.microsoft.com/office/drawing/2014/main" id="{07C33146-4816-4067-9EF7-E7AB53EB7A82}"/>
               </a:ext>
             </a:extLst>
           </p:cNvPr>
@@ -5991,7 +5991,7 @@
           <p:cNvPr id="10" name="">
             <a:extLst xmlns:a="http://schemas.openxmlformats.org/drawingml/2006/main">
               <a:ext uri="{FF2B5EF4-FFF2-40B4-BE49-F238E27FC236}">
-                <a16:creationId xmlns:a16="http://schemas.microsoft.com/office/drawing/2014/main" id="{32BA2BFD-DD1C-4FAE-A279-1B7369E429E8}"/>
+                <a16:creationId xmlns:a16="http://schemas.microsoft.com/office/drawing/2014/main" id="{CB461150-9CC1-499B-AA2A-B28EFF322DC0}"/>
               </a:ext>
             </a:extLst>
           </p:cNvPr>
@@ -6059,7 +6059,7 @@
           <p:cNvPr id="11" name="">
             <a:extLst xmlns:a="http://schemas.openxmlformats.org/drawingml/2006/main">
               <a:ext uri="{FF2B5EF4-FFF2-40B4-BE49-F238E27FC236}">
-                <a16:creationId xmlns:a16="http://schemas.microsoft.com/office/drawing/2014/main" id="{96517E87-A4FF-4A03-B7AB-1316B1481CBA}"/>
+                <a16:creationId xmlns:a16="http://schemas.microsoft.com/office/drawing/2014/main" id="{690649BD-392F-463F-86E3-5773883AFD94}"/>
               </a:ext>
             </a:extLst>
           </p:cNvPr>
@@ -6089,7 +6089,7 @@
           <p:cNvPr id="12" name="">
             <a:extLst xmlns:a="http://schemas.openxmlformats.org/drawingml/2006/main">
               <a:ext uri="{FF2B5EF4-FFF2-40B4-BE49-F238E27FC236}">
-                <a16:creationId xmlns:a16="http://schemas.microsoft.com/office/drawing/2014/main" id="{E0DFB6FB-B0FA-4D3B-A474-D79685090E9F}"/>
+                <a16:creationId xmlns:a16="http://schemas.microsoft.com/office/drawing/2014/main" id="{259E8520-E7B6-4D97-A2DE-19756FA42662}"/>
               </a:ext>
             </a:extLst>
           </p:cNvPr>
@@ -6157,7 +6157,7 @@
           <p:cNvPr id="13" name="">
             <a:extLst xmlns:a="http://schemas.openxmlformats.org/drawingml/2006/main">
               <a:ext uri="{FF2B5EF4-FFF2-40B4-BE49-F238E27FC236}">
-                <a16:creationId xmlns:a16="http://schemas.microsoft.com/office/drawing/2014/main" id="{7C7097B9-6682-4C38-8690-DE412DCE9A6A}"/>
+                <a16:creationId xmlns:a16="http://schemas.microsoft.com/office/drawing/2014/main" id="{BB9DE631-044A-4A6C-9B29-9A078C9408B2}"/>
               </a:ext>
             </a:extLst>
           </p:cNvPr>
@@ -6225,7 +6225,7 @@
           <p:cNvPr id="14" name="">
             <a:extLst xmlns:a="http://schemas.openxmlformats.org/drawingml/2006/main">
               <a:ext uri="{FF2B5EF4-FFF2-40B4-BE49-F238E27FC236}">
-                <a16:creationId xmlns:a16="http://schemas.microsoft.com/office/drawing/2014/main" id="{513E2E82-7767-466B-8639-D664F71363CD}"/>
+                <a16:creationId xmlns:a16="http://schemas.microsoft.com/office/drawing/2014/main" id="{F44986BF-289E-4DE8-BA6B-CDD65566356D}"/>
               </a:ext>
             </a:extLst>
           </p:cNvPr>
@@ -6293,7 +6293,7 @@
           <p:cNvPr id="15" name="">
             <a:extLst xmlns:a="http://schemas.openxmlformats.org/drawingml/2006/main">
               <a:ext uri="{FF2B5EF4-FFF2-40B4-BE49-F238E27FC236}">
-                <a16:creationId xmlns:a16="http://schemas.microsoft.com/office/drawing/2014/main" id="{DB3425C6-2B53-4370-B744-4E38CCD26C9B}"/>
+                <a16:creationId xmlns:a16="http://schemas.microsoft.com/office/drawing/2014/main" id="{25F9D265-65A1-4CCF-90D3-64773DF0D9D8}"/>
               </a:ext>
             </a:extLst>
           </p:cNvPr>
@@ -6361,7 +6361,7 @@
           <p:cNvPr id="16" name="">
             <a:extLst xmlns:a="http://schemas.openxmlformats.org/drawingml/2006/main">
               <a:ext uri="{FF2B5EF4-FFF2-40B4-BE49-F238E27FC236}">
-                <a16:creationId xmlns:a16="http://schemas.microsoft.com/office/drawing/2014/main" id="{9D5B83D9-EAFC-4665-9E59-0312427DBB71}"/>
+                <a16:creationId xmlns:a16="http://schemas.microsoft.com/office/drawing/2014/main" id="{790F12B0-1BC2-4F42-AB62-0C81B88BB10F}"/>
               </a:ext>
             </a:extLst>
           </p:cNvPr>
@@ -6429,7 +6429,7 @@
           <p:cNvPr id="17" name="">
             <a:extLst xmlns:a="http://schemas.openxmlformats.org/drawingml/2006/main">
               <a:ext uri="{FF2B5EF4-FFF2-40B4-BE49-F238E27FC236}">
-                <a16:creationId xmlns:a16="http://schemas.microsoft.com/office/drawing/2014/main" id="{D6685A5A-49EA-4695-B4FE-28BBA3369A81}"/>
+                <a16:creationId xmlns:a16="http://schemas.microsoft.com/office/drawing/2014/main" id="{FF516406-1151-4153-9673-566EF769D978}"/>
               </a:ext>
             </a:extLst>
           </p:cNvPr>
@@ -6495,7 +6495,7 @@
     </p:spTree>
     <p:extLst>
       <p:ext uri="{BB962C8B-B14F-4D97-AF65-F5344CB8AC3E}">
-        <p14:creationId xmlns:p14="http://schemas.microsoft.com/office/powerpoint/2010/main" val="1731940605"/>
+        <p14:creationId xmlns:p14="http://schemas.microsoft.com/office/powerpoint/2010/main" val="15129173"/>
       </p:ext>
     </p:extLst>
   </p:cSld>
@@ -6526,7 +6526,7 @@
           <p:cNvPr id="11" name="">
             <a:extLst xmlns:a="http://schemas.openxmlformats.org/drawingml/2006/main">
               <a:ext uri="{FF2B5EF4-FFF2-40B4-BE49-F238E27FC236}">
-                <a16:creationId xmlns:a16="http://schemas.microsoft.com/office/drawing/2014/main" id="{A1123E88-B70D-4A4B-86F5-B7AC43968DD4}"/>
+                <a16:creationId xmlns:a16="http://schemas.microsoft.com/office/drawing/2014/main" id="{CC0A59E1-F940-4EF4-B1B0-03BFF727151F}"/>
               </a:ext>
             </a:extLst>
           </p:cNvPr>
@@ -6594,7 +6594,7 @@
           <p:cNvPr id="2" name="">
             <a:extLst xmlns:a="http://schemas.openxmlformats.org/drawingml/2006/main">
               <a:ext uri="{FF2B5EF4-FFF2-40B4-BE49-F238E27FC236}">
-                <a16:creationId xmlns:a16="http://schemas.microsoft.com/office/drawing/2014/main" id="{F1DAB37F-E3BA-4966-AA0E-92EDF6FCED7F}"/>
+                <a16:creationId xmlns:a16="http://schemas.microsoft.com/office/drawing/2014/main" id="{2E059704-BF9D-4476-A53F-9068E39A331F}"/>
               </a:ext>
             </a:extLst>
           </p:cNvPr>
@@ -6662,7 +6662,7 @@
           <p:cNvPr id="3" name="">
             <a:extLst xmlns:a="http://schemas.openxmlformats.org/drawingml/2006/main">
               <a:ext uri="{FF2B5EF4-FFF2-40B4-BE49-F238E27FC236}">
-                <a16:creationId xmlns:a16="http://schemas.microsoft.com/office/drawing/2014/main" id="{D8ABB487-3AC7-41AA-99BE-D6D296552729}"/>
+                <a16:creationId xmlns:a16="http://schemas.microsoft.com/office/drawing/2014/main" id="{A07F6238-F637-4181-9312-29F29E7756BB}"/>
               </a:ext>
             </a:extLst>
           </p:cNvPr>
@@ -6692,7 +6692,7 @@
           <p:cNvPr id="4" name="">
             <a:extLst xmlns:a="http://schemas.openxmlformats.org/drawingml/2006/main">
               <a:ext uri="{FF2B5EF4-FFF2-40B4-BE49-F238E27FC236}">
-                <a16:creationId xmlns:a16="http://schemas.microsoft.com/office/drawing/2014/main" id="{9D4844CD-6DDF-43B7-A819-E204A13C9D04}"/>
+                <a16:creationId xmlns:a16="http://schemas.microsoft.com/office/drawing/2014/main" id="{8B820A87-935E-46E2-969E-27889E520E15}"/>
               </a:ext>
             </a:extLst>
           </p:cNvPr>
@@ -6760,7 +6760,7 @@
           <p:cNvPr id="5" name="">
             <a:extLst xmlns:a="http://schemas.openxmlformats.org/drawingml/2006/main">
               <a:ext uri="{FF2B5EF4-FFF2-40B4-BE49-F238E27FC236}">
-                <a16:creationId xmlns:a16="http://schemas.microsoft.com/office/drawing/2014/main" id="{F0D0F480-55F0-4892-8818-B904556AA0B1}"/>
+                <a16:creationId xmlns:a16="http://schemas.microsoft.com/office/drawing/2014/main" id="{ECE39A4D-51E8-429F-AA98-4496C97E4BD6}"/>
               </a:ext>
             </a:extLst>
           </p:cNvPr>
@@ -6790,7 +6790,7 @@
           <p:cNvPr id="6" name="">
             <a:extLst xmlns:a="http://schemas.openxmlformats.org/drawingml/2006/main">
               <a:ext uri="{FF2B5EF4-FFF2-40B4-BE49-F238E27FC236}">
-                <a16:creationId xmlns:a16="http://schemas.microsoft.com/office/drawing/2014/main" id="{456334D7-46A8-4A0F-9697-87A4AC685A05}"/>
+                <a16:creationId xmlns:a16="http://schemas.microsoft.com/office/drawing/2014/main" id="{BBFCC4A0-9F04-4C02-A2EB-5560743EFDD0}"/>
               </a:ext>
             </a:extLst>
           </p:cNvPr>
@@ -6820,7 +6820,7 @@
           <p:cNvPr id="7" name="">
             <a:extLst xmlns:a="http://schemas.openxmlformats.org/drawingml/2006/main">
               <a:ext uri="{FF2B5EF4-FFF2-40B4-BE49-F238E27FC236}">
-                <a16:creationId xmlns:a16="http://schemas.microsoft.com/office/drawing/2014/main" id="{AE75F113-CE2D-48FC-9652-78865A925DF8}"/>
+                <a16:creationId xmlns:a16="http://schemas.microsoft.com/office/drawing/2014/main" id="{EAA19D5C-5856-4765-B56B-6AF065352750}"/>
               </a:ext>
             </a:extLst>
           </p:cNvPr>
@@ -6888,7 +6888,7 @@
           <p:cNvPr id="8" name="">
             <a:extLst xmlns:a="http://schemas.openxmlformats.org/drawingml/2006/main">
               <a:ext uri="{FF2B5EF4-FFF2-40B4-BE49-F238E27FC236}">
-                <a16:creationId xmlns:a16="http://schemas.microsoft.com/office/drawing/2014/main" id="{8F72D158-5B30-4584-B6CA-DDB96FC89495}"/>
+                <a16:creationId xmlns:a16="http://schemas.microsoft.com/office/drawing/2014/main" id="{C4ED762A-B297-481B-B723-4E6C8DEC40E6}"/>
               </a:ext>
             </a:extLst>
           </p:cNvPr>
@@ -6918,7 +6918,7 @@
           <p:cNvPr id="9" name="">
             <a:extLst xmlns:a="http://schemas.openxmlformats.org/drawingml/2006/main">
               <a:ext uri="{FF2B5EF4-FFF2-40B4-BE49-F238E27FC236}">
-                <a16:creationId xmlns:a16="http://schemas.microsoft.com/office/drawing/2014/main" id="{64995B6F-4E0F-4524-84D9-D20BA40CABB8}"/>
+                <a16:creationId xmlns:a16="http://schemas.microsoft.com/office/drawing/2014/main" id="{32299D4A-09D9-4ABE-9BB8-CF80FC91F088}"/>
               </a:ext>
             </a:extLst>
           </p:cNvPr>
@@ -6986,7 +6986,7 @@
           <p:cNvPr id="10" name="">
             <a:extLst xmlns:a="http://schemas.openxmlformats.org/drawingml/2006/main">
               <a:ext uri="{FF2B5EF4-FFF2-40B4-BE49-F238E27FC236}">
-                <a16:creationId xmlns:a16="http://schemas.microsoft.com/office/drawing/2014/main" id="{1EF514B7-4835-4769-9464-F3D4C5368C0E}"/>
+                <a16:creationId xmlns:a16="http://schemas.microsoft.com/office/drawing/2014/main" id="{A0DDCECE-C53C-47E9-8360-E925B12D2A8C}"/>
               </a:ext>
             </a:extLst>
           </p:cNvPr>
@@ -7052,7 +7052,7 @@
     </p:spTree>
     <p:extLst>
       <p:ext uri="{BB962C8B-B14F-4D97-AF65-F5344CB8AC3E}">
-        <p14:creationId xmlns:p14="http://schemas.microsoft.com/office/powerpoint/2010/main" val="2136088364"/>
+        <p14:creationId xmlns:p14="http://schemas.microsoft.com/office/powerpoint/2010/main" val="764470276"/>
       </p:ext>
     </p:extLst>
   </p:cSld>
@@ -7083,7 +7083,7 @@
           <p:cNvPr id="6" name="">
             <a:extLst xmlns:a="http://schemas.openxmlformats.org/drawingml/2006/main">
               <a:ext uri="{FF2B5EF4-FFF2-40B4-BE49-F238E27FC236}">
-                <a16:creationId xmlns:a16="http://schemas.microsoft.com/office/drawing/2014/main" id="{86D8B6E4-D899-463D-9BEC-1929FCFA89B8}"/>
+                <a16:creationId xmlns:a16="http://schemas.microsoft.com/office/drawing/2014/main" id="{EE0B2F49-F468-4FEA-B20B-856325D8C74D}"/>
               </a:ext>
             </a:extLst>
           </p:cNvPr>
@@ -7151,7 +7151,7 @@
           <p:cNvPr id="2" name="">
             <a:extLst xmlns:a="http://schemas.openxmlformats.org/drawingml/2006/main">
               <a:ext uri="{FF2B5EF4-FFF2-40B4-BE49-F238E27FC236}">
-                <a16:creationId xmlns:a16="http://schemas.microsoft.com/office/drawing/2014/main" id="{EDF8CBBD-9CFE-4220-8F6B-1C192CB43CEC}"/>
+                <a16:creationId xmlns:a16="http://schemas.microsoft.com/office/drawing/2014/main" id="{E75D2108-A3E5-40EE-892B-58730E6B8201}"/>
               </a:ext>
             </a:extLst>
           </p:cNvPr>
@@ -7219,7 +7219,7 @@
           <p:cNvPr id="3" name="">
             <a:extLst xmlns:a="http://schemas.openxmlformats.org/drawingml/2006/main">
               <a:ext uri="{FF2B5EF4-FFF2-40B4-BE49-F238E27FC236}">
-                <a16:creationId xmlns:a16="http://schemas.microsoft.com/office/drawing/2014/main" id="{4A396832-6E4C-45D7-85DA-E4315156AFB2}"/>
+                <a16:creationId xmlns:a16="http://schemas.microsoft.com/office/drawing/2014/main" id="{5FABFAE3-A340-40E6-A2D7-CA9D22E98F82}"/>
               </a:ext>
             </a:extLst>
           </p:cNvPr>
@@ -7287,7 +7287,7 @@
           <p:cNvPr id="4" name="">
             <a:extLst xmlns:a="http://schemas.openxmlformats.org/drawingml/2006/main">
               <a:ext uri="{FF2B5EF4-FFF2-40B4-BE49-F238E27FC236}">
-                <a16:creationId xmlns:a16="http://schemas.microsoft.com/office/drawing/2014/main" id="{050D5ACB-4128-4C59-A1F6-EBBCB66F7AD9}"/>
+                <a16:creationId xmlns:a16="http://schemas.microsoft.com/office/drawing/2014/main" id="{B6398BBC-1C37-438D-82DD-A6E7525B826A}"/>
               </a:ext>
             </a:extLst>
           </p:cNvPr>
@@ -7355,7 +7355,7 @@
           <p:cNvPr id="5" name="">
             <a:extLst xmlns:a="http://schemas.openxmlformats.org/drawingml/2006/main">
               <a:ext uri="{FF2B5EF4-FFF2-40B4-BE49-F238E27FC236}">
-                <a16:creationId xmlns:a16="http://schemas.microsoft.com/office/drawing/2014/main" id="{EC9C5626-B4DA-452D-A2CC-C536A0B6EEBE}"/>
+                <a16:creationId xmlns:a16="http://schemas.microsoft.com/office/drawing/2014/main" id="{F0CE5B8A-78B8-4DD4-8797-23EF34B40A02}"/>
               </a:ext>
             </a:extLst>
           </p:cNvPr>
@@ -7421,7 +7421,7 @@
     </p:spTree>
     <p:extLst>
       <p:ext uri="{BB962C8B-B14F-4D97-AF65-F5344CB8AC3E}">
-        <p14:creationId xmlns:p14="http://schemas.microsoft.com/office/powerpoint/2010/main" val="728180069"/>
+        <p14:creationId xmlns:p14="http://schemas.microsoft.com/office/powerpoint/2010/main" val="1241210312"/>
       </p:ext>
     </p:extLst>
   </p:cSld>
@@ -7452,7 +7452,7 @@
           <p:cNvPr id="7" name="">
             <a:extLst xmlns:a="http://schemas.openxmlformats.org/drawingml/2006/main">
               <a:ext uri="{FF2B5EF4-FFF2-40B4-BE49-F238E27FC236}">
-                <a16:creationId xmlns:a16="http://schemas.microsoft.com/office/drawing/2014/main" id="{4BE6C08D-6C82-403E-ACC9-6BC583AE4C76}"/>
+                <a16:creationId xmlns:a16="http://schemas.microsoft.com/office/drawing/2014/main" id="{58A07987-FA31-46EE-AD2B-86C93DDADC35}"/>
               </a:ext>
             </a:extLst>
           </p:cNvPr>
@@ -7520,7 +7520,7 @@
           <p:cNvPr id="2" name="">
             <a:extLst xmlns:a="http://schemas.openxmlformats.org/drawingml/2006/main">
               <a:ext uri="{FF2B5EF4-FFF2-40B4-BE49-F238E27FC236}">
-                <a16:creationId xmlns:a16="http://schemas.microsoft.com/office/drawing/2014/main" id="{2B099948-80AF-4755-BC9D-66D15834077E}"/>
+                <a16:creationId xmlns:a16="http://schemas.microsoft.com/office/drawing/2014/main" id="{3E7FFA0C-7B92-4CBB-8374-850A4E26E027}"/>
               </a:ext>
             </a:extLst>
           </p:cNvPr>
@@ -7588,7 +7588,7 @@
           <p:cNvPr id="3" name="">
             <a:extLst xmlns:a="http://schemas.openxmlformats.org/drawingml/2006/main">
               <a:ext uri="{FF2B5EF4-FFF2-40B4-BE49-F238E27FC236}">
-                <a16:creationId xmlns:a16="http://schemas.microsoft.com/office/drawing/2014/main" id="{6CEFE01A-78CA-410F-8C5F-0481E1475EEC}"/>
+                <a16:creationId xmlns:a16="http://schemas.microsoft.com/office/drawing/2014/main" id="{F8C1B830-670A-444A-88E5-8F0585E25BE8}"/>
               </a:ext>
             </a:extLst>
           </p:cNvPr>
@@ -7656,7 +7656,7 @@
           <p:cNvPr id="4" name="">
             <a:extLst xmlns:a="http://schemas.openxmlformats.org/drawingml/2006/main">
               <a:ext uri="{FF2B5EF4-FFF2-40B4-BE49-F238E27FC236}">
-                <a16:creationId xmlns:a16="http://schemas.microsoft.com/office/drawing/2014/main" id="{2259E8F4-6E42-43BC-8118-97B6128680FD}"/>
+                <a16:creationId xmlns:a16="http://schemas.microsoft.com/office/drawing/2014/main" id="{7F388E5D-873A-4070-8E11-BDDDBCFD3F30}"/>
               </a:ext>
             </a:extLst>
           </p:cNvPr>
@@ -7666,7 +7666,7 @@
           <p:nvPr/>
         </p:nvPicPr>
         <p:blipFill>
-          <a:blip xmlns:r="http://schemas.openxmlformats.org/officeDocument/2006/relationships" xmlns:a="http://schemas.openxmlformats.org/drawingml/2006/main" r:embed="R52df518727ce49a0"/>
+          <a:blip xmlns:r="http://schemas.openxmlformats.org/officeDocument/2006/relationships" xmlns:a="http://schemas.openxmlformats.org/drawingml/2006/main" r:embed="Reca161ab0c244313"/>
           <a:stretch xmlns:a="http://schemas.openxmlformats.org/drawingml/2006/main"/>
         </p:blipFill>
         <p:spPr>
@@ -7684,7 +7684,7 @@
           <p:cNvPr id="5" name="">
             <a:extLst xmlns:a="http://schemas.openxmlformats.org/drawingml/2006/main">
               <a:ext uri="{FF2B5EF4-FFF2-40B4-BE49-F238E27FC236}">
-                <a16:creationId xmlns:a16="http://schemas.microsoft.com/office/drawing/2014/main" id="{087CD8BF-47F1-438E-9CF4-618BDE953733}"/>
+                <a16:creationId xmlns:a16="http://schemas.microsoft.com/office/drawing/2014/main" id="{20D580E6-13FD-4339-BDCD-FB06996B0111}"/>
               </a:ext>
             </a:extLst>
           </p:cNvPr>
@@ -7752,7 +7752,7 @@
           <p:cNvPr id="6" name="">
             <a:extLst xmlns:a="http://schemas.openxmlformats.org/drawingml/2006/main">
               <a:ext uri="{FF2B5EF4-FFF2-40B4-BE49-F238E27FC236}">
-                <a16:creationId xmlns:a16="http://schemas.microsoft.com/office/drawing/2014/main" id="{C843C27F-B039-4F74-9515-AAC8F080CF78}"/>
+                <a16:creationId xmlns:a16="http://schemas.microsoft.com/office/drawing/2014/main" id="{1C9B47D2-32A3-4A13-A423-FC0EAF9B3D48}"/>
               </a:ext>
             </a:extLst>
           </p:cNvPr>
@@ -7818,7 +7818,7 @@
     </p:spTree>
     <p:extLst>
       <p:ext uri="{BB962C8B-B14F-4D97-AF65-F5344CB8AC3E}">
-        <p14:creationId xmlns:p14="http://schemas.microsoft.com/office/powerpoint/2010/main" val="504326415"/>
+        <p14:creationId xmlns:p14="http://schemas.microsoft.com/office/powerpoint/2010/main" val="331939671"/>
       </p:ext>
     </p:extLst>
   </p:cSld>
@@ -7849,7 +7849,7 @@
           <p:cNvPr id="14" name="">
             <a:extLst xmlns:a="http://schemas.openxmlformats.org/drawingml/2006/main">
               <a:ext uri="{FF2B5EF4-FFF2-40B4-BE49-F238E27FC236}">
-                <a16:creationId xmlns:a16="http://schemas.microsoft.com/office/drawing/2014/main" id="{38E66460-D960-4FD6-AF1A-05FD27E62860}"/>
+                <a16:creationId xmlns:a16="http://schemas.microsoft.com/office/drawing/2014/main" id="{157FCB24-9ECE-4CC6-B77F-61DA80B0C9C0}"/>
               </a:ext>
             </a:extLst>
           </p:cNvPr>
@@ -7917,7 +7917,7 @@
           <p:cNvPr id="2" name="">
             <a:extLst xmlns:a="http://schemas.openxmlformats.org/drawingml/2006/main">
               <a:ext uri="{FF2B5EF4-FFF2-40B4-BE49-F238E27FC236}">
-                <a16:creationId xmlns:a16="http://schemas.microsoft.com/office/drawing/2014/main" id="{053D07E6-0D77-49D4-8655-A5D66DC726AF}"/>
+                <a16:creationId xmlns:a16="http://schemas.microsoft.com/office/drawing/2014/main" id="{2CB66BA6-D414-491D-B8BD-C2E8155C467D}"/>
               </a:ext>
             </a:extLst>
           </p:cNvPr>
@@ -7985,7 +7985,7 @@
           <p:cNvPr id="3" name="">
             <a:extLst xmlns:a="http://schemas.openxmlformats.org/drawingml/2006/main">
               <a:ext uri="{FF2B5EF4-FFF2-40B4-BE49-F238E27FC236}">
-                <a16:creationId xmlns:a16="http://schemas.microsoft.com/office/drawing/2014/main" id="{D5120603-2723-4CCF-B04D-A738B462EED0}"/>
+                <a16:creationId xmlns:a16="http://schemas.microsoft.com/office/drawing/2014/main" id="{1487B246-56A2-4756-A1E9-D00536DAEEF9}"/>
               </a:ext>
             </a:extLst>
           </p:cNvPr>
@@ -8015,7 +8015,7 @@
           <p:cNvPr id="4" name="">
             <a:extLst xmlns:a="http://schemas.openxmlformats.org/drawingml/2006/main">
               <a:ext uri="{FF2B5EF4-FFF2-40B4-BE49-F238E27FC236}">
-                <a16:creationId xmlns:a16="http://schemas.microsoft.com/office/drawing/2014/main" id="{4AF922A0-9D52-4444-AE5B-62F1FF85F75E}"/>
+                <a16:creationId xmlns:a16="http://schemas.microsoft.com/office/drawing/2014/main" id="{0D9FF49B-A0E3-4832-8C84-B63B4826829E}"/>
               </a:ext>
             </a:extLst>
           </p:cNvPr>
@@ -8083,7 +8083,7 @@
           <p:cNvPr id="5" name="">
             <a:extLst xmlns:a="http://schemas.openxmlformats.org/drawingml/2006/main">
               <a:ext uri="{FF2B5EF4-FFF2-40B4-BE49-F238E27FC236}">
-                <a16:creationId xmlns:a16="http://schemas.microsoft.com/office/drawing/2014/main" id="{B9F66F0B-7F03-4279-97E6-FD6FD5BC5A29}"/>
+                <a16:creationId xmlns:a16="http://schemas.microsoft.com/office/drawing/2014/main" id="{667CD566-C71A-468D-B735-C5A253C28EF0}"/>
               </a:ext>
             </a:extLst>
           </p:cNvPr>
@@ -8174,7 +8174,7 @@
           <p:cNvPr id="6" name="">
             <a:extLst xmlns:a="http://schemas.openxmlformats.org/drawingml/2006/main">
               <a:ext uri="{FF2B5EF4-FFF2-40B4-BE49-F238E27FC236}">
-                <a16:creationId xmlns:a16="http://schemas.microsoft.com/office/drawing/2014/main" id="{C131F9FB-CB2C-4346-87ED-A2E80064C4C4}"/>
+                <a16:creationId xmlns:a16="http://schemas.microsoft.com/office/drawing/2014/main" id="{0396D9CF-F823-451E-A23F-A9B279FB8B03}"/>
               </a:ext>
             </a:extLst>
           </p:cNvPr>
@@ -8204,7 +8204,7 @@
           <p:cNvPr id="7" name="">
             <a:extLst xmlns:a="http://schemas.openxmlformats.org/drawingml/2006/main">
               <a:ext uri="{FF2B5EF4-FFF2-40B4-BE49-F238E27FC236}">
-                <a16:creationId xmlns:a16="http://schemas.microsoft.com/office/drawing/2014/main" id="{518BED8B-31C9-4E32-9DEF-BD91F7171781}"/>
+                <a16:creationId xmlns:a16="http://schemas.microsoft.com/office/drawing/2014/main" id="{5EEE11E7-CE6E-42D6-967B-5185AAA69249}"/>
               </a:ext>
             </a:extLst>
           </p:cNvPr>
@@ -8272,7 +8272,7 @@
           <p:cNvPr id="8" name="">
             <a:extLst xmlns:a="http://schemas.openxmlformats.org/drawingml/2006/main">
               <a:ext uri="{FF2B5EF4-FFF2-40B4-BE49-F238E27FC236}">
-                <a16:creationId xmlns:a16="http://schemas.microsoft.com/office/drawing/2014/main" id="{592B5856-E657-46D5-9AF8-8700A9968C0E}"/>
+                <a16:creationId xmlns:a16="http://schemas.microsoft.com/office/drawing/2014/main" id="{B5AA8221-C154-4224-B78F-AD42264C28F9}"/>
               </a:ext>
             </a:extLst>
           </p:cNvPr>
@@ -8340,7 +8340,7 @@
           <p:cNvPr id="9" name="">
             <a:extLst xmlns:a="http://schemas.openxmlformats.org/drawingml/2006/main">
               <a:ext uri="{FF2B5EF4-FFF2-40B4-BE49-F238E27FC236}">
-                <a16:creationId xmlns:a16="http://schemas.microsoft.com/office/drawing/2014/main" id="{D691A902-89BE-4757-900D-DFA32AC03D3F}"/>
+                <a16:creationId xmlns:a16="http://schemas.microsoft.com/office/drawing/2014/main" id="{FCF8B8B8-3DAC-4347-886F-66B7C4D66FCE}"/>
               </a:ext>
             </a:extLst>
           </p:cNvPr>
@@ -8370,7 +8370,7 @@
           <p:cNvPr id="10" name="">
             <a:extLst xmlns:a="http://schemas.openxmlformats.org/drawingml/2006/main">
               <a:ext uri="{FF2B5EF4-FFF2-40B4-BE49-F238E27FC236}">
-                <a16:creationId xmlns:a16="http://schemas.microsoft.com/office/drawing/2014/main" id="{D0B7B565-9841-4E4F-BCFD-57FB11A3C35B}"/>
+                <a16:creationId xmlns:a16="http://schemas.microsoft.com/office/drawing/2014/main" id="{83484EB4-504E-4742-99BC-9C5932E05F14}"/>
               </a:ext>
             </a:extLst>
           </p:cNvPr>
@@ -8380,7 +8380,7 @@
           <p:nvPr/>
         </p:nvPicPr>
         <p:blipFill>
-          <a:blip xmlns:r="http://schemas.openxmlformats.org/officeDocument/2006/relationships" xmlns:a="http://schemas.openxmlformats.org/drawingml/2006/main" r:embed="R385b817c7b724199"/>
+          <a:blip xmlns:r="http://schemas.openxmlformats.org/officeDocument/2006/relationships" xmlns:a="http://schemas.openxmlformats.org/drawingml/2006/main" r:embed="R27af8b4708104aed"/>
           <a:stretch xmlns:a="http://schemas.openxmlformats.org/drawingml/2006/main"/>
         </p:blipFill>
         <p:spPr>
@@ -8398,7 +8398,7 @@
           <p:cNvPr id="11" name="">
             <a:extLst xmlns:a="http://schemas.openxmlformats.org/drawingml/2006/main">
               <a:ext uri="{FF2B5EF4-FFF2-40B4-BE49-F238E27FC236}">
-                <a16:creationId xmlns:a16="http://schemas.microsoft.com/office/drawing/2014/main" id="{E0097F5D-3031-4628-A6FA-45208EDECCF4}"/>
+                <a16:creationId xmlns:a16="http://schemas.microsoft.com/office/drawing/2014/main" id="{6AF5FE8A-9DB5-400B-A150-5D92D850EF15}"/>
               </a:ext>
             </a:extLst>
           </p:cNvPr>
@@ -8466,7 +8466,7 @@
           <p:cNvPr id="12" name="">
             <a:extLst xmlns:a="http://schemas.openxmlformats.org/drawingml/2006/main">
               <a:ext uri="{FF2B5EF4-FFF2-40B4-BE49-F238E27FC236}">
-                <a16:creationId xmlns:a16="http://schemas.microsoft.com/office/drawing/2014/main" id="{99B51878-C20E-4EFA-A0A7-FDAA7EA65E10}"/>
+                <a16:creationId xmlns:a16="http://schemas.microsoft.com/office/drawing/2014/main" id="{AE2DAF32-A15C-455D-A1F9-AC6F44E5F558}"/>
               </a:ext>
             </a:extLst>
           </p:cNvPr>
@@ -8534,7 +8534,7 @@
           <p:cNvPr id="13" name="">
             <a:extLst xmlns:a="http://schemas.openxmlformats.org/drawingml/2006/main">
               <a:ext uri="{FF2B5EF4-FFF2-40B4-BE49-F238E27FC236}">
-                <a16:creationId xmlns:a16="http://schemas.microsoft.com/office/drawing/2014/main" id="{98461DB2-7223-4414-8994-D8CFC6F0DD27}"/>
+                <a16:creationId xmlns:a16="http://schemas.microsoft.com/office/drawing/2014/main" id="{52EE0DA4-2D05-4988-B71D-1CEA10F0981C}"/>
               </a:ext>
             </a:extLst>
           </p:cNvPr>
@@ -8600,7 +8600,7 @@
     </p:spTree>
     <p:extLst>
       <p:ext uri="{BB962C8B-B14F-4D97-AF65-F5344CB8AC3E}">
-        <p14:creationId xmlns:p14="http://schemas.microsoft.com/office/powerpoint/2010/main" val="1037200205"/>
+        <p14:creationId xmlns:p14="http://schemas.microsoft.com/office/powerpoint/2010/main" val="605529617"/>
       </p:ext>
     </p:extLst>
   </p:cSld>
@@ -8631,7 +8631,7 @@
           <p:cNvPr id="11" name="">
             <a:extLst xmlns:a="http://schemas.openxmlformats.org/drawingml/2006/main">
               <a:ext uri="{FF2B5EF4-FFF2-40B4-BE49-F238E27FC236}">
-                <a16:creationId xmlns:a16="http://schemas.microsoft.com/office/drawing/2014/main" id="{97088DFC-491C-4C1B-B12F-9897868B5D5F}"/>
+                <a16:creationId xmlns:a16="http://schemas.microsoft.com/office/drawing/2014/main" id="{6DAA0022-DD13-45D0-BC2F-A3449491DDB6}"/>
               </a:ext>
             </a:extLst>
           </p:cNvPr>
@@ -8699,7 +8699,7 @@
           <p:cNvPr id="2" name="">
             <a:extLst xmlns:a="http://schemas.openxmlformats.org/drawingml/2006/main">
               <a:ext uri="{FF2B5EF4-FFF2-40B4-BE49-F238E27FC236}">
-                <a16:creationId xmlns:a16="http://schemas.microsoft.com/office/drawing/2014/main" id="{8B1E144D-E2E1-4FA7-9C94-DF7F3DB9192A}"/>
+                <a16:creationId xmlns:a16="http://schemas.microsoft.com/office/drawing/2014/main" id="{FD65A820-9910-45C7-91CD-9E67BF6A7249}"/>
               </a:ext>
             </a:extLst>
           </p:cNvPr>
@@ -8767,7 +8767,7 @@
           <p:cNvPr id="3" name="">
             <a:extLst xmlns:a="http://schemas.openxmlformats.org/drawingml/2006/main">
               <a:ext uri="{FF2B5EF4-FFF2-40B4-BE49-F238E27FC236}">
-                <a16:creationId xmlns:a16="http://schemas.microsoft.com/office/drawing/2014/main" id="{13922CD8-6E45-4E8B-A6C6-65A49CE65506}"/>
+                <a16:creationId xmlns:a16="http://schemas.microsoft.com/office/drawing/2014/main" id="{EB4D8CB1-3846-4499-B8BE-42F6145757E6}"/>
               </a:ext>
             </a:extLst>
           </p:cNvPr>
@@ -8797,7 +8797,7 @@
           <p:cNvPr id="4" name="">
             <a:extLst xmlns:a="http://schemas.openxmlformats.org/drawingml/2006/main">
               <a:ext uri="{FF2B5EF4-FFF2-40B4-BE49-F238E27FC236}">
-                <a16:creationId xmlns:a16="http://schemas.microsoft.com/office/drawing/2014/main" id="{27B2692C-CF11-4478-AF4B-07E94610A8BD}"/>
+                <a16:creationId xmlns:a16="http://schemas.microsoft.com/office/drawing/2014/main" id="{0AAE86BB-D594-4513-A38A-5D650C72A329}"/>
               </a:ext>
             </a:extLst>
           </p:cNvPr>
@@ -8865,7 +8865,7 @@
           <p:cNvPr id="5" name="">
             <a:extLst xmlns:a="http://schemas.openxmlformats.org/drawingml/2006/main">
               <a:ext uri="{FF2B5EF4-FFF2-40B4-BE49-F238E27FC236}">
-                <a16:creationId xmlns:a16="http://schemas.microsoft.com/office/drawing/2014/main" id="{3D0A9FC0-BF32-46B2-8E32-C8A284B1D5A4}"/>
+                <a16:creationId xmlns:a16="http://schemas.microsoft.com/office/drawing/2014/main" id="{6B4A4FA4-56BF-4714-96BB-BB0B53819710}"/>
               </a:ext>
             </a:extLst>
           </p:cNvPr>
@@ -8956,7 +8956,7 @@
           <p:cNvPr id="6" name="">
             <a:extLst xmlns:a="http://schemas.openxmlformats.org/drawingml/2006/main">
               <a:ext uri="{FF2B5EF4-FFF2-40B4-BE49-F238E27FC236}">
-                <a16:creationId xmlns:a16="http://schemas.microsoft.com/office/drawing/2014/main" id="{1E185101-9405-4936-94C9-4B5E90C08E1E}"/>
+                <a16:creationId xmlns:a16="http://schemas.microsoft.com/office/drawing/2014/main" id="{C0F4BE7C-FD7B-482A-A32C-70636D43123A}"/>
               </a:ext>
             </a:extLst>
           </p:cNvPr>
@@ -8986,7 +8986,7 @@
           <p:cNvPr id="7" name="">
             <a:extLst xmlns:a="http://schemas.openxmlformats.org/drawingml/2006/main">
               <a:ext uri="{FF2B5EF4-FFF2-40B4-BE49-F238E27FC236}">
-                <a16:creationId xmlns:a16="http://schemas.microsoft.com/office/drawing/2014/main" id="{69D63C35-20E5-40F0-A997-AD988FE80E1D}"/>
+                <a16:creationId xmlns:a16="http://schemas.microsoft.com/office/drawing/2014/main" id="{248C4670-C6BD-4D18-A188-139076D79CD6}"/>
               </a:ext>
             </a:extLst>
           </p:cNvPr>
@@ -9054,7 +9054,7 @@
           <p:cNvPr id="8" name="">
             <a:extLst xmlns:a="http://schemas.openxmlformats.org/drawingml/2006/main">
               <a:ext uri="{FF2B5EF4-FFF2-40B4-BE49-F238E27FC236}">
-                <a16:creationId xmlns:a16="http://schemas.microsoft.com/office/drawing/2014/main" id="{FEEDFAC1-6D15-4661-8DEF-C181E89B8F4C}"/>
+                <a16:creationId xmlns:a16="http://schemas.microsoft.com/office/drawing/2014/main" id="{83D00A63-7BB0-4615-AB0E-F051FD514B3A}"/>
               </a:ext>
             </a:extLst>
           </p:cNvPr>
@@ -9145,7 +9145,7 @@
           <p:cNvPr id="9" name="">
             <a:extLst xmlns:a="http://schemas.openxmlformats.org/drawingml/2006/main">
               <a:ext uri="{FF2B5EF4-FFF2-40B4-BE49-F238E27FC236}">
-                <a16:creationId xmlns:a16="http://schemas.microsoft.com/office/drawing/2014/main" id="{453DB956-B5BE-4DA2-9DA0-EB4C25C1097B}"/>
+                <a16:creationId xmlns:a16="http://schemas.microsoft.com/office/drawing/2014/main" id="{8347B59C-6213-4935-B87C-3EE828B0E6BD}"/>
               </a:ext>
             </a:extLst>
           </p:cNvPr>
@@ -9213,7 +9213,7 @@
           <p:cNvPr id="10" name="">
             <a:extLst xmlns:a="http://schemas.openxmlformats.org/drawingml/2006/main">
               <a:ext uri="{FF2B5EF4-FFF2-40B4-BE49-F238E27FC236}">
-                <a16:creationId xmlns:a16="http://schemas.microsoft.com/office/drawing/2014/main" id="{450CA4F0-900B-463A-AD44-E21062968233}"/>
+                <a16:creationId xmlns:a16="http://schemas.microsoft.com/office/drawing/2014/main" id="{892E39E0-9977-44A7-844D-49B907D47EA3}"/>
               </a:ext>
             </a:extLst>
           </p:cNvPr>
@@ -9279,7 +9279,7 @@
     </p:spTree>
     <p:extLst>
       <p:ext uri="{BB962C8B-B14F-4D97-AF65-F5344CB8AC3E}">
-        <p14:creationId xmlns:p14="http://schemas.microsoft.com/office/powerpoint/2010/main" val="1012824638"/>
+        <p14:creationId xmlns:p14="http://schemas.microsoft.com/office/powerpoint/2010/main" val="275728463"/>
       </p:ext>
     </p:extLst>
   </p:cSld>
@@ -9310,7 +9310,7 @@
           <p:cNvPr id="11" name="">
             <a:extLst xmlns:a="http://schemas.openxmlformats.org/drawingml/2006/main">
               <a:ext uri="{FF2B5EF4-FFF2-40B4-BE49-F238E27FC236}">
-                <a16:creationId xmlns:a16="http://schemas.microsoft.com/office/drawing/2014/main" id="{6D91DBC3-70DD-45FB-BCE9-AC98EB1A4FD2}"/>
+                <a16:creationId xmlns:a16="http://schemas.microsoft.com/office/drawing/2014/main" id="{14E004C7-C6E1-4BD6-9BCA-F55709412F03}"/>
               </a:ext>
             </a:extLst>
           </p:cNvPr>
@@ -9378,7 +9378,7 @@
           <p:cNvPr id="2" name="">
             <a:extLst xmlns:a="http://schemas.openxmlformats.org/drawingml/2006/main">
               <a:ext uri="{FF2B5EF4-FFF2-40B4-BE49-F238E27FC236}">
-                <a16:creationId xmlns:a16="http://schemas.microsoft.com/office/drawing/2014/main" id="{66B622D6-7B65-4B56-846E-BC495CB377CB}"/>
+                <a16:creationId xmlns:a16="http://schemas.microsoft.com/office/drawing/2014/main" id="{E9BEA06B-D55C-4A00-BB7A-B5213116A4F8}"/>
               </a:ext>
             </a:extLst>
           </p:cNvPr>
@@ -9446,7 +9446,7 @@
           <p:cNvPr id="3" name="">
             <a:extLst xmlns:a="http://schemas.openxmlformats.org/drawingml/2006/main">
               <a:ext uri="{FF2B5EF4-FFF2-40B4-BE49-F238E27FC236}">
-                <a16:creationId xmlns:a16="http://schemas.microsoft.com/office/drawing/2014/main" id="{F8570920-3805-4AD8-A614-5E1B6C1061E1}"/>
+                <a16:creationId xmlns:a16="http://schemas.microsoft.com/office/drawing/2014/main" id="{5DAA0EDF-1A5E-4F0C-A552-E1200001E84B}"/>
               </a:ext>
             </a:extLst>
           </p:cNvPr>
@@ -9476,7 +9476,7 @@
           <p:cNvPr id="4" name="">
             <a:extLst xmlns:a="http://schemas.openxmlformats.org/drawingml/2006/main">
               <a:ext uri="{FF2B5EF4-FFF2-40B4-BE49-F238E27FC236}">
-                <a16:creationId xmlns:a16="http://schemas.microsoft.com/office/drawing/2014/main" id="{33ECA283-7AFF-40EB-9ECF-2FE06D45B665}"/>
+                <a16:creationId xmlns:a16="http://schemas.microsoft.com/office/drawing/2014/main" id="{7A6E07AB-4AFB-4263-8AFD-97D080608AF9}"/>
               </a:ext>
             </a:extLst>
           </p:cNvPr>
@@ -9544,7 +9544,7 @@
           <p:cNvPr id="5" name="">
             <a:extLst xmlns:a="http://schemas.openxmlformats.org/drawingml/2006/main">
               <a:ext uri="{FF2B5EF4-FFF2-40B4-BE49-F238E27FC236}">
-                <a16:creationId xmlns:a16="http://schemas.microsoft.com/office/drawing/2014/main" id="{A48954D0-F98C-4EAC-826C-272FC162DFC1}"/>
+                <a16:creationId xmlns:a16="http://schemas.microsoft.com/office/drawing/2014/main" id="{1A1A0C1A-19EE-4EE3-BD0A-0CB0C9173709}"/>
               </a:ext>
             </a:extLst>
           </p:cNvPr>
@@ -9704,7 +9704,7 @@
           <p:cNvPr id="6" name="">
             <a:extLst xmlns:a="http://schemas.openxmlformats.org/drawingml/2006/main">
               <a:ext uri="{FF2B5EF4-FFF2-40B4-BE49-F238E27FC236}">
-                <a16:creationId xmlns:a16="http://schemas.microsoft.com/office/drawing/2014/main" id="{2D922D43-6C29-4B84-A89F-F1ADCDCB7603}"/>
+                <a16:creationId xmlns:a16="http://schemas.microsoft.com/office/drawing/2014/main" id="{37E2BE41-1A97-407D-8BCE-8FF27289E5D5}"/>
               </a:ext>
             </a:extLst>
           </p:cNvPr>
@@ -9734,7 +9734,7 @@
           <p:cNvPr id="7" name="">
             <a:extLst xmlns:a="http://schemas.openxmlformats.org/drawingml/2006/main">
               <a:ext uri="{FF2B5EF4-FFF2-40B4-BE49-F238E27FC236}">
-                <a16:creationId xmlns:a16="http://schemas.microsoft.com/office/drawing/2014/main" id="{C0CF020E-7E4D-4792-AEC8-DC9CF0FEA54E}"/>
+                <a16:creationId xmlns:a16="http://schemas.microsoft.com/office/drawing/2014/main" id="{E68D699B-FFBF-4B98-8A63-F69952398C89}"/>
               </a:ext>
             </a:extLst>
           </p:cNvPr>
@@ -9802,7 +9802,7 @@
           <p:cNvPr id="8" name="">
             <a:extLst xmlns:a="http://schemas.openxmlformats.org/drawingml/2006/main">
               <a:ext uri="{FF2B5EF4-FFF2-40B4-BE49-F238E27FC236}">
-                <a16:creationId xmlns:a16="http://schemas.microsoft.com/office/drawing/2014/main" id="{DE4C9B48-39E8-4779-9661-1410F751C791}"/>
+                <a16:creationId xmlns:a16="http://schemas.microsoft.com/office/drawing/2014/main" id="{E0FBA711-1AB7-4525-8C13-CAE2FD7090A0}"/>
               </a:ext>
             </a:extLst>
           </p:cNvPr>
@@ -9962,7 +9962,7 @@
           <p:cNvPr id="9" name="">
             <a:extLst xmlns:a="http://schemas.openxmlformats.org/drawingml/2006/main">
               <a:ext uri="{FF2B5EF4-FFF2-40B4-BE49-F238E27FC236}">
-                <a16:creationId xmlns:a16="http://schemas.microsoft.com/office/drawing/2014/main" id="{1E5FD6B3-4CB6-4B2C-8988-3924317E7CAB}"/>
+                <a16:creationId xmlns:a16="http://schemas.microsoft.com/office/drawing/2014/main" id="{E5627766-1237-443B-8B59-6C1FCBD5AD28}"/>
               </a:ext>
             </a:extLst>
           </p:cNvPr>
@@ -10030,7 +10030,7 @@
           <p:cNvPr id="10" name="">
             <a:extLst xmlns:a="http://schemas.openxmlformats.org/drawingml/2006/main">
               <a:ext uri="{FF2B5EF4-FFF2-40B4-BE49-F238E27FC236}">
-                <a16:creationId xmlns:a16="http://schemas.microsoft.com/office/drawing/2014/main" id="{CA0DE3B4-DB18-4FAF-BB8A-5BB8894744C0}"/>
+                <a16:creationId xmlns:a16="http://schemas.microsoft.com/office/drawing/2014/main" id="{6CCFD999-051C-4A10-9EB2-D55006D3C819}"/>
               </a:ext>
             </a:extLst>
           </p:cNvPr>
@@ -10096,7 +10096,7 @@
     </p:spTree>
     <p:extLst>
       <p:ext uri="{BB962C8B-B14F-4D97-AF65-F5344CB8AC3E}">
-        <p14:creationId xmlns:p14="http://schemas.microsoft.com/office/powerpoint/2010/main" val="146394642"/>
+        <p14:creationId xmlns:p14="http://schemas.microsoft.com/office/powerpoint/2010/main" val="2115651475"/>
       </p:ext>
     </p:extLst>
   </p:cSld>
@@ -10127,7 +10127,7 @@
           <p:cNvPr id="11" name="">
             <a:extLst xmlns:a="http://schemas.openxmlformats.org/drawingml/2006/main">
               <a:ext uri="{FF2B5EF4-FFF2-40B4-BE49-F238E27FC236}">
-                <a16:creationId xmlns:a16="http://schemas.microsoft.com/office/drawing/2014/main" id="{480108A2-7549-4524-AFF7-A9A6E7B6655B}"/>
+                <a16:creationId xmlns:a16="http://schemas.microsoft.com/office/drawing/2014/main" id="{F62434EC-19DE-4D6A-AB3A-B19B1BD2DC0F}"/>
               </a:ext>
             </a:extLst>
           </p:cNvPr>
@@ -10195,7 +10195,7 @@
           <p:cNvPr id="2" name="">
             <a:extLst xmlns:a="http://schemas.openxmlformats.org/drawingml/2006/main">
               <a:ext uri="{FF2B5EF4-FFF2-40B4-BE49-F238E27FC236}">
-                <a16:creationId xmlns:a16="http://schemas.microsoft.com/office/drawing/2014/main" id="{698EB9C9-C471-4F33-A1DC-AE9DB1520AE6}"/>
+                <a16:creationId xmlns:a16="http://schemas.microsoft.com/office/drawing/2014/main" id="{C7CD4669-F803-4046-B6EB-814E74DE17B4}"/>
               </a:ext>
             </a:extLst>
           </p:cNvPr>
@@ -10263,7 +10263,7 @@
           <p:cNvPr id="3" name="">
             <a:extLst xmlns:a="http://schemas.openxmlformats.org/drawingml/2006/main">
               <a:ext uri="{FF2B5EF4-FFF2-40B4-BE49-F238E27FC236}">
-                <a16:creationId xmlns:a16="http://schemas.microsoft.com/office/drawing/2014/main" id="{B8C2AFC0-E7E2-43CF-82C5-BC06D00B4933}"/>
+                <a16:creationId xmlns:a16="http://schemas.microsoft.com/office/drawing/2014/main" id="{4B56667A-9038-4A0B-AD7F-2B1DB9C44175}"/>
               </a:ext>
             </a:extLst>
           </p:cNvPr>
@@ -10293,7 +10293,7 @@
           <p:cNvPr id="4" name="">
             <a:extLst xmlns:a="http://schemas.openxmlformats.org/drawingml/2006/main">
               <a:ext uri="{FF2B5EF4-FFF2-40B4-BE49-F238E27FC236}">
-                <a16:creationId xmlns:a16="http://schemas.microsoft.com/office/drawing/2014/main" id="{DFC190D2-5FCE-4557-A51C-11399A2DE072}"/>
+                <a16:creationId xmlns:a16="http://schemas.microsoft.com/office/drawing/2014/main" id="{88890DB3-F300-404C-8BDE-0835AB951771}"/>
               </a:ext>
             </a:extLst>
           </p:cNvPr>
@@ -10361,7 +10361,7 @@
           <p:cNvPr id="5" name="">
             <a:extLst xmlns:a="http://schemas.openxmlformats.org/drawingml/2006/main">
               <a:ext uri="{FF2B5EF4-FFF2-40B4-BE49-F238E27FC236}">
-                <a16:creationId xmlns:a16="http://schemas.microsoft.com/office/drawing/2014/main" id="{5D98D46A-C831-4456-AB42-B7A411BC6F66}"/>
+                <a16:creationId xmlns:a16="http://schemas.microsoft.com/office/drawing/2014/main" id="{E8008967-A486-4A1E-B234-964AF1E1EC2D}"/>
               </a:ext>
             </a:extLst>
           </p:cNvPr>
@@ -10452,7 +10452,7 @@
           <p:cNvPr id="6" name="">
             <a:extLst xmlns:a="http://schemas.openxmlformats.org/drawingml/2006/main">
               <a:ext uri="{FF2B5EF4-FFF2-40B4-BE49-F238E27FC236}">
-                <a16:creationId xmlns:a16="http://schemas.microsoft.com/office/drawing/2014/main" id="{2E98EC5C-4B3B-4F23-9E67-F1CD2BFA7C2A}"/>
+                <a16:creationId xmlns:a16="http://schemas.microsoft.com/office/drawing/2014/main" id="{DE1FE98F-6ED5-4843-ADC5-684446B07350}"/>
               </a:ext>
             </a:extLst>
           </p:cNvPr>
@@ -10482,7 +10482,7 @@
           <p:cNvPr id="7" name="">
             <a:extLst xmlns:a="http://schemas.openxmlformats.org/drawingml/2006/main">
               <a:ext uri="{FF2B5EF4-FFF2-40B4-BE49-F238E27FC236}">
-                <a16:creationId xmlns:a16="http://schemas.microsoft.com/office/drawing/2014/main" id="{7D934AD7-ACBD-4487-8D6E-2F46CCE2DB1A}"/>
+                <a16:creationId xmlns:a16="http://schemas.microsoft.com/office/drawing/2014/main" id="{4FBA10C6-9C2B-4E6E-B5DE-3A4FA01F2722}"/>
               </a:ext>
             </a:extLst>
           </p:cNvPr>
@@ -10550,7 +10550,7 @@
           <p:cNvPr id="8" name="">
             <a:extLst xmlns:a="http://schemas.openxmlformats.org/drawingml/2006/main">
               <a:ext uri="{FF2B5EF4-FFF2-40B4-BE49-F238E27FC236}">
-                <a16:creationId xmlns:a16="http://schemas.microsoft.com/office/drawing/2014/main" id="{B135813E-7B2E-4BB9-84C7-A293A04DE123}"/>
+                <a16:creationId xmlns:a16="http://schemas.microsoft.com/office/drawing/2014/main" id="{0354203E-E280-47F4-A7D1-41930245048A}"/>
               </a:ext>
             </a:extLst>
           </p:cNvPr>
@@ -10641,7 +10641,7 @@
           <p:cNvPr id="9" name="">
             <a:extLst xmlns:a="http://schemas.openxmlformats.org/drawingml/2006/main">
               <a:ext uri="{FF2B5EF4-FFF2-40B4-BE49-F238E27FC236}">
-                <a16:creationId xmlns:a16="http://schemas.microsoft.com/office/drawing/2014/main" id="{3817BD7F-11FB-46DF-ABBB-7E2DA8B28941}"/>
+                <a16:creationId xmlns:a16="http://schemas.microsoft.com/office/drawing/2014/main" id="{A0E806AB-2164-429B-9F32-4057998F2C72}"/>
               </a:ext>
             </a:extLst>
           </p:cNvPr>
@@ -10709,7 +10709,7 @@
           <p:cNvPr id="10" name="">
             <a:extLst xmlns:a="http://schemas.openxmlformats.org/drawingml/2006/main">
               <a:ext uri="{FF2B5EF4-FFF2-40B4-BE49-F238E27FC236}">
-                <a16:creationId xmlns:a16="http://schemas.microsoft.com/office/drawing/2014/main" id="{259A88A0-EF09-431F-9748-68D2EA2F8E3A}"/>
+                <a16:creationId xmlns:a16="http://schemas.microsoft.com/office/drawing/2014/main" id="{C62B9849-6BBE-4B2E-8AF3-FB699D0260AF}"/>
               </a:ext>
             </a:extLst>
           </p:cNvPr>
@@ -10775,7 +10775,7 @@
     </p:spTree>
     <p:extLst>
       <p:ext uri="{BB962C8B-B14F-4D97-AF65-F5344CB8AC3E}">
-        <p14:creationId xmlns:p14="http://schemas.microsoft.com/office/powerpoint/2010/main" val="2085656208"/>
+        <p14:creationId xmlns:p14="http://schemas.microsoft.com/office/powerpoint/2010/main" val="825767614"/>
       </p:ext>
     </p:extLst>
   </p:cSld>
@@ -10806,19 +10806,19 @@
           <p:cNvPr id="7" name="">
             <a:extLst xmlns:a="http://schemas.openxmlformats.org/drawingml/2006/main">
               <a:ext uri="{FF2B5EF4-FFF2-40B4-BE49-F238E27FC236}">
-                <a16:creationId xmlns:a16="http://schemas.microsoft.com/office/drawing/2014/main" id="{4837E0D5-B8BB-4876-8F42-CE56396E24EE}"/>
-              </a:ext>
-            </a:extLst>
-          </p:cNvPr>
-          <p:cNvSpPr>
-            <a:spLocks xmlns:a="http://schemas.openxmlformats.org/drawingml/2006/main" noGrp="1"/>
-          </p:cNvSpPr>
-          <p:nvPr/>
-        </p:nvSpPr>
-        <p:spPr>
-          <a:xfrm xmlns:a="http://schemas.openxmlformats.org/drawingml/2006/main">
-            <a:off x="914400" y="133350"/>
-            <a:ext cx="10363200" cy="152400"/>
+                <a16:creationId xmlns:a16="http://schemas.microsoft.com/office/drawing/2014/main" id="{2F2DDA7C-34D0-48F5-BD0E-5A0C67E967CF}"/>
+              </a:ext>
+            </a:extLst>
+          </p:cNvPr>
+          <p:cNvSpPr>
+            <a:spLocks xmlns:a="http://schemas.openxmlformats.org/drawingml/2006/main" noGrp="1"/>
+          </p:cNvSpPr>
+          <p:nvPr/>
+        </p:nvSpPr>
+        <p:spPr>
+          <a:xfrm xmlns:a="http://schemas.openxmlformats.org/drawingml/2006/main">
+            <a:off x="1828800" y="457200"/>
+            <a:ext cx="8534400" cy="171450"/>
           </a:xfrm>
           <a:prstGeom xmlns:a="http://schemas.openxmlformats.org/drawingml/2006/main" prst="rect">
             <a:avLst/>
@@ -10834,7 +10834,7 @@
           </a:bodyPr>
           <a:lstStyle xmlns:a="http://schemas.openxmlformats.org/drawingml/2006/main">
             <a:defPPr algn="l">
-              <a:defRPr sz="825" b="1">
+              <a:defRPr sz="900" b="1">
                 <a:solidFill>
                   <a:srgbClr val="9B7744"/>
                 </a:solidFill>
@@ -10846,7 +10846,7 @@
           </a:lstStyle>
           <a:p xmlns:a="http://schemas.openxmlformats.org/drawingml/2006/main">
             <a:pPr algn="l">
-              <a:defRPr sz="825" b="1">
+              <a:defRPr sz="900" b="1">
                 <a:solidFill>
                   <a:srgbClr val="9B7744"/>
                 </a:solidFill>
@@ -10856,7 +10856,7 @@
               </a:defRPr>
             </a:pPr>
             <a:r>
-              <a:rPr sz="825" b="1">
+              <a:rPr sz="900" b="1">
                 <a:solidFill>
                   <a:srgbClr val="9B7744"/>
                 </a:solidFill>
@@ -10874,19 +10874,19 @@
           <p:cNvPr id="2" name="">
             <a:extLst xmlns:a="http://schemas.openxmlformats.org/drawingml/2006/main">
               <a:ext uri="{FF2B5EF4-FFF2-40B4-BE49-F238E27FC236}">
-                <a16:creationId xmlns:a16="http://schemas.microsoft.com/office/drawing/2014/main" id="{ABB2C8B8-8AB4-487D-94D8-B44A3FE793A9}"/>
-              </a:ext>
-            </a:extLst>
-          </p:cNvPr>
-          <p:cNvSpPr>
-            <a:spLocks xmlns:a="http://schemas.openxmlformats.org/drawingml/2006/main" noGrp="1"/>
-          </p:cNvSpPr>
-          <p:nvPr/>
-        </p:nvSpPr>
-        <p:spPr>
-          <a:xfrm xmlns:a="http://schemas.openxmlformats.org/drawingml/2006/main">
-            <a:off x="914400" y="304800"/>
-            <a:ext cx="10363200" cy="381000"/>
+                <a16:creationId xmlns:a16="http://schemas.microsoft.com/office/drawing/2014/main" id="{D05EFA1F-34D2-44CB-B1BF-388071CB60E9}"/>
+              </a:ext>
+            </a:extLst>
+          </p:cNvPr>
+          <p:cNvSpPr>
+            <a:spLocks xmlns:a="http://schemas.openxmlformats.org/drawingml/2006/main" noGrp="1"/>
+          </p:cNvSpPr>
+          <p:nvPr/>
+        </p:nvSpPr>
+        <p:spPr>
+          <a:xfrm xmlns:a="http://schemas.openxmlformats.org/drawingml/2006/main">
+            <a:off x="1828800" y="723900"/>
+            <a:ext cx="8534400" cy="419100"/>
           </a:xfrm>
           <a:prstGeom xmlns:a="http://schemas.openxmlformats.org/drawingml/2006/main" prst="rect">
             <a:avLst/>
@@ -10902,7 +10902,7 @@
           </a:bodyPr>
           <a:lstStyle xmlns:a="http://schemas.openxmlformats.org/drawingml/2006/main">
             <a:defPPr algn="l">
-              <a:defRPr sz="2250" b="1">
+              <a:defRPr sz="2550" b="1">
                 <a:solidFill>
                   <a:srgbClr val="1B1D19"/>
                 </a:solidFill>
@@ -10914,7 +10914,7 @@
           </a:lstStyle>
           <a:p xmlns:a="http://schemas.openxmlformats.org/drawingml/2006/main">
             <a:pPr algn="l">
-              <a:defRPr sz="2250" b="1">
+              <a:defRPr sz="2550" b="1">
                 <a:solidFill>
                   <a:srgbClr val="1B1D19"/>
                 </a:solidFill>
@@ -10924,7 +10924,7 @@
               </a:defRPr>
             </a:pPr>
             <a:r>
-              <a:rPr sz="2250" b="1">
+              <a:rPr sz="2550" b="1">
                 <a:solidFill>
                   <a:srgbClr val="1B1D19"/>
                 </a:solidFill>
@@ -10942,19 +10942,19 @@
           <p:cNvPr id="3" name="">
             <a:extLst xmlns:a="http://schemas.openxmlformats.org/drawingml/2006/main">
               <a:ext uri="{FF2B5EF4-FFF2-40B4-BE49-F238E27FC236}">
-                <a16:creationId xmlns:a16="http://schemas.microsoft.com/office/drawing/2014/main" id="{55D1910B-8D13-496C-9DF2-6C29A628566D}"/>
-              </a:ext>
-            </a:extLst>
-          </p:cNvPr>
-          <p:cNvSpPr>
-            <a:spLocks xmlns:a="http://schemas.openxmlformats.org/drawingml/2006/main" noGrp="1"/>
-          </p:cNvSpPr>
-          <p:nvPr/>
-        </p:nvSpPr>
-        <p:spPr>
-          <a:xfrm xmlns:a="http://schemas.openxmlformats.org/drawingml/2006/main">
-            <a:off x="8039100" y="371475"/>
-            <a:ext cx="3238500" cy="266700"/>
+                <a16:creationId xmlns:a16="http://schemas.microsoft.com/office/drawing/2014/main" id="{C770D052-440D-4B96-AA54-5D56998571B8}"/>
+              </a:ext>
+            </a:extLst>
+          </p:cNvPr>
+          <p:cNvSpPr>
+            <a:spLocks xmlns:a="http://schemas.openxmlformats.org/drawingml/2006/main" noGrp="1"/>
+          </p:cNvSpPr>
+          <p:nvPr/>
+        </p:nvSpPr>
+        <p:spPr>
+          <a:xfrm xmlns:a="http://schemas.openxmlformats.org/drawingml/2006/main">
+            <a:off x="7410450" y="800100"/>
+            <a:ext cx="2952750" cy="266700"/>
           </a:xfrm>
           <a:prstGeom xmlns:a="http://schemas.openxmlformats.org/drawingml/2006/main" prst="rect">
             <a:avLst/>
@@ -11010,19 +11010,19 @@
           <p:cNvPr id="4" name="">
             <a:extLst xmlns:a="http://schemas.openxmlformats.org/drawingml/2006/main">
               <a:ext uri="{FF2B5EF4-FFF2-40B4-BE49-F238E27FC236}">
-                <a16:creationId xmlns:a16="http://schemas.microsoft.com/office/drawing/2014/main" id="{6FC27F45-32AF-4CE2-AD4B-6124173DBECF}"/>
-              </a:ext>
-            </a:extLst>
-          </p:cNvPr>
-          <p:cNvSpPr>
-            <a:spLocks xmlns:a="http://schemas.openxmlformats.org/drawingml/2006/main" noGrp="1"/>
-          </p:cNvSpPr>
-          <p:nvPr/>
-        </p:nvSpPr>
-        <p:spPr>
-          <a:xfrm xmlns:a="http://schemas.openxmlformats.org/drawingml/2006/main">
-            <a:off x="914400" y="723900"/>
-            <a:ext cx="10363200" cy="5829300"/>
+                <a16:creationId xmlns:a16="http://schemas.microsoft.com/office/drawing/2014/main" id="{B6407DEF-901D-45B7-B7A6-327DD30E3BED}"/>
+              </a:ext>
+            </a:extLst>
+          </p:cNvPr>
+          <p:cNvSpPr>
+            <a:spLocks xmlns:a="http://schemas.openxmlformats.org/drawingml/2006/main" noGrp="1"/>
+          </p:cNvSpPr>
+          <p:nvPr/>
+        </p:nvSpPr>
+        <p:spPr>
+          <a:xfrm xmlns:a="http://schemas.openxmlformats.org/drawingml/2006/main">
+            <a:off x="1828800" y="1333500"/>
+            <a:ext cx="8534400" cy="4800600"/>
           </a:xfrm>
           <a:prstGeom xmlns:a="http://schemas.openxmlformats.org/drawingml/2006/main" prst="rect">
             <a:avLst/>
@@ -11040,19 +11040,19 @@
           <p:cNvPr id="5" name="">
             <a:extLst xmlns:a="http://schemas.openxmlformats.org/drawingml/2006/main">
               <a:ext uri="{FF2B5EF4-FFF2-40B4-BE49-F238E27FC236}">
-                <a16:creationId xmlns:a16="http://schemas.microsoft.com/office/drawing/2014/main" id="{61C14C0D-0191-4F5F-B578-208910C2A4A1}"/>
-              </a:ext>
-            </a:extLst>
-          </p:cNvPr>
-          <p:cNvSpPr>
-            <a:spLocks xmlns:a="http://schemas.openxmlformats.org/drawingml/2006/main" noGrp="1"/>
-          </p:cNvSpPr>
-          <p:nvPr/>
-        </p:nvSpPr>
-        <p:spPr>
-          <a:xfrm xmlns:a="http://schemas.openxmlformats.org/drawingml/2006/main">
-            <a:off x="914400" y="6667500"/>
-            <a:ext cx="9525000" cy="152400"/>
+                <a16:creationId xmlns:a16="http://schemas.microsoft.com/office/drawing/2014/main" id="{DD19741D-EE05-4313-85B3-023F0B087C98}"/>
+              </a:ext>
+            </a:extLst>
+          </p:cNvPr>
+          <p:cNvSpPr>
+            <a:spLocks xmlns:a="http://schemas.openxmlformats.org/drawingml/2006/main" noGrp="1"/>
+          </p:cNvSpPr>
+          <p:nvPr/>
+        </p:nvSpPr>
+        <p:spPr>
+          <a:xfrm xmlns:a="http://schemas.openxmlformats.org/drawingml/2006/main">
+            <a:off x="1828800" y="6429375"/>
+            <a:ext cx="7620000" cy="190500"/>
           </a:xfrm>
           <a:prstGeom xmlns:a="http://schemas.openxmlformats.org/drawingml/2006/main" prst="rect">
             <a:avLst/>
@@ -11068,7 +11068,7 @@
           </a:bodyPr>
           <a:lstStyle xmlns:a="http://schemas.openxmlformats.org/drawingml/2006/main">
             <a:defPPr algn="l">
-              <a:defRPr sz="825" b="0">
+              <a:defRPr sz="900" b="0">
                 <a:solidFill>
                   <a:srgbClr val="858B7E"/>
                 </a:solidFill>
@@ -11080,7 +11080,7 @@
           </a:lstStyle>
           <a:p xmlns:a="http://schemas.openxmlformats.org/drawingml/2006/main">
             <a:pPr algn="l">
-              <a:defRPr sz="825" b="0">
+              <a:defRPr sz="900" b="0">
                 <a:solidFill>
                   <a:srgbClr val="858B7E"/>
                 </a:solidFill>
@@ -11090,7 +11090,7 @@
               </a:defRPr>
             </a:pPr>
             <a:r>
-              <a:rPr sz="825" b="0">
+              <a:rPr sz="900" b="0">
                 <a:solidFill>
                   <a:srgbClr val="858B7E"/>
                 </a:solidFill>
@@ -11108,19 +11108,19 @@
           <p:cNvPr id="6" name="">
             <a:extLst xmlns:a="http://schemas.openxmlformats.org/drawingml/2006/main">
               <a:ext uri="{FF2B5EF4-FFF2-40B4-BE49-F238E27FC236}">
-                <a16:creationId xmlns:a16="http://schemas.microsoft.com/office/drawing/2014/main" id="{AC33F3E4-8241-4FB4-A2BF-B543F0828B85}"/>
-              </a:ext>
-            </a:extLst>
-          </p:cNvPr>
-          <p:cNvSpPr>
-            <a:spLocks xmlns:a="http://schemas.openxmlformats.org/drawingml/2006/main" noGrp="1"/>
-          </p:cNvSpPr>
-          <p:nvPr/>
-        </p:nvSpPr>
-        <p:spPr>
-          <a:xfrm xmlns:a="http://schemas.openxmlformats.org/drawingml/2006/main">
-            <a:off x="11049000" y="6667500"/>
-            <a:ext cx="228600" cy="152400"/>
+                <a16:creationId xmlns:a16="http://schemas.microsoft.com/office/drawing/2014/main" id="{B6872958-A1BA-4EEB-B131-A94068731C2F}"/>
+              </a:ext>
+            </a:extLst>
+          </p:cNvPr>
+          <p:cNvSpPr>
+            <a:spLocks xmlns:a="http://schemas.openxmlformats.org/drawingml/2006/main" noGrp="1"/>
+          </p:cNvSpPr>
+          <p:nvPr/>
+        </p:nvSpPr>
+        <p:spPr>
+          <a:xfrm xmlns:a="http://schemas.openxmlformats.org/drawingml/2006/main">
+            <a:off x="10134600" y="6429375"/>
+            <a:ext cx="228600" cy="190500"/>
           </a:xfrm>
           <a:prstGeom xmlns:a="http://schemas.openxmlformats.org/drawingml/2006/main" prst="rect">
             <a:avLst/>
@@ -11136,7 +11136,7 @@
           </a:bodyPr>
           <a:lstStyle xmlns:a="http://schemas.openxmlformats.org/drawingml/2006/main">
             <a:defPPr algn="l">
-              <a:defRPr sz="825" b="0">
+              <a:defRPr sz="900" b="0">
                 <a:solidFill>
                   <a:srgbClr val="858B7E"/>
                 </a:solidFill>
@@ -11148,7 +11148,7 @@
           </a:lstStyle>
           <a:p xmlns:a="http://schemas.openxmlformats.org/drawingml/2006/main">
             <a:pPr algn="l">
-              <a:defRPr sz="825" b="0">
+              <a:defRPr sz="900" b="0">
                 <a:solidFill>
                   <a:srgbClr val="858B7E"/>
                 </a:solidFill>
@@ -11158,7 +11158,7 @@
               </a:defRPr>
             </a:pPr>
             <a:r>
-              <a:rPr sz="825" b="0">
+              <a:rPr sz="900" b="0">
                 <a:solidFill>
                   <a:srgbClr val="858B7E"/>
                 </a:solidFill>
@@ -11174,7 +11174,7 @@
     </p:spTree>
     <p:extLst>
       <p:ext uri="{BB962C8B-B14F-4D97-AF65-F5344CB8AC3E}">
-        <p14:creationId xmlns:p14="http://schemas.microsoft.com/office/powerpoint/2010/main" val="1335954805"/>
+        <p14:creationId xmlns:p14="http://schemas.microsoft.com/office/powerpoint/2010/main" val="1089519647"/>
       </p:ext>
     </p:extLst>
   </p:cSld>
@@ -11205,19 +11205,19 @@
           <p:cNvPr id="6" name="">
             <a:extLst xmlns:a="http://schemas.openxmlformats.org/drawingml/2006/main">
               <a:ext uri="{FF2B5EF4-FFF2-40B4-BE49-F238E27FC236}">
-                <a16:creationId xmlns:a16="http://schemas.microsoft.com/office/drawing/2014/main" id="{15E5453A-74CD-47C7-A5D9-A570EB39C765}"/>
-              </a:ext>
-            </a:extLst>
-          </p:cNvPr>
-          <p:cNvSpPr>
-            <a:spLocks xmlns:a="http://schemas.openxmlformats.org/drawingml/2006/main" noGrp="1"/>
-          </p:cNvSpPr>
-          <p:nvPr/>
-        </p:nvSpPr>
-        <p:spPr>
-          <a:xfrm xmlns:a="http://schemas.openxmlformats.org/drawingml/2006/main">
-            <a:off x="914400" y="133350"/>
-            <a:ext cx="10363200" cy="152400"/>
+                <a16:creationId xmlns:a16="http://schemas.microsoft.com/office/drawing/2014/main" id="{D2C2E6DC-5C34-4B41-BBF9-9A7526D22151}"/>
+              </a:ext>
+            </a:extLst>
+          </p:cNvPr>
+          <p:cNvSpPr>
+            <a:spLocks xmlns:a="http://schemas.openxmlformats.org/drawingml/2006/main" noGrp="1"/>
+          </p:cNvSpPr>
+          <p:nvPr/>
+        </p:nvSpPr>
+        <p:spPr>
+          <a:xfrm xmlns:a="http://schemas.openxmlformats.org/drawingml/2006/main">
+            <a:off x="1828800" y="457200"/>
+            <a:ext cx="8534400" cy="171450"/>
           </a:xfrm>
           <a:prstGeom xmlns:a="http://schemas.openxmlformats.org/drawingml/2006/main" prst="rect">
             <a:avLst/>
@@ -11233,7 +11233,7 @@
           </a:bodyPr>
           <a:lstStyle xmlns:a="http://schemas.openxmlformats.org/drawingml/2006/main">
             <a:defPPr algn="l">
-              <a:defRPr sz="825" b="1">
+              <a:defRPr sz="900" b="1">
                 <a:solidFill>
                   <a:srgbClr val="9B7744"/>
                 </a:solidFill>
@@ -11245,7 +11245,7 @@
           </a:lstStyle>
           <a:p xmlns:a="http://schemas.openxmlformats.org/drawingml/2006/main">
             <a:pPr algn="l">
-              <a:defRPr sz="825" b="1">
+              <a:defRPr sz="900" b="1">
                 <a:solidFill>
                   <a:srgbClr val="9B7744"/>
                 </a:solidFill>
@@ -11255,7 +11255,7 @@
               </a:defRPr>
             </a:pPr>
             <a:r>
-              <a:rPr sz="825" b="1">
+              <a:rPr sz="900" b="1">
                 <a:solidFill>
                   <a:srgbClr val="9B7744"/>
                 </a:solidFill>
@@ -11273,19 +11273,19 @@
           <p:cNvPr id="2" name="">
             <a:extLst xmlns:a="http://schemas.openxmlformats.org/drawingml/2006/main">
               <a:ext uri="{FF2B5EF4-FFF2-40B4-BE49-F238E27FC236}">
-                <a16:creationId xmlns:a16="http://schemas.microsoft.com/office/drawing/2014/main" id="{0C629D3C-F077-4085-9AF6-CCED921E85B2}"/>
-              </a:ext>
-            </a:extLst>
-          </p:cNvPr>
-          <p:cNvSpPr>
-            <a:spLocks xmlns:a="http://schemas.openxmlformats.org/drawingml/2006/main" noGrp="1"/>
-          </p:cNvSpPr>
-          <p:nvPr/>
-        </p:nvSpPr>
-        <p:spPr>
-          <a:xfrm xmlns:a="http://schemas.openxmlformats.org/drawingml/2006/main">
-            <a:off x="914400" y="304800"/>
-            <a:ext cx="10363200" cy="381000"/>
+                <a16:creationId xmlns:a16="http://schemas.microsoft.com/office/drawing/2014/main" id="{E0645EF8-1C29-4CE0-929E-B1BEECA0CB89}"/>
+              </a:ext>
+            </a:extLst>
+          </p:cNvPr>
+          <p:cNvSpPr>
+            <a:spLocks xmlns:a="http://schemas.openxmlformats.org/drawingml/2006/main" noGrp="1"/>
+          </p:cNvSpPr>
+          <p:nvPr/>
+        </p:nvSpPr>
+        <p:spPr>
+          <a:xfrm xmlns:a="http://schemas.openxmlformats.org/drawingml/2006/main">
+            <a:off x="1828800" y="723900"/>
+            <a:ext cx="8534400" cy="419100"/>
           </a:xfrm>
           <a:prstGeom xmlns:a="http://schemas.openxmlformats.org/drawingml/2006/main" prst="rect">
             <a:avLst/>
@@ -11301,7 +11301,7 @@
           </a:bodyPr>
           <a:lstStyle xmlns:a="http://schemas.openxmlformats.org/drawingml/2006/main">
             <a:defPPr algn="l">
-              <a:defRPr sz="2250" b="1">
+              <a:defRPr sz="2550" b="1">
                 <a:solidFill>
                   <a:srgbClr val="1B1D19"/>
                 </a:solidFill>
@@ -11313,7 +11313,7 @@
           </a:lstStyle>
           <a:p xmlns:a="http://schemas.openxmlformats.org/drawingml/2006/main">
             <a:pPr algn="l">
-              <a:defRPr sz="2250" b="1">
+              <a:defRPr sz="2550" b="1">
                 <a:solidFill>
                   <a:srgbClr val="1B1D19"/>
                 </a:solidFill>
@@ -11323,7 +11323,7 @@
               </a:defRPr>
             </a:pPr>
             <a:r>
-              <a:rPr sz="2250" b="1">
+              <a:rPr sz="2550" b="1">
                 <a:solidFill>
                   <a:srgbClr val="1B1D19"/>
                 </a:solidFill>
@@ -11341,19 +11341,19 @@
           <p:cNvPr id="3" name="">
             <a:extLst xmlns:a="http://schemas.openxmlformats.org/drawingml/2006/main">
               <a:ext uri="{FF2B5EF4-FFF2-40B4-BE49-F238E27FC236}">
-                <a16:creationId xmlns:a16="http://schemas.microsoft.com/office/drawing/2014/main" id="{1C835A2E-7974-4597-8652-AB10E2FD0840}"/>
-              </a:ext>
-            </a:extLst>
-          </p:cNvPr>
-          <p:cNvSpPr>
-            <a:spLocks xmlns:a="http://schemas.openxmlformats.org/drawingml/2006/main" noGrp="1"/>
-          </p:cNvSpPr>
-          <p:nvPr/>
-        </p:nvSpPr>
-        <p:spPr>
-          <a:xfrm xmlns:a="http://schemas.openxmlformats.org/drawingml/2006/main">
-            <a:off x="914400" y="723900"/>
-            <a:ext cx="10363200" cy="5829300"/>
+                <a16:creationId xmlns:a16="http://schemas.microsoft.com/office/drawing/2014/main" id="{C9C61C12-295B-45E6-8BA7-545739BCF4AB}"/>
+              </a:ext>
+            </a:extLst>
+          </p:cNvPr>
+          <p:cNvSpPr>
+            <a:spLocks xmlns:a="http://schemas.openxmlformats.org/drawingml/2006/main" noGrp="1"/>
+          </p:cNvSpPr>
+          <p:nvPr/>
+        </p:nvSpPr>
+        <p:spPr>
+          <a:xfrm xmlns:a="http://schemas.openxmlformats.org/drawingml/2006/main">
+            <a:off x="1828800" y="1333500"/>
+            <a:ext cx="8534400" cy="4800600"/>
           </a:xfrm>
           <a:prstGeom xmlns:a="http://schemas.openxmlformats.org/drawingml/2006/main" prst="rect">
             <a:avLst/>
@@ -11371,19 +11371,19 @@
           <p:cNvPr id="4" name="">
             <a:extLst xmlns:a="http://schemas.openxmlformats.org/drawingml/2006/main">
               <a:ext uri="{FF2B5EF4-FFF2-40B4-BE49-F238E27FC236}">
-                <a16:creationId xmlns:a16="http://schemas.microsoft.com/office/drawing/2014/main" id="{DC36C5BE-7D2A-4FD6-9F59-054D2A039D79}"/>
-              </a:ext>
-            </a:extLst>
-          </p:cNvPr>
-          <p:cNvSpPr>
-            <a:spLocks xmlns:a="http://schemas.openxmlformats.org/drawingml/2006/main" noGrp="1"/>
-          </p:cNvSpPr>
-          <p:nvPr/>
-        </p:nvSpPr>
-        <p:spPr>
-          <a:xfrm xmlns:a="http://schemas.openxmlformats.org/drawingml/2006/main">
-            <a:off x="914400" y="6667500"/>
-            <a:ext cx="9525000" cy="152400"/>
+                <a16:creationId xmlns:a16="http://schemas.microsoft.com/office/drawing/2014/main" id="{1DB46B4E-1899-4CE3-A433-0DD55D8B1082}"/>
+              </a:ext>
+            </a:extLst>
+          </p:cNvPr>
+          <p:cNvSpPr>
+            <a:spLocks xmlns:a="http://schemas.openxmlformats.org/drawingml/2006/main" noGrp="1"/>
+          </p:cNvSpPr>
+          <p:nvPr/>
+        </p:nvSpPr>
+        <p:spPr>
+          <a:xfrm xmlns:a="http://schemas.openxmlformats.org/drawingml/2006/main">
+            <a:off x="1828800" y="6429375"/>
+            <a:ext cx="7620000" cy="190500"/>
           </a:xfrm>
           <a:prstGeom xmlns:a="http://schemas.openxmlformats.org/drawingml/2006/main" prst="rect">
             <a:avLst/>
@@ -11399,7 +11399,7 @@
           </a:bodyPr>
           <a:lstStyle xmlns:a="http://schemas.openxmlformats.org/drawingml/2006/main">
             <a:defPPr algn="l">
-              <a:defRPr sz="825" b="0">
+              <a:defRPr sz="900" b="0">
                 <a:solidFill>
                   <a:srgbClr val="858B7E"/>
                 </a:solidFill>
@@ -11411,7 +11411,7 @@
           </a:lstStyle>
           <a:p xmlns:a="http://schemas.openxmlformats.org/drawingml/2006/main">
             <a:pPr algn="l">
-              <a:defRPr sz="825" b="0">
+              <a:defRPr sz="900" b="0">
                 <a:solidFill>
                   <a:srgbClr val="858B7E"/>
                 </a:solidFill>
@@ -11421,7 +11421,7 @@
               </a:defRPr>
             </a:pPr>
             <a:r>
-              <a:rPr sz="825" b="0">
+              <a:rPr sz="900" b="0">
                 <a:solidFill>
                   <a:srgbClr val="858B7E"/>
                 </a:solidFill>
@@ -11439,19 +11439,19 @@
           <p:cNvPr id="5" name="">
             <a:extLst xmlns:a="http://schemas.openxmlformats.org/drawingml/2006/main">
               <a:ext uri="{FF2B5EF4-FFF2-40B4-BE49-F238E27FC236}">
-                <a16:creationId xmlns:a16="http://schemas.microsoft.com/office/drawing/2014/main" id="{BCFFFD73-AB2E-4DA2-944E-9CE28C1275EE}"/>
-              </a:ext>
-            </a:extLst>
-          </p:cNvPr>
-          <p:cNvSpPr>
-            <a:spLocks xmlns:a="http://schemas.openxmlformats.org/drawingml/2006/main" noGrp="1"/>
-          </p:cNvSpPr>
-          <p:nvPr/>
-        </p:nvSpPr>
-        <p:spPr>
-          <a:xfrm xmlns:a="http://schemas.openxmlformats.org/drawingml/2006/main">
-            <a:off x="11049000" y="6667500"/>
-            <a:ext cx="228600" cy="152400"/>
+                <a16:creationId xmlns:a16="http://schemas.microsoft.com/office/drawing/2014/main" id="{F4EC7BEE-0AFC-4E0E-A4C2-97D5B6B49DD3}"/>
+              </a:ext>
+            </a:extLst>
+          </p:cNvPr>
+          <p:cNvSpPr>
+            <a:spLocks xmlns:a="http://schemas.openxmlformats.org/drawingml/2006/main" noGrp="1"/>
+          </p:cNvSpPr>
+          <p:nvPr/>
+        </p:nvSpPr>
+        <p:spPr>
+          <a:xfrm xmlns:a="http://schemas.openxmlformats.org/drawingml/2006/main">
+            <a:off x="10134600" y="6429375"/>
+            <a:ext cx="228600" cy="190500"/>
           </a:xfrm>
           <a:prstGeom xmlns:a="http://schemas.openxmlformats.org/drawingml/2006/main" prst="rect">
             <a:avLst/>
@@ -11467,7 +11467,7 @@
           </a:bodyPr>
           <a:lstStyle xmlns:a="http://schemas.openxmlformats.org/drawingml/2006/main">
             <a:defPPr algn="l">
-              <a:defRPr sz="825" b="0">
+              <a:defRPr sz="900" b="0">
                 <a:solidFill>
                   <a:srgbClr val="858B7E"/>
                 </a:solidFill>
@@ -11479,7 +11479,7 @@
           </a:lstStyle>
           <a:p xmlns:a="http://schemas.openxmlformats.org/drawingml/2006/main">
             <a:pPr algn="l">
-              <a:defRPr sz="825" b="0">
+              <a:defRPr sz="900" b="0">
                 <a:solidFill>
                   <a:srgbClr val="858B7E"/>
                 </a:solidFill>
@@ -11489,7 +11489,7 @@
               </a:defRPr>
             </a:pPr>
             <a:r>
-              <a:rPr sz="825" b="0">
+              <a:rPr sz="900" b="0">
                 <a:solidFill>
                   <a:srgbClr val="858B7E"/>
                 </a:solidFill>
@@ -11505,7 +11505,7 @@
     </p:spTree>
     <p:extLst>
       <p:ext uri="{BB962C8B-B14F-4D97-AF65-F5344CB8AC3E}">
-        <p14:creationId xmlns:p14="http://schemas.microsoft.com/office/powerpoint/2010/main" val="1374361539"/>
+        <p14:creationId xmlns:p14="http://schemas.microsoft.com/office/powerpoint/2010/main" val="39369703"/>
       </p:ext>
     </p:extLst>
   </p:cSld>
@@ -11536,19 +11536,19 @@
           <p:cNvPr id="6" name="">
             <a:extLst xmlns:a="http://schemas.openxmlformats.org/drawingml/2006/main">
               <a:ext uri="{FF2B5EF4-FFF2-40B4-BE49-F238E27FC236}">
-                <a16:creationId xmlns:a16="http://schemas.microsoft.com/office/drawing/2014/main" id="{C8BD1FF4-16E7-47E8-A9F5-3A3A7A711A50}"/>
-              </a:ext>
-            </a:extLst>
-          </p:cNvPr>
-          <p:cNvSpPr>
-            <a:spLocks xmlns:a="http://schemas.openxmlformats.org/drawingml/2006/main" noGrp="1"/>
-          </p:cNvSpPr>
-          <p:nvPr/>
-        </p:nvSpPr>
-        <p:spPr>
-          <a:xfrm xmlns:a="http://schemas.openxmlformats.org/drawingml/2006/main">
-            <a:off x="914400" y="133350"/>
-            <a:ext cx="10363200" cy="152400"/>
+                <a16:creationId xmlns:a16="http://schemas.microsoft.com/office/drawing/2014/main" id="{64BAE02E-3ABD-452E-B0C7-CB24C147240F}"/>
+              </a:ext>
+            </a:extLst>
+          </p:cNvPr>
+          <p:cNvSpPr>
+            <a:spLocks xmlns:a="http://schemas.openxmlformats.org/drawingml/2006/main" noGrp="1"/>
+          </p:cNvSpPr>
+          <p:nvPr/>
+        </p:nvSpPr>
+        <p:spPr>
+          <a:xfrm xmlns:a="http://schemas.openxmlformats.org/drawingml/2006/main">
+            <a:off x="1828800" y="457200"/>
+            <a:ext cx="8534400" cy="171450"/>
           </a:xfrm>
           <a:prstGeom xmlns:a="http://schemas.openxmlformats.org/drawingml/2006/main" prst="rect">
             <a:avLst/>
@@ -11564,7 +11564,7 @@
           </a:bodyPr>
           <a:lstStyle xmlns:a="http://schemas.openxmlformats.org/drawingml/2006/main">
             <a:defPPr algn="l">
-              <a:defRPr sz="825" b="1">
+              <a:defRPr sz="900" b="1">
                 <a:solidFill>
                   <a:srgbClr val="9B7744"/>
                 </a:solidFill>
@@ -11576,7 +11576,7 @@
           </a:lstStyle>
           <a:p xmlns:a="http://schemas.openxmlformats.org/drawingml/2006/main">
             <a:pPr algn="l">
-              <a:defRPr sz="825" b="1">
+              <a:defRPr sz="900" b="1">
                 <a:solidFill>
                   <a:srgbClr val="9B7744"/>
                 </a:solidFill>
@@ -11586,7 +11586,7 @@
               </a:defRPr>
             </a:pPr>
             <a:r>
-              <a:rPr sz="825" b="1">
+              <a:rPr sz="900" b="1">
                 <a:solidFill>
                   <a:srgbClr val="9B7744"/>
                 </a:solidFill>
@@ -11604,19 +11604,19 @@
           <p:cNvPr id="2" name="">
             <a:extLst xmlns:a="http://schemas.openxmlformats.org/drawingml/2006/main">
               <a:ext uri="{FF2B5EF4-FFF2-40B4-BE49-F238E27FC236}">
-                <a16:creationId xmlns:a16="http://schemas.microsoft.com/office/drawing/2014/main" id="{B116C21E-C437-46A1-B87D-D52C8C765964}"/>
-              </a:ext>
-            </a:extLst>
-          </p:cNvPr>
-          <p:cNvSpPr>
-            <a:spLocks xmlns:a="http://schemas.openxmlformats.org/drawingml/2006/main" noGrp="1"/>
-          </p:cNvSpPr>
-          <p:nvPr/>
-        </p:nvSpPr>
-        <p:spPr>
-          <a:xfrm xmlns:a="http://schemas.openxmlformats.org/drawingml/2006/main">
-            <a:off x="914400" y="304800"/>
-            <a:ext cx="10363200" cy="381000"/>
+                <a16:creationId xmlns:a16="http://schemas.microsoft.com/office/drawing/2014/main" id="{C3C70D2A-95EE-4839-B015-8CE59F1FBAEC}"/>
+              </a:ext>
+            </a:extLst>
+          </p:cNvPr>
+          <p:cNvSpPr>
+            <a:spLocks xmlns:a="http://schemas.openxmlformats.org/drawingml/2006/main" noGrp="1"/>
+          </p:cNvSpPr>
+          <p:nvPr/>
+        </p:nvSpPr>
+        <p:spPr>
+          <a:xfrm xmlns:a="http://schemas.openxmlformats.org/drawingml/2006/main">
+            <a:off x="1828800" y="723900"/>
+            <a:ext cx="8534400" cy="419100"/>
           </a:xfrm>
           <a:prstGeom xmlns:a="http://schemas.openxmlformats.org/drawingml/2006/main" prst="rect">
             <a:avLst/>
@@ -11632,7 +11632,7 @@
           </a:bodyPr>
           <a:lstStyle xmlns:a="http://schemas.openxmlformats.org/drawingml/2006/main">
             <a:defPPr algn="l">
-              <a:defRPr sz="2250" b="1">
+              <a:defRPr sz="2550" b="1">
                 <a:solidFill>
                   <a:srgbClr val="1B1D19"/>
                 </a:solidFill>
@@ -11644,7 +11644,7 @@
           </a:lstStyle>
           <a:p xmlns:a="http://schemas.openxmlformats.org/drawingml/2006/main">
             <a:pPr algn="l">
-              <a:defRPr sz="2250" b="1">
+              <a:defRPr sz="2550" b="1">
                 <a:solidFill>
                   <a:srgbClr val="1B1D19"/>
                 </a:solidFill>
@@ -11654,7 +11654,7 @@
               </a:defRPr>
             </a:pPr>
             <a:r>
-              <a:rPr sz="2250" b="1">
+              <a:rPr sz="2550" b="1">
                 <a:solidFill>
                   <a:srgbClr val="1B1D19"/>
                 </a:solidFill>
@@ -11672,19 +11672,19 @@
           <p:cNvPr id="3" name="">
             <a:extLst xmlns:a="http://schemas.openxmlformats.org/drawingml/2006/main">
               <a:ext uri="{FF2B5EF4-FFF2-40B4-BE49-F238E27FC236}">
-                <a16:creationId xmlns:a16="http://schemas.microsoft.com/office/drawing/2014/main" id="{058CF802-5BD1-40C2-AA19-87DFEBF933CC}"/>
-              </a:ext>
-            </a:extLst>
-          </p:cNvPr>
-          <p:cNvSpPr>
-            <a:spLocks xmlns:a="http://schemas.openxmlformats.org/drawingml/2006/main" noGrp="1"/>
-          </p:cNvSpPr>
-          <p:nvPr/>
-        </p:nvSpPr>
-        <p:spPr>
-          <a:xfrm xmlns:a="http://schemas.openxmlformats.org/drawingml/2006/main">
-            <a:off x="914400" y="723900"/>
-            <a:ext cx="10363200" cy="5829300"/>
+                <a16:creationId xmlns:a16="http://schemas.microsoft.com/office/drawing/2014/main" id="{29DE4336-45AD-4BC9-9BC3-F8B2F4924F3D}"/>
+              </a:ext>
+            </a:extLst>
+          </p:cNvPr>
+          <p:cNvSpPr>
+            <a:spLocks xmlns:a="http://schemas.openxmlformats.org/drawingml/2006/main" noGrp="1"/>
+          </p:cNvSpPr>
+          <p:nvPr/>
+        </p:nvSpPr>
+        <p:spPr>
+          <a:xfrm xmlns:a="http://schemas.openxmlformats.org/drawingml/2006/main">
+            <a:off x="1828800" y="1333500"/>
+            <a:ext cx="8534400" cy="4800600"/>
           </a:xfrm>
           <a:prstGeom xmlns:a="http://schemas.openxmlformats.org/drawingml/2006/main" prst="rect">
             <a:avLst/>
@@ -11702,19 +11702,19 @@
           <p:cNvPr id="4" name="">
             <a:extLst xmlns:a="http://schemas.openxmlformats.org/drawingml/2006/main">
               <a:ext uri="{FF2B5EF4-FFF2-40B4-BE49-F238E27FC236}">
-                <a16:creationId xmlns:a16="http://schemas.microsoft.com/office/drawing/2014/main" id="{3E623818-FD7C-478E-8CA3-82F2F6D73D9A}"/>
-              </a:ext>
-            </a:extLst>
-          </p:cNvPr>
-          <p:cNvSpPr>
-            <a:spLocks xmlns:a="http://schemas.openxmlformats.org/drawingml/2006/main" noGrp="1"/>
-          </p:cNvSpPr>
-          <p:nvPr/>
-        </p:nvSpPr>
-        <p:spPr>
-          <a:xfrm xmlns:a="http://schemas.openxmlformats.org/drawingml/2006/main">
-            <a:off x="914400" y="6667500"/>
-            <a:ext cx="9525000" cy="152400"/>
+                <a16:creationId xmlns:a16="http://schemas.microsoft.com/office/drawing/2014/main" id="{25B8FA47-E236-4D10-B2EA-D9E8C70B09DC}"/>
+              </a:ext>
+            </a:extLst>
+          </p:cNvPr>
+          <p:cNvSpPr>
+            <a:spLocks xmlns:a="http://schemas.openxmlformats.org/drawingml/2006/main" noGrp="1"/>
+          </p:cNvSpPr>
+          <p:nvPr/>
+        </p:nvSpPr>
+        <p:spPr>
+          <a:xfrm xmlns:a="http://schemas.openxmlformats.org/drawingml/2006/main">
+            <a:off x="1828800" y="6429375"/>
+            <a:ext cx="7620000" cy="190500"/>
           </a:xfrm>
           <a:prstGeom xmlns:a="http://schemas.openxmlformats.org/drawingml/2006/main" prst="rect">
             <a:avLst/>
@@ -11730,7 +11730,7 @@
           </a:bodyPr>
           <a:lstStyle xmlns:a="http://schemas.openxmlformats.org/drawingml/2006/main">
             <a:defPPr algn="l">
-              <a:defRPr sz="825" b="0">
+              <a:defRPr sz="900" b="0">
                 <a:solidFill>
                   <a:srgbClr val="858B7E"/>
                 </a:solidFill>
@@ -11742,7 +11742,7 @@
           </a:lstStyle>
           <a:p xmlns:a="http://schemas.openxmlformats.org/drawingml/2006/main">
             <a:pPr algn="l">
-              <a:defRPr sz="825" b="0">
+              <a:defRPr sz="900" b="0">
                 <a:solidFill>
                   <a:srgbClr val="858B7E"/>
                 </a:solidFill>
@@ -11752,7 +11752,7 @@
               </a:defRPr>
             </a:pPr>
             <a:r>
-              <a:rPr sz="825" b="0">
+              <a:rPr sz="900" b="0">
                 <a:solidFill>
                   <a:srgbClr val="858B7E"/>
                 </a:solidFill>
@@ -11770,19 +11770,19 @@
           <p:cNvPr id="5" name="">
             <a:extLst xmlns:a="http://schemas.openxmlformats.org/drawingml/2006/main">
               <a:ext uri="{FF2B5EF4-FFF2-40B4-BE49-F238E27FC236}">
-                <a16:creationId xmlns:a16="http://schemas.microsoft.com/office/drawing/2014/main" id="{41CBFFE8-9C63-4959-BE72-9A9DDEF23BC2}"/>
-              </a:ext>
-            </a:extLst>
-          </p:cNvPr>
-          <p:cNvSpPr>
-            <a:spLocks xmlns:a="http://schemas.openxmlformats.org/drawingml/2006/main" noGrp="1"/>
-          </p:cNvSpPr>
-          <p:nvPr/>
-        </p:nvSpPr>
-        <p:spPr>
-          <a:xfrm xmlns:a="http://schemas.openxmlformats.org/drawingml/2006/main">
-            <a:off x="11049000" y="6667500"/>
-            <a:ext cx="228600" cy="152400"/>
+                <a16:creationId xmlns:a16="http://schemas.microsoft.com/office/drawing/2014/main" id="{B2F8A071-05BC-4181-A71E-736D0B585E2F}"/>
+              </a:ext>
+            </a:extLst>
+          </p:cNvPr>
+          <p:cNvSpPr>
+            <a:spLocks xmlns:a="http://schemas.openxmlformats.org/drawingml/2006/main" noGrp="1"/>
+          </p:cNvSpPr>
+          <p:nvPr/>
+        </p:nvSpPr>
+        <p:spPr>
+          <a:xfrm xmlns:a="http://schemas.openxmlformats.org/drawingml/2006/main">
+            <a:off x="10134600" y="6429375"/>
+            <a:ext cx="228600" cy="190500"/>
           </a:xfrm>
           <a:prstGeom xmlns:a="http://schemas.openxmlformats.org/drawingml/2006/main" prst="rect">
             <a:avLst/>
@@ -11798,7 +11798,7 @@
           </a:bodyPr>
           <a:lstStyle xmlns:a="http://schemas.openxmlformats.org/drawingml/2006/main">
             <a:defPPr algn="l">
-              <a:defRPr sz="825" b="0">
+              <a:defRPr sz="900" b="0">
                 <a:solidFill>
                   <a:srgbClr val="858B7E"/>
                 </a:solidFill>
@@ -11810,7 +11810,7 @@
           </a:lstStyle>
           <a:p xmlns:a="http://schemas.openxmlformats.org/drawingml/2006/main">
             <a:pPr algn="l">
-              <a:defRPr sz="825" b="0">
+              <a:defRPr sz="900" b="0">
                 <a:solidFill>
                   <a:srgbClr val="858B7E"/>
                 </a:solidFill>
@@ -11820,7 +11820,7 @@
               </a:defRPr>
             </a:pPr>
             <a:r>
-              <a:rPr sz="825" b="0">
+              <a:rPr sz="900" b="0">
                 <a:solidFill>
                   <a:srgbClr val="858B7E"/>
                 </a:solidFill>
@@ -11836,7 +11836,7 @@
     </p:spTree>
     <p:extLst>
       <p:ext uri="{BB962C8B-B14F-4D97-AF65-F5344CB8AC3E}">
-        <p14:creationId xmlns:p14="http://schemas.microsoft.com/office/powerpoint/2010/main" val="1916071384"/>
+        <p14:creationId xmlns:p14="http://schemas.microsoft.com/office/powerpoint/2010/main" val="545203653"/>
       </p:ext>
     </p:extLst>
   </p:cSld>

</xml_diff>

<commit_message>
Update preoperative laboratory tests and speaker cues
</commit_message>
<xml_diff>
--- a/downloads/highst-perioperative-webinar.pptx
+++ b/downloads/highst-perioperative-webinar.pptx
@@ -2,25 +2,25 @@
 <file path=ppt/presentation.xml><?xml version="1.0" encoding="utf-8"?>
 <p:presentation xmlns:p="http://schemas.openxmlformats.org/presentationml/2006/main">
   <p:sldMasterIdLst>
-    <p:sldMasterId xmlns:r="http://schemas.openxmlformats.org/officeDocument/2006/relationships" id="2147483648" r:id="R1e4b86797d624a58"/>
+    <p:sldMasterId xmlns:r="http://schemas.openxmlformats.org/officeDocument/2006/relationships" id="2147483648" r:id="Rf174e4b225cf4283"/>
   </p:sldMasterIdLst>
   <p:notesMasterIdLst>
-    <p:notesMasterId xmlns:r="http://schemas.openxmlformats.org/officeDocument/2006/relationships" r:id="Ra2ab7c1ce639433c"/>
+    <p:notesMasterId xmlns:r="http://schemas.openxmlformats.org/officeDocument/2006/relationships" r:id="R70bdac0a05a54c6c"/>
   </p:notesMasterIdLst>
   <p:sldIdLst>
-    <p:sldId xmlns:r="http://schemas.openxmlformats.org/officeDocument/2006/relationships" id="256" r:id="Rf5779f12b4bf4dd1"/>
-    <p:sldId xmlns:r="http://schemas.openxmlformats.org/officeDocument/2006/relationships" id="257" r:id="Rc8e44ee479844dff"/>
-    <p:sldId xmlns:r="http://schemas.openxmlformats.org/officeDocument/2006/relationships" id="258" r:id="Re05371eaadb245f4"/>
-    <p:sldId xmlns:r="http://schemas.openxmlformats.org/officeDocument/2006/relationships" id="259" r:id="R354e1223462e42c5"/>
-    <p:sldId xmlns:r="http://schemas.openxmlformats.org/officeDocument/2006/relationships" id="260" r:id="Rcb6e510a8f7e42e0"/>
-    <p:sldId xmlns:r="http://schemas.openxmlformats.org/officeDocument/2006/relationships" id="261" r:id="R18d9c8f53bb94cdd"/>
-    <p:sldId xmlns:r="http://schemas.openxmlformats.org/officeDocument/2006/relationships" id="262" r:id="R16881e609b6144b9"/>
-    <p:sldId xmlns:r="http://schemas.openxmlformats.org/officeDocument/2006/relationships" id="263" r:id="R1bd36b85784741f5"/>
-    <p:sldId xmlns:r="http://schemas.openxmlformats.org/officeDocument/2006/relationships" id="264" r:id="R2a3eaae7ab8b4d78"/>
-    <p:sldId xmlns:r="http://schemas.openxmlformats.org/officeDocument/2006/relationships" id="265" r:id="Rcffa18540e0e4d81"/>
-    <p:sldId xmlns:r="http://schemas.openxmlformats.org/officeDocument/2006/relationships" id="266" r:id="R87daa993a2704043"/>
-    <p:sldId xmlns:r="http://schemas.openxmlformats.org/officeDocument/2006/relationships" id="267" r:id="Rd84b121b5a704b7a"/>
-    <p:sldId xmlns:r="http://schemas.openxmlformats.org/officeDocument/2006/relationships" id="268" r:id="R669cbb7d9d814bb9"/>
+    <p:sldId xmlns:r="http://schemas.openxmlformats.org/officeDocument/2006/relationships" id="256" r:id="Rbe58da2b5b2d4067"/>
+    <p:sldId xmlns:r="http://schemas.openxmlformats.org/officeDocument/2006/relationships" id="257" r:id="Rafd89f7b87474059"/>
+    <p:sldId xmlns:r="http://schemas.openxmlformats.org/officeDocument/2006/relationships" id="258" r:id="R195a4354cd494fa9"/>
+    <p:sldId xmlns:r="http://schemas.openxmlformats.org/officeDocument/2006/relationships" id="259" r:id="Rcf15e413812e4434"/>
+    <p:sldId xmlns:r="http://schemas.openxmlformats.org/officeDocument/2006/relationships" id="260" r:id="Rd7289ae521a54173"/>
+    <p:sldId xmlns:r="http://schemas.openxmlformats.org/officeDocument/2006/relationships" id="261" r:id="Rf1dc2c0a987d4bcc"/>
+    <p:sldId xmlns:r="http://schemas.openxmlformats.org/officeDocument/2006/relationships" id="262" r:id="Ra0b5ffc5ab06461e"/>
+    <p:sldId xmlns:r="http://schemas.openxmlformats.org/officeDocument/2006/relationships" id="263" r:id="Raf84e70c01f34baf"/>
+    <p:sldId xmlns:r="http://schemas.openxmlformats.org/officeDocument/2006/relationships" id="264" r:id="R18dfae837995417d"/>
+    <p:sldId xmlns:r="http://schemas.openxmlformats.org/officeDocument/2006/relationships" id="265" r:id="R34bd665d9de04d03"/>
+    <p:sldId xmlns:r="http://schemas.openxmlformats.org/officeDocument/2006/relationships" id="266" r:id="R73d659385c174b99"/>
+    <p:sldId xmlns:r="http://schemas.openxmlformats.org/officeDocument/2006/relationships" id="267" r:id="R978007f9dc064b17"/>
+    <p:sldId xmlns:r="http://schemas.openxmlformats.org/officeDocument/2006/relationships" id="268" r:id="R3c096cac75f140a3"/>
   </p:sldIdLst>
   <p:sldSz cx="12192000" cy="6858000"/>
   <p:notesSz cx="6858000" cy="9144000"/>
@@ -454,6 +454,51 @@
           <a:lstStyle xmlns:a="http://schemas.openxmlformats.org/drawingml/2006/main"/>
           <a:p xmlns:a="http://schemas.openxmlformats.org/drawingml/2006/main">
             <a:r>
+              <a:t>English speaker cues</a:t>
+            </a:r>
+          </a:p>
+          <a:p xmlns:a="http://schemas.openxmlformats.org/drawingml/2006/main">
+            <a:r>
+              <a:t>1. Welcome: Thank you for joining us today.</a:t>
+            </a:r>
+          </a:p>
+          <a:p xmlns:a="http://schemas.openxmlformats.org/drawingml/2006/main">
+            <a:r>
+              <a:t>2. Introduction: Jinmo Koo / HIGHST Urology, Korea</a:t>
+            </a:r>
+          </a:p>
+          <a:p xmlns:a="http://schemas.openxmlformats.org/drawingml/2006/main">
+            <a:r>
+              <a:t>3. Topic: MegaDerm penile augmentation</a:t>
+            </a:r>
+          </a:p>
+          <a:p xmlns:a="http://schemas.openxmlformats.org/drawingml/2006/main">
+            <a:r>
+              <a:t>4. Today’s focus: Preoperative evaluation / surgical videos / complications / postoperative care</a:t>
+            </a:r>
+          </a:p>
+          <a:p xmlns:a="http://schemas.openxmlformats.org/drawingml/2006/main">
+            <a:r>
+              <a:t/>
+            </a:r>
+          </a:p>
+          <a:p xmlns:a="http://schemas.openxmlformats.org/drawingml/2006/main">
+            <a:r>
+              <a:t>Next: First, let me briefly introduce myself.</a:t>
+            </a:r>
+          </a:p>
+          <a:p xmlns:a="http://schemas.openxmlformats.org/drawingml/2006/main">
+            <a:r>
+              <a:t/>
+            </a:r>
+          </a:p>
+          <a:p xmlns:a="http://schemas.openxmlformats.org/drawingml/2006/main">
+            <a:r>
+              <a:t>Reference notes</a:t>
+            </a:r>
+          </a:p>
+          <a:p xmlns:a="http://schemas.openxmlformats.org/drawingml/2006/main">
+            <a:r>
               <a:t>Jinmo Koo, HIGHST Urology. Vietnam MegaDerm Webinar, 21 October 2026. Portrait supplied by HIGHST. Brand reference: https://www.highsturology.co.kr/v2/proud/doctor.php</a:t>
             </a:r>
           </a:p>
@@ -524,6 +569,51 @@
           <a:lstStyle xmlns:a="http://schemas.openxmlformats.org/drawingml/2006/main"/>
           <a:p xmlns:a="http://schemas.openxmlformats.org/drawingml/2006/main">
             <a:r>
+              <a:t>English speaker cues</a:t>
+            </a:r>
+          </a:p>
+          <a:p xmlns:a="http://schemas.openxmlformats.org/drawingml/2006/main">
+            <a:r>
+              <a:t>1. Case 5: Contour step-off correction</a:t>
+            </a:r>
+          </a:p>
+          <a:p xmlns:a="http://schemas.openxmlformats.org/drawingml/2006/main">
+            <a:r>
+              <a:t>2. Case introduction: Location of the contour concern</a:t>
+            </a:r>
+          </a:p>
+          <a:p xmlns:a="http://schemas.openxmlformats.org/drawingml/2006/main">
+            <a:r>
+              <a:t>3. Video walkthrough: Correction shown in the video</a:t>
+            </a:r>
+          </a:p>
+          <a:p xmlns:a="http://schemas.openxmlformats.org/drawingml/2006/main">
+            <a:r>
+              <a:t>4. Discussion: Main points from this case</a:t>
+            </a:r>
+          </a:p>
+          <a:p xmlns:a="http://schemas.openxmlformats.org/drawingml/2006/main">
+            <a:r>
+              <a:t/>
+            </a:r>
+          </a:p>
+          <a:p xmlns:a="http://schemas.openxmlformats.org/drawingml/2006/main">
+            <a:r>
+              <a:t>Next: After these cases, let’s review potential complications.</a:t>
+            </a:r>
+          </a:p>
+          <a:p xmlns:a="http://schemas.openxmlformats.org/drawingml/2006/main">
+            <a:r>
+              <a:t/>
+            </a:r>
+          </a:p>
+          <a:p xmlns:a="http://schemas.openxmlformats.org/drawingml/2006/main">
+            <a:r>
+              <a:t>Reference notes</a:t>
+            </a:r>
+          </a:p>
+          <a:p xmlns:a="http://schemas.openxmlformats.org/drawingml/2006/main">
+            <a:r>
               <a:t>Case 5: Contour Step-off Correction.</a:t>
             </a:r>
           </a:p>
@@ -594,6 +684,51 @@
           <a:lstStyle xmlns:a="http://schemas.openxmlformats.org/drawingml/2006/main"/>
           <a:p xmlns:a="http://schemas.openxmlformats.org/drawingml/2006/main">
             <a:r>
+              <a:t>English speaker cues</a:t>
+            </a:r>
+          </a:p>
+          <a:p xmlns:a="http://schemas.openxmlformats.org/drawingml/2006/main">
+            <a:r>
+              <a:t>1. Context: Published ADM literature / not HIGHST- or MegaDerm-specific outcome data</a:t>
+            </a:r>
+          </a:p>
+          <a:p xmlns:a="http://schemas.openxmlformats.org/drawingml/2006/main">
+            <a:r>
+              <a:t>2. Bleeding and swelling: Hematoma / foreskin edema</a:t>
+            </a:r>
+          </a:p>
+          <a:p xmlns:a="http://schemas.openxmlformats.org/drawingml/2006/main">
+            <a:r>
+              <a:t>3. Wound complications: Delayed healing / infection / skin necrosis</a:t>
+            </a:r>
+          </a:p>
+          <a:p xmlns:a="http://schemas.openxmlformats.org/drawingml/2006/main">
+            <a:r>
+              <a:t>4. Contour and discomfort: Graft contour irregularity / discomfort during erection</a:t>
+            </a:r>
+          </a:p>
+          <a:p xmlns:a="http://schemas.openxmlformats.org/drawingml/2006/main">
+            <a:r>
+              <a:t/>
+            </a:r>
+          </a:p>
+          <a:p xmlns:a="http://schemas.openxmlformats.org/drawingml/2006/main">
+            <a:r>
+              <a:t>Next: Finally, I’ll discuss postoperative care and dressing.</a:t>
+            </a:r>
+          </a:p>
+          <a:p xmlns:a="http://schemas.openxmlformats.org/drawingml/2006/main">
+            <a:r>
+              <a:t/>
+            </a:r>
+          </a:p>
+          <a:p xmlns:a="http://schemas.openxmlformats.org/drawingml/2006/main">
+            <a:r>
+              <a:t>Reference notes</a:t>
+            </a:r>
+          </a:p>
+          <a:p xmlns:a="http://schemas.openxmlformats.org/drawingml/2006/main">
+            <a:r>
               <a:t>These categories are reported in published ADM augmentation literature. They do not represent HIGHST or MegaDerm-specific outcome data. No incidence rates are extrapolated to HIGHST.</a:t>
             </a:r>
           </a:p>
@@ -679,6 +814,46 @@
           <a:lstStyle xmlns:a="http://schemas.openxmlformats.org/drawingml/2006/main"/>
           <a:p xmlns:a="http://schemas.openxmlformats.org/drawingml/2006/main">
             <a:r>
+              <a:t>English speaker cues</a:t>
+            </a:r>
+          </a:p>
+          <a:p xmlns:a="http://schemas.openxmlformats.org/drawingml/2006/main">
+            <a:r>
+              <a:t>1. Postoperative care: Main instructions to explain</a:t>
+            </a:r>
+          </a:p>
+          <a:p xmlns:a="http://schemas.openxmlformats.org/drawingml/2006/main">
+            <a:r>
+              <a:t>2. Dressing: Sequence shown in the video</a:t>
+            </a:r>
+          </a:p>
+          <a:p xmlns:a="http://schemas.openxmlformats.org/drawingml/2006/main">
+            <a:r>
+              <a:t>3. Follow-up: Points to discuss with the patient</a:t>
+            </a:r>
+          </a:p>
+          <a:p xmlns:a="http://schemas.openxmlformats.org/drawingml/2006/main">
+            <a:r>
+              <a:t/>
+            </a:r>
+          </a:p>
+          <a:p xmlns:a="http://schemas.openxmlformats.org/drawingml/2006/main">
+            <a:r>
+              <a:t>Next: Thank you for your attention. I’m happy to take your questions.</a:t>
+            </a:r>
+          </a:p>
+          <a:p xmlns:a="http://schemas.openxmlformats.org/drawingml/2006/main">
+            <a:r>
+              <a:t/>
+            </a:r>
+          </a:p>
+          <a:p xmlns:a="http://schemas.openxmlformats.org/drawingml/2006/main">
+            <a:r>
+              <a:t>Reference notes</a:t>
+            </a:r>
+          </a:p>
+          <a:p xmlns:a="http://schemas.openxmlformats.org/drawingml/2006/main">
+            <a:r>
               <a:t>Postoperative care and dressing technique.</a:t>
             </a:r>
           </a:p>
@@ -749,6 +924,41 @@
           <a:lstStyle xmlns:a="http://schemas.openxmlformats.org/drawingml/2006/main"/>
           <a:p xmlns:a="http://schemas.openxmlformats.org/drawingml/2006/main">
             <a:r>
+              <a:t>English speaker cues</a:t>
+            </a:r>
+          </a:p>
+          <a:p xmlns:a="http://schemas.openxmlformats.org/drawingml/2006/main">
+            <a:r>
+              <a:t>1. Thank you: Thank you for your time and attention.</a:t>
+            </a:r>
+          </a:p>
+          <a:p xmlns:a="http://schemas.openxmlformats.org/drawingml/2006/main">
+            <a:r>
+              <a:t>2. Questions: I’d be happy to discuss your questions.</a:t>
+            </a:r>
+          </a:p>
+          <a:p xmlns:a="http://schemas.openxmlformats.org/drawingml/2006/main">
+            <a:r>
+              <a:t>3. Clarify: Could you please repeat or clarify the question?</a:t>
+            </a:r>
+          </a:p>
+          <a:p xmlns:a="http://schemas.openxmlformats.org/drawingml/2006/main">
+            <a:r>
+              <a:t>4. Close: Thank you for the discussion.</a:t>
+            </a:r>
+          </a:p>
+          <a:p xmlns:a="http://schemas.openxmlformats.org/drawingml/2006/main">
+            <a:r>
+              <a:t/>
+            </a:r>
+          </a:p>
+          <a:p xmlns:a="http://schemas.openxmlformats.org/drawingml/2006/main">
+            <a:r>
+              <a:t>Reference notes</a:t>
+            </a:r>
+          </a:p>
+          <a:p xmlns:a="http://schemas.openxmlformats.org/drawingml/2006/main">
+            <a:r>
               <a:t>Thank you.</a:t>
             </a:r>
           </a:p>
@@ -819,6 +1029,61 @@
           <a:lstStyle xmlns:a="http://schemas.openxmlformats.org/drawingml/2006/main"/>
           <a:p xmlns:a="http://schemas.openxmlformats.org/drawingml/2006/main">
             <a:r>
+              <a:t>English speaker cues</a:t>
+            </a:r>
+          </a:p>
+          <a:p xmlns:a="http://schemas.openxmlformats.org/drawingml/2006/main">
+            <a:r>
+              <a:t>1. Education: Korea University College of Medicine</a:t>
+            </a:r>
+          </a:p>
+          <a:p xmlns:a="http://schemas.openxmlformats.org/drawingml/2006/main">
+            <a:r>
+              <a:t>2. Current role: Chief Director, HIGHST Urology</a:t>
+            </a:r>
+          </a:p>
+          <a:p xmlns:a="http://schemas.openxmlformats.org/drawingml/2006/main">
+            <a:r>
+              <a:t>3. Clinical background: Former Chief Director, PROUD Urology / adjunct professor, Ewha Mokdong Hospital</a:t>
+            </a:r>
+          </a:p>
+          <a:p xmlns:a="http://schemas.openxmlformats.org/drawingml/2006/main">
+            <a:r>
+              <a:t>4. Training: Erectile dysfunction training at UCI / international training and designated physician roles</a:t>
+            </a:r>
+          </a:p>
+          <a:p xmlns:a="http://schemas.openxmlformats.org/drawingml/2006/main">
+            <a:r>
+              <a:t>5. Recognition: 2024 Outstanding Presentation Award, Taiwan Andrology Association</a:t>
+            </a:r>
+          </a:p>
+          <a:p xmlns:a="http://schemas.openxmlformats.org/drawingml/2006/main">
+            <a:r>
+              <a:t>6. Professional societies: Korean Urological Association / ISSM / APSSM</a:t>
+            </a:r>
+          </a:p>
+          <a:p xmlns:a="http://schemas.openxmlformats.org/drawingml/2006/main">
+            <a:r>
+              <a:t/>
+            </a:r>
+          </a:p>
+          <a:p xmlns:a="http://schemas.openxmlformats.org/drawingml/2006/main">
+            <a:r>
+              <a:t>Next: Let’s begin with the materials: MegaDerm and MegaFill.</a:t>
+            </a:r>
+          </a:p>
+          <a:p xmlns:a="http://schemas.openxmlformats.org/drawingml/2006/main">
+            <a:r>
+              <a:t/>
+            </a:r>
+          </a:p>
+          <a:p xmlns:a="http://schemas.openxmlformats.org/drawingml/2006/main">
+            <a:r>
+              <a:t>Reference notes</a:t>
+            </a:r>
+          </a:p>
+          <a:p xmlns:a="http://schemas.openxmlformats.org/drawingml/2006/main">
+            <a:r>
               <a:t>Jinmo Koo, HIGHST Urology.</a:t>
             </a:r>
           </a:p>
@@ -1029,6 +1294,51 @@
           <a:lstStyle xmlns:a="http://schemas.openxmlformats.org/drawingml/2006/main"/>
           <a:p xmlns:a="http://schemas.openxmlformats.org/drawingml/2006/main">
             <a:r>
+              <a:t>English speaker cues</a:t>
+            </a:r>
+          </a:p>
+          <a:p xmlns:a="http://schemas.openxmlformats.org/drawingml/2006/main">
+            <a:r>
+              <a:t>1. MegaDerm: Sheet acellular dermal matrix</a:t>
+            </a:r>
+          </a:p>
+          <a:p xmlns:a="http://schemas.openxmlformats.org/drawingml/2006/main">
+            <a:r>
+              <a:t>2. Two types: Hydrated / freeze-dried</a:t>
+            </a:r>
+          </a:p>
+          <a:p xmlns:a="http://schemas.openxmlformats.org/drawingml/2006/main">
+            <a:r>
+              <a:t>3. Our stock: 3–5 mm thick / 5 × 6, 5 × 8, 5 × 10, 6 × 12 cm</a:t>
+            </a:r>
+          </a:p>
+          <a:p xmlns:a="http://schemas.openxmlformats.org/drawingml/2006/main">
+            <a:r>
+              <a:t>4. MegaFill: Micronized acellular dermal matrix</a:t>
+            </a:r>
+          </a:p>
+          <a:p xmlns:a="http://schemas.openxmlformats.org/drawingml/2006/main">
+            <a:r>
+              <a:t/>
+            </a:r>
+          </a:p>
+          <a:p xmlns:a="http://schemas.openxmlformats.org/drawingml/2006/main">
+            <a:r>
+              <a:t>Next: Next, I’ll go through our preoperative evaluation.</a:t>
+            </a:r>
+          </a:p>
+          <a:p xmlns:a="http://schemas.openxmlformats.org/drawingml/2006/main">
+            <a:r>
+              <a:t/>
+            </a:r>
+          </a:p>
+          <a:p xmlns:a="http://schemas.openxmlformats.org/drawingml/2006/main">
+            <a:r>
+              <a:t>Reference notes</a:t>
+            </a:r>
+          </a:p>
+          <a:p xmlns:a="http://schemas.openxmlformats.org/drawingml/2006/main">
+            <a:r>
               <a:t>MegaDerm is a sheet acellular dermal matrix. HIGHST stocks hydrated and freeze-dried types. The stated thickness and sizes describe HIGHST's inventory. MegaFill is a micronized form of acellular dermal matrix. The photograph is supplied by HIGHST. Individual packages are not assigned type labels.</a:t>
             </a:r>
           </a:p>
@@ -1114,7 +1424,132 @@
           <a:lstStyle xmlns:a="http://schemas.openxmlformats.org/drawingml/2006/main"/>
           <a:p xmlns:a="http://schemas.openxmlformats.org/drawingml/2006/main">
             <a:r>
-              <a:t>Preoperative assessment at HIGHST includes IIEF and PEDT questionnaires, the listed laboratory and infection tests, flaccid and stretched penile length measurement, and penile biothesiometry. HbA1c denotes glycated hemoglobin. Sources: https://pubmed.ncbi.nlm.nih.gov/9187685/ ; https://pubmed.ncbi.nlm.nih.gov/17568761/ ; https://www.niddk.nih.gov/health-information/diagnostic-tests/a1c-test/ ; https://pubmed.ncbi.nlm.nih.gov/28874780/</a:t>
+              <a:t>English speaker cues</a:t>
+            </a:r>
+          </a:p>
+          <a:p xmlns:a="http://schemas.openxmlformats.org/drawingml/2006/main">
+            <a:r>
+              <a:t>1. Questionnaires: IIEF: erectile function / PEDT: premature ejaculation</a:t>
+            </a:r>
+          </a:p>
+          <a:p xmlns:a="http://schemas.openxmlformats.org/drawingml/2006/main">
+            <a:r>
+              <a:t>2. Blood tests: Coagulation: PT/PTT / TTT: testosterone / CBC / PSA / blood glucose: BST/HbA1c</a:t>
+            </a:r>
+          </a:p>
+          <a:p xmlns:a="http://schemas.openxmlformats.org/drawingml/2006/main">
+            <a:r>
+              <a:t>3. Screening: HIV / syphilis / urine testing / liver enzymes: GOT/GPT/GGT / inflammatory markers</a:t>
+            </a:r>
+          </a:p>
+          <a:p xmlns:a="http://schemas.openxmlformats.org/drawingml/2006/main">
+            <a:r>
+              <a:t>4. Physical examination: Penile length: flaccid and stretched</a:t>
+            </a:r>
+          </a:p>
+          <a:p xmlns:a="http://schemas.openxmlformats.org/drawingml/2006/main">
+            <a:r>
+              <a:t>5. Sensitivity: Penile biothesiometry / vibration perception threshold</a:t>
+            </a:r>
+          </a:p>
+          <a:p xmlns:a="http://schemas.openxmlformats.org/drawingml/2006/main">
+            <a:r>
+              <a:t/>
+            </a:r>
+          </a:p>
+          <a:p xmlns:a="http://schemas.openxmlformats.org/drawingml/2006/main">
+            <a:r>
+              <a:t>Next: With the evaluation complete, let’s move on to surgical preparation.</a:t>
+            </a:r>
+          </a:p>
+          <a:p xmlns:a="http://schemas.openxmlformats.org/drawingml/2006/main">
+            <a:r>
+              <a:t/>
+            </a:r>
+          </a:p>
+          <a:p xmlns:a="http://schemas.openxmlformats.org/drawingml/2006/main">
+            <a:r>
+              <a:t>Reference notes</a:t>
+            </a:r>
+          </a:p>
+          <a:p xmlns:a="http://schemas.openxmlformats.org/drawingml/2006/main">
+            <a:r>
+              <a:t>Preoperative assessment at HIGHST includes IIEF and PEDT questionnaires, flaccid and stretched penile length measurement, and penile biothesiometry.</a:t>
+            </a:r>
+          </a:p>
+          <a:p xmlns:a="http://schemas.openxmlformats.org/drawingml/2006/main">
+            <a:r>
+              <a:t/>
+            </a:r>
+          </a:p>
+          <a:p xmlns:a="http://schemas.openxmlformats.org/drawingml/2006/main">
+            <a:r>
+              <a:t>Laboratory tests</a:t>
+            </a:r>
+          </a:p>
+          <a:p xmlns:a="http://schemas.openxmlformats.org/drawingml/2006/main">
+            <a:r>
+              <a:t>Blood coagulation tests (PT/PTT)</a:t>
+            </a:r>
+          </a:p>
+          <a:p xmlns:a="http://schemas.openxmlformats.org/drawingml/2006/main">
+            <a:r>
+              <a:t>TTT (testosterone)</a:t>
+            </a:r>
+          </a:p>
+          <a:p xmlns:a="http://schemas.openxmlformats.org/drawingml/2006/main">
+            <a:r>
+              <a:t>Complete blood count (CBC)</a:t>
+            </a:r>
+          </a:p>
+          <a:p xmlns:a="http://schemas.openxmlformats.org/drawingml/2006/main">
+            <a:r>
+              <a:t>Prostate-specific antigen (PSA)</a:t>
+            </a:r>
+          </a:p>
+          <a:p xmlns:a="http://schemas.openxmlformats.org/drawingml/2006/main">
+            <a:r>
+              <a:t>Blood glucose (BST/HbA1c)</a:t>
+            </a:r>
+          </a:p>
+          <a:p xmlns:a="http://schemas.openxmlformats.org/drawingml/2006/main">
+            <a:r>
+              <a:t>HIV testing</a:t>
+            </a:r>
+          </a:p>
+          <a:p xmlns:a="http://schemas.openxmlformats.org/drawingml/2006/main">
+            <a:r>
+              <a:t>Syphilis testing</a:t>
+            </a:r>
+          </a:p>
+          <a:p xmlns:a="http://schemas.openxmlformats.org/drawingml/2006/main">
+            <a:r>
+              <a:t>Urine testing</a:t>
+            </a:r>
+          </a:p>
+          <a:p xmlns:a="http://schemas.openxmlformats.org/drawingml/2006/main">
+            <a:r>
+              <a:t>Liver enzymes (GOT/GPT/GGT)</a:t>
+            </a:r>
+          </a:p>
+          <a:p xmlns:a="http://schemas.openxmlformats.org/drawingml/2006/main">
+            <a:r>
+              <a:t>Inflammatory markers</a:t>
+            </a:r>
+          </a:p>
+          <a:p xmlns:a="http://schemas.openxmlformats.org/drawingml/2006/main">
+            <a:r>
+              <a:t/>
+            </a:r>
+          </a:p>
+          <a:p xmlns:a="http://schemas.openxmlformats.org/drawingml/2006/main">
+            <a:r>
+              <a:t>HbA1c denotes glycated hemoglobin and appears under the blood glucose heading.</a:t>
+            </a:r>
+          </a:p>
+          <a:p xmlns:a="http://schemas.openxmlformats.org/drawingml/2006/main">
+            <a:r>
+              <a:t>Sources: https://pubmed.ncbi.nlm.nih.gov/9187685/ ; https://pubmed.ncbi.nlm.nih.gov/17568761/ ; https://www.niddk.nih.gov/health-information/diagnostic-tests/a1c-test/ ; https://pubmed.ncbi.nlm.nih.gov/28874780/</a:t>
             </a:r>
           </a:p>
         </p:txBody>
@@ -1184,6 +1619,46 @@
           <a:lstStyle xmlns:a="http://schemas.openxmlformats.org/drawingml/2006/main"/>
           <a:p xmlns:a="http://schemas.openxmlformats.org/drawingml/2006/main">
             <a:r>
+              <a:t>English speaker cues</a:t>
+            </a:r>
+          </a:p>
+          <a:p xmlns:a="http://schemas.openxmlformats.org/drawingml/2006/main">
+            <a:r>
+              <a:t>1. Preparation: Shaving and draping</a:t>
+            </a:r>
+          </a:p>
+          <a:p xmlns:a="http://schemas.openxmlformats.org/drawingml/2006/main">
+            <a:r>
+              <a:t>2. Shaving: Preparation area shown in the video</a:t>
+            </a:r>
+          </a:p>
+          <a:p xmlns:a="http://schemas.openxmlformats.org/drawingml/2006/main">
+            <a:r>
+              <a:t>3. Draping: Sequence shown in the video</a:t>
+            </a:r>
+          </a:p>
+          <a:p xmlns:a="http://schemas.openxmlformats.org/drawingml/2006/main">
+            <a:r>
+              <a:t/>
+            </a:r>
+          </a:p>
+          <a:p xmlns:a="http://schemas.openxmlformats.org/drawingml/2006/main">
+            <a:r>
+              <a:t>Next: Now, let’s look at the first case: a pubic incision.</a:t>
+            </a:r>
+          </a:p>
+          <a:p xmlns:a="http://schemas.openxmlformats.org/drawingml/2006/main">
+            <a:r>
+              <a:t/>
+            </a:r>
+          </a:p>
+          <a:p xmlns:a="http://schemas.openxmlformats.org/drawingml/2006/main">
+            <a:r>
+              <a:t>Reference notes</a:t>
+            </a:r>
+          </a:p>
+          <a:p xmlns:a="http://schemas.openxmlformats.org/drawingml/2006/main">
+            <a:r>
               <a:t>Shaving and draping.</a:t>
             </a:r>
           </a:p>
@@ -1254,6 +1729,51 @@
           <a:lstStyle xmlns:a="http://schemas.openxmlformats.org/drawingml/2006/main"/>
           <a:p xmlns:a="http://schemas.openxmlformats.org/drawingml/2006/main">
             <a:r>
+              <a:t>English speaker cues</a:t>
+            </a:r>
+          </a:p>
+          <a:p xmlns:a="http://schemas.openxmlformats.org/drawingml/2006/main">
+            <a:r>
+              <a:t>1. Case 1: Pubic incision</a:t>
+            </a:r>
+          </a:p>
+          <a:p xmlns:a="http://schemas.openxmlformats.org/drawingml/2006/main">
+            <a:r>
+              <a:t>2. Case introduction: Clinical background / choice of incision</a:t>
+            </a:r>
+          </a:p>
+          <a:p xmlns:a="http://schemas.openxmlformats.org/drawingml/2006/main">
+            <a:r>
+              <a:t>3. Video walkthrough: Incision / key operative stages</a:t>
+            </a:r>
+          </a:p>
+          <a:p xmlns:a="http://schemas.openxmlformats.org/drawingml/2006/main">
+            <a:r>
+              <a:t>4. Discussion: Main points from this case</a:t>
+            </a:r>
+          </a:p>
+          <a:p xmlns:a="http://schemas.openxmlformats.org/drawingml/2006/main">
+            <a:r>
+              <a:t/>
+            </a:r>
+          </a:p>
+          <a:p xmlns:a="http://schemas.openxmlformats.org/drawingml/2006/main">
+            <a:r>
+              <a:t>Next: The next case uses a circumcision-line incision.</a:t>
+            </a:r>
+          </a:p>
+          <a:p xmlns:a="http://schemas.openxmlformats.org/drawingml/2006/main">
+            <a:r>
+              <a:t/>
+            </a:r>
+          </a:p>
+          <a:p xmlns:a="http://schemas.openxmlformats.org/drawingml/2006/main">
+            <a:r>
+              <a:t>Reference notes</a:t>
+            </a:r>
+          </a:p>
+          <a:p xmlns:a="http://schemas.openxmlformats.org/drawingml/2006/main">
+            <a:r>
               <a:t>Case 1: Pubic Incision.</a:t>
             </a:r>
           </a:p>
@@ -1324,6 +1844,51 @@
           <a:lstStyle xmlns:a="http://schemas.openxmlformats.org/drawingml/2006/main"/>
           <a:p xmlns:a="http://schemas.openxmlformats.org/drawingml/2006/main">
             <a:r>
+              <a:t>English speaker cues</a:t>
+            </a:r>
+          </a:p>
+          <a:p xmlns:a="http://schemas.openxmlformats.org/drawingml/2006/main">
+            <a:r>
+              <a:t>1. Case 2: Circumcision-line incision</a:t>
+            </a:r>
+          </a:p>
+          <a:p xmlns:a="http://schemas.openxmlformats.org/drawingml/2006/main">
+            <a:r>
+              <a:t>2. Case introduction: Clinical background / choice of incision</a:t>
+            </a:r>
+          </a:p>
+          <a:p xmlns:a="http://schemas.openxmlformats.org/drawingml/2006/main">
+            <a:r>
+              <a:t>3. Video walkthrough: Incision / key operative stages</a:t>
+            </a:r>
+          </a:p>
+          <a:p xmlns:a="http://schemas.openxmlformats.org/drawingml/2006/main">
+            <a:r>
+              <a:t>4. Comparison: Points to compare with the pubic approach</a:t>
+            </a:r>
+          </a:p>
+          <a:p xmlns:a="http://schemas.openxmlformats.org/drawingml/2006/main">
+            <a:r>
+              <a:t/>
+            </a:r>
+          </a:p>
+          <a:p xmlns:a="http://schemas.openxmlformats.org/drawingml/2006/main">
+            <a:r>
+              <a:t>Next: Next, we’ll look at secondary dermal grafting.</a:t>
+            </a:r>
+          </a:p>
+          <a:p xmlns:a="http://schemas.openxmlformats.org/drawingml/2006/main">
+            <a:r>
+              <a:t/>
+            </a:r>
+          </a:p>
+          <a:p xmlns:a="http://schemas.openxmlformats.org/drawingml/2006/main">
+            <a:r>
+              <a:t>Reference notes</a:t>
+            </a:r>
+          </a:p>
+          <a:p xmlns:a="http://schemas.openxmlformats.org/drawingml/2006/main">
+            <a:r>
               <a:t>Case 2: Circumcision-line Incision.</a:t>
             </a:r>
           </a:p>
@@ -1394,6 +1959,51 @@
           <a:lstStyle xmlns:a="http://schemas.openxmlformats.org/drawingml/2006/main"/>
           <a:p xmlns:a="http://schemas.openxmlformats.org/drawingml/2006/main">
             <a:r>
+              <a:t>English speaker cues</a:t>
+            </a:r>
+          </a:p>
+          <a:p xmlns:a="http://schemas.openxmlformats.org/drawingml/2006/main">
+            <a:r>
+              <a:t>1. Case 3: Secondary dermal grafting</a:t>
+            </a:r>
+          </a:p>
+          <a:p xmlns:a="http://schemas.openxmlformats.org/drawingml/2006/main">
+            <a:r>
+              <a:t>2. Background: Previous procedure / reason for a second graft</a:t>
+            </a:r>
+          </a:p>
+          <a:p xmlns:a="http://schemas.openxmlformats.org/drawingml/2006/main">
+            <a:r>
+              <a:t>3. Video walkthrough: Key operative stages</a:t>
+            </a:r>
+          </a:p>
+          <a:p xmlns:a="http://schemas.openxmlformats.org/drawingml/2006/main">
+            <a:r>
+              <a:t>4. Discussion: Main considerations in this case</a:t>
+            </a:r>
+          </a:p>
+          <a:p xmlns:a="http://schemas.openxmlformats.org/drawingml/2006/main">
+            <a:r>
+              <a:t/>
+            </a:r>
+          </a:p>
+          <a:p xmlns:a="http://schemas.openxmlformats.org/drawingml/2006/main">
+            <a:r>
+              <a:t>Next: Let’s move on to the revision surgery case.</a:t>
+            </a:r>
+          </a:p>
+          <a:p xmlns:a="http://schemas.openxmlformats.org/drawingml/2006/main">
+            <a:r>
+              <a:t/>
+            </a:r>
+          </a:p>
+          <a:p xmlns:a="http://schemas.openxmlformats.org/drawingml/2006/main">
+            <a:r>
+              <a:t>Reference notes</a:t>
+            </a:r>
+          </a:p>
+          <a:p xmlns:a="http://schemas.openxmlformats.org/drawingml/2006/main">
+            <a:r>
               <a:t>Case 3: Secondary Dermal Grafting.</a:t>
             </a:r>
           </a:p>
@@ -1464,6 +2074,51 @@
           <a:lstStyle xmlns:a="http://schemas.openxmlformats.org/drawingml/2006/main"/>
           <a:p xmlns:a="http://schemas.openxmlformats.org/drawingml/2006/main">
             <a:r>
+              <a:t>English speaker cues</a:t>
+            </a:r>
+          </a:p>
+          <a:p xmlns:a="http://schemas.openxmlformats.org/drawingml/2006/main">
+            <a:r>
+              <a:t>1. Case 4: Revision surgery</a:t>
+            </a:r>
+          </a:p>
+          <a:p xmlns:a="http://schemas.openxmlformats.org/drawingml/2006/main">
+            <a:r>
+              <a:t>2. Background: Previous procedure / reason for revision</a:t>
+            </a:r>
+          </a:p>
+          <a:p xmlns:a="http://schemas.openxmlformats.org/drawingml/2006/main">
+            <a:r>
+              <a:t>3. Video walkthrough: Operative findings / key stages</a:t>
+            </a:r>
+          </a:p>
+          <a:p xmlns:a="http://schemas.openxmlformats.org/drawingml/2006/main">
+            <a:r>
+              <a:t>4. Discussion: Points to highlight in revision surgery</a:t>
+            </a:r>
+          </a:p>
+          <a:p xmlns:a="http://schemas.openxmlformats.org/drawingml/2006/main">
+            <a:r>
+              <a:t/>
+            </a:r>
+          </a:p>
+          <a:p xmlns:a="http://schemas.openxmlformats.org/drawingml/2006/main">
+            <a:r>
+              <a:t>Next: The final case focuses on contour step-off correction.</a:t>
+            </a:r>
+          </a:p>
+          <a:p xmlns:a="http://schemas.openxmlformats.org/drawingml/2006/main">
+            <a:r>
+              <a:t/>
+            </a:r>
+          </a:p>
+          <a:p xmlns:a="http://schemas.openxmlformats.org/drawingml/2006/main">
+            <a:r>
+              <a:t>Reference notes</a:t>
+            </a:r>
+          </a:p>
+          <a:p xmlns:a="http://schemas.openxmlformats.org/drawingml/2006/main">
+            <a:r>
               <a:t>Case 4: Revision Surgery.</a:t>
             </a:r>
           </a:p>
@@ -1511,7 +2166,7 @@
           <p:cNvPr id="3" name="Title">
             <a:extLst xmlns:a="http://schemas.openxmlformats.org/drawingml/2006/main">
               <a:ext uri="{FF2B5EF4-FFF2-40B4-BE49-F238E27FC236}">
-                <a16:creationId xmlns:a16="http://schemas.microsoft.com/office/drawing/2014/main" id="{BA6E44E8-36A2-48F6-92E2-2C97D5563E81}"/>
+                <a16:creationId xmlns:a16="http://schemas.microsoft.com/office/drawing/2014/main" id="{27C6096E-E675-4380-B15A-048DD894C14E}"/>
               </a:ext>
             </a:extLst>
           </p:cNvPr>
@@ -1668,7 +2323,7 @@
           <p:cNvPr id="2" name="Subtitle">
             <a:extLst xmlns:a="http://schemas.openxmlformats.org/drawingml/2006/main">
               <a:ext uri="{FF2B5EF4-FFF2-40B4-BE49-F238E27FC236}">
-                <a16:creationId xmlns:a16="http://schemas.microsoft.com/office/drawing/2014/main" id="{8377F09F-61C5-4117-B6FF-CAF930E61879}"/>
+                <a16:creationId xmlns:a16="http://schemas.microsoft.com/office/drawing/2014/main" id="{17D2D398-B998-4049-B67B-A1C56877972D}"/>
               </a:ext>
             </a:extLst>
           </p:cNvPr>
@@ -1842,7 +2497,7 @@
           <p:cNvPr id="2" name="Section title">
             <a:extLst xmlns:a="http://schemas.openxmlformats.org/drawingml/2006/main">
               <a:ext uri="{FF2B5EF4-FFF2-40B4-BE49-F238E27FC236}">
-                <a16:creationId xmlns:a16="http://schemas.microsoft.com/office/drawing/2014/main" id="{1B3A2E59-D483-4F2F-B85D-769B5E3D00DB}"/>
+                <a16:creationId xmlns:a16="http://schemas.microsoft.com/office/drawing/2014/main" id="{994B1434-F3C9-4B68-BFB4-FD8F4C17A42E}"/>
               </a:ext>
             </a:extLst>
           </p:cNvPr>
@@ -2016,7 +2671,7 @@
           <p:cNvPr id="3" name="Title">
             <a:extLst xmlns:a="http://schemas.openxmlformats.org/drawingml/2006/main">
               <a:ext uri="{FF2B5EF4-FFF2-40B4-BE49-F238E27FC236}">
-                <a16:creationId xmlns:a16="http://schemas.microsoft.com/office/drawing/2014/main" id="{97EC275D-06C9-430E-A7B4-06E8C22A702A}"/>
+                <a16:creationId xmlns:a16="http://schemas.microsoft.com/office/drawing/2014/main" id="{260B1DB4-5880-4901-AEB5-A0D182AE3E4B}"/>
               </a:ext>
             </a:extLst>
           </p:cNvPr>
@@ -2173,7 +2828,7 @@
           <p:cNvPr id="2" name="Body">
             <a:extLst xmlns:a="http://schemas.openxmlformats.org/drawingml/2006/main">
               <a:ext uri="{FF2B5EF4-FFF2-40B4-BE49-F238E27FC236}">
-                <a16:creationId xmlns:a16="http://schemas.microsoft.com/office/drawing/2014/main" id="{6A8556CA-28A7-4FBC-9532-D7C5527857B2}"/>
+                <a16:creationId xmlns:a16="http://schemas.microsoft.com/office/drawing/2014/main" id="{A700FADC-1DA2-4DC4-A14A-D41D2ECAAA08}"/>
               </a:ext>
             </a:extLst>
           </p:cNvPr>
@@ -2347,7 +3002,7 @@
           <p:cNvPr id="4" name="Title">
             <a:extLst xmlns:a="http://schemas.openxmlformats.org/drawingml/2006/main">
               <a:ext uri="{FF2B5EF4-FFF2-40B4-BE49-F238E27FC236}">
-                <a16:creationId xmlns:a16="http://schemas.microsoft.com/office/drawing/2014/main" id="{BF69A508-08B1-41F4-942C-B4784B007BA4}"/>
+                <a16:creationId xmlns:a16="http://schemas.microsoft.com/office/drawing/2014/main" id="{1D072A85-2F9A-46FB-8E94-C805E047E7FA}"/>
               </a:ext>
             </a:extLst>
           </p:cNvPr>
@@ -2504,7 +3159,7 @@
           <p:cNvPr id="2" name="Left column">
             <a:extLst xmlns:a="http://schemas.openxmlformats.org/drawingml/2006/main">
               <a:ext uri="{FF2B5EF4-FFF2-40B4-BE49-F238E27FC236}">
-                <a16:creationId xmlns:a16="http://schemas.microsoft.com/office/drawing/2014/main" id="{E85EF9FD-27EB-422A-8667-50F2D0DDF09C}"/>
+                <a16:creationId xmlns:a16="http://schemas.microsoft.com/office/drawing/2014/main" id="{86B9D404-A29F-4355-935F-DAD68C0FF903}"/>
               </a:ext>
             </a:extLst>
           </p:cNvPr>
@@ -2661,7 +3316,7 @@
           <p:cNvPr id="3" name="Right column">
             <a:extLst xmlns:a="http://schemas.openxmlformats.org/drawingml/2006/main">
               <a:ext uri="{FF2B5EF4-FFF2-40B4-BE49-F238E27FC236}">
-                <a16:creationId xmlns:a16="http://schemas.microsoft.com/office/drawing/2014/main" id="{C568216B-8AC9-410A-9ADA-52996E576049}"/>
+                <a16:creationId xmlns:a16="http://schemas.microsoft.com/office/drawing/2014/main" id="{416575E4-2548-43E1-BC38-C5B844EEA2A7}"/>
               </a:ext>
             </a:extLst>
           </p:cNvPr>
@@ -2835,7 +3490,7 @@
           <p:cNvPr id="3" name="Title">
             <a:extLst xmlns:a="http://schemas.openxmlformats.org/drawingml/2006/main">
               <a:ext uri="{FF2B5EF4-FFF2-40B4-BE49-F238E27FC236}">
-                <a16:creationId xmlns:a16="http://schemas.microsoft.com/office/drawing/2014/main" id="{8FBB7E8F-CB9C-4629-9493-7F46CC3C682A}"/>
+                <a16:creationId xmlns:a16="http://schemas.microsoft.com/office/drawing/2014/main" id="{DC5FC2AC-46E1-47D9-BBB5-4D0FB235D22C}"/>
               </a:ext>
             </a:extLst>
           </p:cNvPr>
@@ -2992,7 +3647,7 @@
           <p:cNvPr id="2" name="Left column">
             <a:extLst xmlns:a="http://schemas.openxmlformats.org/drawingml/2006/main">
               <a:ext uri="{FF2B5EF4-FFF2-40B4-BE49-F238E27FC236}">
-                <a16:creationId xmlns:a16="http://schemas.microsoft.com/office/drawing/2014/main" id="{C3A317F4-05E1-4441-9077-6D8960B0D364}"/>
+                <a16:creationId xmlns:a16="http://schemas.microsoft.com/office/drawing/2014/main" id="{F6D3A1C0-EA1A-4D31-8D61-D46F6D32F187}"/>
               </a:ext>
             </a:extLst>
           </p:cNvPr>
@@ -3187,12 +3842,12 @@
   </p:cSld>
   <p:clrMap bg1="lt1" tx1="dk1" bg2="lt2" tx2="dk2" accent1="accent1" accent2="accent2" accent3="accent3" accent4="accent4" accent5="accent5" accent6="accent6" hlink="hlink" folHlink="folHlink"/>
   <p:sldLayoutIdLst>
-    <p:sldLayoutId xmlns:r="http://schemas.openxmlformats.org/officeDocument/2006/relationships" id="2147483649" r:id="Rc4724ac84be746b1"/>
-    <p:sldLayoutId xmlns:r="http://schemas.openxmlformats.org/officeDocument/2006/relationships" id="2147483650" r:id="Rb1eb53b8fd6f4483"/>
-    <p:sldLayoutId xmlns:r="http://schemas.openxmlformats.org/officeDocument/2006/relationships" id="2147483651" r:id="Re94d184f823f4d91"/>
-    <p:sldLayoutId xmlns:r="http://schemas.openxmlformats.org/officeDocument/2006/relationships" id="2147483652" r:id="Rfc070b71b8854a19"/>
-    <p:sldLayoutId xmlns:r="http://schemas.openxmlformats.org/officeDocument/2006/relationships" id="2147483653" r:id="Rc1c8252ac377411c"/>
-    <p:sldLayoutId xmlns:r="http://schemas.openxmlformats.org/officeDocument/2006/relationships" id="2147483654" r:id="Re0385a36e136425f"/>
+    <p:sldLayoutId xmlns:r="http://schemas.openxmlformats.org/officeDocument/2006/relationships" id="2147483649" r:id="Rd19d98a4e9574cd8"/>
+    <p:sldLayoutId xmlns:r="http://schemas.openxmlformats.org/officeDocument/2006/relationships" id="2147483650" r:id="Rd89c8810b2a84e08"/>
+    <p:sldLayoutId xmlns:r="http://schemas.openxmlformats.org/officeDocument/2006/relationships" id="2147483651" r:id="Re3a7eb4a41ae4188"/>
+    <p:sldLayoutId xmlns:r="http://schemas.openxmlformats.org/officeDocument/2006/relationships" id="2147483652" r:id="R6d7986affa2b4985"/>
+    <p:sldLayoutId xmlns:r="http://schemas.openxmlformats.org/officeDocument/2006/relationships" id="2147483653" r:id="Rcbab3b194cf04a45"/>
+    <p:sldLayoutId xmlns:r="http://schemas.openxmlformats.org/officeDocument/2006/relationships" id="2147483654" r:id="R1bb94d15d9b047cd"/>
   </p:sldLayoutIdLst>
   <p:txStyles>
     <p:titleStyle>
@@ -3743,7 +4398,7 @@
           <p:cNvPr id="10" name="">
             <a:extLst xmlns:a="http://schemas.openxmlformats.org/drawingml/2006/main">
               <a:ext uri="{FF2B5EF4-FFF2-40B4-BE49-F238E27FC236}">
-                <a16:creationId xmlns:a16="http://schemas.microsoft.com/office/drawing/2014/main" id="{A591CCF0-2539-48EC-B549-390411116881}"/>
+                <a16:creationId xmlns:a16="http://schemas.microsoft.com/office/drawing/2014/main" id="{9E47E1F0-1CD4-4D5D-9CBC-BB90E5818A61}"/>
               </a:ext>
             </a:extLst>
           </p:cNvPr>
@@ -3753,7 +4408,7 @@
           <p:nvPr/>
         </p:nvPicPr>
         <p:blipFill>
-          <a:blip xmlns:r="http://schemas.openxmlformats.org/officeDocument/2006/relationships" xmlns:a="http://schemas.openxmlformats.org/drawingml/2006/main" r:embed="R2a47e04123a042c6"/>
+          <a:blip xmlns:r="http://schemas.openxmlformats.org/officeDocument/2006/relationships" xmlns:a="http://schemas.openxmlformats.org/drawingml/2006/main" r:embed="Rcb30f71bcb7d405e"/>
           <a:stretch xmlns:a="http://schemas.openxmlformats.org/drawingml/2006/main"/>
         </p:blipFill>
         <p:spPr>
@@ -3771,7 +4426,7 @@
           <p:cNvPr id="2" name="">
             <a:extLst xmlns:a="http://schemas.openxmlformats.org/drawingml/2006/main">
               <a:ext uri="{FF2B5EF4-FFF2-40B4-BE49-F238E27FC236}">
-                <a16:creationId xmlns:a16="http://schemas.microsoft.com/office/drawing/2014/main" id="{41D26FB7-B807-4589-BB9A-3C89F554B5BE}"/>
+                <a16:creationId xmlns:a16="http://schemas.microsoft.com/office/drawing/2014/main" id="{11EB56E4-2F35-441F-A096-F3F3F30F9F36}"/>
               </a:ext>
             </a:extLst>
           </p:cNvPr>
@@ -3781,7 +4436,7 @@
           <p:nvPr/>
         </p:nvPicPr>
         <p:blipFill>
-          <a:blip xmlns:r="http://schemas.openxmlformats.org/officeDocument/2006/relationships" xmlns:a="http://schemas.openxmlformats.org/drawingml/2006/main" r:embed="R7d596187d54343c3"/>
+          <a:blip xmlns:r="http://schemas.openxmlformats.org/officeDocument/2006/relationships" xmlns:a="http://schemas.openxmlformats.org/drawingml/2006/main" r:embed="Rc6123dde08094660"/>
           <a:srcRect xmlns:a="http://schemas.openxmlformats.org/drawingml/2006/main" l="33753" t="0" r="33753" b="0"/>
           <a:stretch xmlns:a="http://schemas.openxmlformats.org/drawingml/2006/main">
             <a:fillRect l="0" t="0" r="0" b="0"/>
@@ -3802,7 +4457,7 @@
           <p:cNvPr id="3" name="">
             <a:extLst xmlns:a="http://schemas.openxmlformats.org/drawingml/2006/main">
               <a:ext uri="{FF2B5EF4-FFF2-40B4-BE49-F238E27FC236}">
-                <a16:creationId xmlns:a16="http://schemas.microsoft.com/office/drawing/2014/main" id="{FD499451-1EBE-44EE-A063-F19D15B18BF7}"/>
+                <a16:creationId xmlns:a16="http://schemas.microsoft.com/office/drawing/2014/main" id="{8EE0AC53-D362-4FEC-A254-0DB0D6897805}"/>
               </a:ext>
             </a:extLst>
           </p:cNvPr>
@@ -3870,7 +4525,7 @@
           <p:cNvPr id="4" name="">
             <a:extLst xmlns:a="http://schemas.openxmlformats.org/drawingml/2006/main">
               <a:ext uri="{FF2B5EF4-FFF2-40B4-BE49-F238E27FC236}">
-                <a16:creationId xmlns:a16="http://schemas.microsoft.com/office/drawing/2014/main" id="{E48F6B55-A3CE-46A1-9338-5D6766B51F48}"/>
+                <a16:creationId xmlns:a16="http://schemas.microsoft.com/office/drawing/2014/main" id="{28EBEFA5-8A15-4B5C-9D6B-9D9213F9C948}"/>
               </a:ext>
             </a:extLst>
           </p:cNvPr>
@@ -3938,7 +4593,7 @@
           <p:cNvPr id="5" name="">
             <a:extLst xmlns:a="http://schemas.openxmlformats.org/drawingml/2006/main">
               <a:ext uri="{FF2B5EF4-FFF2-40B4-BE49-F238E27FC236}">
-                <a16:creationId xmlns:a16="http://schemas.microsoft.com/office/drawing/2014/main" id="{11AEA38E-BE10-4125-9DDF-FB18401763AC}"/>
+                <a16:creationId xmlns:a16="http://schemas.microsoft.com/office/drawing/2014/main" id="{7D3D55EA-F3A9-4D9A-880C-F4102DBD5DC7}"/>
               </a:ext>
             </a:extLst>
           </p:cNvPr>
@@ -4006,7 +4661,7 @@
           <p:cNvPr id="6" name="">
             <a:extLst xmlns:a="http://schemas.openxmlformats.org/drawingml/2006/main">
               <a:ext uri="{FF2B5EF4-FFF2-40B4-BE49-F238E27FC236}">
-                <a16:creationId xmlns:a16="http://schemas.microsoft.com/office/drawing/2014/main" id="{8671C907-7001-4257-A167-1069279BA2E0}"/>
+                <a16:creationId xmlns:a16="http://schemas.microsoft.com/office/drawing/2014/main" id="{7B44CA6E-364A-4D94-8D09-04E7E04520A1}"/>
               </a:ext>
             </a:extLst>
           </p:cNvPr>
@@ -4074,7 +4729,7 @@
           <p:cNvPr id="7" name="">
             <a:extLst xmlns:a="http://schemas.openxmlformats.org/drawingml/2006/main">
               <a:ext uri="{FF2B5EF4-FFF2-40B4-BE49-F238E27FC236}">
-                <a16:creationId xmlns:a16="http://schemas.microsoft.com/office/drawing/2014/main" id="{2EB36733-837F-4304-85ED-D87D871A94C8}"/>
+                <a16:creationId xmlns:a16="http://schemas.microsoft.com/office/drawing/2014/main" id="{BF18D874-585A-4AF1-A337-0386EEA9B5FA}"/>
               </a:ext>
             </a:extLst>
           </p:cNvPr>
@@ -4142,7 +4797,7 @@
           <p:cNvPr id="8" name="">
             <a:extLst xmlns:a="http://schemas.openxmlformats.org/drawingml/2006/main">
               <a:ext uri="{FF2B5EF4-FFF2-40B4-BE49-F238E27FC236}">
-                <a16:creationId xmlns:a16="http://schemas.microsoft.com/office/drawing/2014/main" id="{767ED2A9-F42B-47A0-84E7-C52E6DC90345}"/>
+                <a16:creationId xmlns:a16="http://schemas.microsoft.com/office/drawing/2014/main" id="{2B93DB93-CD5C-4ED8-80BE-65DCD50DC6F2}"/>
               </a:ext>
             </a:extLst>
           </p:cNvPr>
@@ -4210,7 +4865,7 @@
           <p:cNvPr id="9" name="">
             <a:extLst xmlns:a="http://schemas.openxmlformats.org/drawingml/2006/main">
               <a:ext uri="{FF2B5EF4-FFF2-40B4-BE49-F238E27FC236}">
-                <a16:creationId xmlns:a16="http://schemas.microsoft.com/office/drawing/2014/main" id="{84F06D45-54D4-4D05-940C-D4540FF05B9C}"/>
+                <a16:creationId xmlns:a16="http://schemas.microsoft.com/office/drawing/2014/main" id="{C05F4DDB-91D3-4CA8-9903-C11AA20E1EAC}"/>
               </a:ext>
             </a:extLst>
           </p:cNvPr>
@@ -4276,7 +4931,7 @@
     </p:spTree>
     <p:extLst>
       <p:ext uri="{BB962C8B-B14F-4D97-AF65-F5344CB8AC3E}">
-        <p14:creationId xmlns:p14="http://schemas.microsoft.com/office/powerpoint/2010/main" val="194976157"/>
+        <p14:creationId xmlns:p14="http://schemas.microsoft.com/office/powerpoint/2010/main" val="1772130009"/>
       </p:ext>
     </p:extLst>
   </p:cSld>
@@ -4307,7 +4962,7 @@
           <p:cNvPr id="7" name="">
             <a:extLst xmlns:a="http://schemas.openxmlformats.org/drawingml/2006/main">
               <a:ext uri="{FF2B5EF4-FFF2-40B4-BE49-F238E27FC236}">
-                <a16:creationId xmlns:a16="http://schemas.microsoft.com/office/drawing/2014/main" id="{26CC8578-BE60-47F4-AEA0-46737A50AF15}"/>
+                <a16:creationId xmlns:a16="http://schemas.microsoft.com/office/drawing/2014/main" id="{CEB84374-0108-4269-BC3B-7146CF9A3259}"/>
               </a:ext>
             </a:extLst>
           </p:cNvPr>
@@ -4375,7 +5030,7 @@
           <p:cNvPr id="2" name="">
             <a:extLst xmlns:a="http://schemas.openxmlformats.org/drawingml/2006/main">
               <a:ext uri="{FF2B5EF4-FFF2-40B4-BE49-F238E27FC236}">
-                <a16:creationId xmlns:a16="http://schemas.microsoft.com/office/drawing/2014/main" id="{FDF9F4FA-198F-4D36-99AA-C7F859ECECC0}"/>
+                <a16:creationId xmlns:a16="http://schemas.microsoft.com/office/drawing/2014/main" id="{27A65675-A167-4367-85D7-AC6864AEBE73}"/>
               </a:ext>
             </a:extLst>
           </p:cNvPr>
@@ -4443,7 +5098,7 @@
           <p:cNvPr id="3" name="">
             <a:extLst xmlns:a="http://schemas.openxmlformats.org/drawingml/2006/main">
               <a:ext uri="{FF2B5EF4-FFF2-40B4-BE49-F238E27FC236}">
-                <a16:creationId xmlns:a16="http://schemas.microsoft.com/office/drawing/2014/main" id="{E3722FED-58C5-4CF9-9D75-C0E52A159F55}"/>
+                <a16:creationId xmlns:a16="http://schemas.microsoft.com/office/drawing/2014/main" id="{4CEA7D54-F4B9-4CA7-805D-B3EDAECF94D7}"/>
               </a:ext>
             </a:extLst>
           </p:cNvPr>
@@ -4453,7 +5108,7 @@
           <p:nvPr/>
         </p:nvPicPr>
         <p:blipFill>
-          <a:blip xmlns:r="http://schemas.openxmlformats.org/officeDocument/2006/relationships" xmlns:a="http://schemas.openxmlformats.org/drawingml/2006/main" r:embed="Rcdb83d08ba654c5f"/>
+          <a:blip xmlns:r="http://schemas.openxmlformats.org/officeDocument/2006/relationships" xmlns:a="http://schemas.openxmlformats.org/drawingml/2006/main" r:embed="Ra08f033cecff44b9"/>
           <a:stretch xmlns:a="http://schemas.openxmlformats.org/drawingml/2006/main"/>
         </p:blipFill>
         <p:spPr>
@@ -4471,7 +5126,7 @@
           <p:cNvPr id="4" name="">
             <a:extLst xmlns:a="http://schemas.openxmlformats.org/drawingml/2006/main">
               <a:ext uri="{FF2B5EF4-FFF2-40B4-BE49-F238E27FC236}">
-                <a16:creationId xmlns:a16="http://schemas.microsoft.com/office/drawing/2014/main" id="{7B75758C-78CE-4C36-A0A3-D8BBF900E3F2}"/>
+                <a16:creationId xmlns:a16="http://schemas.microsoft.com/office/drawing/2014/main" id="{1DB844E3-8995-447A-BB2E-78ABAE1A80F4}"/>
               </a:ext>
             </a:extLst>
           </p:cNvPr>
@@ -4501,7 +5156,7 @@
           <p:cNvPr id="5" name="">
             <a:extLst xmlns:a="http://schemas.openxmlformats.org/drawingml/2006/main">
               <a:ext uri="{FF2B5EF4-FFF2-40B4-BE49-F238E27FC236}">
-                <a16:creationId xmlns:a16="http://schemas.microsoft.com/office/drawing/2014/main" id="{7A062B07-BC86-4147-BA28-D47C5FAB428A}"/>
+                <a16:creationId xmlns:a16="http://schemas.microsoft.com/office/drawing/2014/main" id="{62D8CFD7-62F8-4E9F-BE50-C44F0EE619A5}"/>
               </a:ext>
             </a:extLst>
           </p:cNvPr>
@@ -4569,7 +5224,7 @@
           <p:cNvPr id="6" name="">
             <a:extLst xmlns:a="http://schemas.openxmlformats.org/drawingml/2006/main">
               <a:ext uri="{FF2B5EF4-FFF2-40B4-BE49-F238E27FC236}">
-                <a16:creationId xmlns:a16="http://schemas.microsoft.com/office/drawing/2014/main" id="{31D684FD-AEC7-4EE4-B93D-3C2BADE10F69}"/>
+                <a16:creationId xmlns:a16="http://schemas.microsoft.com/office/drawing/2014/main" id="{5AA004F3-9460-4B27-9664-CB39D1A5117D}"/>
               </a:ext>
             </a:extLst>
           </p:cNvPr>
@@ -4635,7 +5290,7 @@
     </p:spTree>
     <p:extLst>
       <p:ext uri="{BB962C8B-B14F-4D97-AF65-F5344CB8AC3E}">
-        <p14:creationId xmlns:p14="http://schemas.microsoft.com/office/powerpoint/2010/main" val="539547310"/>
+        <p14:creationId xmlns:p14="http://schemas.microsoft.com/office/powerpoint/2010/main" val="1983049174"/>
       </p:ext>
     </p:extLst>
   </p:cSld>
@@ -4666,7 +5321,7 @@
           <p:cNvPr id="15" name="">
             <a:extLst xmlns:a="http://schemas.openxmlformats.org/drawingml/2006/main">
               <a:ext uri="{FF2B5EF4-FFF2-40B4-BE49-F238E27FC236}">
-                <a16:creationId xmlns:a16="http://schemas.microsoft.com/office/drawing/2014/main" id="{E938EF6B-FE62-445D-AE07-6BBD213B7ED7}"/>
+                <a16:creationId xmlns:a16="http://schemas.microsoft.com/office/drawing/2014/main" id="{83825552-2A7F-4A93-9708-20354F35901C}"/>
               </a:ext>
             </a:extLst>
           </p:cNvPr>
@@ -4734,7 +5389,7 @@
           <p:cNvPr id="2" name="">
             <a:extLst xmlns:a="http://schemas.openxmlformats.org/drawingml/2006/main">
               <a:ext uri="{FF2B5EF4-FFF2-40B4-BE49-F238E27FC236}">
-                <a16:creationId xmlns:a16="http://schemas.microsoft.com/office/drawing/2014/main" id="{D599F160-A985-41CF-9F75-7E709AF682BB}"/>
+                <a16:creationId xmlns:a16="http://schemas.microsoft.com/office/drawing/2014/main" id="{F87BFEE2-2E36-47A9-A6DC-5AC77C56A7DC}"/>
               </a:ext>
             </a:extLst>
           </p:cNvPr>
@@ -4744,7 +5399,7 @@
           <p:nvPr/>
         </p:nvPicPr>
         <p:blipFill>
-          <a:blip xmlns:r="http://schemas.openxmlformats.org/officeDocument/2006/relationships" xmlns:a="http://schemas.openxmlformats.org/drawingml/2006/main" r:embed="R8624a900c7574ce9"/>
+          <a:blip xmlns:r="http://schemas.openxmlformats.org/officeDocument/2006/relationships" xmlns:a="http://schemas.openxmlformats.org/drawingml/2006/main" r:embed="Rfc687dbf8e9b4b20"/>
           <a:stretch xmlns:a="http://schemas.openxmlformats.org/drawingml/2006/main"/>
         </p:blipFill>
         <p:spPr>
@@ -4762,7 +5417,7 @@
           <p:cNvPr id="3" name="">
             <a:extLst xmlns:a="http://schemas.openxmlformats.org/drawingml/2006/main">
               <a:ext uri="{FF2B5EF4-FFF2-40B4-BE49-F238E27FC236}">
-                <a16:creationId xmlns:a16="http://schemas.microsoft.com/office/drawing/2014/main" id="{1D9F9C19-7850-4A53-94E9-9DF147D1BE60}"/>
+                <a16:creationId xmlns:a16="http://schemas.microsoft.com/office/drawing/2014/main" id="{BC1904BA-09CF-4EFC-80AE-E6084129F06B}"/>
               </a:ext>
             </a:extLst>
           </p:cNvPr>
@@ -4792,7 +5447,7 @@
           <p:cNvPr id="4" name="">
             <a:extLst xmlns:a="http://schemas.openxmlformats.org/drawingml/2006/main">
               <a:ext uri="{FF2B5EF4-FFF2-40B4-BE49-F238E27FC236}">
-                <a16:creationId xmlns:a16="http://schemas.microsoft.com/office/drawing/2014/main" id="{DCBE49D6-D68B-43C6-831D-6AFF98455B49}"/>
+                <a16:creationId xmlns:a16="http://schemas.microsoft.com/office/drawing/2014/main" id="{259ECCB0-1AB6-4A99-B400-8F0E96CAC20F}"/>
               </a:ext>
             </a:extLst>
           </p:cNvPr>
@@ -4860,7 +5515,7 @@
           <p:cNvPr id="5" name="">
             <a:extLst xmlns:a="http://schemas.openxmlformats.org/drawingml/2006/main">
               <a:ext uri="{FF2B5EF4-FFF2-40B4-BE49-F238E27FC236}">
-                <a16:creationId xmlns:a16="http://schemas.microsoft.com/office/drawing/2014/main" id="{C38A8C58-EEFD-4BEB-B5C0-2764DDDD405B}"/>
+                <a16:creationId xmlns:a16="http://schemas.microsoft.com/office/drawing/2014/main" id="{A0A979B5-68AA-4C8A-9180-D871AF608CD6}"/>
               </a:ext>
             </a:extLst>
           </p:cNvPr>
@@ -4928,7 +5583,7 @@
           <p:cNvPr id="6" name="">
             <a:extLst xmlns:a="http://schemas.openxmlformats.org/drawingml/2006/main">
               <a:ext uri="{FF2B5EF4-FFF2-40B4-BE49-F238E27FC236}">
-                <a16:creationId xmlns:a16="http://schemas.microsoft.com/office/drawing/2014/main" id="{4893B469-E634-4F73-B3FC-7BED0291DE8D}"/>
+                <a16:creationId xmlns:a16="http://schemas.microsoft.com/office/drawing/2014/main" id="{26A1F5DC-FBB7-43E5-A757-4834B85C08CE}"/>
               </a:ext>
             </a:extLst>
           </p:cNvPr>
@@ -4958,7 +5613,7 @@
           <p:cNvPr id="7" name="">
             <a:extLst xmlns:a="http://schemas.openxmlformats.org/drawingml/2006/main">
               <a:ext uri="{FF2B5EF4-FFF2-40B4-BE49-F238E27FC236}">
-                <a16:creationId xmlns:a16="http://schemas.microsoft.com/office/drawing/2014/main" id="{43E72C7B-002D-4A2B-856F-51634CFF38E4}"/>
+                <a16:creationId xmlns:a16="http://schemas.microsoft.com/office/drawing/2014/main" id="{B53A1577-AC64-4BD4-9F52-BFBF31855AA1}"/>
               </a:ext>
             </a:extLst>
           </p:cNvPr>
@@ -5026,7 +5681,7 @@
           <p:cNvPr id="8" name="">
             <a:extLst xmlns:a="http://schemas.openxmlformats.org/drawingml/2006/main">
               <a:ext uri="{FF2B5EF4-FFF2-40B4-BE49-F238E27FC236}">
-                <a16:creationId xmlns:a16="http://schemas.microsoft.com/office/drawing/2014/main" id="{20F6FE1E-F795-4E2E-BBBE-40D373556423}"/>
+                <a16:creationId xmlns:a16="http://schemas.microsoft.com/office/drawing/2014/main" id="{3506AE67-4482-4AD8-921C-08CBE1E9674E}"/>
               </a:ext>
             </a:extLst>
           </p:cNvPr>
@@ -5094,7 +5749,7 @@
           <p:cNvPr id="9" name="">
             <a:extLst xmlns:a="http://schemas.openxmlformats.org/drawingml/2006/main">
               <a:ext uri="{FF2B5EF4-FFF2-40B4-BE49-F238E27FC236}">
-                <a16:creationId xmlns:a16="http://schemas.microsoft.com/office/drawing/2014/main" id="{8B73CDEA-F920-4B8C-82FF-53BA65709298}"/>
+                <a16:creationId xmlns:a16="http://schemas.microsoft.com/office/drawing/2014/main" id="{0181C33D-853D-4494-BF92-E378DEF1AA90}"/>
               </a:ext>
             </a:extLst>
           </p:cNvPr>
@@ -5124,7 +5779,7 @@
           <p:cNvPr id="10" name="">
             <a:extLst xmlns:a="http://schemas.openxmlformats.org/drawingml/2006/main">
               <a:ext uri="{FF2B5EF4-FFF2-40B4-BE49-F238E27FC236}">
-                <a16:creationId xmlns:a16="http://schemas.microsoft.com/office/drawing/2014/main" id="{8C81E8F1-16E2-45B9-ABA3-4124514375FE}"/>
+                <a16:creationId xmlns:a16="http://schemas.microsoft.com/office/drawing/2014/main" id="{6C66D1F9-B2F2-4EC9-8246-1072FF26A5EF}"/>
               </a:ext>
             </a:extLst>
           </p:cNvPr>
@@ -5192,7 +5847,7 @@
           <p:cNvPr id="11" name="">
             <a:extLst xmlns:a="http://schemas.openxmlformats.org/drawingml/2006/main">
               <a:ext uri="{FF2B5EF4-FFF2-40B4-BE49-F238E27FC236}">
-                <a16:creationId xmlns:a16="http://schemas.microsoft.com/office/drawing/2014/main" id="{BF74F988-AEA3-4763-AE33-2D3ABE030505}"/>
+                <a16:creationId xmlns:a16="http://schemas.microsoft.com/office/drawing/2014/main" id="{062746EE-D539-41FE-AF04-7CF075BA6E1B}"/>
               </a:ext>
             </a:extLst>
           </p:cNvPr>
@@ -5260,7 +5915,7 @@
           <p:cNvPr id="12" name="">
             <a:extLst xmlns:a="http://schemas.openxmlformats.org/drawingml/2006/main">
               <a:ext uri="{FF2B5EF4-FFF2-40B4-BE49-F238E27FC236}">
-                <a16:creationId xmlns:a16="http://schemas.microsoft.com/office/drawing/2014/main" id="{D7B7C36E-2529-459A-8F50-C60309B01DE3}"/>
+                <a16:creationId xmlns:a16="http://schemas.microsoft.com/office/drawing/2014/main" id="{520EF028-D0BB-43A8-A843-741A3B3101D8}"/>
               </a:ext>
             </a:extLst>
           </p:cNvPr>
@@ -5328,7 +5983,7 @@
           <p:cNvPr id="13" name="">
             <a:extLst xmlns:a="http://schemas.openxmlformats.org/drawingml/2006/main">
               <a:ext uri="{FF2B5EF4-FFF2-40B4-BE49-F238E27FC236}">
-                <a16:creationId xmlns:a16="http://schemas.microsoft.com/office/drawing/2014/main" id="{5B4DDC7C-E4ED-4F5E-BEB7-DB7EE346B2DE}"/>
+                <a16:creationId xmlns:a16="http://schemas.microsoft.com/office/drawing/2014/main" id="{358A7FB0-60D6-459A-9F5D-86B1ED255E82}"/>
               </a:ext>
             </a:extLst>
           </p:cNvPr>
@@ -5396,7 +6051,7 @@
           <p:cNvPr id="14" name="">
             <a:extLst xmlns:a="http://schemas.openxmlformats.org/drawingml/2006/main">
               <a:ext uri="{FF2B5EF4-FFF2-40B4-BE49-F238E27FC236}">
-                <a16:creationId xmlns:a16="http://schemas.microsoft.com/office/drawing/2014/main" id="{7ED8E5D1-35EA-4557-8E95-E08D1D2804B9}"/>
+                <a16:creationId xmlns:a16="http://schemas.microsoft.com/office/drawing/2014/main" id="{E59AC33E-5F60-4998-B48B-8E46E0515A6C}"/>
               </a:ext>
             </a:extLst>
           </p:cNvPr>
@@ -5462,7 +6117,7 @@
     </p:spTree>
     <p:extLst>
       <p:ext uri="{BB962C8B-B14F-4D97-AF65-F5344CB8AC3E}">
-        <p14:creationId xmlns:p14="http://schemas.microsoft.com/office/powerpoint/2010/main" val="2024460941"/>
+        <p14:creationId xmlns:p14="http://schemas.microsoft.com/office/powerpoint/2010/main" val="1836885466"/>
       </p:ext>
     </p:extLst>
   </p:cSld>
@@ -5493,7 +6148,7 @@
           <p:cNvPr id="7" name="">
             <a:extLst xmlns:a="http://schemas.openxmlformats.org/drawingml/2006/main">
               <a:ext uri="{FF2B5EF4-FFF2-40B4-BE49-F238E27FC236}">
-                <a16:creationId xmlns:a16="http://schemas.microsoft.com/office/drawing/2014/main" id="{C8C1743D-69D1-4881-B3C6-7DA851C2460D}"/>
+                <a16:creationId xmlns:a16="http://schemas.microsoft.com/office/drawing/2014/main" id="{56366853-6D60-4E32-8F64-FE48E0427472}"/>
               </a:ext>
             </a:extLst>
           </p:cNvPr>
@@ -5561,7 +6216,7 @@
           <p:cNvPr id="2" name="">
             <a:extLst xmlns:a="http://schemas.openxmlformats.org/drawingml/2006/main">
               <a:ext uri="{FF2B5EF4-FFF2-40B4-BE49-F238E27FC236}">
-                <a16:creationId xmlns:a16="http://schemas.microsoft.com/office/drawing/2014/main" id="{77D78B7C-92A0-4C4C-8BF4-B974E3A8E7B0}"/>
+                <a16:creationId xmlns:a16="http://schemas.microsoft.com/office/drawing/2014/main" id="{7B1EB06E-1860-4523-B45A-7A51BEA35341}"/>
               </a:ext>
             </a:extLst>
           </p:cNvPr>
@@ -5629,7 +6284,7 @@
           <p:cNvPr id="3" name="">
             <a:extLst xmlns:a="http://schemas.openxmlformats.org/drawingml/2006/main">
               <a:ext uri="{FF2B5EF4-FFF2-40B4-BE49-F238E27FC236}">
-                <a16:creationId xmlns:a16="http://schemas.microsoft.com/office/drawing/2014/main" id="{B0191C6E-690D-4906-9BBC-6527E8B10607}"/>
+                <a16:creationId xmlns:a16="http://schemas.microsoft.com/office/drawing/2014/main" id="{7F45A8FC-B90A-4424-863F-602DF6FBDEC4}"/>
               </a:ext>
             </a:extLst>
           </p:cNvPr>
@@ -5639,7 +6294,7 @@
           <p:nvPr/>
         </p:nvPicPr>
         <p:blipFill>
-          <a:blip xmlns:r="http://schemas.openxmlformats.org/officeDocument/2006/relationships" xmlns:a="http://schemas.openxmlformats.org/drawingml/2006/main" r:embed="R5baffcb496f841ed"/>
+          <a:blip xmlns:r="http://schemas.openxmlformats.org/officeDocument/2006/relationships" xmlns:a="http://schemas.openxmlformats.org/drawingml/2006/main" r:embed="Rfdad506937c64a19"/>
           <a:stretch xmlns:a="http://schemas.openxmlformats.org/drawingml/2006/main"/>
         </p:blipFill>
         <p:spPr>
@@ -5657,7 +6312,7 @@
           <p:cNvPr id="4" name="">
             <a:extLst xmlns:a="http://schemas.openxmlformats.org/drawingml/2006/main">
               <a:ext uri="{FF2B5EF4-FFF2-40B4-BE49-F238E27FC236}">
-                <a16:creationId xmlns:a16="http://schemas.microsoft.com/office/drawing/2014/main" id="{0B6D85C5-E428-4F2F-8FDA-4C091A765892}"/>
+                <a16:creationId xmlns:a16="http://schemas.microsoft.com/office/drawing/2014/main" id="{2FCA793D-9449-4B3E-BAB3-1E266F50B3F3}"/>
               </a:ext>
             </a:extLst>
           </p:cNvPr>
@@ -5687,7 +6342,7 @@
           <p:cNvPr id="5" name="">
             <a:extLst xmlns:a="http://schemas.openxmlformats.org/drawingml/2006/main">
               <a:ext uri="{FF2B5EF4-FFF2-40B4-BE49-F238E27FC236}">
-                <a16:creationId xmlns:a16="http://schemas.microsoft.com/office/drawing/2014/main" id="{69A56D27-7C4B-42A8-A1F5-898EC9A28AFA}"/>
+                <a16:creationId xmlns:a16="http://schemas.microsoft.com/office/drawing/2014/main" id="{01E0AD2D-BD20-4267-835A-3F3E09FEF9A7}"/>
               </a:ext>
             </a:extLst>
           </p:cNvPr>
@@ -5755,7 +6410,7 @@
           <p:cNvPr id="6" name="">
             <a:extLst xmlns:a="http://schemas.openxmlformats.org/drawingml/2006/main">
               <a:ext uri="{FF2B5EF4-FFF2-40B4-BE49-F238E27FC236}">
-                <a16:creationId xmlns:a16="http://schemas.microsoft.com/office/drawing/2014/main" id="{2603BE37-0DB2-4C71-95FE-A14424081114}"/>
+                <a16:creationId xmlns:a16="http://schemas.microsoft.com/office/drawing/2014/main" id="{7F3CCD03-6A3A-4D11-8304-A824E6B58BF3}"/>
               </a:ext>
             </a:extLst>
           </p:cNvPr>
@@ -5821,7 +6476,7 @@
     </p:spTree>
     <p:extLst>
       <p:ext uri="{BB962C8B-B14F-4D97-AF65-F5344CB8AC3E}">
-        <p14:creationId xmlns:p14="http://schemas.microsoft.com/office/powerpoint/2010/main" val="1968743258"/>
+        <p14:creationId xmlns:p14="http://schemas.microsoft.com/office/powerpoint/2010/main" val="750610031"/>
       </p:ext>
     </p:extLst>
   </p:cSld>
@@ -5852,7 +6507,7 @@
           <p:cNvPr id="6" name="">
             <a:extLst xmlns:a="http://schemas.openxmlformats.org/drawingml/2006/main">
               <a:ext uri="{FF2B5EF4-FFF2-40B4-BE49-F238E27FC236}">
-                <a16:creationId xmlns:a16="http://schemas.microsoft.com/office/drawing/2014/main" id="{AE66AAD5-68CC-4FB3-95D9-B593DAB5EC3A}"/>
+                <a16:creationId xmlns:a16="http://schemas.microsoft.com/office/drawing/2014/main" id="{0F9A734B-4EF1-4212-BFC3-6534B097DF9E}"/>
               </a:ext>
             </a:extLst>
           </p:cNvPr>
@@ -5862,7 +6517,7 @@
           <p:nvPr/>
         </p:nvPicPr>
         <p:blipFill>
-          <a:blip xmlns:r="http://schemas.openxmlformats.org/officeDocument/2006/relationships" xmlns:a="http://schemas.openxmlformats.org/drawingml/2006/main" r:embed="R41c5cbb4bb394230"/>
+          <a:blip xmlns:r="http://schemas.openxmlformats.org/officeDocument/2006/relationships" xmlns:a="http://schemas.openxmlformats.org/drawingml/2006/main" r:embed="R65837f39e4014c10"/>
           <a:stretch xmlns:a="http://schemas.openxmlformats.org/drawingml/2006/main"/>
         </p:blipFill>
         <p:spPr>
@@ -5880,7 +6535,7 @@
           <p:cNvPr id="2" name="">
             <a:extLst xmlns:a="http://schemas.openxmlformats.org/drawingml/2006/main">
               <a:ext uri="{FF2B5EF4-FFF2-40B4-BE49-F238E27FC236}">
-                <a16:creationId xmlns:a16="http://schemas.microsoft.com/office/drawing/2014/main" id="{5CB83C39-3F9E-4216-AD9E-4C226AAC3DBF}"/>
+                <a16:creationId xmlns:a16="http://schemas.microsoft.com/office/drawing/2014/main" id="{262D81E0-1EE7-46BD-B93B-43BCD74C43C2}"/>
               </a:ext>
             </a:extLst>
           </p:cNvPr>
@@ -5948,7 +6603,7 @@
           <p:cNvPr id="3" name="">
             <a:extLst xmlns:a="http://schemas.openxmlformats.org/drawingml/2006/main">
               <a:ext uri="{FF2B5EF4-FFF2-40B4-BE49-F238E27FC236}">
-                <a16:creationId xmlns:a16="http://schemas.microsoft.com/office/drawing/2014/main" id="{AF8E8CE9-B339-41DB-AFE0-27085541D46F}"/>
+                <a16:creationId xmlns:a16="http://schemas.microsoft.com/office/drawing/2014/main" id="{7AE98739-72A2-492C-B6C4-E64E7547E85F}"/>
               </a:ext>
             </a:extLst>
           </p:cNvPr>
@@ -6016,7 +6671,7 @@
           <p:cNvPr id="4" name="">
             <a:extLst xmlns:a="http://schemas.openxmlformats.org/drawingml/2006/main">
               <a:ext uri="{FF2B5EF4-FFF2-40B4-BE49-F238E27FC236}">
-                <a16:creationId xmlns:a16="http://schemas.microsoft.com/office/drawing/2014/main" id="{3F9E155C-1E16-4155-BAC2-4E204A7A7283}"/>
+                <a16:creationId xmlns:a16="http://schemas.microsoft.com/office/drawing/2014/main" id="{85302E21-F78F-43FE-A5B0-1A1E8DE748EB}"/>
               </a:ext>
             </a:extLst>
           </p:cNvPr>
@@ -6084,7 +6739,7 @@
           <p:cNvPr id="5" name="">
             <a:extLst xmlns:a="http://schemas.openxmlformats.org/drawingml/2006/main">
               <a:ext uri="{FF2B5EF4-FFF2-40B4-BE49-F238E27FC236}">
-                <a16:creationId xmlns:a16="http://schemas.microsoft.com/office/drawing/2014/main" id="{A67C0277-E035-45C2-A494-9B0A35FCEDA3}"/>
+                <a16:creationId xmlns:a16="http://schemas.microsoft.com/office/drawing/2014/main" id="{717E1972-224C-433B-869E-0267B84D8165}"/>
               </a:ext>
             </a:extLst>
           </p:cNvPr>
@@ -6150,7 +6805,7 @@
     </p:spTree>
     <p:extLst>
       <p:ext uri="{BB962C8B-B14F-4D97-AF65-F5344CB8AC3E}">
-        <p14:creationId xmlns:p14="http://schemas.microsoft.com/office/powerpoint/2010/main" val="49594142"/>
+        <p14:creationId xmlns:p14="http://schemas.microsoft.com/office/powerpoint/2010/main" val="1662911044"/>
       </p:ext>
     </p:extLst>
   </p:cSld>
@@ -6181,7 +6836,7 @@
           <p:cNvPr id="28" name="">
             <a:extLst xmlns:a="http://schemas.openxmlformats.org/drawingml/2006/main">
               <a:ext uri="{FF2B5EF4-FFF2-40B4-BE49-F238E27FC236}">
-                <a16:creationId xmlns:a16="http://schemas.microsoft.com/office/drawing/2014/main" id="{A40CBA8B-655B-407B-8CBE-F6293A1F6FD4}"/>
+                <a16:creationId xmlns:a16="http://schemas.microsoft.com/office/drawing/2014/main" id="{28342B41-EBE2-4773-B2BE-6403EA46757C}"/>
               </a:ext>
             </a:extLst>
           </p:cNvPr>
@@ -6191,7 +6846,7 @@
           <p:nvPr/>
         </p:nvPicPr>
         <p:blipFill>
-          <a:blip xmlns:r="http://schemas.openxmlformats.org/officeDocument/2006/relationships" xmlns:a="http://schemas.openxmlformats.org/drawingml/2006/main" r:embed="R272bb7b107eb4819"/>
+          <a:blip xmlns:r="http://schemas.openxmlformats.org/officeDocument/2006/relationships" xmlns:a="http://schemas.openxmlformats.org/drawingml/2006/main" r:embed="R02e8748aff6a41f3"/>
           <a:srcRect xmlns:a="http://schemas.openxmlformats.org/drawingml/2006/main" l="0" t="0" r="0" b="0"/>
           <a:stretch xmlns:a="http://schemas.openxmlformats.org/drawingml/2006/main">
             <a:fillRect l="0" t="0" r="0" b="0"/>
@@ -6212,7 +6867,7 @@
           <p:cNvPr id="2" name="">
             <a:extLst xmlns:a="http://schemas.openxmlformats.org/drawingml/2006/main">
               <a:ext uri="{FF2B5EF4-FFF2-40B4-BE49-F238E27FC236}">
-                <a16:creationId xmlns:a16="http://schemas.microsoft.com/office/drawing/2014/main" id="{209DC17B-A94A-4454-88A7-581CC0376E4B}"/>
+                <a16:creationId xmlns:a16="http://schemas.microsoft.com/office/drawing/2014/main" id="{A56A2F6C-0D2A-41F7-B8A9-2F58A52D4E8A}"/>
               </a:ext>
             </a:extLst>
           </p:cNvPr>
@@ -6280,7 +6935,7 @@
           <p:cNvPr id="3" name="">
             <a:extLst xmlns:a="http://schemas.openxmlformats.org/drawingml/2006/main">
               <a:ext uri="{FF2B5EF4-FFF2-40B4-BE49-F238E27FC236}">
-                <a16:creationId xmlns:a16="http://schemas.microsoft.com/office/drawing/2014/main" id="{B41781DF-1921-4842-BE82-B5B8F87224D6}"/>
+                <a16:creationId xmlns:a16="http://schemas.microsoft.com/office/drawing/2014/main" id="{629DFB93-5309-4A24-8241-EAB75EBE517E}"/>
               </a:ext>
             </a:extLst>
           </p:cNvPr>
@@ -6348,7 +7003,7 @@
           <p:cNvPr id="4" name="">
             <a:extLst xmlns:a="http://schemas.openxmlformats.org/drawingml/2006/main">
               <a:ext uri="{FF2B5EF4-FFF2-40B4-BE49-F238E27FC236}">
-                <a16:creationId xmlns:a16="http://schemas.microsoft.com/office/drawing/2014/main" id="{2A3C6D4A-EE18-4F45-85B3-B8B379A8C70A}"/>
+                <a16:creationId xmlns:a16="http://schemas.microsoft.com/office/drawing/2014/main" id="{B5E62C32-F4A2-4162-B8E4-3A1E957E194B}"/>
               </a:ext>
             </a:extLst>
           </p:cNvPr>
@@ -6416,7 +7071,7 @@
           <p:cNvPr id="5" name="">
             <a:extLst xmlns:a="http://schemas.openxmlformats.org/drawingml/2006/main">
               <a:ext uri="{FF2B5EF4-FFF2-40B4-BE49-F238E27FC236}">
-                <a16:creationId xmlns:a16="http://schemas.microsoft.com/office/drawing/2014/main" id="{FC7E7185-5A2A-451E-870B-312B9DAE79B8}"/>
+                <a16:creationId xmlns:a16="http://schemas.microsoft.com/office/drawing/2014/main" id="{0978F407-959B-4438-ADBC-0BCF390A0CA3}"/>
               </a:ext>
             </a:extLst>
           </p:cNvPr>
@@ -6426,7 +7081,7 @@
           <p:nvPr/>
         </p:nvPicPr>
         <p:blipFill>
-          <a:blip xmlns:r="http://schemas.openxmlformats.org/officeDocument/2006/relationships" xmlns:a="http://schemas.openxmlformats.org/drawingml/2006/main" r:embed="Rd11d0aa752834341"/>
+          <a:blip xmlns:r="http://schemas.openxmlformats.org/officeDocument/2006/relationships" xmlns:a="http://schemas.openxmlformats.org/drawingml/2006/main" r:embed="R7dfe56bdcf744814"/>
           <a:stretch xmlns:a="http://schemas.openxmlformats.org/drawingml/2006/main"/>
         </p:blipFill>
         <p:spPr>
@@ -6444,7 +7099,7 @@
           <p:cNvPr id="6" name="">
             <a:extLst xmlns:a="http://schemas.openxmlformats.org/drawingml/2006/main">
               <a:ext uri="{FF2B5EF4-FFF2-40B4-BE49-F238E27FC236}">
-                <a16:creationId xmlns:a16="http://schemas.microsoft.com/office/drawing/2014/main" id="{7D00A424-EE8F-4C57-AA10-6792B542B80F}"/>
+                <a16:creationId xmlns:a16="http://schemas.microsoft.com/office/drawing/2014/main" id="{AF76D479-6B72-4118-B145-F4AC6F6D3695}"/>
               </a:ext>
             </a:extLst>
           </p:cNvPr>
@@ -6474,7 +7129,7 @@
           <p:cNvPr id="7" name="">
             <a:extLst xmlns:a="http://schemas.openxmlformats.org/drawingml/2006/main">
               <a:ext uri="{FF2B5EF4-FFF2-40B4-BE49-F238E27FC236}">
-                <a16:creationId xmlns:a16="http://schemas.microsoft.com/office/drawing/2014/main" id="{F65E8D31-867F-44D1-B19E-272E4A921799}"/>
+                <a16:creationId xmlns:a16="http://schemas.microsoft.com/office/drawing/2014/main" id="{DD838CE9-DE1D-48C8-8E2E-22F8F4B14760}"/>
               </a:ext>
             </a:extLst>
           </p:cNvPr>
@@ -6542,7 +7197,7 @@
           <p:cNvPr id="8" name="">
             <a:extLst xmlns:a="http://schemas.openxmlformats.org/drawingml/2006/main">
               <a:ext uri="{FF2B5EF4-FFF2-40B4-BE49-F238E27FC236}">
-                <a16:creationId xmlns:a16="http://schemas.microsoft.com/office/drawing/2014/main" id="{AB22ACAA-9141-41C1-9298-8340FEE8CBA6}"/>
+                <a16:creationId xmlns:a16="http://schemas.microsoft.com/office/drawing/2014/main" id="{7653C0F5-8783-4E51-90AB-8FDA80A37F8C}"/>
               </a:ext>
             </a:extLst>
           </p:cNvPr>
@@ -6610,7 +7265,7 @@
           <p:cNvPr id="9" name="">
             <a:extLst xmlns:a="http://schemas.openxmlformats.org/drawingml/2006/main">
               <a:ext uri="{FF2B5EF4-FFF2-40B4-BE49-F238E27FC236}">
-                <a16:creationId xmlns:a16="http://schemas.microsoft.com/office/drawing/2014/main" id="{A321041A-9BDC-4F00-BC87-A794ED6DB276}"/>
+                <a16:creationId xmlns:a16="http://schemas.microsoft.com/office/drawing/2014/main" id="{CB64823E-6519-416F-A38B-44AE05668A9B}"/>
               </a:ext>
             </a:extLst>
           </p:cNvPr>
@@ -6678,7 +7333,7 @@
           <p:cNvPr id="10" name="">
             <a:extLst xmlns:a="http://schemas.openxmlformats.org/drawingml/2006/main">
               <a:ext uri="{FF2B5EF4-FFF2-40B4-BE49-F238E27FC236}">
-                <a16:creationId xmlns:a16="http://schemas.microsoft.com/office/drawing/2014/main" id="{B8B6A706-10D3-436D-9BF7-6D14F0418E61}"/>
+                <a16:creationId xmlns:a16="http://schemas.microsoft.com/office/drawing/2014/main" id="{39722C97-D291-4291-A178-8AF13229E0C5}"/>
               </a:ext>
             </a:extLst>
           </p:cNvPr>
@@ -6746,7 +7401,7 @@
           <p:cNvPr id="11" name="">
             <a:extLst xmlns:a="http://schemas.openxmlformats.org/drawingml/2006/main">
               <a:ext uri="{FF2B5EF4-FFF2-40B4-BE49-F238E27FC236}">
-                <a16:creationId xmlns:a16="http://schemas.microsoft.com/office/drawing/2014/main" id="{ED18DE71-B3E3-4365-B61E-639E8ADA6134}"/>
+                <a16:creationId xmlns:a16="http://schemas.microsoft.com/office/drawing/2014/main" id="{DA01BEE3-0649-4CD7-8509-A0ECA4476593}"/>
               </a:ext>
             </a:extLst>
           </p:cNvPr>
@@ -6814,7 +7469,7 @@
           <p:cNvPr id="12" name="">
             <a:extLst xmlns:a="http://schemas.openxmlformats.org/drawingml/2006/main">
               <a:ext uri="{FF2B5EF4-FFF2-40B4-BE49-F238E27FC236}">
-                <a16:creationId xmlns:a16="http://schemas.microsoft.com/office/drawing/2014/main" id="{CF1ECD39-A434-4085-9CDE-22653AF5CF41}"/>
+                <a16:creationId xmlns:a16="http://schemas.microsoft.com/office/drawing/2014/main" id="{8425F3D8-BED8-4031-AE87-A5377D8F093F}"/>
               </a:ext>
             </a:extLst>
           </p:cNvPr>
@@ -6882,7 +7537,7 @@
           <p:cNvPr id="13" name="">
             <a:extLst xmlns:a="http://schemas.openxmlformats.org/drawingml/2006/main">
               <a:ext uri="{FF2B5EF4-FFF2-40B4-BE49-F238E27FC236}">
-                <a16:creationId xmlns:a16="http://schemas.microsoft.com/office/drawing/2014/main" id="{B127DDB7-C062-43A6-B816-7D2FE93CB10C}"/>
+                <a16:creationId xmlns:a16="http://schemas.microsoft.com/office/drawing/2014/main" id="{B9AC4E39-A5AF-4274-BD95-0B42AD0BEDD6}"/>
               </a:ext>
             </a:extLst>
           </p:cNvPr>
@@ -6950,7 +7605,7 @@
           <p:cNvPr id="14" name="">
             <a:extLst xmlns:a="http://schemas.openxmlformats.org/drawingml/2006/main">
               <a:ext uri="{FF2B5EF4-FFF2-40B4-BE49-F238E27FC236}">
-                <a16:creationId xmlns:a16="http://schemas.microsoft.com/office/drawing/2014/main" id="{5A34CC5E-E8B9-41C7-B38A-F6D30A19A49D}"/>
+                <a16:creationId xmlns:a16="http://schemas.microsoft.com/office/drawing/2014/main" id="{61201C22-FF19-4046-A1CC-52A2E45F1F54}"/>
               </a:ext>
             </a:extLst>
           </p:cNvPr>
@@ -7018,7 +7673,7 @@
           <p:cNvPr id="15" name="">
             <a:extLst xmlns:a="http://schemas.openxmlformats.org/drawingml/2006/main">
               <a:ext uri="{FF2B5EF4-FFF2-40B4-BE49-F238E27FC236}">
-                <a16:creationId xmlns:a16="http://schemas.microsoft.com/office/drawing/2014/main" id="{B74DF2CA-161E-445B-8072-95D2B62D8753}"/>
+                <a16:creationId xmlns:a16="http://schemas.microsoft.com/office/drawing/2014/main" id="{2DE25EAB-976D-4629-8A8A-7C3C2BD0F976}"/>
               </a:ext>
             </a:extLst>
           </p:cNvPr>
@@ -7086,7 +7741,7 @@
           <p:cNvPr id="16" name="">
             <a:extLst xmlns:a="http://schemas.openxmlformats.org/drawingml/2006/main">
               <a:ext uri="{FF2B5EF4-FFF2-40B4-BE49-F238E27FC236}">
-                <a16:creationId xmlns:a16="http://schemas.microsoft.com/office/drawing/2014/main" id="{29E40D3E-AF98-4C33-8C81-02DA5129E1A6}"/>
+                <a16:creationId xmlns:a16="http://schemas.microsoft.com/office/drawing/2014/main" id="{79FEBADD-7DD2-43D7-9875-DF118EB27E53}"/>
               </a:ext>
             </a:extLst>
           </p:cNvPr>
@@ -7154,7 +7809,7 @@
           <p:cNvPr id="17" name="">
             <a:extLst xmlns:a="http://schemas.openxmlformats.org/drawingml/2006/main">
               <a:ext uri="{FF2B5EF4-FFF2-40B4-BE49-F238E27FC236}">
-                <a16:creationId xmlns:a16="http://schemas.microsoft.com/office/drawing/2014/main" id="{4201E918-8579-40AD-B5F3-5552F70E54E5}"/>
+                <a16:creationId xmlns:a16="http://schemas.microsoft.com/office/drawing/2014/main" id="{CD131FA3-B7FE-4378-BB22-BCA7A4AF4B9F}"/>
               </a:ext>
             </a:extLst>
           </p:cNvPr>
@@ -7222,7 +7877,7 @@
           <p:cNvPr id="18" name="">
             <a:extLst xmlns:a="http://schemas.openxmlformats.org/drawingml/2006/main">
               <a:ext uri="{FF2B5EF4-FFF2-40B4-BE49-F238E27FC236}">
-                <a16:creationId xmlns:a16="http://schemas.microsoft.com/office/drawing/2014/main" id="{C2BE6877-0B40-434F-8443-D229A946B613}"/>
+                <a16:creationId xmlns:a16="http://schemas.microsoft.com/office/drawing/2014/main" id="{0E3526C3-7CCC-48EA-8B72-9646B567C76F}"/>
               </a:ext>
             </a:extLst>
           </p:cNvPr>
@@ -7290,7 +7945,7 @@
           <p:cNvPr id="19" name="">
             <a:extLst xmlns:a="http://schemas.openxmlformats.org/drawingml/2006/main">
               <a:ext uri="{FF2B5EF4-FFF2-40B4-BE49-F238E27FC236}">
-                <a16:creationId xmlns:a16="http://schemas.microsoft.com/office/drawing/2014/main" id="{58F010C1-F6C7-45F2-8067-0ACF17255956}"/>
+                <a16:creationId xmlns:a16="http://schemas.microsoft.com/office/drawing/2014/main" id="{D7D46E8E-283B-4C12-AEF8-B7B7B796D5CC}"/>
               </a:ext>
             </a:extLst>
           </p:cNvPr>
@@ -7358,7 +8013,7 @@
           <p:cNvPr id="20" name="">
             <a:extLst xmlns:a="http://schemas.openxmlformats.org/drawingml/2006/main">
               <a:ext uri="{FF2B5EF4-FFF2-40B4-BE49-F238E27FC236}">
-                <a16:creationId xmlns:a16="http://schemas.microsoft.com/office/drawing/2014/main" id="{85D867B4-2BAB-4F74-9E8C-68A3856B9034}"/>
+                <a16:creationId xmlns:a16="http://schemas.microsoft.com/office/drawing/2014/main" id="{9AC2A519-7A3A-4E77-A9FB-9D553398E797}"/>
               </a:ext>
             </a:extLst>
           </p:cNvPr>
@@ -7426,7 +8081,7 @@
           <p:cNvPr id="21" name="">
             <a:extLst xmlns:a="http://schemas.openxmlformats.org/drawingml/2006/main">
               <a:ext uri="{FF2B5EF4-FFF2-40B4-BE49-F238E27FC236}">
-                <a16:creationId xmlns:a16="http://schemas.microsoft.com/office/drawing/2014/main" id="{B4FAF73B-17C8-4F95-BCC6-ECC5D70B36AA}"/>
+                <a16:creationId xmlns:a16="http://schemas.microsoft.com/office/drawing/2014/main" id="{9EAB77B3-B1B2-4FAF-99B3-C0050E8D7565}"/>
               </a:ext>
             </a:extLst>
           </p:cNvPr>
@@ -7494,7 +8149,7 @@
           <p:cNvPr id="22" name="">
             <a:extLst xmlns:a="http://schemas.openxmlformats.org/drawingml/2006/main">
               <a:ext uri="{FF2B5EF4-FFF2-40B4-BE49-F238E27FC236}">
-                <a16:creationId xmlns:a16="http://schemas.microsoft.com/office/drawing/2014/main" id="{6DD9F533-98A2-4ED1-9A48-1F747BEED1B9}"/>
+                <a16:creationId xmlns:a16="http://schemas.microsoft.com/office/drawing/2014/main" id="{B4FECC2C-FEA9-4248-AF48-C14A091F8E01}"/>
               </a:ext>
             </a:extLst>
           </p:cNvPr>
@@ -7562,7 +8217,7 @@
           <p:cNvPr id="23" name="">
             <a:extLst xmlns:a="http://schemas.openxmlformats.org/drawingml/2006/main">
               <a:ext uri="{FF2B5EF4-FFF2-40B4-BE49-F238E27FC236}">
-                <a16:creationId xmlns:a16="http://schemas.microsoft.com/office/drawing/2014/main" id="{3E8AE860-92CA-4F32-A324-9781E7250EF0}"/>
+                <a16:creationId xmlns:a16="http://schemas.microsoft.com/office/drawing/2014/main" id="{94D014AE-29AF-460F-B326-A86EEB281CC0}"/>
               </a:ext>
             </a:extLst>
           </p:cNvPr>
@@ -7630,7 +8285,7 @@
           <p:cNvPr id="24" name="">
             <a:extLst xmlns:a="http://schemas.openxmlformats.org/drawingml/2006/main">
               <a:ext uri="{FF2B5EF4-FFF2-40B4-BE49-F238E27FC236}">
-                <a16:creationId xmlns:a16="http://schemas.microsoft.com/office/drawing/2014/main" id="{19660224-0471-4FBC-B962-ECD0B154F29D}"/>
+                <a16:creationId xmlns:a16="http://schemas.microsoft.com/office/drawing/2014/main" id="{8ED7B6D7-FD9B-421E-A15E-A9408C10B494}"/>
               </a:ext>
             </a:extLst>
           </p:cNvPr>
@@ -7698,7 +8353,7 @@
           <p:cNvPr id="25" name="">
             <a:extLst xmlns:a="http://schemas.openxmlformats.org/drawingml/2006/main">
               <a:ext uri="{FF2B5EF4-FFF2-40B4-BE49-F238E27FC236}">
-                <a16:creationId xmlns:a16="http://schemas.microsoft.com/office/drawing/2014/main" id="{4E4EA976-545E-47A3-84A5-899F450CFB50}"/>
+                <a16:creationId xmlns:a16="http://schemas.microsoft.com/office/drawing/2014/main" id="{A9F3F7E7-399A-4877-905C-89E01E948911}"/>
               </a:ext>
             </a:extLst>
           </p:cNvPr>
@@ -7766,7 +8421,7 @@
           <p:cNvPr id="26" name="">
             <a:extLst xmlns:a="http://schemas.openxmlformats.org/drawingml/2006/main">
               <a:ext uri="{FF2B5EF4-FFF2-40B4-BE49-F238E27FC236}">
-                <a16:creationId xmlns:a16="http://schemas.microsoft.com/office/drawing/2014/main" id="{C90B9035-C482-49D9-8E43-DAE830C3E087}"/>
+                <a16:creationId xmlns:a16="http://schemas.microsoft.com/office/drawing/2014/main" id="{D03352B4-A759-408A-B466-A24BAE948B0A}"/>
               </a:ext>
             </a:extLst>
           </p:cNvPr>
@@ -7834,7 +8489,7 @@
           <p:cNvPr id="27" name="">
             <a:extLst xmlns:a="http://schemas.openxmlformats.org/drawingml/2006/main">
               <a:ext uri="{FF2B5EF4-FFF2-40B4-BE49-F238E27FC236}">
-                <a16:creationId xmlns:a16="http://schemas.microsoft.com/office/drawing/2014/main" id="{63382D8C-1899-48A2-A947-2A8C2A8C0E6B}"/>
+                <a16:creationId xmlns:a16="http://schemas.microsoft.com/office/drawing/2014/main" id="{E39BA2D2-EE6F-4C9C-8B60-CCF3BB8E6FD2}"/>
               </a:ext>
             </a:extLst>
           </p:cNvPr>
@@ -7900,7 +8555,7 @@
     </p:spTree>
     <p:extLst>
       <p:ext uri="{BB962C8B-B14F-4D97-AF65-F5344CB8AC3E}">
-        <p14:creationId xmlns:p14="http://schemas.microsoft.com/office/powerpoint/2010/main" val="1807343917"/>
+        <p14:creationId xmlns:p14="http://schemas.microsoft.com/office/powerpoint/2010/main" val="1730114855"/>
       </p:ext>
     </p:extLst>
   </p:cSld>
@@ -7931,7 +8586,7 @@
           <p:cNvPr id="14" name="">
             <a:extLst xmlns:a="http://schemas.openxmlformats.org/drawingml/2006/main">
               <a:ext uri="{FF2B5EF4-FFF2-40B4-BE49-F238E27FC236}">
-                <a16:creationId xmlns:a16="http://schemas.microsoft.com/office/drawing/2014/main" id="{151A0334-C97C-46B2-B54A-81B9D919D2D7}"/>
+                <a16:creationId xmlns:a16="http://schemas.microsoft.com/office/drawing/2014/main" id="{9EDB460E-23BA-443B-B96C-78BAF57945A8}"/>
               </a:ext>
             </a:extLst>
           </p:cNvPr>
@@ -7999,7 +8654,7 @@
           <p:cNvPr id="2" name="">
             <a:extLst xmlns:a="http://schemas.openxmlformats.org/drawingml/2006/main">
               <a:ext uri="{FF2B5EF4-FFF2-40B4-BE49-F238E27FC236}">
-                <a16:creationId xmlns:a16="http://schemas.microsoft.com/office/drawing/2014/main" id="{528E3710-EE2C-4015-9C91-BB0331C37728}"/>
+                <a16:creationId xmlns:a16="http://schemas.microsoft.com/office/drawing/2014/main" id="{2EA0FEBC-5F59-4461-A09C-1F475AA5CBC0}"/>
               </a:ext>
             </a:extLst>
           </p:cNvPr>
@@ -8009,7 +8664,7 @@
           <p:nvPr/>
         </p:nvPicPr>
         <p:blipFill>
-          <a:blip xmlns:r="http://schemas.openxmlformats.org/officeDocument/2006/relationships" xmlns:a="http://schemas.openxmlformats.org/drawingml/2006/main" r:embed="R738ba423897c4d0a"/>
+          <a:blip xmlns:r="http://schemas.openxmlformats.org/officeDocument/2006/relationships" xmlns:a="http://schemas.openxmlformats.org/drawingml/2006/main" r:embed="Rea2ca80944844ecd"/>
           <a:stretch xmlns:a="http://schemas.openxmlformats.org/drawingml/2006/main"/>
         </p:blipFill>
         <p:spPr>
@@ -8027,7 +8682,7 @@
           <p:cNvPr id="3" name="">
             <a:extLst xmlns:a="http://schemas.openxmlformats.org/drawingml/2006/main">
               <a:ext uri="{FF2B5EF4-FFF2-40B4-BE49-F238E27FC236}">
-                <a16:creationId xmlns:a16="http://schemas.microsoft.com/office/drawing/2014/main" id="{DA40F29F-FFD1-46E8-870A-23C1D9DDF83A}"/>
+                <a16:creationId xmlns:a16="http://schemas.microsoft.com/office/drawing/2014/main" id="{738F9CDD-8B66-421F-A6CF-529744B0ED86}"/>
               </a:ext>
             </a:extLst>
           </p:cNvPr>
@@ -8057,7 +8712,7 @@
           <p:cNvPr id="4" name="">
             <a:extLst xmlns:a="http://schemas.openxmlformats.org/drawingml/2006/main">
               <a:ext uri="{FF2B5EF4-FFF2-40B4-BE49-F238E27FC236}">
-                <a16:creationId xmlns:a16="http://schemas.microsoft.com/office/drawing/2014/main" id="{AD33F486-66A1-4934-B370-C9B46D5D8F1A}"/>
+                <a16:creationId xmlns:a16="http://schemas.microsoft.com/office/drawing/2014/main" id="{F51DB3B7-2788-469D-B235-9C8C55FF02AB}"/>
               </a:ext>
             </a:extLst>
           </p:cNvPr>
@@ -8125,7 +8780,7 @@
           <p:cNvPr id="5" name="">
             <a:extLst xmlns:a="http://schemas.openxmlformats.org/drawingml/2006/main">
               <a:ext uri="{FF2B5EF4-FFF2-40B4-BE49-F238E27FC236}">
-                <a16:creationId xmlns:a16="http://schemas.microsoft.com/office/drawing/2014/main" id="{E9B72789-2BF5-44A5-9A1E-334490779E16}"/>
+                <a16:creationId xmlns:a16="http://schemas.microsoft.com/office/drawing/2014/main" id="{E58A7C24-F914-4A26-817F-A0B26063C682}"/>
               </a:ext>
             </a:extLst>
           </p:cNvPr>
@@ -8193,7 +8848,7 @@
           <p:cNvPr id="6" name="">
             <a:extLst xmlns:a="http://schemas.openxmlformats.org/drawingml/2006/main">
               <a:ext uri="{FF2B5EF4-FFF2-40B4-BE49-F238E27FC236}">
-                <a16:creationId xmlns:a16="http://schemas.microsoft.com/office/drawing/2014/main" id="{3B53C90F-8D84-43D7-A469-E780CC08EFCF}"/>
+                <a16:creationId xmlns:a16="http://schemas.microsoft.com/office/drawing/2014/main" id="{1D45C206-34D5-4D8E-A77D-32C41D4F9B3B}"/>
               </a:ext>
             </a:extLst>
           </p:cNvPr>
@@ -8261,7 +8916,7 @@
           <p:cNvPr id="7" name="">
             <a:extLst xmlns:a="http://schemas.openxmlformats.org/drawingml/2006/main">
               <a:ext uri="{FF2B5EF4-FFF2-40B4-BE49-F238E27FC236}">
-                <a16:creationId xmlns:a16="http://schemas.microsoft.com/office/drawing/2014/main" id="{5395F2CF-4132-46FF-AD8A-669AEB89E706}"/>
+                <a16:creationId xmlns:a16="http://schemas.microsoft.com/office/drawing/2014/main" id="{EE35CD8F-25F0-44CA-9809-FC81679AA4F5}"/>
               </a:ext>
             </a:extLst>
           </p:cNvPr>
@@ -8329,7 +8984,7 @@
           <p:cNvPr id="8" name="">
             <a:extLst xmlns:a="http://schemas.openxmlformats.org/drawingml/2006/main">
               <a:ext uri="{FF2B5EF4-FFF2-40B4-BE49-F238E27FC236}">
-                <a16:creationId xmlns:a16="http://schemas.microsoft.com/office/drawing/2014/main" id="{2C69283B-DFF7-4382-8F5C-71C37B4B2000}"/>
+                <a16:creationId xmlns:a16="http://schemas.microsoft.com/office/drawing/2014/main" id="{C0D3C98A-F440-4EEB-B3A5-7B82D1CC1E74}"/>
               </a:ext>
             </a:extLst>
           </p:cNvPr>
@@ -8397,7 +9052,7 @@
           <p:cNvPr id="9" name="">
             <a:extLst xmlns:a="http://schemas.openxmlformats.org/drawingml/2006/main">
               <a:ext uri="{FF2B5EF4-FFF2-40B4-BE49-F238E27FC236}">
-                <a16:creationId xmlns:a16="http://schemas.microsoft.com/office/drawing/2014/main" id="{BE9B3DAC-C75D-4412-8713-EB09B37CC3A6}"/>
+                <a16:creationId xmlns:a16="http://schemas.microsoft.com/office/drawing/2014/main" id="{FBBD4AA2-CFC6-4241-9C37-E2247D01A59F}"/>
               </a:ext>
             </a:extLst>
           </p:cNvPr>
@@ -8407,7 +9062,7 @@
           <p:nvPr/>
         </p:nvPicPr>
         <p:blipFill>
-          <a:blip xmlns:r="http://schemas.openxmlformats.org/officeDocument/2006/relationships" xmlns:a="http://schemas.openxmlformats.org/drawingml/2006/main" r:embed="R59154e3b60e943af"/>
+          <a:blip xmlns:r="http://schemas.openxmlformats.org/officeDocument/2006/relationships" xmlns:a="http://schemas.openxmlformats.org/drawingml/2006/main" r:embed="R78d509a739164644"/>
           <a:stretch xmlns:a="http://schemas.openxmlformats.org/drawingml/2006/main"/>
         </p:blipFill>
         <p:spPr>
@@ -8425,7 +9080,7 @@
           <p:cNvPr id="10" name="">
             <a:extLst xmlns:a="http://schemas.openxmlformats.org/drawingml/2006/main">
               <a:ext uri="{FF2B5EF4-FFF2-40B4-BE49-F238E27FC236}">
-                <a16:creationId xmlns:a16="http://schemas.microsoft.com/office/drawing/2014/main" id="{E3D24736-92BE-4B27-A440-F3AD01C5B62D}"/>
+                <a16:creationId xmlns:a16="http://schemas.microsoft.com/office/drawing/2014/main" id="{B96A5C54-A0CF-447F-99B7-F43F1D7B69D3}"/>
               </a:ext>
             </a:extLst>
           </p:cNvPr>
@@ -8493,7 +9148,7 @@
           <p:cNvPr id="11" name="">
             <a:extLst xmlns:a="http://schemas.openxmlformats.org/drawingml/2006/main">
               <a:ext uri="{FF2B5EF4-FFF2-40B4-BE49-F238E27FC236}">
-                <a16:creationId xmlns:a16="http://schemas.microsoft.com/office/drawing/2014/main" id="{FF36D451-9D73-4ADA-8D04-C201D7111769}"/>
+                <a16:creationId xmlns:a16="http://schemas.microsoft.com/office/drawing/2014/main" id="{3ADC01FD-BEA4-4537-97D0-598307F4CB90}"/>
               </a:ext>
             </a:extLst>
           </p:cNvPr>
@@ -8561,7 +9216,7 @@
           <p:cNvPr id="12" name="">
             <a:extLst xmlns:a="http://schemas.openxmlformats.org/drawingml/2006/main">
               <a:ext uri="{FF2B5EF4-FFF2-40B4-BE49-F238E27FC236}">
-                <a16:creationId xmlns:a16="http://schemas.microsoft.com/office/drawing/2014/main" id="{4085BA29-D50C-4629-BFA2-88DA0BC33F57}"/>
+                <a16:creationId xmlns:a16="http://schemas.microsoft.com/office/drawing/2014/main" id="{74B6B796-B7E7-4C71-AB03-8F6145B0FCD1}"/>
               </a:ext>
             </a:extLst>
           </p:cNvPr>
@@ -8629,7 +9284,7 @@
           <p:cNvPr id="13" name="">
             <a:extLst xmlns:a="http://schemas.openxmlformats.org/drawingml/2006/main">
               <a:ext uri="{FF2B5EF4-FFF2-40B4-BE49-F238E27FC236}">
-                <a16:creationId xmlns:a16="http://schemas.microsoft.com/office/drawing/2014/main" id="{80954C12-A78C-47E2-A933-AB9250D1F36A}"/>
+                <a16:creationId xmlns:a16="http://schemas.microsoft.com/office/drawing/2014/main" id="{81040C28-C012-4F6F-BA63-E70D4A98BD15}"/>
               </a:ext>
             </a:extLst>
           </p:cNvPr>
@@ -8695,7 +9350,7 @@
     </p:spTree>
     <p:extLst>
       <p:ext uri="{BB962C8B-B14F-4D97-AF65-F5344CB8AC3E}">
-        <p14:creationId xmlns:p14="http://schemas.microsoft.com/office/powerpoint/2010/main" val="1289620313"/>
+        <p14:creationId xmlns:p14="http://schemas.microsoft.com/office/powerpoint/2010/main" val="419368492"/>
       </p:ext>
     </p:extLst>
   </p:cSld>
@@ -8726,7 +9381,7 @@
           <p:cNvPr id="27" name="">
             <a:extLst xmlns:a="http://schemas.openxmlformats.org/drawingml/2006/main">
               <a:ext uri="{FF2B5EF4-FFF2-40B4-BE49-F238E27FC236}">
-                <a16:creationId xmlns:a16="http://schemas.microsoft.com/office/drawing/2014/main" id="{DF58A240-2066-4E5A-AD99-7D50F2CA51B0}"/>
+                <a16:creationId xmlns:a16="http://schemas.microsoft.com/office/drawing/2014/main" id="{A9F3087A-EBF5-42E9-9E42-0A55CD71A0BC}"/>
               </a:ext>
             </a:extLst>
           </p:cNvPr>
@@ -8794,7 +9449,7 @@
           <p:cNvPr id="2" name="">
             <a:extLst xmlns:a="http://schemas.openxmlformats.org/drawingml/2006/main">
               <a:ext uri="{FF2B5EF4-FFF2-40B4-BE49-F238E27FC236}">
-                <a16:creationId xmlns:a16="http://schemas.microsoft.com/office/drawing/2014/main" id="{BB90022F-24E1-40D5-BF8D-2D46B2C9C671}"/>
+                <a16:creationId xmlns:a16="http://schemas.microsoft.com/office/drawing/2014/main" id="{46301F1F-963C-4CE6-A2AB-C4A62814BED0}"/>
               </a:ext>
             </a:extLst>
           </p:cNvPr>
@@ -8804,7 +9459,7 @@
           <p:nvPr/>
         </p:nvPicPr>
         <p:blipFill>
-          <a:blip xmlns:r="http://schemas.openxmlformats.org/officeDocument/2006/relationships" xmlns:a="http://schemas.openxmlformats.org/drawingml/2006/main" r:embed="Rb0caf6ee2325477c"/>
+          <a:blip xmlns:r="http://schemas.openxmlformats.org/officeDocument/2006/relationships" xmlns:a="http://schemas.openxmlformats.org/drawingml/2006/main" r:embed="Rbba9081c54554a87"/>
           <a:stretch xmlns:a="http://schemas.openxmlformats.org/drawingml/2006/main"/>
         </p:blipFill>
         <p:spPr>
@@ -8822,7 +9477,7 @@
           <p:cNvPr id="3" name="">
             <a:extLst xmlns:a="http://schemas.openxmlformats.org/drawingml/2006/main">
               <a:ext uri="{FF2B5EF4-FFF2-40B4-BE49-F238E27FC236}">
-                <a16:creationId xmlns:a16="http://schemas.microsoft.com/office/drawing/2014/main" id="{6C43C7AF-62FC-4932-9AA3-6921C7B4C833}"/>
+                <a16:creationId xmlns:a16="http://schemas.microsoft.com/office/drawing/2014/main" id="{045A961E-F221-4535-BC45-41002EA1E1CB}"/>
               </a:ext>
             </a:extLst>
           </p:cNvPr>
@@ -8852,7 +9507,7 @@
           <p:cNvPr id="4" name="">
             <a:extLst xmlns:a="http://schemas.openxmlformats.org/drawingml/2006/main">
               <a:ext uri="{FF2B5EF4-FFF2-40B4-BE49-F238E27FC236}">
-                <a16:creationId xmlns:a16="http://schemas.microsoft.com/office/drawing/2014/main" id="{934A56C0-55AE-4DC1-BE43-DD5C7ACEBD9A}"/>
+                <a16:creationId xmlns:a16="http://schemas.microsoft.com/office/drawing/2014/main" id="{C41B0539-B458-4A20-AFF0-8D10422DA087}"/>
               </a:ext>
             </a:extLst>
           </p:cNvPr>
@@ -8920,7 +9575,7 @@
           <p:cNvPr id="5" name="">
             <a:extLst xmlns:a="http://schemas.openxmlformats.org/drawingml/2006/main">
               <a:ext uri="{FF2B5EF4-FFF2-40B4-BE49-F238E27FC236}">
-                <a16:creationId xmlns:a16="http://schemas.microsoft.com/office/drawing/2014/main" id="{A23B8F1B-3570-449D-99DE-0F30916F2C1F}"/>
+                <a16:creationId xmlns:a16="http://schemas.microsoft.com/office/drawing/2014/main" id="{7E3A240D-085A-4C5F-AA84-D67CAC23A35C}"/>
               </a:ext>
             </a:extLst>
           </p:cNvPr>
@@ -8988,7 +9643,7 @@
           <p:cNvPr id="6" name="">
             <a:extLst xmlns:a="http://schemas.openxmlformats.org/drawingml/2006/main">
               <a:ext uri="{FF2B5EF4-FFF2-40B4-BE49-F238E27FC236}">
-                <a16:creationId xmlns:a16="http://schemas.microsoft.com/office/drawing/2014/main" id="{7CD2E4E9-8924-4ADE-B1AF-1034FD8E7531}"/>
+                <a16:creationId xmlns:a16="http://schemas.microsoft.com/office/drawing/2014/main" id="{E0C2E65A-7BA5-4576-8DC9-BA372DA66CE6}"/>
               </a:ext>
             </a:extLst>
           </p:cNvPr>
@@ -9056,7 +9711,7 @@
           <p:cNvPr id="7" name="">
             <a:extLst xmlns:a="http://schemas.openxmlformats.org/drawingml/2006/main">
               <a:ext uri="{FF2B5EF4-FFF2-40B4-BE49-F238E27FC236}">
-                <a16:creationId xmlns:a16="http://schemas.microsoft.com/office/drawing/2014/main" id="{C9F44EEA-69A8-4AAA-95B7-70A6425CCD73}"/>
+                <a16:creationId xmlns:a16="http://schemas.microsoft.com/office/drawing/2014/main" id="{E644C3B5-1827-464D-993D-30EED6A96D34}"/>
               </a:ext>
             </a:extLst>
           </p:cNvPr>
@@ -9124,7 +9779,7 @@
           <p:cNvPr id="8" name="">
             <a:extLst xmlns:a="http://schemas.openxmlformats.org/drawingml/2006/main">
               <a:ext uri="{FF2B5EF4-FFF2-40B4-BE49-F238E27FC236}">
-                <a16:creationId xmlns:a16="http://schemas.microsoft.com/office/drawing/2014/main" id="{7496F1EF-98DD-488A-822D-1AE5195D495C}"/>
+                <a16:creationId xmlns:a16="http://schemas.microsoft.com/office/drawing/2014/main" id="{7CF20F5C-40B4-4F99-963C-2F1C36FDF99A}"/>
               </a:ext>
             </a:extLst>
           </p:cNvPr>
@@ -9192,7 +9847,7 @@
           <p:cNvPr id="9" name="">
             <a:extLst xmlns:a="http://schemas.openxmlformats.org/drawingml/2006/main">
               <a:ext uri="{FF2B5EF4-FFF2-40B4-BE49-F238E27FC236}">
-                <a16:creationId xmlns:a16="http://schemas.microsoft.com/office/drawing/2014/main" id="{4CDEB3B5-94F2-4B39-8C05-980B812E5C01}"/>
+                <a16:creationId xmlns:a16="http://schemas.microsoft.com/office/drawing/2014/main" id="{9910DA49-BC08-4C81-AC67-486706D2FB35}"/>
               </a:ext>
             </a:extLst>
           </p:cNvPr>
@@ -9260,7 +9915,7 @@
           <p:cNvPr id="10" name="">
             <a:extLst xmlns:a="http://schemas.openxmlformats.org/drawingml/2006/main">
               <a:ext uri="{FF2B5EF4-FFF2-40B4-BE49-F238E27FC236}">
-                <a16:creationId xmlns:a16="http://schemas.microsoft.com/office/drawing/2014/main" id="{D7811411-1721-4A2E-B25C-ECFCC686E505}"/>
+                <a16:creationId xmlns:a16="http://schemas.microsoft.com/office/drawing/2014/main" id="{E96DD434-C599-4ECC-A6F0-EF89A7B6494D}"/>
               </a:ext>
             </a:extLst>
           </p:cNvPr>
@@ -9328,7 +9983,7 @@
           <p:cNvPr id="11" name="">
             <a:extLst xmlns:a="http://schemas.openxmlformats.org/drawingml/2006/main">
               <a:ext uri="{FF2B5EF4-FFF2-40B4-BE49-F238E27FC236}">
-                <a16:creationId xmlns:a16="http://schemas.microsoft.com/office/drawing/2014/main" id="{4B601EE9-EE19-4FB0-9314-8B7FC96ACCAC}"/>
+                <a16:creationId xmlns:a16="http://schemas.microsoft.com/office/drawing/2014/main" id="{52E34FC9-6886-43E5-A29F-389FFAA0EDAD}"/>
               </a:ext>
             </a:extLst>
           </p:cNvPr>
@@ -9396,7 +10051,7 @@
           <p:cNvPr id="12" name="">
             <a:extLst xmlns:a="http://schemas.openxmlformats.org/drawingml/2006/main">
               <a:ext uri="{FF2B5EF4-FFF2-40B4-BE49-F238E27FC236}">
-                <a16:creationId xmlns:a16="http://schemas.microsoft.com/office/drawing/2014/main" id="{51B68B89-0734-4E97-9E38-B790152BA702}"/>
+                <a16:creationId xmlns:a16="http://schemas.microsoft.com/office/drawing/2014/main" id="{62FDFA93-057A-4347-849F-4D0600AFDD23}"/>
               </a:ext>
             </a:extLst>
           </p:cNvPr>
@@ -9464,7 +10119,7 @@
           <p:cNvPr id="13" name="">
             <a:extLst xmlns:a="http://schemas.openxmlformats.org/drawingml/2006/main">
               <a:ext uri="{FF2B5EF4-FFF2-40B4-BE49-F238E27FC236}">
-                <a16:creationId xmlns:a16="http://schemas.microsoft.com/office/drawing/2014/main" id="{8F4A765D-7056-4494-BE41-F3BB9653C7B9}"/>
+                <a16:creationId xmlns:a16="http://schemas.microsoft.com/office/drawing/2014/main" id="{A7AC09BC-04B9-4559-8F5A-1ADDEE7BD031}"/>
               </a:ext>
             </a:extLst>
           </p:cNvPr>
@@ -9494,7 +10149,7 @@
           <p:cNvPr id="14" name="">
             <a:extLst xmlns:a="http://schemas.openxmlformats.org/drawingml/2006/main">
               <a:ext uri="{FF2B5EF4-FFF2-40B4-BE49-F238E27FC236}">
-                <a16:creationId xmlns:a16="http://schemas.microsoft.com/office/drawing/2014/main" id="{F35672D1-EB36-4032-9092-E24A0CB28D4A}"/>
+                <a16:creationId xmlns:a16="http://schemas.microsoft.com/office/drawing/2014/main" id="{0274EF11-E764-4DBC-A248-59782E0A5DFA}"/>
               </a:ext>
             </a:extLst>
           </p:cNvPr>
@@ -9562,7 +10217,7 @@
           <p:cNvPr id="15" name="">
             <a:extLst xmlns:a="http://schemas.openxmlformats.org/drawingml/2006/main">
               <a:ext uri="{FF2B5EF4-FFF2-40B4-BE49-F238E27FC236}">
-                <a16:creationId xmlns:a16="http://schemas.microsoft.com/office/drawing/2014/main" id="{E7D46F99-0CFC-4E8F-BC68-53C9E50EF572}"/>
+                <a16:creationId xmlns:a16="http://schemas.microsoft.com/office/drawing/2014/main" id="{D646AFB0-748F-4818-A5DA-0AC1C64A9B02}"/>
               </a:ext>
             </a:extLst>
           </p:cNvPr>
@@ -9620,7 +10275,7 @@
                 <a:ea typeface="Pretendard"/>
                 <a:cs typeface="Pretendard"/>
               </a:rPr>
-              <a:t>Blood coagulation tests</a:t>
+              <a:t>Blood coagulation tests (PT/PTT)</a:t>
             </a:r>
           </a:p>
         </p:txBody>
@@ -9630,7 +10285,7 @@
           <p:cNvPr id="16" name="">
             <a:extLst xmlns:a="http://schemas.openxmlformats.org/drawingml/2006/main">
               <a:ext uri="{FF2B5EF4-FFF2-40B4-BE49-F238E27FC236}">
-                <a16:creationId xmlns:a16="http://schemas.microsoft.com/office/drawing/2014/main" id="{DAD3E60B-1A62-4446-8680-70E361EB42E6}"/>
+                <a16:creationId xmlns:a16="http://schemas.microsoft.com/office/drawing/2014/main" id="{4572127D-5224-4988-81EC-F464098C6B48}"/>
               </a:ext>
             </a:extLst>
           </p:cNvPr>
@@ -9688,7 +10343,7 @@
                 <a:ea typeface="Pretendard"/>
                 <a:cs typeface="Pretendard"/>
               </a:rPr>
-              <a:t>Complete blood count (CBC)</a:t>
+              <a:t>TTT (testosterone)</a:t>
             </a:r>
           </a:p>
         </p:txBody>
@@ -9698,7 +10353,7 @@
           <p:cNvPr id="17" name="">
             <a:extLst xmlns:a="http://schemas.openxmlformats.org/drawingml/2006/main">
               <a:ext uri="{FF2B5EF4-FFF2-40B4-BE49-F238E27FC236}">
-                <a16:creationId xmlns:a16="http://schemas.microsoft.com/office/drawing/2014/main" id="{411D0599-3FA7-4655-8D2C-EE663B790610}"/>
+                <a16:creationId xmlns:a16="http://schemas.microsoft.com/office/drawing/2014/main" id="{D8885DF0-7083-4683-8DDB-36E4D7831D42}"/>
               </a:ext>
             </a:extLst>
           </p:cNvPr>
@@ -9756,7 +10411,7 @@
                 <a:ea typeface="Pretendard"/>
                 <a:cs typeface="Pretendard"/>
               </a:rPr>
-              <a:t>Prostate-specific antigen (PSA)</a:t>
+              <a:t>Complete blood count (CBC)</a:t>
             </a:r>
           </a:p>
         </p:txBody>
@@ -9766,7 +10421,7 @@
           <p:cNvPr id="18" name="">
             <a:extLst xmlns:a="http://schemas.openxmlformats.org/drawingml/2006/main">
               <a:ext uri="{FF2B5EF4-FFF2-40B4-BE49-F238E27FC236}">
-                <a16:creationId xmlns:a16="http://schemas.microsoft.com/office/drawing/2014/main" id="{7CD23F2F-C37E-4183-B6B7-C63FCB5D0235}"/>
+                <a16:creationId xmlns:a16="http://schemas.microsoft.com/office/drawing/2014/main" id="{8E70D519-64A3-4420-8763-EC075D8C8742}"/>
               </a:ext>
             </a:extLst>
           </p:cNvPr>
@@ -9824,7 +10479,7 @@
                 <a:ea typeface="Pretendard"/>
                 <a:cs typeface="Pretendard"/>
               </a:rPr>
-              <a:t>Blood glucose</a:t>
+              <a:t>Prostate-specific antigen (PSA)</a:t>
             </a:r>
           </a:p>
         </p:txBody>
@@ -9834,7 +10489,7 @@
           <p:cNvPr id="19" name="">
             <a:extLst xmlns:a="http://schemas.openxmlformats.org/drawingml/2006/main">
               <a:ext uri="{FF2B5EF4-FFF2-40B4-BE49-F238E27FC236}">
-                <a16:creationId xmlns:a16="http://schemas.microsoft.com/office/drawing/2014/main" id="{6B8ED8E9-25ED-4CAB-9A42-8395AC36B760}"/>
+                <a16:creationId xmlns:a16="http://schemas.microsoft.com/office/drawing/2014/main" id="{8348EAC8-A711-45FA-8D95-F16FEA685E1E}"/>
               </a:ext>
             </a:extLst>
           </p:cNvPr>
@@ -9892,7 +10547,7 @@
                 <a:ea typeface="Pretendard"/>
                 <a:cs typeface="Pretendard"/>
               </a:rPr>
-              <a:t>HbA1c (glycated hemoglobin)</a:t>
+              <a:t>Blood glucose (BST/HbA1c)</a:t>
             </a:r>
           </a:p>
         </p:txBody>
@@ -9902,7 +10557,7 @@
           <p:cNvPr id="20" name="">
             <a:extLst xmlns:a="http://schemas.openxmlformats.org/drawingml/2006/main">
               <a:ext uri="{FF2B5EF4-FFF2-40B4-BE49-F238E27FC236}">
-                <a16:creationId xmlns:a16="http://schemas.microsoft.com/office/drawing/2014/main" id="{F9C5AF21-A132-4FE2-AA38-17670C57A6DE}"/>
+                <a16:creationId xmlns:a16="http://schemas.microsoft.com/office/drawing/2014/main" id="{6F8C8ECC-E7D2-4AE6-BA76-773FDD53EC75}"/>
               </a:ext>
             </a:extLst>
           </p:cNvPr>
@@ -9960,7 +10615,7 @@
                 <a:ea typeface="Pretendard"/>
                 <a:cs typeface="Pretendard"/>
               </a:rPr>
-              <a:t>HPV testing</a:t>
+              <a:t>HIV testing</a:t>
             </a:r>
           </a:p>
         </p:txBody>
@@ -9970,7 +10625,7 @@
           <p:cNvPr id="21" name="">
             <a:extLst xmlns:a="http://schemas.openxmlformats.org/drawingml/2006/main">
               <a:ext uri="{FF2B5EF4-FFF2-40B4-BE49-F238E27FC236}">
-                <a16:creationId xmlns:a16="http://schemas.microsoft.com/office/drawing/2014/main" id="{6645BEA7-DBD0-421E-94CE-8AEA969D7345}"/>
+                <a16:creationId xmlns:a16="http://schemas.microsoft.com/office/drawing/2014/main" id="{9DFE3FAA-6786-46D1-A152-6DB09E894A80}"/>
               </a:ext>
             </a:extLst>
           </p:cNvPr>
@@ -10038,7 +10693,7 @@
           <p:cNvPr id="22" name="">
             <a:extLst xmlns:a="http://schemas.openxmlformats.org/drawingml/2006/main">
               <a:ext uri="{FF2B5EF4-FFF2-40B4-BE49-F238E27FC236}">
-                <a16:creationId xmlns:a16="http://schemas.microsoft.com/office/drawing/2014/main" id="{F1F9584A-E4AF-4476-B712-462BEAA7A0F1}"/>
+                <a16:creationId xmlns:a16="http://schemas.microsoft.com/office/drawing/2014/main" id="{4EE96B60-A34A-4F28-9930-59938805EA7B}"/>
               </a:ext>
             </a:extLst>
           </p:cNvPr>
@@ -10106,7 +10761,7 @@
           <p:cNvPr id="23" name="">
             <a:extLst xmlns:a="http://schemas.openxmlformats.org/drawingml/2006/main">
               <a:ext uri="{FF2B5EF4-FFF2-40B4-BE49-F238E27FC236}">
-                <a16:creationId xmlns:a16="http://schemas.microsoft.com/office/drawing/2014/main" id="{0B7AFEDF-8484-4566-B882-42D9249DD9FB}"/>
+                <a16:creationId xmlns:a16="http://schemas.microsoft.com/office/drawing/2014/main" id="{C3C3EDF9-26AF-437C-99EF-CEDC79F07F8B}"/>
               </a:ext>
             </a:extLst>
           </p:cNvPr>
@@ -10164,7 +10819,7 @@
                 <a:ea typeface="Pretendard"/>
                 <a:cs typeface="Pretendard"/>
               </a:rPr>
-              <a:t>Liver function</a:t>
+              <a:t>Liver enzymes (GOT/GPT/GGT)</a:t>
             </a:r>
           </a:p>
         </p:txBody>
@@ -10174,7 +10829,7 @@
           <p:cNvPr id="24" name="">
             <a:extLst xmlns:a="http://schemas.openxmlformats.org/drawingml/2006/main">
               <a:ext uri="{FF2B5EF4-FFF2-40B4-BE49-F238E27FC236}">
-                <a16:creationId xmlns:a16="http://schemas.microsoft.com/office/drawing/2014/main" id="{7E3443A2-5A73-401F-AE23-E064823F62BF}"/>
+                <a16:creationId xmlns:a16="http://schemas.microsoft.com/office/drawing/2014/main" id="{B2892F91-C133-4502-9E75-EF0A6426979F}"/>
               </a:ext>
             </a:extLst>
           </p:cNvPr>
@@ -10242,7 +10897,7 @@
           <p:cNvPr id="25" name="">
             <a:extLst xmlns:a="http://schemas.openxmlformats.org/drawingml/2006/main">
               <a:ext uri="{FF2B5EF4-FFF2-40B4-BE49-F238E27FC236}">
-                <a16:creationId xmlns:a16="http://schemas.microsoft.com/office/drawing/2014/main" id="{AF42D713-6D6B-4A28-86DC-9B9618B68593}"/>
+                <a16:creationId xmlns:a16="http://schemas.microsoft.com/office/drawing/2014/main" id="{033DF740-109A-4633-887E-C589301DC08E}"/>
               </a:ext>
             </a:extLst>
           </p:cNvPr>
@@ -10310,7 +10965,7 @@
           <p:cNvPr id="26" name="">
             <a:extLst xmlns:a="http://schemas.openxmlformats.org/drawingml/2006/main">
               <a:ext uri="{FF2B5EF4-FFF2-40B4-BE49-F238E27FC236}">
-                <a16:creationId xmlns:a16="http://schemas.microsoft.com/office/drawing/2014/main" id="{1FA6672E-A783-4D16-9A27-035C12082961}"/>
+                <a16:creationId xmlns:a16="http://schemas.microsoft.com/office/drawing/2014/main" id="{7B7FEAD0-9BB7-4087-9437-BC1B1BEEA4EE}"/>
               </a:ext>
             </a:extLst>
           </p:cNvPr>
@@ -10376,7 +11031,7 @@
     </p:spTree>
     <p:extLst>
       <p:ext uri="{BB962C8B-B14F-4D97-AF65-F5344CB8AC3E}">
-        <p14:creationId xmlns:p14="http://schemas.microsoft.com/office/powerpoint/2010/main" val="489602420"/>
+        <p14:creationId xmlns:p14="http://schemas.microsoft.com/office/powerpoint/2010/main" val="161805036"/>
       </p:ext>
     </p:extLst>
   </p:cSld>
@@ -10407,7 +11062,7 @@
           <p:cNvPr id="7" name="">
             <a:extLst xmlns:a="http://schemas.openxmlformats.org/drawingml/2006/main">
               <a:ext uri="{FF2B5EF4-FFF2-40B4-BE49-F238E27FC236}">
-                <a16:creationId xmlns:a16="http://schemas.microsoft.com/office/drawing/2014/main" id="{827D09AD-F5D8-42BF-94EF-CFB2EE192036}"/>
+                <a16:creationId xmlns:a16="http://schemas.microsoft.com/office/drawing/2014/main" id="{871F1DC7-0711-4FD8-8222-E755C521248E}"/>
               </a:ext>
             </a:extLst>
           </p:cNvPr>
@@ -10475,7 +11130,7 @@
           <p:cNvPr id="2" name="">
             <a:extLst xmlns:a="http://schemas.openxmlformats.org/drawingml/2006/main">
               <a:ext uri="{FF2B5EF4-FFF2-40B4-BE49-F238E27FC236}">
-                <a16:creationId xmlns:a16="http://schemas.microsoft.com/office/drawing/2014/main" id="{A93B6540-F3DD-4C63-91E3-3D81E79AB990}"/>
+                <a16:creationId xmlns:a16="http://schemas.microsoft.com/office/drawing/2014/main" id="{83E559EE-89AD-4476-8EE1-B2180305B0FA}"/>
               </a:ext>
             </a:extLst>
           </p:cNvPr>
@@ -10543,7 +11198,7 @@
           <p:cNvPr id="3" name="">
             <a:extLst xmlns:a="http://schemas.openxmlformats.org/drawingml/2006/main">
               <a:ext uri="{FF2B5EF4-FFF2-40B4-BE49-F238E27FC236}">
-                <a16:creationId xmlns:a16="http://schemas.microsoft.com/office/drawing/2014/main" id="{B89DA20D-4428-4C4B-A4F4-698245AB596C}"/>
+                <a16:creationId xmlns:a16="http://schemas.microsoft.com/office/drawing/2014/main" id="{92E8407A-0E67-44DC-8298-5ABD475938D9}"/>
               </a:ext>
             </a:extLst>
           </p:cNvPr>
@@ -10553,7 +11208,7 @@
           <p:nvPr/>
         </p:nvPicPr>
         <p:blipFill>
-          <a:blip xmlns:r="http://schemas.openxmlformats.org/officeDocument/2006/relationships" xmlns:a="http://schemas.openxmlformats.org/drawingml/2006/main" r:embed="Rc52bb6764c05416d"/>
+          <a:blip xmlns:r="http://schemas.openxmlformats.org/officeDocument/2006/relationships" xmlns:a="http://schemas.openxmlformats.org/drawingml/2006/main" r:embed="R82245ccac42848b4"/>
           <a:stretch xmlns:a="http://schemas.openxmlformats.org/drawingml/2006/main"/>
         </p:blipFill>
         <p:spPr>
@@ -10571,7 +11226,7 @@
           <p:cNvPr id="4" name="">
             <a:extLst xmlns:a="http://schemas.openxmlformats.org/drawingml/2006/main">
               <a:ext uri="{FF2B5EF4-FFF2-40B4-BE49-F238E27FC236}">
-                <a16:creationId xmlns:a16="http://schemas.microsoft.com/office/drawing/2014/main" id="{13F70C19-F192-4A49-9598-9354B62E14E7}"/>
+                <a16:creationId xmlns:a16="http://schemas.microsoft.com/office/drawing/2014/main" id="{442BCE9A-4E69-4BA2-98A7-705C5956A18A}"/>
               </a:ext>
             </a:extLst>
           </p:cNvPr>
@@ -10601,7 +11256,7 @@
           <p:cNvPr id="5" name="">
             <a:extLst xmlns:a="http://schemas.openxmlformats.org/drawingml/2006/main">
               <a:ext uri="{FF2B5EF4-FFF2-40B4-BE49-F238E27FC236}">
-                <a16:creationId xmlns:a16="http://schemas.microsoft.com/office/drawing/2014/main" id="{FE470C87-4D92-4116-B9A1-BDC52F79B882}"/>
+                <a16:creationId xmlns:a16="http://schemas.microsoft.com/office/drawing/2014/main" id="{118997D5-4AB6-4172-8A7B-1F37BCF98B64}"/>
               </a:ext>
             </a:extLst>
           </p:cNvPr>
@@ -10669,7 +11324,7 @@
           <p:cNvPr id="6" name="">
             <a:extLst xmlns:a="http://schemas.openxmlformats.org/drawingml/2006/main">
               <a:ext uri="{FF2B5EF4-FFF2-40B4-BE49-F238E27FC236}">
-                <a16:creationId xmlns:a16="http://schemas.microsoft.com/office/drawing/2014/main" id="{3144870D-0D3E-4278-9EF2-5A82126E9620}"/>
+                <a16:creationId xmlns:a16="http://schemas.microsoft.com/office/drawing/2014/main" id="{C9D78242-349D-45E8-BDF6-E930311E9A50}"/>
               </a:ext>
             </a:extLst>
           </p:cNvPr>
@@ -10735,7 +11390,7 @@
     </p:spTree>
     <p:extLst>
       <p:ext uri="{BB962C8B-B14F-4D97-AF65-F5344CB8AC3E}">
-        <p14:creationId xmlns:p14="http://schemas.microsoft.com/office/powerpoint/2010/main" val="43236006"/>
+        <p14:creationId xmlns:p14="http://schemas.microsoft.com/office/powerpoint/2010/main" val="964826449"/>
       </p:ext>
     </p:extLst>
   </p:cSld>
@@ -10766,7 +11421,7 @@
           <p:cNvPr id="7" name="">
             <a:extLst xmlns:a="http://schemas.openxmlformats.org/drawingml/2006/main">
               <a:ext uri="{FF2B5EF4-FFF2-40B4-BE49-F238E27FC236}">
-                <a16:creationId xmlns:a16="http://schemas.microsoft.com/office/drawing/2014/main" id="{5C77C5B1-328B-4EE5-A4ED-674805CDB200}"/>
+                <a16:creationId xmlns:a16="http://schemas.microsoft.com/office/drawing/2014/main" id="{2C8D0742-AD12-4E59-A4AC-F5DCE09CCABD}"/>
               </a:ext>
             </a:extLst>
           </p:cNvPr>
@@ -10834,7 +11489,7 @@
           <p:cNvPr id="2" name="">
             <a:extLst xmlns:a="http://schemas.openxmlformats.org/drawingml/2006/main">
               <a:ext uri="{FF2B5EF4-FFF2-40B4-BE49-F238E27FC236}">
-                <a16:creationId xmlns:a16="http://schemas.microsoft.com/office/drawing/2014/main" id="{BCA8FCE8-F615-42CE-A51D-86F9D065BDE0}"/>
+                <a16:creationId xmlns:a16="http://schemas.microsoft.com/office/drawing/2014/main" id="{341A5E4A-0A7B-406A-B212-4994C49CAD29}"/>
               </a:ext>
             </a:extLst>
           </p:cNvPr>
@@ -10902,7 +11557,7 @@
           <p:cNvPr id="3" name="">
             <a:extLst xmlns:a="http://schemas.openxmlformats.org/drawingml/2006/main">
               <a:ext uri="{FF2B5EF4-FFF2-40B4-BE49-F238E27FC236}">
-                <a16:creationId xmlns:a16="http://schemas.microsoft.com/office/drawing/2014/main" id="{B2DBF23C-4743-49AC-9A19-BFDDE55E49CE}"/>
+                <a16:creationId xmlns:a16="http://schemas.microsoft.com/office/drawing/2014/main" id="{637E1D12-415C-49EA-8564-DE54F21B58FC}"/>
               </a:ext>
             </a:extLst>
           </p:cNvPr>
@@ -10912,7 +11567,7 @@
           <p:nvPr/>
         </p:nvPicPr>
         <p:blipFill>
-          <a:blip xmlns:r="http://schemas.openxmlformats.org/officeDocument/2006/relationships" xmlns:a="http://schemas.openxmlformats.org/drawingml/2006/main" r:embed="Re50b36ccc947498f"/>
+          <a:blip xmlns:r="http://schemas.openxmlformats.org/officeDocument/2006/relationships" xmlns:a="http://schemas.openxmlformats.org/drawingml/2006/main" r:embed="R7361408f9a654f87"/>
           <a:stretch xmlns:a="http://schemas.openxmlformats.org/drawingml/2006/main"/>
         </p:blipFill>
         <p:spPr>
@@ -10930,7 +11585,7 @@
           <p:cNvPr id="4" name="">
             <a:extLst xmlns:a="http://schemas.openxmlformats.org/drawingml/2006/main">
               <a:ext uri="{FF2B5EF4-FFF2-40B4-BE49-F238E27FC236}">
-                <a16:creationId xmlns:a16="http://schemas.microsoft.com/office/drawing/2014/main" id="{AC90B3C0-6AD1-4A36-8E71-574A91F42A1A}"/>
+                <a16:creationId xmlns:a16="http://schemas.microsoft.com/office/drawing/2014/main" id="{9C10178B-BE7E-49E8-A596-21D046CEBBFC}"/>
               </a:ext>
             </a:extLst>
           </p:cNvPr>
@@ -10960,7 +11615,7 @@
           <p:cNvPr id="5" name="">
             <a:extLst xmlns:a="http://schemas.openxmlformats.org/drawingml/2006/main">
               <a:ext uri="{FF2B5EF4-FFF2-40B4-BE49-F238E27FC236}">
-                <a16:creationId xmlns:a16="http://schemas.microsoft.com/office/drawing/2014/main" id="{0F4E9914-8503-4B4D-ABA2-690F6E1F8785}"/>
+                <a16:creationId xmlns:a16="http://schemas.microsoft.com/office/drawing/2014/main" id="{417CB957-964D-40E8-9861-358265BEE2CB}"/>
               </a:ext>
             </a:extLst>
           </p:cNvPr>
@@ -11028,7 +11683,7 @@
           <p:cNvPr id="6" name="">
             <a:extLst xmlns:a="http://schemas.openxmlformats.org/drawingml/2006/main">
               <a:ext uri="{FF2B5EF4-FFF2-40B4-BE49-F238E27FC236}">
-                <a16:creationId xmlns:a16="http://schemas.microsoft.com/office/drawing/2014/main" id="{0B83710F-FCE4-454C-BCC8-678F7619E550}"/>
+                <a16:creationId xmlns:a16="http://schemas.microsoft.com/office/drawing/2014/main" id="{D6E9E2F8-813D-463B-971B-74CBBD6E0B5B}"/>
               </a:ext>
             </a:extLst>
           </p:cNvPr>
@@ -11094,7 +11749,7 @@
     </p:spTree>
     <p:extLst>
       <p:ext uri="{BB962C8B-B14F-4D97-AF65-F5344CB8AC3E}">
-        <p14:creationId xmlns:p14="http://schemas.microsoft.com/office/powerpoint/2010/main" val="1460051088"/>
+        <p14:creationId xmlns:p14="http://schemas.microsoft.com/office/powerpoint/2010/main" val="562962979"/>
       </p:ext>
     </p:extLst>
   </p:cSld>
@@ -11125,7 +11780,7 @@
           <p:cNvPr id="7" name="">
             <a:extLst xmlns:a="http://schemas.openxmlformats.org/drawingml/2006/main">
               <a:ext uri="{FF2B5EF4-FFF2-40B4-BE49-F238E27FC236}">
-                <a16:creationId xmlns:a16="http://schemas.microsoft.com/office/drawing/2014/main" id="{66E65A33-1478-45DE-A55B-860E66174ED4}"/>
+                <a16:creationId xmlns:a16="http://schemas.microsoft.com/office/drawing/2014/main" id="{BDCB4C41-E973-4B04-82A8-7E787910F437}"/>
               </a:ext>
             </a:extLst>
           </p:cNvPr>
@@ -11193,7 +11848,7 @@
           <p:cNvPr id="2" name="">
             <a:extLst xmlns:a="http://schemas.openxmlformats.org/drawingml/2006/main">
               <a:ext uri="{FF2B5EF4-FFF2-40B4-BE49-F238E27FC236}">
-                <a16:creationId xmlns:a16="http://schemas.microsoft.com/office/drawing/2014/main" id="{52F71B2E-90D2-4701-BC43-5F211436DE7B}"/>
+                <a16:creationId xmlns:a16="http://schemas.microsoft.com/office/drawing/2014/main" id="{D6483EEA-D620-4C0E-973B-714571A4DAD8}"/>
               </a:ext>
             </a:extLst>
           </p:cNvPr>
@@ -11261,7 +11916,7 @@
           <p:cNvPr id="3" name="">
             <a:extLst xmlns:a="http://schemas.openxmlformats.org/drawingml/2006/main">
               <a:ext uri="{FF2B5EF4-FFF2-40B4-BE49-F238E27FC236}">
-                <a16:creationId xmlns:a16="http://schemas.microsoft.com/office/drawing/2014/main" id="{14E4716D-5330-4F48-BEA9-25F31212A679}"/>
+                <a16:creationId xmlns:a16="http://schemas.microsoft.com/office/drawing/2014/main" id="{8C621C21-92D0-4AF3-AEFE-32A680B94CFC}"/>
               </a:ext>
             </a:extLst>
           </p:cNvPr>
@@ -11271,7 +11926,7 @@
           <p:nvPr/>
         </p:nvPicPr>
         <p:blipFill>
-          <a:blip xmlns:r="http://schemas.openxmlformats.org/officeDocument/2006/relationships" xmlns:a="http://schemas.openxmlformats.org/drawingml/2006/main" r:embed="Ra69d2eebf0f8423c"/>
+          <a:blip xmlns:r="http://schemas.openxmlformats.org/officeDocument/2006/relationships" xmlns:a="http://schemas.openxmlformats.org/drawingml/2006/main" r:embed="Rf84f5926fd584d12"/>
           <a:stretch xmlns:a="http://schemas.openxmlformats.org/drawingml/2006/main"/>
         </p:blipFill>
         <p:spPr>
@@ -11289,7 +11944,7 @@
           <p:cNvPr id="4" name="">
             <a:extLst xmlns:a="http://schemas.openxmlformats.org/drawingml/2006/main">
               <a:ext uri="{FF2B5EF4-FFF2-40B4-BE49-F238E27FC236}">
-                <a16:creationId xmlns:a16="http://schemas.microsoft.com/office/drawing/2014/main" id="{1D5A63D8-D951-41FF-B99C-023FDC51B58B}"/>
+                <a16:creationId xmlns:a16="http://schemas.microsoft.com/office/drawing/2014/main" id="{1C51E2C9-1B2F-4EEE-A561-4CB0B476F295}"/>
               </a:ext>
             </a:extLst>
           </p:cNvPr>
@@ -11319,7 +11974,7 @@
           <p:cNvPr id="5" name="">
             <a:extLst xmlns:a="http://schemas.openxmlformats.org/drawingml/2006/main">
               <a:ext uri="{FF2B5EF4-FFF2-40B4-BE49-F238E27FC236}">
-                <a16:creationId xmlns:a16="http://schemas.microsoft.com/office/drawing/2014/main" id="{81CD9DCF-87AA-4557-89CA-41CCBFA8D115}"/>
+                <a16:creationId xmlns:a16="http://schemas.microsoft.com/office/drawing/2014/main" id="{BB2D8F1C-3430-4124-9CC1-A373707B3FAC}"/>
               </a:ext>
             </a:extLst>
           </p:cNvPr>
@@ -11387,7 +12042,7 @@
           <p:cNvPr id="6" name="">
             <a:extLst xmlns:a="http://schemas.openxmlformats.org/drawingml/2006/main">
               <a:ext uri="{FF2B5EF4-FFF2-40B4-BE49-F238E27FC236}">
-                <a16:creationId xmlns:a16="http://schemas.microsoft.com/office/drawing/2014/main" id="{65A0508E-7F63-44EC-8DEE-34C68ED8E72A}"/>
+                <a16:creationId xmlns:a16="http://schemas.microsoft.com/office/drawing/2014/main" id="{3419E3DB-FD25-4058-AA93-D83D152C2615}"/>
               </a:ext>
             </a:extLst>
           </p:cNvPr>
@@ -11453,7 +12108,7 @@
     </p:spTree>
     <p:extLst>
       <p:ext uri="{BB962C8B-B14F-4D97-AF65-F5344CB8AC3E}">
-        <p14:creationId xmlns:p14="http://schemas.microsoft.com/office/powerpoint/2010/main" val="50214318"/>
+        <p14:creationId xmlns:p14="http://schemas.microsoft.com/office/powerpoint/2010/main" val="1230044322"/>
       </p:ext>
     </p:extLst>
   </p:cSld>
@@ -11484,7 +12139,7 @@
           <p:cNvPr id="7" name="">
             <a:extLst xmlns:a="http://schemas.openxmlformats.org/drawingml/2006/main">
               <a:ext uri="{FF2B5EF4-FFF2-40B4-BE49-F238E27FC236}">
-                <a16:creationId xmlns:a16="http://schemas.microsoft.com/office/drawing/2014/main" id="{FDFE57C6-71EB-4AAD-A1C6-534667093B2B}"/>
+                <a16:creationId xmlns:a16="http://schemas.microsoft.com/office/drawing/2014/main" id="{013B8CFE-AFAC-4F29-BAE2-22E42E93959B}"/>
               </a:ext>
             </a:extLst>
           </p:cNvPr>
@@ -11552,7 +12207,7 @@
           <p:cNvPr id="2" name="">
             <a:extLst xmlns:a="http://schemas.openxmlformats.org/drawingml/2006/main">
               <a:ext uri="{FF2B5EF4-FFF2-40B4-BE49-F238E27FC236}">
-                <a16:creationId xmlns:a16="http://schemas.microsoft.com/office/drawing/2014/main" id="{EEE9FE4B-75D8-4C3B-9CD0-1D8CA7B45A23}"/>
+                <a16:creationId xmlns:a16="http://schemas.microsoft.com/office/drawing/2014/main" id="{34B3691A-77AB-415A-AC36-367285055C12}"/>
               </a:ext>
             </a:extLst>
           </p:cNvPr>
@@ -11620,7 +12275,7 @@
           <p:cNvPr id="3" name="">
             <a:extLst xmlns:a="http://schemas.openxmlformats.org/drawingml/2006/main">
               <a:ext uri="{FF2B5EF4-FFF2-40B4-BE49-F238E27FC236}">
-                <a16:creationId xmlns:a16="http://schemas.microsoft.com/office/drawing/2014/main" id="{E5722E21-3F88-4521-82CA-3B3BB0947D94}"/>
+                <a16:creationId xmlns:a16="http://schemas.microsoft.com/office/drawing/2014/main" id="{0F80B87A-A315-446F-80F9-1AB3A3EC42C6}"/>
               </a:ext>
             </a:extLst>
           </p:cNvPr>
@@ -11630,7 +12285,7 @@
           <p:nvPr/>
         </p:nvPicPr>
         <p:blipFill>
-          <a:blip xmlns:r="http://schemas.openxmlformats.org/officeDocument/2006/relationships" xmlns:a="http://schemas.openxmlformats.org/drawingml/2006/main" r:embed="R9356ea0803d2489b"/>
+          <a:blip xmlns:r="http://schemas.openxmlformats.org/officeDocument/2006/relationships" xmlns:a="http://schemas.openxmlformats.org/drawingml/2006/main" r:embed="Rf8b0d752d97c42c2"/>
           <a:stretch xmlns:a="http://schemas.openxmlformats.org/drawingml/2006/main"/>
         </p:blipFill>
         <p:spPr>
@@ -11648,7 +12303,7 @@
           <p:cNvPr id="4" name="">
             <a:extLst xmlns:a="http://schemas.openxmlformats.org/drawingml/2006/main">
               <a:ext uri="{FF2B5EF4-FFF2-40B4-BE49-F238E27FC236}">
-                <a16:creationId xmlns:a16="http://schemas.microsoft.com/office/drawing/2014/main" id="{C7AE2A5A-3136-4E1B-8D3A-6379304D3F07}"/>
+                <a16:creationId xmlns:a16="http://schemas.microsoft.com/office/drawing/2014/main" id="{F9E7166F-FAE2-491B-B7C1-9DB1CE2BE20E}"/>
               </a:ext>
             </a:extLst>
           </p:cNvPr>
@@ -11678,7 +12333,7 @@
           <p:cNvPr id="5" name="">
             <a:extLst xmlns:a="http://schemas.openxmlformats.org/drawingml/2006/main">
               <a:ext uri="{FF2B5EF4-FFF2-40B4-BE49-F238E27FC236}">
-                <a16:creationId xmlns:a16="http://schemas.microsoft.com/office/drawing/2014/main" id="{AAE17AEB-65FA-4218-A45F-FF350D3BEA98}"/>
+                <a16:creationId xmlns:a16="http://schemas.microsoft.com/office/drawing/2014/main" id="{11736035-198A-4DD5-956C-AA1AA059B4C8}"/>
               </a:ext>
             </a:extLst>
           </p:cNvPr>
@@ -11746,7 +12401,7 @@
           <p:cNvPr id="6" name="">
             <a:extLst xmlns:a="http://schemas.openxmlformats.org/drawingml/2006/main">
               <a:ext uri="{FF2B5EF4-FFF2-40B4-BE49-F238E27FC236}">
-                <a16:creationId xmlns:a16="http://schemas.microsoft.com/office/drawing/2014/main" id="{DB584A84-242D-42FE-B60B-AAC075009550}"/>
+                <a16:creationId xmlns:a16="http://schemas.microsoft.com/office/drawing/2014/main" id="{52D42E1C-28E5-4F7B-83B9-9C67936654A5}"/>
               </a:ext>
             </a:extLst>
           </p:cNvPr>
@@ -11812,7 +12467,7 @@
     </p:spTree>
     <p:extLst>
       <p:ext uri="{BB962C8B-B14F-4D97-AF65-F5344CB8AC3E}">
-        <p14:creationId xmlns:p14="http://schemas.microsoft.com/office/powerpoint/2010/main" val="1758296185"/>
+        <p14:creationId xmlns:p14="http://schemas.microsoft.com/office/powerpoint/2010/main" val="1796714502"/>
       </p:ext>
     </p:extLst>
   </p:cSld>
@@ -11843,7 +12498,7 @@
           <p:cNvPr id="7" name="">
             <a:extLst xmlns:a="http://schemas.openxmlformats.org/drawingml/2006/main">
               <a:ext uri="{FF2B5EF4-FFF2-40B4-BE49-F238E27FC236}">
-                <a16:creationId xmlns:a16="http://schemas.microsoft.com/office/drawing/2014/main" id="{2BEFFF0C-5F1A-430F-8F68-794ADC1F1643}"/>
+                <a16:creationId xmlns:a16="http://schemas.microsoft.com/office/drawing/2014/main" id="{30B38F70-727C-4F05-AA52-804227A197EA}"/>
               </a:ext>
             </a:extLst>
           </p:cNvPr>
@@ -11911,7 +12566,7 @@
           <p:cNvPr id="2" name="">
             <a:extLst xmlns:a="http://schemas.openxmlformats.org/drawingml/2006/main">
               <a:ext uri="{FF2B5EF4-FFF2-40B4-BE49-F238E27FC236}">
-                <a16:creationId xmlns:a16="http://schemas.microsoft.com/office/drawing/2014/main" id="{AA37BA3E-90F8-4BE9-9A09-4798F6E16573}"/>
+                <a16:creationId xmlns:a16="http://schemas.microsoft.com/office/drawing/2014/main" id="{D14034BC-B393-42B6-BBC2-6CCF0240FBD9}"/>
               </a:ext>
             </a:extLst>
           </p:cNvPr>
@@ -11979,7 +12634,7 @@
           <p:cNvPr id="3" name="">
             <a:extLst xmlns:a="http://schemas.openxmlformats.org/drawingml/2006/main">
               <a:ext uri="{FF2B5EF4-FFF2-40B4-BE49-F238E27FC236}">
-                <a16:creationId xmlns:a16="http://schemas.microsoft.com/office/drawing/2014/main" id="{E921F0D3-F3F2-4EB6-A693-4FCAE4BCE6FA}"/>
+                <a16:creationId xmlns:a16="http://schemas.microsoft.com/office/drawing/2014/main" id="{8F244830-DA4D-4636-83B9-149D9F68E373}"/>
               </a:ext>
             </a:extLst>
           </p:cNvPr>
@@ -11989,7 +12644,7 @@
           <p:nvPr/>
         </p:nvPicPr>
         <p:blipFill>
-          <a:blip xmlns:r="http://schemas.openxmlformats.org/officeDocument/2006/relationships" xmlns:a="http://schemas.openxmlformats.org/drawingml/2006/main" r:embed="Rf976ad09c42345e5"/>
+          <a:blip xmlns:r="http://schemas.openxmlformats.org/officeDocument/2006/relationships" xmlns:a="http://schemas.openxmlformats.org/drawingml/2006/main" r:embed="R8e8f5a2ce3b44bf3"/>
           <a:stretch xmlns:a="http://schemas.openxmlformats.org/drawingml/2006/main"/>
         </p:blipFill>
         <p:spPr>
@@ -12007,7 +12662,7 @@
           <p:cNvPr id="4" name="">
             <a:extLst xmlns:a="http://schemas.openxmlformats.org/drawingml/2006/main">
               <a:ext uri="{FF2B5EF4-FFF2-40B4-BE49-F238E27FC236}">
-                <a16:creationId xmlns:a16="http://schemas.microsoft.com/office/drawing/2014/main" id="{229ABFE0-A0C8-49ED-99B1-BD252FC6DAAE}"/>
+                <a16:creationId xmlns:a16="http://schemas.microsoft.com/office/drawing/2014/main" id="{A8992244-DA3A-4CF9-8EBD-BA2FDA08E421}"/>
               </a:ext>
             </a:extLst>
           </p:cNvPr>
@@ -12037,7 +12692,7 @@
           <p:cNvPr id="5" name="">
             <a:extLst xmlns:a="http://schemas.openxmlformats.org/drawingml/2006/main">
               <a:ext uri="{FF2B5EF4-FFF2-40B4-BE49-F238E27FC236}">
-                <a16:creationId xmlns:a16="http://schemas.microsoft.com/office/drawing/2014/main" id="{9CE3A00B-9BFB-46BA-8F40-36EA2F76030D}"/>
+                <a16:creationId xmlns:a16="http://schemas.microsoft.com/office/drawing/2014/main" id="{AD26CD87-9580-4ABB-AAB2-8688D99C3A45}"/>
               </a:ext>
             </a:extLst>
           </p:cNvPr>
@@ -12105,7 +12760,7 @@
           <p:cNvPr id="6" name="">
             <a:extLst xmlns:a="http://schemas.openxmlformats.org/drawingml/2006/main">
               <a:ext uri="{FF2B5EF4-FFF2-40B4-BE49-F238E27FC236}">
-                <a16:creationId xmlns:a16="http://schemas.microsoft.com/office/drawing/2014/main" id="{37B75E12-02D1-4A19-ABA2-7A225ACA85A0}"/>
+                <a16:creationId xmlns:a16="http://schemas.microsoft.com/office/drawing/2014/main" id="{5CAB2392-F8FE-46B6-BF4C-00BE773AC863}"/>
               </a:ext>
             </a:extLst>
           </p:cNvPr>
@@ -12171,7 +12826,7 @@
     </p:spTree>
     <p:extLst>
       <p:ext uri="{BB962C8B-B14F-4D97-AF65-F5344CB8AC3E}">
-        <p14:creationId xmlns:p14="http://schemas.microsoft.com/office/powerpoint/2010/main" val="533758187"/>
+        <p14:creationId xmlns:p14="http://schemas.microsoft.com/office/powerpoint/2010/main" val="1990357416"/>
       </p:ext>
     </p:extLst>
   </p:cSld>

</xml_diff>

<commit_message>
Condense presenter notes to a single keyword line
</commit_message>
<xml_diff>
--- a/downloads/highst-perioperative-webinar.pptx
+++ b/downloads/highst-perioperative-webinar.pptx
@@ -2,25 +2,25 @@
 <file path=ppt/presentation.xml><?xml version="1.0" encoding="utf-8"?>
 <p:presentation xmlns:p="http://schemas.openxmlformats.org/presentationml/2006/main">
   <p:sldMasterIdLst>
-    <p:sldMasterId xmlns:r="http://schemas.openxmlformats.org/officeDocument/2006/relationships" id="2147483648" r:id="Rf174e4b225cf4283"/>
+    <p:sldMasterId xmlns:r="http://schemas.openxmlformats.org/officeDocument/2006/relationships" id="2147483648" r:id="R77cca2339b0745d5"/>
   </p:sldMasterIdLst>
   <p:notesMasterIdLst>
-    <p:notesMasterId xmlns:r="http://schemas.openxmlformats.org/officeDocument/2006/relationships" r:id="R70bdac0a05a54c6c"/>
+    <p:notesMasterId xmlns:r="http://schemas.openxmlformats.org/officeDocument/2006/relationships" r:id="Rb73c3fa6615b4094"/>
   </p:notesMasterIdLst>
   <p:sldIdLst>
-    <p:sldId xmlns:r="http://schemas.openxmlformats.org/officeDocument/2006/relationships" id="256" r:id="Rbe58da2b5b2d4067"/>
-    <p:sldId xmlns:r="http://schemas.openxmlformats.org/officeDocument/2006/relationships" id="257" r:id="Rafd89f7b87474059"/>
-    <p:sldId xmlns:r="http://schemas.openxmlformats.org/officeDocument/2006/relationships" id="258" r:id="R195a4354cd494fa9"/>
-    <p:sldId xmlns:r="http://schemas.openxmlformats.org/officeDocument/2006/relationships" id="259" r:id="Rcf15e413812e4434"/>
-    <p:sldId xmlns:r="http://schemas.openxmlformats.org/officeDocument/2006/relationships" id="260" r:id="Rd7289ae521a54173"/>
-    <p:sldId xmlns:r="http://schemas.openxmlformats.org/officeDocument/2006/relationships" id="261" r:id="Rf1dc2c0a987d4bcc"/>
-    <p:sldId xmlns:r="http://schemas.openxmlformats.org/officeDocument/2006/relationships" id="262" r:id="Ra0b5ffc5ab06461e"/>
-    <p:sldId xmlns:r="http://schemas.openxmlformats.org/officeDocument/2006/relationships" id="263" r:id="Raf84e70c01f34baf"/>
-    <p:sldId xmlns:r="http://schemas.openxmlformats.org/officeDocument/2006/relationships" id="264" r:id="R18dfae837995417d"/>
-    <p:sldId xmlns:r="http://schemas.openxmlformats.org/officeDocument/2006/relationships" id="265" r:id="R34bd665d9de04d03"/>
-    <p:sldId xmlns:r="http://schemas.openxmlformats.org/officeDocument/2006/relationships" id="266" r:id="R73d659385c174b99"/>
-    <p:sldId xmlns:r="http://schemas.openxmlformats.org/officeDocument/2006/relationships" id="267" r:id="R978007f9dc064b17"/>
-    <p:sldId xmlns:r="http://schemas.openxmlformats.org/officeDocument/2006/relationships" id="268" r:id="R3c096cac75f140a3"/>
+    <p:sldId xmlns:r="http://schemas.openxmlformats.org/officeDocument/2006/relationships" id="256" r:id="Rc6675f97d6ab4d92"/>
+    <p:sldId xmlns:r="http://schemas.openxmlformats.org/officeDocument/2006/relationships" id="257" r:id="R6ca85a7fdef54dc8"/>
+    <p:sldId xmlns:r="http://schemas.openxmlformats.org/officeDocument/2006/relationships" id="258" r:id="Rc26acf5f1c564da5"/>
+    <p:sldId xmlns:r="http://schemas.openxmlformats.org/officeDocument/2006/relationships" id="259" r:id="R74405e35741c4b0e"/>
+    <p:sldId xmlns:r="http://schemas.openxmlformats.org/officeDocument/2006/relationships" id="260" r:id="R133da9dfdc8243e7"/>
+    <p:sldId xmlns:r="http://schemas.openxmlformats.org/officeDocument/2006/relationships" id="261" r:id="R0778751e8bcd40dd"/>
+    <p:sldId xmlns:r="http://schemas.openxmlformats.org/officeDocument/2006/relationships" id="262" r:id="R7f87b04a50f2468e"/>
+    <p:sldId xmlns:r="http://schemas.openxmlformats.org/officeDocument/2006/relationships" id="263" r:id="R7a568f22282544be"/>
+    <p:sldId xmlns:r="http://schemas.openxmlformats.org/officeDocument/2006/relationships" id="264" r:id="R1970b293a238427f"/>
+    <p:sldId xmlns:r="http://schemas.openxmlformats.org/officeDocument/2006/relationships" id="265" r:id="R0b4f76b2b5c74266"/>
+    <p:sldId xmlns:r="http://schemas.openxmlformats.org/officeDocument/2006/relationships" id="266" r:id="R6356119bf56a423e"/>
+    <p:sldId xmlns:r="http://schemas.openxmlformats.org/officeDocument/2006/relationships" id="267" r:id="Ra74d322a2cd8447e"/>
+    <p:sldId xmlns:r="http://schemas.openxmlformats.org/officeDocument/2006/relationships" id="268" r:id="R40ff92a41776400e"/>
   </p:sldIdLst>
   <p:sldSz cx="12192000" cy="6858000"/>
   <p:notesSz cx="6858000" cy="9144000"/>
@@ -454,52 +454,7 @@
           <a:lstStyle xmlns:a="http://schemas.openxmlformats.org/drawingml/2006/main"/>
           <a:p xmlns:a="http://schemas.openxmlformats.org/drawingml/2006/main">
             <a:r>
-              <a:t>English speaker cues</a:t>
-            </a:r>
-          </a:p>
-          <a:p xmlns:a="http://schemas.openxmlformats.org/drawingml/2006/main">
-            <a:r>
-              <a:t>1. Welcome: Thank you for joining us today.</a:t>
-            </a:r>
-          </a:p>
-          <a:p xmlns:a="http://schemas.openxmlformats.org/drawingml/2006/main">
-            <a:r>
-              <a:t>2. Introduction: Jinmo Koo / HIGHST Urology, Korea</a:t>
-            </a:r>
-          </a:p>
-          <a:p xmlns:a="http://schemas.openxmlformats.org/drawingml/2006/main">
-            <a:r>
-              <a:t>3. Topic: MegaDerm penile augmentation</a:t>
-            </a:r>
-          </a:p>
-          <a:p xmlns:a="http://schemas.openxmlformats.org/drawingml/2006/main">
-            <a:r>
-              <a:t>4. Today’s focus: Preoperative evaluation / surgical videos / complications / postoperative care</a:t>
-            </a:r>
-          </a:p>
-          <a:p xmlns:a="http://schemas.openxmlformats.org/drawingml/2006/main">
-            <a:r>
-              <a:t/>
-            </a:r>
-          </a:p>
-          <a:p xmlns:a="http://schemas.openxmlformats.org/drawingml/2006/main">
-            <a:r>
-              <a:t>Next: First, let me briefly introduce myself.</a:t>
-            </a:r>
-          </a:p>
-          <a:p xmlns:a="http://schemas.openxmlformats.org/drawingml/2006/main">
-            <a:r>
-              <a:t/>
-            </a:r>
-          </a:p>
-          <a:p xmlns:a="http://schemas.openxmlformats.org/drawingml/2006/main">
-            <a:r>
-              <a:t>Reference notes</a:t>
-            </a:r>
-          </a:p>
-          <a:p xmlns:a="http://schemas.openxmlformats.org/drawingml/2006/main">
-            <a:r>
-              <a:t>Jinmo Koo, HIGHST Urology. Vietnam MegaDerm Webinar, 21 October 2026. Portrait supplied by HIGHST. Brand reference: https://www.highsturology.co.kr/v2/proud/doctor.php</a:t>
+              <a:t>Welcome / Jinmo Koo / HIGHST / MegaDerm / Clinical cases</a:t>
             </a:r>
           </a:p>
         </p:txBody>
@@ -569,52 +524,7 @@
           <a:lstStyle xmlns:a="http://schemas.openxmlformats.org/drawingml/2006/main"/>
           <a:p xmlns:a="http://schemas.openxmlformats.org/drawingml/2006/main">
             <a:r>
-              <a:t>English speaker cues</a:t>
-            </a:r>
-          </a:p>
-          <a:p xmlns:a="http://schemas.openxmlformats.org/drawingml/2006/main">
-            <a:r>
-              <a:t>1. Case 5: Contour step-off correction</a:t>
-            </a:r>
-          </a:p>
-          <a:p xmlns:a="http://schemas.openxmlformats.org/drawingml/2006/main">
-            <a:r>
-              <a:t>2. Case introduction: Location of the contour concern</a:t>
-            </a:r>
-          </a:p>
-          <a:p xmlns:a="http://schemas.openxmlformats.org/drawingml/2006/main">
-            <a:r>
-              <a:t>3. Video walkthrough: Correction shown in the video</a:t>
-            </a:r>
-          </a:p>
-          <a:p xmlns:a="http://schemas.openxmlformats.org/drawingml/2006/main">
-            <a:r>
-              <a:t>4. Discussion: Main points from this case</a:t>
-            </a:r>
-          </a:p>
-          <a:p xmlns:a="http://schemas.openxmlformats.org/drawingml/2006/main">
-            <a:r>
-              <a:t/>
-            </a:r>
-          </a:p>
-          <a:p xmlns:a="http://schemas.openxmlformats.org/drawingml/2006/main">
-            <a:r>
-              <a:t>Next: After these cases, let’s review potential complications.</a:t>
-            </a:r>
-          </a:p>
-          <a:p xmlns:a="http://schemas.openxmlformats.org/drawingml/2006/main">
-            <a:r>
-              <a:t/>
-            </a:r>
-          </a:p>
-          <a:p xmlns:a="http://schemas.openxmlformats.org/drawingml/2006/main">
-            <a:r>
-              <a:t>Reference notes</a:t>
-            </a:r>
-          </a:p>
-          <a:p xmlns:a="http://schemas.openxmlformats.org/drawingml/2006/main">
-            <a:r>
-              <a:t>Case 5: Contour Step-off Correction.</a:t>
+              <a:t>Contour step-off / Location / Correction / Video / Key points</a:t>
             </a:r>
           </a:p>
         </p:txBody>
@@ -684,67 +594,7 @@
           <a:lstStyle xmlns:a="http://schemas.openxmlformats.org/drawingml/2006/main"/>
           <a:p xmlns:a="http://schemas.openxmlformats.org/drawingml/2006/main">
             <a:r>
-              <a:t>English speaker cues</a:t>
-            </a:r>
-          </a:p>
-          <a:p xmlns:a="http://schemas.openxmlformats.org/drawingml/2006/main">
-            <a:r>
-              <a:t>1. Context: Published ADM literature / not HIGHST- or MegaDerm-specific outcome data</a:t>
-            </a:r>
-          </a:p>
-          <a:p xmlns:a="http://schemas.openxmlformats.org/drawingml/2006/main">
-            <a:r>
-              <a:t>2. Bleeding and swelling: Hematoma / foreskin edema</a:t>
-            </a:r>
-          </a:p>
-          <a:p xmlns:a="http://schemas.openxmlformats.org/drawingml/2006/main">
-            <a:r>
-              <a:t>3. Wound complications: Delayed healing / infection / skin necrosis</a:t>
-            </a:r>
-          </a:p>
-          <a:p xmlns:a="http://schemas.openxmlformats.org/drawingml/2006/main">
-            <a:r>
-              <a:t>4. Contour and discomfort: Graft contour irregularity / discomfort during erection</a:t>
-            </a:r>
-          </a:p>
-          <a:p xmlns:a="http://schemas.openxmlformats.org/drawingml/2006/main">
-            <a:r>
-              <a:t/>
-            </a:r>
-          </a:p>
-          <a:p xmlns:a="http://schemas.openxmlformats.org/drawingml/2006/main">
-            <a:r>
-              <a:t>Next: Finally, I’ll discuss postoperative care and dressing.</a:t>
-            </a:r>
-          </a:p>
-          <a:p xmlns:a="http://schemas.openxmlformats.org/drawingml/2006/main">
-            <a:r>
-              <a:t/>
-            </a:r>
-          </a:p>
-          <a:p xmlns:a="http://schemas.openxmlformats.org/drawingml/2006/main">
-            <a:r>
-              <a:t>Reference notes</a:t>
-            </a:r>
-          </a:p>
-          <a:p xmlns:a="http://schemas.openxmlformats.org/drawingml/2006/main">
-            <a:r>
-              <a:t>These categories are reported in published ADM augmentation literature. They do not represent HIGHST or MegaDerm-specific outcome data. No incidence rates are extrapolated to HIGHST.</a:t>
-            </a:r>
-          </a:p>
-          <a:p xmlns:a="http://schemas.openxmlformats.org/drawingml/2006/main">
-            <a:r>
-              <a:t/>
-            </a:r>
-          </a:p>
-          <a:p xmlns:a="http://schemas.openxmlformats.org/drawingml/2006/main">
-            <a:r>
-              <a:t>Sources</a:t>
-            </a:r>
-          </a:p>
-          <a:p xmlns:a="http://schemas.openxmlformats.org/drawingml/2006/main">
-            <a:r>
-              <a:t>https://pubmed.ncbi.nlm.nih.gov/31420614/</a:t>
+              <a:t>Published ADM reports / Hematoma, edema / Wound / Contour, discomfort</a:t>
             </a:r>
           </a:p>
         </p:txBody>
@@ -814,47 +664,7 @@
           <a:lstStyle xmlns:a="http://schemas.openxmlformats.org/drawingml/2006/main"/>
           <a:p xmlns:a="http://schemas.openxmlformats.org/drawingml/2006/main">
             <a:r>
-              <a:t>English speaker cues</a:t>
-            </a:r>
-          </a:p>
-          <a:p xmlns:a="http://schemas.openxmlformats.org/drawingml/2006/main">
-            <a:r>
-              <a:t>1. Postoperative care: Main instructions to explain</a:t>
-            </a:r>
-          </a:p>
-          <a:p xmlns:a="http://schemas.openxmlformats.org/drawingml/2006/main">
-            <a:r>
-              <a:t>2. Dressing: Sequence shown in the video</a:t>
-            </a:r>
-          </a:p>
-          <a:p xmlns:a="http://schemas.openxmlformats.org/drawingml/2006/main">
-            <a:r>
-              <a:t>3. Follow-up: Points to discuss with the patient</a:t>
-            </a:r>
-          </a:p>
-          <a:p xmlns:a="http://schemas.openxmlformats.org/drawingml/2006/main">
-            <a:r>
-              <a:t/>
-            </a:r>
-          </a:p>
-          <a:p xmlns:a="http://schemas.openxmlformats.org/drawingml/2006/main">
-            <a:r>
-              <a:t>Next: Thank you for your attention. I’m happy to take your questions.</a:t>
-            </a:r>
-          </a:p>
-          <a:p xmlns:a="http://schemas.openxmlformats.org/drawingml/2006/main">
-            <a:r>
-              <a:t/>
-            </a:r>
-          </a:p>
-          <a:p xmlns:a="http://schemas.openxmlformats.org/drawingml/2006/main">
-            <a:r>
-              <a:t>Reference notes</a:t>
-            </a:r>
-          </a:p>
-          <a:p xmlns:a="http://schemas.openxmlformats.org/drawingml/2006/main">
-            <a:r>
-              <a:t>Postoperative care and dressing technique.</a:t>
+              <a:t>Care instructions / Dressing video / Follow-up / Questions</a:t>
             </a:r>
           </a:p>
         </p:txBody>
@@ -924,42 +734,7 @@
           <a:lstStyle xmlns:a="http://schemas.openxmlformats.org/drawingml/2006/main"/>
           <a:p xmlns:a="http://schemas.openxmlformats.org/drawingml/2006/main">
             <a:r>
-              <a:t>English speaker cues</a:t>
-            </a:r>
-          </a:p>
-          <a:p xmlns:a="http://schemas.openxmlformats.org/drawingml/2006/main">
-            <a:r>
-              <a:t>1. Thank you: Thank you for your time and attention.</a:t>
-            </a:r>
-          </a:p>
-          <a:p xmlns:a="http://schemas.openxmlformats.org/drawingml/2006/main">
-            <a:r>
-              <a:t>2. Questions: I’d be happy to discuss your questions.</a:t>
-            </a:r>
-          </a:p>
-          <a:p xmlns:a="http://schemas.openxmlformats.org/drawingml/2006/main">
-            <a:r>
-              <a:t>3. Clarify: Could you please repeat or clarify the question?</a:t>
-            </a:r>
-          </a:p>
-          <a:p xmlns:a="http://schemas.openxmlformats.org/drawingml/2006/main">
-            <a:r>
-              <a:t>4. Close: Thank you for the discussion.</a:t>
-            </a:r>
-          </a:p>
-          <a:p xmlns:a="http://schemas.openxmlformats.org/drawingml/2006/main">
-            <a:r>
-              <a:t/>
-            </a:r>
-          </a:p>
-          <a:p xmlns:a="http://schemas.openxmlformats.org/drawingml/2006/main">
-            <a:r>
-              <a:t>Reference notes</a:t>
-            </a:r>
-          </a:p>
-          <a:p xmlns:a="http://schemas.openxmlformats.org/drawingml/2006/main">
-            <a:r>
-              <a:t>Thank you.</a:t>
+              <a:t>Thank you / Questions / Clarify / Discussion / Closing</a:t>
             </a:r>
           </a:p>
         </p:txBody>
@@ -1029,202 +804,7 @@
           <a:lstStyle xmlns:a="http://schemas.openxmlformats.org/drawingml/2006/main"/>
           <a:p xmlns:a="http://schemas.openxmlformats.org/drawingml/2006/main">
             <a:r>
-              <a:t>English speaker cues</a:t>
-            </a:r>
-          </a:p>
-          <a:p xmlns:a="http://schemas.openxmlformats.org/drawingml/2006/main">
-            <a:r>
-              <a:t>1. Education: Korea University College of Medicine</a:t>
-            </a:r>
-          </a:p>
-          <a:p xmlns:a="http://schemas.openxmlformats.org/drawingml/2006/main">
-            <a:r>
-              <a:t>2. Current role: Chief Director, HIGHST Urology</a:t>
-            </a:r>
-          </a:p>
-          <a:p xmlns:a="http://schemas.openxmlformats.org/drawingml/2006/main">
-            <a:r>
-              <a:t>3. Clinical background: Former Chief Director, PROUD Urology / adjunct professor, Ewha Mokdong Hospital</a:t>
-            </a:r>
-          </a:p>
-          <a:p xmlns:a="http://schemas.openxmlformats.org/drawingml/2006/main">
-            <a:r>
-              <a:t>4. Training: Erectile dysfunction training at UCI / international training and designated physician roles</a:t>
-            </a:r>
-          </a:p>
-          <a:p xmlns:a="http://schemas.openxmlformats.org/drawingml/2006/main">
-            <a:r>
-              <a:t>5. Recognition: 2024 Outstanding Presentation Award, Taiwan Andrology Association</a:t>
-            </a:r>
-          </a:p>
-          <a:p xmlns:a="http://schemas.openxmlformats.org/drawingml/2006/main">
-            <a:r>
-              <a:t>6. Professional societies: Korean Urological Association / ISSM / APSSM</a:t>
-            </a:r>
-          </a:p>
-          <a:p xmlns:a="http://schemas.openxmlformats.org/drawingml/2006/main">
-            <a:r>
-              <a:t/>
-            </a:r>
-          </a:p>
-          <a:p xmlns:a="http://schemas.openxmlformats.org/drawingml/2006/main">
-            <a:r>
-              <a:t>Next: Let’s begin with the materials: MegaDerm and MegaFill.</a:t>
-            </a:r>
-          </a:p>
-          <a:p xmlns:a="http://schemas.openxmlformats.org/drawingml/2006/main">
-            <a:r>
-              <a:t/>
-            </a:r>
-          </a:p>
-          <a:p xmlns:a="http://schemas.openxmlformats.org/drawingml/2006/main">
-            <a:r>
-              <a:t>Reference notes</a:t>
-            </a:r>
-          </a:p>
-          <a:p xmlns:a="http://schemas.openxmlformats.org/drawingml/2006/main">
-            <a:r>
-              <a:t>Jinmo Koo, HIGHST Urology.</a:t>
-            </a:r>
-          </a:p>
-          <a:p xmlns:a="http://schemas.openxmlformats.org/drawingml/2006/main">
-            <a:r>
-              <a:t/>
-            </a:r>
-          </a:p>
-          <a:p xmlns:a="http://schemas.openxmlformats.org/drawingml/2006/main">
-            <a:r>
-              <a:t>Education</a:t>
-            </a:r>
-          </a:p>
-          <a:p xmlns:a="http://schemas.openxmlformats.org/drawingml/2006/main">
-            <a:r>
-              <a:t>Graduated from Korea University College of Medicine.</a:t>
-            </a:r>
-          </a:p>
-          <a:p xmlns:a="http://schemas.openxmlformats.org/drawingml/2006/main">
-            <a:r>
-              <a:t/>
-            </a:r>
-          </a:p>
-          <a:p xmlns:a="http://schemas.openxmlformats.org/drawingml/2006/main">
-            <a:r>
-              <a:t>Clinical and academic appointments</a:t>
-            </a:r>
-          </a:p>
-          <a:p xmlns:a="http://schemas.openxmlformats.org/drawingml/2006/main">
-            <a:r>
-              <a:t>Current Chief Director, HIGHST Urology.</a:t>
-            </a:r>
-          </a:p>
-          <a:p xmlns:a="http://schemas.openxmlformats.org/drawingml/2006/main">
-            <a:r>
-              <a:t>Former Chief Director, PROUD Urology.</a:t>
-            </a:r>
-          </a:p>
-          <a:p xmlns:a="http://schemas.openxmlformats.org/drawingml/2006/main">
-            <a:r>
-              <a:t>Adjunct Professor of Urology, Ewha Womans University Mokdong Hospital.</a:t>
-            </a:r>
-          </a:p>
-          <a:p xmlns:a="http://schemas.openxmlformats.org/drawingml/2006/main">
-            <a:r>
-              <a:t/>
-            </a:r>
-          </a:p>
-          <a:p xmlns:a="http://schemas.openxmlformats.org/drawingml/2006/main">
-            <a:r>
-              <a:t>Training, appointments and recognition</a:t>
-            </a:r>
-          </a:p>
-          <a:p xmlns:a="http://schemas.openxmlformats.org/drawingml/2006/main">
-            <a:r>
-              <a:t>Completed erectile dysfunction training at UCI, USA.</a:t>
-            </a:r>
-          </a:p>
-          <a:p xmlns:a="http://schemas.openxmlformats.org/drawingml/2006/main">
-            <a:r>
-              <a:t>Coloplast Reference Doctor.</a:t>
-            </a:r>
-          </a:p>
-          <a:p xmlns:a="http://schemas.openxmlformats.org/drawingml/2006/main">
-            <a:r>
-              <a:t>Designated physician, Boston Scientific Center of Education.</a:t>
-            </a:r>
-          </a:p>
-          <a:p xmlns:a="http://schemas.openxmlformats.org/drawingml/2006/main">
-            <a:r>
-              <a:t>Designated physician, Boston Scientific Center of Excellence.</a:t>
-            </a:r>
-          </a:p>
-          <a:p xmlns:a="http://schemas.openxmlformats.org/drawingml/2006/main">
-            <a:r>
-              <a:t>Rigicon Certificate of Recognition.</a:t>
-            </a:r>
-          </a:p>
-          <a:p xmlns:a="http://schemas.openxmlformats.org/drawingml/2006/main">
-            <a:r>
-              <a:t>Designated physician, Litemed Training Center.</a:t>
-            </a:r>
-          </a:p>
-          <a:p xmlns:a="http://schemas.openxmlformats.org/drawingml/2006/main">
-            <a:r>
-              <a:t>Designated physician, Hsing-Chi Training Center.</a:t>
-            </a:r>
-          </a:p>
-          <a:p xmlns:a="http://schemas.openxmlformats.org/drawingml/2006/main">
-            <a:r>
-              <a:t>Officially appointed consultant for international training, L&amp;C Bio.</a:t>
-            </a:r>
-          </a:p>
-          <a:p xmlns:a="http://schemas.openxmlformats.org/drawingml/2006/main">
-            <a:r>
-              <a:t>Outstanding Presentation Award, Taiwan Andrology Association (TAA), 2024.</a:t>
-            </a:r>
-          </a:p>
-          <a:p xmlns:a="http://schemas.openxmlformats.org/drawingml/2006/main">
-            <a:r>
-              <a:t/>
-            </a:r>
-          </a:p>
-          <a:p xmlns:a="http://schemas.openxmlformats.org/drawingml/2006/main">
-            <a:r>
-              <a:t>Full member of the Korean Urological Association, International Society for Sexual Medicine and Asia Pacific Society for Sexual Medicine.</a:t>
-            </a:r>
-          </a:p>
-          <a:p xmlns:a="http://schemas.openxmlformats.org/drawingml/2006/main">
-            <a:r>
-              <a:t>Portrait supplied by HIGHST.</a:t>
-            </a:r>
-          </a:p>
-          <a:p xmlns:a="http://schemas.openxmlformats.org/drawingml/2006/main">
-            <a:r>
-              <a:t/>
-            </a:r>
-          </a:p>
-          <a:p xmlns:a="http://schemas.openxmlformats.org/drawingml/2006/main">
-            <a:r>
-              <a:t>Sources</a:t>
-            </a:r>
-          </a:p>
-          <a:p xmlns:a="http://schemas.openxmlformats.org/drawingml/2006/main">
-            <a:r>
-              <a:t>https://www.highsturology.co.kr/v2/proud/doctor.php</a:t>
-            </a:r>
-          </a:p>
-          <a:p xmlns:a="http://schemas.openxmlformats.org/drawingml/2006/main">
-            <a:r>
-              <a:t>https://www.issm.info/public/about/vision-and-mission</a:t>
-            </a:r>
-          </a:p>
-          <a:p xmlns:a="http://schemas.openxmlformats.org/drawingml/2006/main">
-            <a:r>
-              <a:t>https://apssm.asia/</a:t>
-            </a:r>
-          </a:p>
-          <a:p xmlns:a="http://schemas.openxmlformats.org/drawingml/2006/main">
-            <a:r>
-              <a:t>https://uroweb.org/education-events/78th-annual-meeting-of-the-korean-urological-association-kua-2026</a:t>
+              <a:t>Korea University / HIGHST / Ewha Mokdong / Training / TAA award</a:t>
             </a:r>
           </a:p>
         </p:txBody>
@@ -1294,67 +874,7 @@
           <a:lstStyle xmlns:a="http://schemas.openxmlformats.org/drawingml/2006/main"/>
           <a:p xmlns:a="http://schemas.openxmlformats.org/drawingml/2006/main">
             <a:r>
-              <a:t>English speaker cues</a:t>
-            </a:r>
-          </a:p>
-          <a:p xmlns:a="http://schemas.openxmlformats.org/drawingml/2006/main">
-            <a:r>
-              <a:t>1. MegaDerm: Sheet acellular dermal matrix</a:t>
-            </a:r>
-          </a:p>
-          <a:p xmlns:a="http://schemas.openxmlformats.org/drawingml/2006/main">
-            <a:r>
-              <a:t>2. Two types: Hydrated / freeze-dried</a:t>
-            </a:r>
-          </a:p>
-          <a:p xmlns:a="http://schemas.openxmlformats.org/drawingml/2006/main">
-            <a:r>
-              <a:t>3. Our stock: 3–5 mm thick / 5 × 6, 5 × 8, 5 × 10, 6 × 12 cm</a:t>
-            </a:r>
-          </a:p>
-          <a:p xmlns:a="http://schemas.openxmlformats.org/drawingml/2006/main">
-            <a:r>
-              <a:t>4. MegaFill: Micronized acellular dermal matrix</a:t>
-            </a:r>
-          </a:p>
-          <a:p xmlns:a="http://schemas.openxmlformats.org/drawingml/2006/main">
-            <a:r>
-              <a:t/>
-            </a:r>
-          </a:p>
-          <a:p xmlns:a="http://schemas.openxmlformats.org/drawingml/2006/main">
-            <a:r>
-              <a:t>Next: Next, I’ll go through our preoperative evaluation.</a:t>
-            </a:r>
-          </a:p>
-          <a:p xmlns:a="http://schemas.openxmlformats.org/drawingml/2006/main">
-            <a:r>
-              <a:t/>
-            </a:r>
-          </a:p>
-          <a:p xmlns:a="http://schemas.openxmlformats.org/drawingml/2006/main">
-            <a:r>
-              <a:t>Reference notes</a:t>
-            </a:r>
-          </a:p>
-          <a:p xmlns:a="http://schemas.openxmlformats.org/drawingml/2006/main">
-            <a:r>
-              <a:t>MegaDerm is a sheet acellular dermal matrix. HIGHST stocks hydrated and freeze-dried types. The stated thickness and sizes describe HIGHST's inventory. MegaFill is a micronized form of acellular dermal matrix. The photograph is supplied by HIGHST. Individual packages are not assigned type labels.</a:t>
-            </a:r>
-          </a:p>
-          <a:p xmlns:a="http://schemas.openxmlformats.org/drawingml/2006/main">
-            <a:r>
-              <a:t/>
-            </a:r>
-          </a:p>
-          <a:p xmlns:a="http://schemas.openxmlformats.org/drawingml/2006/main">
-            <a:r>
-              <a:t>Sources</a:t>
-            </a:r>
-          </a:p>
-          <a:p xmlns:a="http://schemas.openxmlformats.org/drawingml/2006/main">
-            <a:r>
-              <a:t>https://lncbio.co.kr/theme/basic/images/L%26CBIO_catalog.pdf</a:t>
+              <a:t>MegaDerm sheet / Hydrated or dry / 3–5 mm / Sizes / MegaFill</a:t>
             </a:r>
           </a:p>
         </p:txBody>
@@ -1424,132 +944,7 @@
           <a:lstStyle xmlns:a="http://schemas.openxmlformats.org/drawingml/2006/main"/>
           <a:p xmlns:a="http://schemas.openxmlformats.org/drawingml/2006/main">
             <a:r>
-              <a:t>English speaker cues</a:t>
-            </a:r>
-          </a:p>
-          <a:p xmlns:a="http://schemas.openxmlformats.org/drawingml/2006/main">
-            <a:r>
-              <a:t>1. Questionnaires: IIEF: erectile function / PEDT: premature ejaculation</a:t>
-            </a:r>
-          </a:p>
-          <a:p xmlns:a="http://schemas.openxmlformats.org/drawingml/2006/main">
-            <a:r>
-              <a:t>2. Blood tests: Coagulation: PT/PTT / TTT: testosterone / CBC / PSA / blood glucose: BST/HbA1c</a:t>
-            </a:r>
-          </a:p>
-          <a:p xmlns:a="http://schemas.openxmlformats.org/drawingml/2006/main">
-            <a:r>
-              <a:t>3. Screening: HIV / syphilis / urine testing / liver enzymes: GOT/GPT/GGT / inflammatory markers</a:t>
-            </a:r>
-          </a:p>
-          <a:p xmlns:a="http://schemas.openxmlformats.org/drawingml/2006/main">
-            <a:r>
-              <a:t>4. Physical examination: Penile length: flaccid and stretched</a:t>
-            </a:r>
-          </a:p>
-          <a:p xmlns:a="http://schemas.openxmlformats.org/drawingml/2006/main">
-            <a:r>
-              <a:t>5. Sensitivity: Penile biothesiometry / vibration perception threshold</a:t>
-            </a:r>
-          </a:p>
-          <a:p xmlns:a="http://schemas.openxmlformats.org/drawingml/2006/main">
-            <a:r>
-              <a:t/>
-            </a:r>
-          </a:p>
-          <a:p xmlns:a="http://schemas.openxmlformats.org/drawingml/2006/main">
-            <a:r>
-              <a:t>Next: With the evaluation complete, let’s move on to surgical preparation.</a:t>
-            </a:r>
-          </a:p>
-          <a:p xmlns:a="http://schemas.openxmlformats.org/drawingml/2006/main">
-            <a:r>
-              <a:t/>
-            </a:r>
-          </a:p>
-          <a:p xmlns:a="http://schemas.openxmlformats.org/drawingml/2006/main">
-            <a:r>
-              <a:t>Reference notes</a:t>
-            </a:r>
-          </a:p>
-          <a:p xmlns:a="http://schemas.openxmlformats.org/drawingml/2006/main">
-            <a:r>
-              <a:t>Preoperative assessment at HIGHST includes IIEF and PEDT questionnaires, flaccid and stretched penile length measurement, and penile biothesiometry.</a:t>
-            </a:r>
-          </a:p>
-          <a:p xmlns:a="http://schemas.openxmlformats.org/drawingml/2006/main">
-            <a:r>
-              <a:t/>
-            </a:r>
-          </a:p>
-          <a:p xmlns:a="http://schemas.openxmlformats.org/drawingml/2006/main">
-            <a:r>
-              <a:t>Laboratory tests</a:t>
-            </a:r>
-          </a:p>
-          <a:p xmlns:a="http://schemas.openxmlformats.org/drawingml/2006/main">
-            <a:r>
-              <a:t>Blood coagulation tests (PT/PTT)</a:t>
-            </a:r>
-          </a:p>
-          <a:p xmlns:a="http://schemas.openxmlformats.org/drawingml/2006/main">
-            <a:r>
-              <a:t>TTT (testosterone)</a:t>
-            </a:r>
-          </a:p>
-          <a:p xmlns:a="http://schemas.openxmlformats.org/drawingml/2006/main">
-            <a:r>
-              <a:t>Complete blood count (CBC)</a:t>
-            </a:r>
-          </a:p>
-          <a:p xmlns:a="http://schemas.openxmlformats.org/drawingml/2006/main">
-            <a:r>
-              <a:t>Prostate-specific antigen (PSA)</a:t>
-            </a:r>
-          </a:p>
-          <a:p xmlns:a="http://schemas.openxmlformats.org/drawingml/2006/main">
-            <a:r>
-              <a:t>Blood glucose (BST/HbA1c)</a:t>
-            </a:r>
-          </a:p>
-          <a:p xmlns:a="http://schemas.openxmlformats.org/drawingml/2006/main">
-            <a:r>
-              <a:t>HIV testing</a:t>
-            </a:r>
-          </a:p>
-          <a:p xmlns:a="http://schemas.openxmlformats.org/drawingml/2006/main">
-            <a:r>
-              <a:t>Syphilis testing</a:t>
-            </a:r>
-          </a:p>
-          <a:p xmlns:a="http://schemas.openxmlformats.org/drawingml/2006/main">
-            <a:r>
-              <a:t>Urine testing</a:t>
-            </a:r>
-          </a:p>
-          <a:p xmlns:a="http://schemas.openxmlformats.org/drawingml/2006/main">
-            <a:r>
-              <a:t>Liver enzymes (GOT/GPT/GGT)</a:t>
-            </a:r>
-          </a:p>
-          <a:p xmlns:a="http://schemas.openxmlformats.org/drawingml/2006/main">
-            <a:r>
-              <a:t>Inflammatory markers</a:t>
-            </a:r>
-          </a:p>
-          <a:p xmlns:a="http://schemas.openxmlformats.org/drawingml/2006/main">
-            <a:r>
-              <a:t/>
-            </a:r>
-          </a:p>
-          <a:p xmlns:a="http://schemas.openxmlformats.org/drawingml/2006/main">
-            <a:r>
-              <a:t>HbA1c denotes glycated hemoglobin and appears under the blood glucose heading.</a:t>
-            </a:r>
-          </a:p>
-          <a:p xmlns:a="http://schemas.openxmlformats.org/drawingml/2006/main">
-            <a:r>
-              <a:t>Sources: https://pubmed.ncbi.nlm.nih.gov/9187685/ ; https://pubmed.ncbi.nlm.nih.gov/17568761/ ; https://www.niddk.nih.gov/health-information/diagnostic-tests/a1c-test/ ; https://pubmed.ncbi.nlm.nih.gov/28874780/</a:t>
+              <a:t>IIEF/PEDT / PT/PTT, TTT, CBC, PSA / BST/HbA1c / HIV, syphilis / Urine, liver / Length, sensitivity</a:t>
             </a:r>
           </a:p>
         </p:txBody>
@@ -1619,47 +1014,7 @@
           <a:lstStyle xmlns:a="http://schemas.openxmlformats.org/drawingml/2006/main"/>
           <a:p xmlns:a="http://schemas.openxmlformats.org/drawingml/2006/main">
             <a:r>
-              <a:t>English speaker cues</a:t>
-            </a:r>
-          </a:p>
-          <a:p xmlns:a="http://schemas.openxmlformats.org/drawingml/2006/main">
-            <a:r>
-              <a:t>1. Preparation: Shaving and draping</a:t>
-            </a:r>
-          </a:p>
-          <a:p xmlns:a="http://schemas.openxmlformats.org/drawingml/2006/main">
-            <a:r>
-              <a:t>2. Shaving: Preparation area shown in the video</a:t>
-            </a:r>
-          </a:p>
-          <a:p xmlns:a="http://schemas.openxmlformats.org/drawingml/2006/main">
-            <a:r>
-              <a:t>3. Draping: Sequence shown in the video</a:t>
-            </a:r>
-          </a:p>
-          <a:p xmlns:a="http://schemas.openxmlformats.org/drawingml/2006/main">
-            <a:r>
-              <a:t/>
-            </a:r>
-          </a:p>
-          <a:p xmlns:a="http://schemas.openxmlformats.org/drawingml/2006/main">
-            <a:r>
-              <a:t>Next: Now, let’s look at the first case: a pubic incision.</a:t>
-            </a:r>
-          </a:p>
-          <a:p xmlns:a="http://schemas.openxmlformats.org/drawingml/2006/main">
-            <a:r>
-              <a:t/>
-            </a:r>
-          </a:p>
-          <a:p xmlns:a="http://schemas.openxmlformats.org/drawingml/2006/main">
-            <a:r>
-              <a:t>Reference notes</a:t>
-            </a:r>
-          </a:p>
-          <a:p xmlns:a="http://schemas.openxmlformats.org/drawingml/2006/main">
-            <a:r>
-              <a:t>Shaving and draping.</a:t>
+              <a:t>Shaving / Draping / First case</a:t>
             </a:r>
           </a:p>
         </p:txBody>
@@ -1729,52 +1084,7 @@
           <a:lstStyle xmlns:a="http://schemas.openxmlformats.org/drawingml/2006/main"/>
           <a:p xmlns:a="http://schemas.openxmlformats.org/drawingml/2006/main">
             <a:r>
-              <a:t>English speaker cues</a:t>
-            </a:r>
-          </a:p>
-          <a:p xmlns:a="http://schemas.openxmlformats.org/drawingml/2006/main">
-            <a:r>
-              <a:t>1. Case 1: Pubic incision</a:t>
-            </a:r>
-          </a:p>
-          <a:p xmlns:a="http://schemas.openxmlformats.org/drawingml/2006/main">
-            <a:r>
-              <a:t>2. Case introduction: Clinical background / choice of incision</a:t>
-            </a:r>
-          </a:p>
-          <a:p xmlns:a="http://schemas.openxmlformats.org/drawingml/2006/main">
-            <a:r>
-              <a:t>3. Video walkthrough: Incision / key operative stages</a:t>
-            </a:r>
-          </a:p>
-          <a:p xmlns:a="http://schemas.openxmlformats.org/drawingml/2006/main">
-            <a:r>
-              <a:t>4. Discussion: Main points from this case</a:t>
-            </a:r>
-          </a:p>
-          <a:p xmlns:a="http://schemas.openxmlformats.org/drawingml/2006/main">
-            <a:r>
-              <a:t/>
-            </a:r>
-          </a:p>
-          <a:p xmlns:a="http://schemas.openxmlformats.org/drawingml/2006/main">
-            <a:r>
-              <a:t>Next: The next case uses a circumcision-line incision.</a:t>
-            </a:r>
-          </a:p>
-          <a:p xmlns:a="http://schemas.openxmlformats.org/drawingml/2006/main">
-            <a:r>
-              <a:t/>
-            </a:r>
-          </a:p>
-          <a:p xmlns:a="http://schemas.openxmlformats.org/drawingml/2006/main">
-            <a:r>
-              <a:t>Reference notes</a:t>
-            </a:r>
-          </a:p>
-          <a:p xmlns:a="http://schemas.openxmlformats.org/drawingml/2006/main">
-            <a:r>
-              <a:t>Case 1: Pubic Incision.</a:t>
+              <a:t>Pubic incision / Background / Incision choice / Video / Key points</a:t>
             </a:r>
           </a:p>
         </p:txBody>
@@ -1844,52 +1154,7 @@
           <a:lstStyle xmlns:a="http://schemas.openxmlformats.org/drawingml/2006/main"/>
           <a:p xmlns:a="http://schemas.openxmlformats.org/drawingml/2006/main">
             <a:r>
-              <a:t>English speaker cues</a:t>
-            </a:r>
-          </a:p>
-          <a:p xmlns:a="http://schemas.openxmlformats.org/drawingml/2006/main">
-            <a:r>
-              <a:t>1. Case 2: Circumcision-line incision</a:t>
-            </a:r>
-          </a:p>
-          <a:p xmlns:a="http://schemas.openxmlformats.org/drawingml/2006/main">
-            <a:r>
-              <a:t>2. Case introduction: Clinical background / choice of incision</a:t>
-            </a:r>
-          </a:p>
-          <a:p xmlns:a="http://schemas.openxmlformats.org/drawingml/2006/main">
-            <a:r>
-              <a:t>3. Video walkthrough: Incision / key operative stages</a:t>
-            </a:r>
-          </a:p>
-          <a:p xmlns:a="http://schemas.openxmlformats.org/drawingml/2006/main">
-            <a:r>
-              <a:t>4. Comparison: Points to compare with the pubic approach</a:t>
-            </a:r>
-          </a:p>
-          <a:p xmlns:a="http://schemas.openxmlformats.org/drawingml/2006/main">
-            <a:r>
-              <a:t/>
-            </a:r>
-          </a:p>
-          <a:p xmlns:a="http://schemas.openxmlformats.org/drawingml/2006/main">
-            <a:r>
-              <a:t>Next: Next, we’ll look at secondary dermal grafting.</a:t>
-            </a:r>
-          </a:p>
-          <a:p xmlns:a="http://schemas.openxmlformats.org/drawingml/2006/main">
-            <a:r>
-              <a:t/>
-            </a:r>
-          </a:p>
-          <a:p xmlns:a="http://schemas.openxmlformats.org/drawingml/2006/main">
-            <a:r>
-              <a:t>Reference notes</a:t>
-            </a:r>
-          </a:p>
-          <a:p xmlns:a="http://schemas.openxmlformats.org/drawingml/2006/main">
-            <a:r>
-              <a:t>Case 2: Circumcision-line Incision.</a:t>
+              <a:t>Circumcision line / Background / Video / Compare approaches</a:t>
             </a:r>
           </a:p>
         </p:txBody>
@@ -1959,52 +1224,7 @@
           <a:lstStyle xmlns:a="http://schemas.openxmlformats.org/drawingml/2006/main"/>
           <a:p xmlns:a="http://schemas.openxmlformats.org/drawingml/2006/main">
             <a:r>
-              <a:t>English speaker cues</a:t>
-            </a:r>
-          </a:p>
-          <a:p xmlns:a="http://schemas.openxmlformats.org/drawingml/2006/main">
-            <a:r>
-              <a:t>1. Case 3: Secondary dermal grafting</a:t>
-            </a:r>
-          </a:p>
-          <a:p xmlns:a="http://schemas.openxmlformats.org/drawingml/2006/main">
-            <a:r>
-              <a:t>2. Background: Previous procedure / reason for a second graft</a:t>
-            </a:r>
-          </a:p>
-          <a:p xmlns:a="http://schemas.openxmlformats.org/drawingml/2006/main">
-            <a:r>
-              <a:t>3. Video walkthrough: Key operative stages</a:t>
-            </a:r>
-          </a:p>
-          <a:p xmlns:a="http://schemas.openxmlformats.org/drawingml/2006/main">
-            <a:r>
-              <a:t>4. Discussion: Main considerations in this case</a:t>
-            </a:r>
-          </a:p>
-          <a:p xmlns:a="http://schemas.openxmlformats.org/drawingml/2006/main">
-            <a:r>
-              <a:t/>
-            </a:r>
-          </a:p>
-          <a:p xmlns:a="http://schemas.openxmlformats.org/drawingml/2006/main">
-            <a:r>
-              <a:t>Next: Let’s move on to the revision surgery case.</a:t>
-            </a:r>
-          </a:p>
-          <a:p xmlns:a="http://schemas.openxmlformats.org/drawingml/2006/main">
-            <a:r>
-              <a:t/>
-            </a:r>
-          </a:p>
-          <a:p xmlns:a="http://schemas.openxmlformats.org/drawingml/2006/main">
-            <a:r>
-              <a:t>Reference notes</a:t>
-            </a:r>
-          </a:p>
-          <a:p xmlns:a="http://schemas.openxmlformats.org/drawingml/2006/main">
-            <a:r>
-              <a:t>Case 3: Secondary Dermal Grafting.</a:t>
+              <a:t>Previous procedure / Reason for second graft / Video / Key points</a:t>
             </a:r>
           </a:p>
         </p:txBody>
@@ -2074,52 +1294,7 @@
           <a:lstStyle xmlns:a="http://schemas.openxmlformats.org/drawingml/2006/main"/>
           <a:p xmlns:a="http://schemas.openxmlformats.org/drawingml/2006/main">
             <a:r>
-              <a:t>English speaker cues</a:t>
-            </a:r>
-          </a:p>
-          <a:p xmlns:a="http://schemas.openxmlformats.org/drawingml/2006/main">
-            <a:r>
-              <a:t>1. Case 4: Revision surgery</a:t>
-            </a:r>
-          </a:p>
-          <a:p xmlns:a="http://schemas.openxmlformats.org/drawingml/2006/main">
-            <a:r>
-              <a:t>2. Background: Previous procedure / reason for revision</a:t>
-            </a:r>
-          </a:p>
-          <a:p xmlns:a="http://schemas.openxmlformats.org/drawingml/2006/main">
-            <a:r>
-              <a:t>3. Video walkthrough: Operative findings / key stages</a:t>
-            </a:r>
-          </a:p>
-          <a:p xmlns:a="http://schemas.openxmlformats.org/drawingml/2006/main">
-            <a:r>
-              <a:t>4. Discussion: Points to highlight in revision surgery</a:t>
-            </a:r>
-          </a:p>
-          <a:p xmlns:a="http://schemas.openxmlformats.org/drawingml/2006/main">
-            <a:r>
-              <a:t/>
-            </a:r>
-          </a:p>
-          <a:p xmlns:a="http://schemas.openxmlformats.org/drawingml/2006/main">
-            <a:r>
-              <a:t>Next: The final case focuses on contour step-off correction.</a:t>
-            </a:r>
-          </a:p>
-          <a:p xmlns:a="http://schemas.openxmlformats.org/drawingml/2006/main">
-            <a:r>
-              <a:t/>
-            </a:r>
-          </a:p>
-          <a:p xmlns:a="http://schemas.openxmlformats.org/drawingml/2006/main">
-            <a:r>
-              <a:t>Reference notes</a:t>
-            </a:r>
-          </a:p>
-          <a:p xmlns:a="http://schemas.openxmlformats.org/drawingml/2006/main">
-            <a:r>
-              <a:t>Case 4: Revision Surgery.</a:t>
+              <a:t>Previous surgery / Reason for revision / Findings / Video</a:t>
             </a:r>
           </a:p>
         </p:txBody>
@@ -2166,7 +1341,7 @@
           <p:cNvPr id="3" name="Title">
             <a:extLst xmlns:a="http://schemas.openxmlformats.org/drawingml/2006/main">
               <a:ext uri="{FF2B5EF4-FFF2-40B4-BE49-F238E27FC236}">
-                <a16:creationId xmlns:a16="http://schemas.microsoft.com/office/drawing/2014/main" id="{27C6096E-E675-4380-B15A-048DD894C14E}"/>
+                <a16:creationId xmlns:a16="http://schemas.microsoft.com/office/drawing/2014/main" id="{DDE9E892-EF78-4E24-A30F-5E61FEB5DA44}"/>
               </a:ext>
             </a:extLst>
           </p:cNvPr>
@@ -2323,7 +1498,7 @@
           <p:cNvPr id="2" name="Subtitle">
             <a:extLst xmlns:a="http://schemas.openxmlformats.org/drawingml/2006/main">
               <a:ext uri="{FF2B5EF4-FFF2-40B4-BE49-F238E27FC236}">
-                <a16:creationId xmlns:a16="http://schemas.microsoft.com/office/drawing/2014/main" id="{17D2D398-B998-4049-B67B-A1C56877972D}"/>
+                <a16:creationId xmlns:a16="http://schemas.microsoft.com/office/drawing/2014/main" id="{1D5B5325-8445-470E-9E66-9642E15EBE91}"/>
               </a:ext>
             </a:extLst>
           </p:cNvPr>
@@ -2497,7 +1672,7 @@
           <p:cNvPr id="2" name="Section title">
             <a:extLst xmlns:a="http://schemas.openxmlformats.org/drawingml/2006/main">
               <a:ext uri="{FF2B5EF4-FFF2-40B4-BE49-F238E27FC236}">
-                <a16:creationId xmlns:a16="http://schemas.microsoft.com/office/drawing/2014/main" id="{994B1434-F3C9-4B68-BFB4-FD8F4C17A42E}"/>
+                <a16:creationId xmlns:a16="http://schemas.microsoft.com/office/drawing/2014/main" id="{7B862DED-DA8D-43D6-8F51-4E770C35726A}"/>
               </a:ext>
             </a:extLst>
           </p:cNvPr>
@@ -2671,7 +1846,7 @@
           <p:cNvPr id="3" name="Title">
             <a:extLst xmlns:a="http://schemas.openxmlformats.org/drawingml/2006/main">
               <a:ext uri="{FF2B5EF4-FFF2-40B4-BE49-F238E27FC236}">
-                <a16:creationId xmlns:a16="http://schemas.microsoft.com/office/drawing/2014/main" id="{260B1DB4-5880-4901-AEB5-A0D182AE3E4B}"/>
+                <a16:creationId xmlns:a16="http://schemas.microsoft.com/office/drawing/2014/main" id="{3E700B97-132B-444E-8C2F-9D6926BAAB61}"/>
               </a:ext>
             </a:extLst>
           </p:cNvPr>
@@ -2828,7 +2003,7 @@
           <p:cNvPr id="2" name="Body">
             <a:extLst xmlns:a="http://schemas.openxmlformats.org/drawingml/2006/main">
               <a:ext uri="{FF2B5EF4-FFF2-40B4-BE49-F238E27FC236}">
-                <a16:creationId xmlns:a16="http://schemas.microsoft.com/office/drawing/2014/main" id="{A700FADC-1DA2-4DC4-A14A-D41D2ECAAA08}"/>
+                <a16:creationId xmlns:a16="http://schemas.microsoft.com/office/drawing/2014/main" id="{65B83C84-1341-4E1C-882D-2B52067017BF}"/>
               </a:ext>
             </a:extLst>
           </p:cNvPr>
@@ -3002,7 +2177,7 @@
           <p:cNvPr id="4" name="Title">
             <a:extLst xmlns:a="http://schemas.openxmlformats.org/drawingml/2006/main">
               <a:ext uri="{FF2B5EF4-FFF2-40B4-BE49-F238E27FC236}">
-                <a16:creationId xmlns:a16="http://schemas.microsoft.com/office/drawing/2014/main" id="{1D072A85-2F9A-46FB-8E94-C805E047E7FA}"/>
+                <a16:creationId xmlns:a16="http://schemas.microsoft.com/office/drawing/2014/main" id="{B7F1E8E9-CC67-4828-B875-2C7BB7A5FD4E}"/>
               </a:ext>
             </a:extLst>
           </p:cNvPr>
@@ -3159,7 +2334,7 @@
           <p:cNvPr id="2" name="Left column">
             <a:extLst xmlns:a="http://schemas.openxmlformats.org/drawingml/2006/main">
               <a:ext uri="{FF2B5EF4-FFF2-40B4-BE49-F238E27FC236}">
-                <a16:creationId xmlns:a16="http://schemas.microsoft.com/office/drawing/2014/main" id="{86B9D404-A29F-4355-935F-DAD68C0FF903}"/>
+                <a16:creationId xmlns:a16="http://schemas.microsoft.com/office/drawing/2014/main" id="{0C2F0D8A-F036-412B-86AB-65CE72D965CD}"/>
               </a:ext>
             </a:extLst>
           </p:cNvPr>
@@ -3316,7 +2491,7 @@
           <p:cNvPr id="3" name="Right column">
             <a:extLst xmlns:a="http://schemas.openxmlformats.org/drawingml/2006/main">
               <a:ext uri="{FF2B5EF4-FFF2-40B4-BE49-F238E27FC236}">
-                <a16:creationId xmlns:a16="http://schemas.microsoft.com/office/drawing/2014/main" id="{416575E4-2548-43E1-BC38-C5B844EEA2A7}"/>
+                <a16:creationId xmlns:a16="http://schemas.microsoft.com/office/drawing/2014/main" id="{4F3E2F59-4D85-4BF1-8AA5-02FF893C98BA}"/>
               </a:ext>
             </a:extLst>
           </p:cNvPr>
@@ -3490,7 +2665,7 @@
           <p:cNvPr id="3" name="Title">
             <a:extLst xmlns:a="http://schemas.openxmlformats.org/drawingml/2006/main">
               <a:ext uri="{FF2B5EF4-FFF2-40B4-BE49-F238E27FC236}">
-                <a16:creationId xmlns:a16="http://schemas.microsoft.com/office/drawing/2014/main" id="{DC5FC2AC-46E1-47D9-BBB5-4D0FB235D22C}"/>
+                <a16:creationId xmlns:a16="http://schemas.microsoft.com/office/drawing/2014/main" id="{44610F45-6699-4CAF-AFB4-73CB103DA9C8}"/>
               </a:ext>
             </a:extLst>
           </p:cNvPr>
@@ -3647,7 +2822,7 @@
           <p:cNvPr id="2" name="Left column">
             <a:extLst xmlns:a="http://schemas.openxmlformats.org/drawingml/2006/main">
               <a:ext uri="{FF2B5EF4-FFF2-40B4-BE49-F238E27FC236}">
-                <a16:creationId xmlns:a16="http://schemas.microsoft.com/office/drawing/2014/main" id="{F6D3A1C0-EA1A-4D31-8D61-D46F6D32F187}"/>
+                <a16:creationId xmlns:a16="http://schemas.microsoft.com/office/drawing/2014/main" id="{FE675CDB-0795-49A7-8A09-1E68A44355A8}"/>
               </a:ext>
             </a:extLst>
           </p:cNvPr>
@@ -3842,12 +3017,12 @@
   </p:cSld>
   <p:clrMap bg1="lt1" tx1="dk1" bg2="lt2" tx2="dk2" accent1="accent1" accent2="accent2" accent3="accent3" accent4="accent4" accent5="accent5" accent6="accent6" hlink="hlink" folHlink="folHlink"/>
   <p:sldLayoutIdLst>
-    <p:sldLayoutId xmlns:r="http://schemas.openxmlformats.org/officeDocument/2006/relationships" id="2147483649" r:id="Rd19d98a4e9574cd8"/>
-    <p:sldLayoutId xmlns:r="http://schemas.openxmlformats.org/officeDocument/2006/relationships" id="2147483650" r:id="Rd89c8810b2a84e08"/>
-    <p:sldLayoutId xmlns:r="http://schemas.openxmlformats.org/officeDocument/2006/relationships" id="2147483651" r:id="Re3a7eb4a41ae4188"/>
-    <p:sldLayoutId xmlns:r="http://schemas.openxmlformats.org/officeDocument/2006/relationships" id="2147483652" r:id="R6d7986affa2b4985"/>
-    <p:sldLayoutId xmlns:r="http://schemas.openxmlformats.org/officeDocument/2006/relationships" id="2147483653" r:id="Rcbab3b194cf04a45"/>
-    <p:sldLayoutId xmlns:r="http://schemas.openxmlformats.org/officeDocument/2006/relationships" id="2147483654" r:id="R1bb94d15d9b047cd"/>
+    <p:sldLayoutId xmlns:r="http://schemas.openxmlformats.org/officeDocument/2006/relationships" id="2147483649" r:id="R79ae4f223bc04e31"/>
+    <p:sldLayoutId xmlns:r="http://schemas.openxmlformats.org/officeDocument/2006/relationships" id="2147483650" r:id="Reca0c13d1b5b47f3"/>
+    <p:sldLayoutId xmlns:r="http://schemas.openxmlformats.org/officeDocument/2006/relationships" id="2147483651" r:id="R0569b75d796f4fb5"/>
+    <p:sldLayoutId xmlns:r="http://schemas.openxmlformats.org/officeDocument/2006/relationships" id="2147483652" r:id="Rd9c288ec90d043e0"/>
+    <p:sldLayoutId xmlns:r="http://schemas.openxmlformats.org/officeDocument/2006/relationships" id="2147483653" r:id="Rab9d62db7eb341b5"/>
+    <p:sldLayoutId xmlns:r="http://schemas.openxmlformats.org/officeDocument/2006/relationships" id="2147483654" r:id="Ra53d9d37a23e4e7c"/>
   </p:sldLayoutIdLst>
   <p:txStyles>
     <p:titleStyle>
@@ -4398,7 +3573,7 @@
           <p:cNvPr id="10" name="">
             <a:extLst xmlns:a="http://schemas.openxmlformats.org/drawingml/2006/main">
               <a:ext uri="{FF2B5EF4-FFF2-40B4-BE49-F238E27FC236}">
-                <a16:creationId xmlns:a16="http://schemas.microsoft.com/office/drawing/2014/main" id="{9E47E1F0-1CD4-4D5D-9CBC-BB90E5818A61}"/>
+                <a16:creationId xmlns:a16="http://schemas.microsoft.com/office/drawing/2014/main" id="{5805C272-F2EF-40A1-A40C-4A368CD89356}"/>
               </a:ext>
             </a:extLst>
           </p:cNvPr>
@@ -4408,7 +3583,7 @@
           <p:nvPr/>
         </p:nvPicPr>
         <p:blipFill>
-          <a:blip xmlns:r="http://schemas.openxmlformats.org/officeDocument/2006/relationships" xmlns:a="http://schemas.openxmlformats.org/drawingml/2006/main" r:embed="Rcb30f71bcb7d405e"/>
+          <a:blip xmlns:r="http://schemas.openxmlformats.org/officeDocument/2006/relationships" xmlns:a="http://schemas.openxmlformats.org/drawingml/2006/main" r:embed="R47781616cb744a36"/>
           <a:stretch xmlns:a="http://schemas.openxmlformats.org/drawingml/2006/main"/>
         </p:blipFill>
         <p:spPr>
@@ -4426,7 +3601,7 @@
           <p:cNvPr id="2" name="">
             <a:extLst xmlns:a="http://schemas.openxmlformats.org/drawingml/2006/main">
               <a:ext uri="{FF2B5EF4-FFF2-40B4-BE49-F238E27FC236}">
-                <a16:creationId xmlns:a16="http://schemas.microsoft.com/office/drawing/2014/main" id="{11EB56E4-2F35-441F-A096-F3F3F30F9F36}"/>
+                <a16:creationId xmlns:a16="http://schemas.microsoft.com/office/drawing/2014/main" id="{7B533956-48E5-46DF-83C1-BF88F05D99E3}"/>
               </a:ext>
             </a:extLst>
           </p:cNvPr>
@@ -4436,7 +3611,7 @@
           <p:nvPr/>
         </p:nvPicPr>
         <p:blipFill>
-          <a:blip xmlns:r="http://schemas.openxmlformats.org/officeDocument/2006/relationships" xmlns:a="http://schemas.openxmlformats.org/drawingml/2006/main" r:embed="Rc6123dde08094660"/>
+          <a:blip xmlns:r="http://schemas.openxmlformats.org/officeDocument/2006/relationships" xmlns:a="http://schemas.openxmlformats.org/drawingml/2006/main" r:embed="Re82db9e8d7ed4b2d"/>
           <a:srcRect xmlns:a="http://schemas.openxmlformats.org/drawingml/2006/main" l="33753" t="0" r="33753" b="0"/>
           <a:stretch xmlns:a="http://schemas.openxmlformats.org/drawingml/2006/main">
             <a:fillRect l="0" t="0" r="0" b="0"/>
@@ -4457,7 +3632,7 @@
           <p:cNvPr id="3" name="">
             <a:extLst xmlns:a="http://schemas.openxmlformats.org/drawingml/2006/main">
               <a:ext uri="{FF2B5EF4-FFF2-40B4-BE49-F238E27FC236}">
-                <a16:creationId xmlns:a16="http://schemas.microsoft.com/office/drawing/2014/main" id="{8EE0AC53-D362-4FEC-A254-0DB0D6897805}"/>
+                <a16:creationId xmlns:a16="http://schemas.microsoft.com/office/drawing/2014/main" id="{4915C424-B320-4323-AB3E-686C20D926E0}"/>
               </a:ext>
             </a:extLst>
           </p:cNvPr>
@@ -4525,7 +3700,7 @@
           <p:cNvPr id="4" name="">
             <a:extLst xmlns:a="http://schemas.openxmlformats.org/drawingml/2006/main">
               <a:ext uri="{FF2B5EF4-FFF2-40B4-BE49-F238E27FC236}">
-                <a16:creationId xmlns:a16="http://schemas.microsoft.com/office/drawing/2014/main" id="{28EBEFA5-8A15-4B5C-9D6B-9D9213F9C948}"/>
+                <a16:creationId xmlns:a16="http://schemas.microsoft.com/office/drawing/2014/main" id="{043AC662-D6C9-426D-A7F2-75165A88969B}"/>
               </a:ext>
             </a:extLst>
           </p:cNvPr>
@@ -4593,7 +3768,7 @@
           <p:cNvPr id="5" name="">
             <a:extLst xmlns:a="http://schemas.openxmlformats.org/drawingml/2006/main">
               <a:ext uri="{FF2B5EF4-FFF2-40B4-BE49-F238E27FC236}">
-                <a16:creationId xmlns:a16="http://schemas.microsoft.com/office/drawing/2014/main" id="{7D3D55EA-F3A9-4D9A-880C-F4102DBD5DC7}"/>
+                <a16:creationId xmlns:a16="http://schemas.microsoft.com/office/drawing/2014/main" id="{5F37809F-8F94-4618-B927-73603A277313}"/>
               </a:ext>
             </a:extLst>
           </p:cNvPr>
@@ -4661,7 +3836,7 @@
           <p:cNvPr id="6" name="">
             <a:extLst xmlns:a="http://schemas.openxmlformats.org/drawingml/2006/main">
               <a:ext uri="{FF2B5EF4-FFF2-40B4-BE49-F238E27FC236}">
-                <a16:creationId xmlns:a16="http://schemas.microsoft.com/office/drawing/2014/main" id="{7B44CA6E-364A-4D94-8D09-04E7E04520A1}"/>
+                <a16:creationId xmlns:a16="http://schemas.microsoft.com/office/drawing/2014/main" id="{72ADAA83-6BE3-4991-B3B6-A608878DA868}"/>
               </a:ext>
             </a:extLst>
           </p:cNvPr>
@@ -4729,7 +3904,7 @@
           <p:cNvPr id="7" name="">
             <a:extLst xmlns:a="http://schemas.openxmlformats.org/drawingml/2006/main">
               <a:ext uri="{FF2B5EF4-FFF2-40B4-BE49-F238E27FC236}">
-                <a16:creationId xmlns:a16="http://schemas.microsoft.com/office/drawing/2014/main" id="{BF18D874-585A-4AF1-A337-0386EEA9B5FA}"/>
+                <a16:creationId xmlns:a16="http://schemas.microsoft.com/office/drawing/2014/main" id="{C47ED0DB-0859-4B19-A417-DD7116292CAE}"/>
               </a:ext>
             </a:extLst>
           </p:cNvPr>
@@ -4797,7 +3972,7 @@
           <p:cNvPr id="8" name="">
             <a:extLst xmlns:a="http://schemas.openxmlformats.org/drawingml/2006/main">
               <a:ext uri="{FF2B5EF4-FFF2-40B4-BE49-F238E27FC236}">
-                <a16:creationId xmlns:a16="http://schemas.microsoft.com/office/drawing/2014/main" id="{2B93DB93-CD5C-4ED8-80BE-65DCD50DC6F2}"/>
+                <a16:creationId xmlns:a16="http://schemas.microsoft.com/office/drawing/2014/main" id="{933D3B92-79B3-498C-9949-3304472E6A67}"/>
               </a:ext>
             </a:extLst>
           </p:cNvPr>
@@ -4865,7 +4040,7 @@
           <p:cNvPr id="9" name="">
             <a:extLst xmlns:a="http://schemas.openxmlformats.org/drawingml/2006/main">
               <a:ext uri="{FF2B5EF4-FFF2-40B4-BE49-F238E27FC236}">
-                <a16:creationId xmlns:a16="http://schemas.microsoft.com/office/drawing/2014/main" id="{C05F4DDB-91D3-4CA8-9903-C11AA20E1EAC}"/>
+                <a16:creationId xmlns:a16="http://schemas.microsoft.com/office/drawing/2014/main" id="{CBC0FEE1-0E66-4269-A8FA-CC7D7B03ED55}"/>
               </a:ext>
             </a:extLst>
           </p:cNvPr>
@@ -4931,7 +4106,7 @@
     </p:spTree>
     <p:extLst>
       <p:ext uri="{BB962C8B-B14F-4D97-AF65-F5344CB8AC3E}">
-        <p14:creationId xmlns:p14="http://schemas.microsoft.com/office/powerpoint/2010/main" val="1772130009"/>
+        <p14:creationId xmlns:p14="http://schemas.microsoft.com/office/powerpoint/2010/main" val="969126132"/>
       </p:ext>
     </p:extLst>
   </p:cSld>
@@ -4962,7 +4137,7 @@
           <p:cNvPr id="7" name="">
             <a:extLst xmlns:a="http://schemas.openxmlformats.org/drawingml/2006/main">
               <a:ext uri="{FF2B5EF4-FFF2-40B4-BE49-F238E27FC236}">
-                <a16:creationId xmlns:a16="http://schemas.microsoft.com/office/drawing/2014/main" id="{CEB84374-0108-4269-BC3B-7146CF9A3259}"/>
+                <a16:creationId xmlns:a16="http://schemas.microsoft.com/office/drawing/2014/main" id="{12A3F1B4-3958-4920-A759-47DB275EA0F3}"/>
               </a:ext>
             </a:extLst>
           </p:cNvPr>
@@ -5030,7 +4205,7 @@
           <p:cNvPr id="2" name="">
             <a:extLst xmlns:a="http://schemas.openxmlformats.org/drawingml/2006/main">
               <a:ext uri="{FF2B5EF4-FFF2-40B4-BE49-F238E27FC236}">
-                <a16:creationId xmlns:a16="http://schemas.microsoft.com/office/drawing/2014/main" id="{27A65675-A167-4367-85D7-AC6864AEBE73}"/>
+                <a16:creationId xmlns:a16="http://schemas.microsoft.com/office/drawing/2014/main" id="{3DA524FD-9DAD-4909-9A44-886473ECF206}"/>
               </a:ext>
             </a:extLst>
           </p:cNvPr>
@@ -5098,7 +4273,7 @@
           <p:cNvPr id="3" name="">
             <a:extLst xmlns:a="http://schemas.openxmlformats.org/drawingml/2006/main">
               <a:ext uri="{FF2B5EF4-FFF2-40B4-BE49-F238E27FC236}">
-                <a16:creationId xmlns:a16="http://schemas.microsoft.com/office/drawing/2014/main" id="{4CEA7D54-F4B9-4CA7-805D-B3EDAECF94D7}"/>
+                <a16:creationId xmlns:a16="http://schemas.microsoft.com/office/drawing/2014/main" id="{38276699-051E-4984-BE9C-4160310B5C0D}"/>
               </a:ext>
             </a:extLst>
           </p:cNvPr>
@@ -5108,7 +4283,7 @@
           <p:nvPr/>
         </p:nvPicPr>
         <p:blipFill>
-          <a:blip xmlns:r="http://schemas.openxmlformats.org/officeDocument/2006/relationships" xmlns:a="http://schemas.openxmlformats.org/drawingml/2006/main" r:embed="Ra08f033cecff44b9"/>
+          <a:blip xmlns:r="http://schemas.openxmlformats.org/officeDocument/2006/relationships" xmlns:a="http://schemas.openxmlformats.org/drawingml/2006/main" r:embed="R8a983fa4336b4d30"/>
           <a:stretch xmlns:a="http://schemas.openxmlformats.org/drawingml/2006/main"/>
         </p:blipFill>
         <p:spPr>
@@ -5126,7 +4301,7 @@
           <p:cNvPr id="4" name="">
             <a:extLst xmlns:a="http://schemas.openxmlformats.org/drawingml/2006/main">
               <a:ext uri="{FF2B5EF4-FFF2-40B4-BE49-F238E27FC236}">
-                <a16:creationId xmlns:a16="http://schemas.microsoft.com/office/drawing/2014/main" id="{1DB844E3-8995-447A-BB2E-78ABAE1A80F4}"/>
+                <a16:creationId xmlns:a16="http://schemas.microsoft.com/office/drawing/2014/main" id="{5E125B03-1899-403E-B375-E3708DA0E84D}"/>
               </a:ext>
             </a:extLst>
           </p:cNvPr>
@@ -5156,7 +4331,7 @@
           <p:cNvPr id="5" name="">
             <a:extLst xmlns:a="http://schemas.openxmlformats.org/drawingml/2006/main">
               <a:ext uri="{FF2B5EF4-FFF2-40B4-BE49-F238E27FC236}">
-                <a16:creationId xmlns:a16="http://schemas.microsoft.com/office/drawing/2014/main" id="{62D8CFD7-62F8-4E9F-BE50-C44F0EE619A5}"/>
+                <a16:creationId xmlns:a16="http://schemas.microsoft.com/office/drawing/2014/main" id="{68EF5AF1-F717-4A82-931C-6B69FB0BC3FC}"/>
               </a:ext>
             </a:extLst>
           </p:cNvPr>
@@ -5224,7 +4399,7 @@
           <p:cNvPr id="6" name="">
             <a:extLst xmlns:a="http://schemas.openxmlformats.org/drawingml/2006/main">
               <a:ext uri="{FF2B5EF4-FFF2-40B4-BE49-F238E27FC236}">
-                <a16:creationId xmlns:a16="http://schemas.microsoft.com/office/drawing/2014/main" id="{5AA004F3-9460-4B27-9664-CB39D1A5117D}"/>
+                <a16:creationId xmlns:a16="http://schemas.microsoft.com/office/drawing/2014/main" id="{F70980B0-C2AC-42D7-B175-FED4AC977989}"/>
               </a:ext>
             </a:extLst>
           </p:cNvPr>
@@ -5290,7 +4465,7 @@
     </p:spTree>
     <p:extLst>
       <p:ext uri="{BB962C8B-B14F-4D97-AF65-F5344CB8AC3E}">
-        <p14:creationId xmlns:p14="http://schemas.microsoft.com/office/powerpoint/2010/main" val="1983049174"/>
+        <p14:creationId xmlns:p14="http://schemas.microsoft.com/office/powerpoint/2010/main" val="837687268"/>
       </p:ext>
     </p:extLst>
   </p:cSld>
@@ -5321,7 +4496,7 @@
           <p:cNvPr id="15" name="">
             <a:extLst xmlns:a="http://schemas.openxmlformats.org/drawingml/2006/main">
               <a:ext uri="{FF2B5EF4-FFF2-40B4-BE49-F238E27FC236}">
-                <a16:creationId xmlns:a16="http://schemas.microsoft.com/office/drawing/2014/main" id="{83825552-2A7F-4A93-9708-20354F35901C}"/>
+                <a16:creationId xmlns:a16="http://schemas.microsoft.com/office/drawing/2014/main" id="{52FBA7F1-87B4-4EF4-AD54-39EE4E77F172}"/>
               </a:ext>
             </a:extLst>
           </p:cNvPr>
@@ -5389,7 +4564,7 @@
           <p:cNvPr id="2" name="">
             <a:extLst xmlns:a="http://schemas.openxmlformats.org/drawingml/2006/main">
               <a:ext uri="{FF2B5EF4-FFF2-40B4-BE49-F238E27FC236}">
-                <a16:creationId xmlns:a16="http://schemas.microsoft.com/office/drawing/2014/main" id="{F87BFEE2-2E36-47A9-A6DC-5AC77C56A7DC}"/>
+                <a16:creationId xmlns:a16="http://schemas.microsoft.com/office/drawing/2014/main" id="{E6CBB3AF-A3FB-4454-B55E-AD6A3FB6C330}"/>
               </a:ext>
             </a:extLst>
           </p:cNvPr>
@@ -5399,7 +4574,7 @@
           <p:nvPr/>
         </p:nvPicPr>
         <p:blipFill>
-          <a:blip xmlns:r="http://schemas.openxmlformats.org/officeDocument/2006/relationships" xmlns:a="http://schemas.openxmlformats.org/drawingml/2006/main" r:embed="Rfc687dbf8e9b4b20"/>
+          <a:blip xmlns:r="http://schemas.openxmlformats.org/officeDocument/2006/relationships" xmlns:a="http://schemas.openxmlformats.org/drawingml/2006/main" r:embed="R5267abb327f64f46"/>
           <a:stretch xmlns:a="http://schemas.openxmlformats.org/drawingml/2006/main"/>
         </p:blipFill>
         <p:spPr>
@@ -5417,7 +4592,7 @@
           <p:cNvPr id="3" name="">
             <a:extLst xmlns:a="http://schemas.openxmlformats.org/drawingml/2006/main">
               <a:ext uri="{FF2B5EF4-FFF2-40B4-BE49-F238E27FC236}">
-                <a16:creationId xmlns:a16="http://schemas.microsoft.com/office/drawing/2014/main" id="{BC1904BA-09CF-4EFC-80AE-E6084129F06B}"/>
+                <a16:creationId xmlns:a16="http://schemas.microsoft.com/office/drawing/2014/main" id="{18FC7DE4-DDF7-4518-883C-4B671A1AF2B8}"/>
               </a:ext>
             </a:extLst>
           </p:cNvPr>
@@ -5447,7 +4622,7 @@
           <p:cNvPr id="4" name="">
             <a:extLst xmlns:a="http://schemas.openxmlformats.org/drawingml/2006/main">
               <a:ext uri="{FF2B5EF4-FFF2-40B4-BE49-F238E27FC236}">
-                <a16:creationId xmlns:a16="http://schemas.microsoft.com/office/drawing/2014/main" id="{259ECCB0-1AB6-4A99-B400-8F0E96CAC20F}"/>
+                <a16:creationId xmlns:a16="http://schemas.microsoft.com/office/drawing/2014/main" id="{73BC4F5D-AAC0-4E81-97A1-E30E3382E95E}"/>
               </a:ext>
             </a:extLst>
           </p:cNvPr>
@@ -5515,7 +4690,7 @@
           <p:cNvPr id="5" name="">
             <a:extLst xmlns:a="http://schemas.openxmlformats.org/drawingml/2006/main">
               <a:ext uri="{FF2B5EF4-FFF2-40B4-BE49-F238E27FC236}">
-                <a16:creationId xmlns:a16="http://schemas.microsoft.com/office/drawing/2014/main" id="{A0A979B5-68AA-4C8A-9180-D871AF608CD6}"/>
+                <a16:creationId xmlns:a16="http://schemas.microsoft.com/office/drawing/2014/main" id="{7D25776B-9CEB-444E-BD85-B4B353F4C4C5}"/>
               </a:ext>
             </a:extLst>
           </p:cNvPr>
@@ -5583,7 +4758,7 @@
           <p:cNvPr id="6" name="">
             <a:extLst xmlns:a="http://schemas.openxmlformats.org/drawingml/2006/main">
               <a:ext uri="{FF2B5EF4-FFF2-40B4-BE49-F238E27FC236}">
-                <a16:creationId xmlns:a16="http://schemas.microsoft.com/office/drawing/2014/main" id="{26A1F5DC-FBB7-43E5-A757-4834B85C08CE}"/>
+                <a16:creationId xmlns:a16="http://schemas.microsoft.com/office/drawing/2014/main" id="{DC6A23FB-1D4B-45F7-99D9-9BFE9AF168B1}"/>
               </a:ext>
             </a:extLst>
           </p:cNvPr>
@@ -5613,7 +4788,7 @@
           <p:cNvPr id="7" name="">
             <a:extLst xmlns:a="http://schemas.openxmlformats.org/drawingml/2006/main">
               <a:ext uri="{FF2B5EF4-FFF2-40B4-BE49-F238E27FC236}">
-                <a16:creationId xmlns:a16="http://schemas.microsoft.com/office/drawing/2014/main" id="{B53A1577-AC64-4BD4-9F52-BFBF31855AA1}"/>
+                <a16:creationId xmlns:a16="http://schemas.microsoft.com/office/drawing/2014/main" id="{DE7C5624-D968-4CF1-9C68-CB6133372482}"/>
               </a:ext>
             </a:extLst>
           </p:cNvPr>
@@ -5681,7 +4856,7 @@
           <p:cNvPr id="8" name="">
             <a:extLst xmlns:a="http://schemas.openxmlformats.org/drawingml/2006/main">
               <a:ext uri="{FF2B5EF4-FFF2-40B4-BE49-F238E27FC236}">
-                <a16:creationId xmlns:a16="http://schemas.microsoft.com/office/drawing/2014/main" id="{3506AE67-4482-4AD8-921C-08CBE1E9674E}"/>
+                <a16:creationId xmlns:a16="http://schemas.microsoft.com/office/drawing/2014/main" id="{B2281128-1F96-43B9-9498-567D8531A85F}"/>
               </a:ext>
             </a:extLst>
           </p:cNvPr>
@@ -5749,7 +4924,7 @@
           <p:cNvPr id="9" name="">
             <a:extLst xmlns:a="http://schemas.openxmlformats.org/drawingml/2006/main">
               <a:ext uri="{FF2B5EF4-FFF2-40B4-BE49-F238E27FC236}">
-                <a16:creationId xmlns:a16="http://schemas.microsoft.com/office/drawing/2014/main" id="{0181C33D-853D-4494-BF92-E378DEF1AA90}"/>
+                <a16:creationId xmlns:a16="http://schemas.microsoft.com/office/drawing/2014/main" id="{CBCA837E-6961-4DE6-921A-98CDA321D722}"/>
               </a:ext>
             </a:extLst>
           </p:cNvPr>
@@ -5779,7 +4954,7 @@
           <p:cNvPr id="10" name="">
             <a:extLst xmlns:a="http://schemas.openxmlformats.org/drawingml/2006/main">
               <a:ext uri="{FF2B5EF4-FFF2-40B4-BE49-F238E27FC236}">
-                <a16:creationId xmlns:a16="http://schemas.microsoft.com/office/drawing/2014/main" id="{6C66D1F9-B2F2-4EC9-8246-1072FF26A5EF}"/>
+                <a16:creationId xmlns:a16="http://schemas.microsoft.com/office/drawing/2014/main" id="{94CF228B-EB3A-4299-A4D0-92DFA3194D0A}"/>
               </a:ext>
             </a:extLst>
           </p:cNvPr>
@@ -5847,7 +5022,7 @@
           <p:cNvPr id="11" name="">
             <a:extLst xmlns:a="http://schemas.openxmlformats.org/drawingml/2006/main">
               <a:ext uri="{FF2B5EF4-FFF2-40B4-BE49-F238E27FC236}">
-                <a16:creationId xmlns:a16="http://schemas.microsoft.com/office/drawing/2014/main" id="{062746EE-D539-41FE-AF04-7CF075BA6E1B}"/>
+                <a16:creationId xmlns:a16="http://schemas.microsoft.com/office/drawing/2014/main" id="{D240F7A4-16B7-42A9-97ED-74C39A926D7B}"/>
               </a:ext>
             </a:extLst>
           </p:cNvPr>
@@ -5915,7 +5090,7 @@
           <p:cNvPr id="12" name="">
             <a:extLst xmlns:a="http://schemas.openxmlformats.org/drawingml/2006/main">
               <a:ext uri="{FF2B5EF4-FFF2-40B4-BE49-F238E27FC236}">
-                <a16:creationId xmlns:a16="http://schemas.microsoft.com/office/drawing/2014/main" id="{520EF028-D0BB-43A8-A843-741A3B3101D8}"/>
+                <a16:creationId xmlns:a16="http://schemas.microsoft.com/office/drawing/2014/main" id="{FECBEFD0-96BD-4E67-806C-D29C9853BF5B}"/>
               </a:ext>
             </a:extLst>
           </p:cNvPr>
@@ -5983,7 +5158,7 @@
           <p:cNvPr id="13" name="">
             <a:extLst xmlns:a="http://schemas.openxmlformats.org/drawingml/2006/main">
               <a:ext uri="{FF2B5EF4-FFF2-40B4-BE49-F238E27FC236}">
-                <a16:creationId xmlns:a16="http://schemas.microsoft.com/office/drawing/2014/main" id="{358A7FB0-60D6-459A-9F5D-86B1ED255E82}"/>
+                <a16:creationId xmlns:a16="http://schemas.microsoft.com/office/drawing/2014/main" id="{4CAD71B4-54B5-4316-A3AD-708B5A9A60C8}"/>
               </a:ext>
             </a:extLst>
           </p:cNvPr>
@@ -6051,7 +5226,7 @@
           <p:cNvPr id="14" name="">
             <a:extLst xmlns:a="http://schemas.openxmlformats.org/drawingml/2006/main">
               <a:ext uri="{FF2B5EF4-FFF2-40B4-BE49-F238E27FC236}">
-                <a16:creationId xmlns:a16="http://schemas.microsoft.com/office/drawing/2014/main" id="{E59AC33E-5F60-4998-B48B-8E46E0515A6C}"/>
+                <a16:creationId xmlns:a16="http://schemas.microsoft.com/office/drawing/2014/main" id="{936B5328-1B0B-45E3-99AA-B7BB02DAD3C1}"/>
               </a:ext>
             </a:extLst>
           </p:cNvPr>
@@ -6117,7 +5292,7 @@
     </p:spTree>
     <p:extLst>
       <p:ext uri="{BB962C8B-B14F-4D97-AF65-F5344CB8AC3E}">
-        <p14:creationId xmlns:p14="http://schemas.microsoft.com/office/powerpoint/2010/main" val="1836885466"/>
+        <p14:creationId xmlns:p14="http://schemas.microsoft.com/office/powerpoint/2010/main" val="109899234"/>
       </p:ext>
     </p:extLst>
   </p:cSld>
@@ -6148,7 +5323,7 @@
           <p:cNvPr id="7" name="">
             <a:extLst xmlns:a="http://schemas.openxmlformats.org/drawingml/2006/main">
               <a:ext uri="{FF2B5EF4-FFF2-40B4-BE49-F238E27FC236}">
-                <a16:creationId xmlns:a16="http://schemas.microsoft.com/office/drawing/2014/main" id="{56366853-6D60-4E32-8F64-FE48E0427472}"/>
+                <a16:creationId xmlns:a16="http://schemas.microsoft.com/office/drawing/2014/main" id="{9AE87080-0C9C-46E5-BC32-5964C6A8D0AE}"/>
               </a:ext>
             </a:extLst>
           </p:cNvPr>
@@ -6216,7 +5391,7 @@
           <p:cNvPr id="2" name="">
             <a:extLst xmlns:a="http://schemas.openxmlformats.org/drawingml/2006/main">
               <a:ext uri="{FF2B5EF4-FFF2-40B4-BE49-F238E27FC236}">
-                <a16:creationId xmlns:a16="http://schemas.microsoft.com/office/drawing/2014/main" id="{7B1EB06E-1860-4523-B45A-7A51BEA35341}"/>
+                <a16:creationId xmlns:a16="http://schemas.microsoft.com/office/drawing/2014/main" id="{E3F21D67-615F-494D-AF90-5B449FB170B0}"/>
               </a:ext>
             </a:extLst>
           </p:cNvPr>
@@ -6284,7 +5459,7 @@
           <p:cNvPr id="3" name="">
             <a:extLst xmlns:a="http://schemas.openxmlformats.org/drawingml/2006/main">
               <a:ext uri="{FF2B5EF4-FFF2-40B4-BE49-F238E27FC236}">
-                <a16:creationId xmlns:a16="http://schemas.microsoft.com/office/drawing/2014/main" id="{7F45A8FC-B90A-4424-863F-602DF6FBDEC4}"/>
+                <a16:creationId xmlns:a16="http://schemas.microsoft.com/office/drawing/2014/main" id="{14F4D59C-0818-498E-ADF8-334285246ECE}"/>
               </a:ext>
             </a:extLst>
           </p:cNvPr>
@@ -6294,7 +5469,7 @@
           <p:nvPr/>
         </p:nvPicPr>
         <p:blipFill>
-          <a:blip xmlns:r="http://schemas.openxmlformats.org/officeDocument/2006/relationships" xmlns:a="http://schemas.openxmlformats.org/drawingml/2006/main" r:embed="Rfdad506937c64a19"/>
+          <a:blip xmlns:r="http://schemas.openxmlformats.org/officeDocument/2006/relationships" xmlns:a="http://schemas.openxmlformats.org/drawingml/2006/main" r:embed="R582701f7941648f7"/>
           <a:stretch xmlns:a="http://schemas.openxmlformats.org/drawingml/2006/main"/>
         </p:blipFill>
         <p:spPr>
@@ -6312,7 +5487,7 @@
           <p:cNvPr id="4" name="">
             <a:extLst xmlns:a="http://schemas.openxmlformats.org/drawingml/2006/main">
               <a:ext uri="{FF2B5EF4-FFF2-40B4-BE49-F238E27FC236}">
-                <a16:creationId xmlns:a16="http://schemas.microsoft.com/office/drawing/2014/main" id="{2FCA793D-9449-4B3E-BAB3-1E266F50B3F3}"/>
+                <a16:creationId xmlns:a16="http://schemas.microsoft.com/office/drawing/2014/main" id="{43905F52-65A7-4CF6-86B7-BF239676944C}"/>
               </a:ext>
             </a:extLst>
           </p:cNvPr>
@@ -6342,7 +5517,7 @@
           <p:cNvPr id="5" name="">
             <a:extLst xmlns:a="http://schemas.openxmlformats.org/drawingml/2006/main">
               <a:ext uri="{FF2B5EF4-FFF2-40B4-BE49-F238E27FC236}">
-                <a16:creationId xmlns:a16="http://schemas.microsoft.com/office/drawing/2014/main" id="{01E0AD2D-BD20-4267-835A-3F3E09FEF9A7}"/>
+                <a16:creationId xmlns:a16="http://schemas.microsoft.com/office/drawing/2014/main" id="{FC7543C7-F3B6-4BE9-AC91-ADA48252EC55}"/>
               </a:ext>
             </a:extLst>
           </p:cNvPr>
@@ -6410,7 +5585,7 @@
           <p:cNvPr id="6" name="">
             <a:extLst xmlns:a="http://schemas.openxmlformats.org/drawingml/2006/main">
               <a:ext uri="{FF2B5EF4-FFF2-40B4-BE49-F238E27FC236}">
-                <a16:creationId xmlns:a16="http://schemas.microsoft.com/office/drawing/2014/main" id="{7F3CCD03-6A3A-4D11-8304-A824E6B58BF3}"/>
+                <a16:creationId xmlns:a16="http://schemas.microsoft.com/office/drawing/2014/main" id="{7681E578-1031-4B91-B9E8-5E0FED0A14E2}"/>
               </a:ext>
             </a:extLst>
           </p:cNvPr>
@@ -6476,7 +5651,7 @@
     </p:spTree>
     <p:extLst>
       <p:ext uri="{BB962C8B-B14F-4D97-AF65-F5344CB8AC3E}">
-        <p14:creationId xmlns:p14="http://schemas.microsoft.com/office/powerpoint/2010/main" val="750610031"/>
+        <p14:creationId xmlns:p14="http://schemas.microsoft.com/office/powerpoint/2010/main" val="1554024406"/>
       </p:ext>
     </p:extLst>
   </p:cSld>
@@ -6507,7 +5682,7 @@
           <p:cNvPr id="6" name="">
             <a:extLst xmlns:a="http://schemas.openxmlformats.org/drawingml/2006/main">
               <a:ext uri="{FF2B5EF4-FFF2-40B4-BE49-F238E27FC236}">
-                <a16:creationId xmlns:a16="http://schemas.microsoft.com/office/drawing/2014/main" id="{0F9A734B-4EF1-4212-BFC3-6534B097DF9E}"/>
+                <a16:creationId xmlns:a16="http://schemas.microsoft.com/office/drawing/2014/main" id="{61FE0A04-EE09-4CA0-BCA0-4B07C538B6DB}"/>
               </a:ext>
             </a:extLst>
           </p:cNvPr>
@@ -6517,7 +5692,7 @@
           <p:nvPr/>
         </p:nvPicPr>
         <p:blipFill>
-          <a:blip xmlns:r="http://schemas.openxmlformats.org/officeDocument/2006/relationships" xmlns:a="http://schemas.openxmlformats.org/drawingml/2006/main" r:embed="R65837f39e4014c10"/>
+          <a:blip xmlns:r="http://schemas.openxmlformats.org/officeDocument/2006/relationships" xmlns:a="http://schemas.openxmlformats.org/drawingml/2006/main" r:embed="R8ae438da2db74641"/>
           <a:stretch xmlns:a="http://schemas.openxmlformats.org/drawingml/2006/main"/>
         </p:blipFill>
         <p:spPr>
@@ -6535,7 +5710,7 @@
           <p:cNvPr id="2" name="">
             <a:extLst xmlns:a="http://schemas.openxmlformats.org/drawingml/2006/main">
               <a:ext uri="{FF2B5EF4-FFF2-40B4-BE49-F238E27FC236}">
-                <a16:creationId xmlns:a16="http://schemas.microsoft.com/office/drawing/2014/main" id="{262D81E0-1EE7-46BD-B93B-43BCD74C43C2}"/>
+                <a16:creationId xmlns:a16="http://schemas.microsoft.com/office/drawing/2014/main" id="{D2280318-4813-4BCE-BB2A-5503C63CCCB7}"/>
               </a:ext>
             </a:extLst>
           </p:cNvPr>
@@ -6603,7 +5778,7 @@
           <p:cNvPr id="3" name="">
             <a:extLst xmlns:a="http://schemas.openxmlformats.org/drawingml/2006/main">
               <a:ext uri="{FF2B5EF4-FFF2-40B4-BE49-F238E27FC236}">
-                <a16:creationId xmlns:a16="http://schemas.microsoft.com/office/drawing/2014/main" id="{7AE98739-72A2-492C-B6C4-E64E7547E85F}"/>
+                <a16:creationId xmlns:a16="http://schemas.microsoft.com/office/drawing/2014/main" id="{778D60CB-36BD-40E9-BFE5-E1ABF8A889D3}"/>
               </a:ext>
             </a:extLst>
           </p:cNvPr>
@@ -6671,7 +5846,7 @@
           <p:cNvPr id="4" name="">
             <a:extLst xmlns:a="http://schemas.openxmlformats.org/drawingml/2006/main">
               <a:ext uri="{FF2B5EF4-FFF2-40B4-BE49-F238E27FC236}">
-                <a16:creationId xmlns:a16="http://schemas.microsoft.com/office/drawing/2014/main" id="{85302E21-F78F-43FE-A5B0-1A1E8DE748EB}"/>
+                <a16:creationId xmlns:a16="http://schemas.microsoft.com/office/drawing/2014/main" id="{BFC4EA1D-685D-479D-A01C-16A0B9ADEE52}"/>
               </a:ext>
             </a:extLst>
           </p:cNvPr>
@@ -6739,7 +5914,7 @@
           <p:cNvPr id="5" name="">
             <a:extLst xmlns:a="http://schemas.openxmlformats.org/drawingml/2006/main">
               <a:ext uri="{FF2B5EF4-FFF2-40B4-BE49-F238E27FC236}">
-                <a16:creationId xmlns:a16="http://schemas.microsoft.com/office/drawing/2014/main" id="{717E1972-224C-433B-869E-0267B84D8165}"/>
+                <a16:creationId xmlns:a16="http://schemas.microsoft.com/office/drawing/2014/main" id="{C8C35B83-0514-4FEA-9AC2-54B8023B337D}"/>
               </a:ext>
             </a:extLst>
           </p:cNvPr>
@@ -6805,7 +5980,7 @@
     </p:spTree>
     <p:extLst>
       <p:ext uri="{BB962C8B-B14F-4D97-AF65-F5344CB8AC3E}">
-        <p14:creationId xmlns:p14="http://schemas.microsoft.com/office/powerpoint/2010/main" val="1662911044"/>
+        <p14:creationId xmlns:p14="http://schemas.microsoft.com/office/powerpoint/2010/main" val="308384400"/>
       </p:ext>
     </p:extLst>
   </p:cSld>
@@ -6836,7 +6011,7 @@
           <p:cNvPr id="28" name="">
             <a:extLst xmlns:a="http://schemas.openxmlformats.org/drawingml/2006/main">
               <a:ext uri="{FF2B5EF4-FFF2-40B4-BE49-F238E27FC236}">
-                <a16:creationId xmlns:a16="http://schemas.microsoft.com/office/drawing/2014/main" id="{28342B41-EBE2-4773-B2BE-6403EA46757C}"/>
+                <a16:creationId xmlns:a16="http://schemas.microsoft.com/office/drawing/2014/main" id="{497CB6F6-9186-4C74-BBFB-CCA5F9211B40}"/>
               </a:ext>
             </a:extLst>
           </p:cNvPr>
@@ -6846,7 +6021,7 @@
           <p:nvPr/>
         </p:nvPicPr>
         <p:blipFill>
-          <a:blip xmlns:r="http://schemas.openxmlformats.org/officeDocument/2006/relationships" xmlns:a="http://schemas.openxmlformats.org/drawingml/2006/main" r:embed="R02e8748aff6a41f3"/>
+          <a:blip xmlns:r="http://schemas.openxmlformats.org/officeDocument/2006/relationships" xmlns:a="http://schemas.openxmlformats.org/drawingml/2006/main" r:embed="R1734c51700394497"/>
           <a:srcRect xmlns:a="http://schemas.openxmlformats.org/drawingml/2006/main" l="0" t="0" r="0" b="0"/>
           <a:stretch xmlns:a="http://schemas.openxmlformats.org/drawingml/2006/main">
             <a:fillRect l="0" t="0" r="0" b="0"/>
@@ -6867,7 +6042,7 @@
           <p:cNvPr id="2" name="">
             <a:extLst xmlns:a="http://schemas.openxmlformats.org/drawingml/2006/main">
               <a:ext uri="{FF2B5EF4-FFF2-40B4-BE49-F238E27FC236}">
-                <a16:creationId xmlns:a16="http://schemas.microsoft.com/office/drawing/2014/main" id="{A56A2F6C-0D2A-41F7-B8A9-2F58A52D4E8A}"/>
+                <a16:creationId xmlns:a16="http://schemas.microsoft.com/office/drawing/2014/main" id="{CE5A4705-EBF3-48BE-9945-AA88EE0D68B3}"/>
               </a:ext>
             </a:extLst>
           </p:cNvPr>
@@ -6935,7 +6110,7 @@
           <p:cNvPr id="3" name="">
             <a:extLst xmlns:a="http://schemas.openxmlformats.org/drawingml/2006/main">
               <a:ext uri="{FF2B5EF4-FFF2-40B4-BE49-F238E27FC236}">
-                <a16:creationId xmlns:a16="http://schemas.microsoft.com/office/drawing/2014/main" id="{629DFB93-5309-4A24-8241-EAB75EBE517E}"/>
+                <a16:creationId xmlns:a16="http://schemas.microsoft.com/office/drawing/2014/main" id="{78775FB3-712F-4A74-A60B-A48825A9A96F}"/>
               </a:ext>
             </a:extLst>
           </p:cNvPr>
@@ -7003,7 +6178,7 @@
           <p:cNvPr id="4" name="">
             <a:extLst xmlns:a="http://schemas.openxmlformats.org/drawingml/2006/main">
               <a:ext uri="{FF2B5EF4-FFF2-40B4-BE49-F238E27FC236}">
-                <a16:creationId xmlns:a16="http://schemas.microsoft.com/office/drawing/2014/main" id="{B5E62C32-F4A2-4162-B8E4-3A1E957E194B}"/>
+                <a16:creationId xmlns:a16="http://schemas.microsoft.com/office/drawing/2014/main" id="{2CC38E57-71E9-4A19-B213-38D7FB3B54A5}"/>
               </a:ext>
             </a:extLst>
           </p:cNvPr>
@@ -7071,7 +6246,7 @@
           <p:cNvPr id="5" name="">
             <a:extLst xmlns:a="http://schemas.openxmlformats.org/drawingml/2006/main">
               <a:ext uri="{FF2B5EF4-FFF2-40B4-BE49-F238E27FC236}">
-                <a16:creationId xmlns:a16="http://schemas.microsoft.com/office/drawing/2014/main" id="{0978F407-959B-4438-ADBC-0BCF390A0CA3}"/>
+                <a16:creationId xmlns:a16="http://schemas.microsoft.com/office/drawing/2014/main" id="{4078B16B-D63D-40F1-A19C-4DEA56A1FBDB}"/>
               </a:ext>
             </a:extLst>
           </p:cNvPr>
@@ -7081,7 +6256,7 @@
           <p:nvPr/>
         </p:nvPicPr>
         <p:blipFill>
-          <a:blip xmlns:r="http://schemas.openxmlformats.org/officeDocument/2006/relationships" xmlns:a="http://schemas.openxmlformats.org/drawingml/2006/main" r:embed="R7dfe56bdcf744814"/>
+          <a:blip xmlns:r="http://schemas.openxmlformats.org/officeDocument/2006/relationships" xmlns:a="http://schemas.openxmlformats.org/drawingml/2006/main" r:embed="R4bd00ef6fc044248"/>
           <a:stretch xmlns:a="http://schemas.openxmlformats.org/drawingml/2006/main"/>
         </p:blipFill>
         <p:spPr>
@@ -7099,7 +6274,7 @@
           <p:cNvPr id="6" name="">
             <a:extLst xmlns:a="http://schemas.openxmlformats.org/drawingml/2006/main">
               <a:ext uri="{FF2B5EF4-FFF2-40B4-BE49-F238E27FC236}">
-                <a16:creationId xmlns:a16="http://schemas.microsoft.com/office/drawing/2014/main" id="{AF76D479-6B72-4118-B145-F4AC6F6D3695}"/>
+                <a16:creationId xmlns:a16="http://schemas.microsoft.com/office/drawing/2014/main" id="{66823170-2805-4EC7-AC5D-BB5A6676F51E}"/>
               </a:ext>
             </a:extLst>
           </p:cNvPr>
@@ -7129,7 +6304,7 @@
           <p:cNvPr id="7" name="">
             <a:extLst xmlns:a="http://schemas.openxmlformats.org/drawingml/2006/main">
               <a:ext uri="{FF2B5EF4-FFF2-40B4-BE49-F238E27FC236}">
-                <a16:creationId xmlns:a16="http://schemas.microsoft.com/office/drawing/2014/main" id="{DD838CE9-DE1D-48C8-8E2E-22F8F4B14760}"/>
+                <a16:creationId xmlns:a16="http://schemas.microsoft.com/office/drawing/2014/main" id="{1A28C138-953F-4E34-BC50-5292F05FBA26}"/>
               </a:ext>
             </a:extLst>
           </p:cNvPr>
@@ -7197,7 +6372,7 @@
           <p:cNvPr id="8" name="">
             <a:extLst xmlns:a="http://schemas.openxmlformats.org/drawingml/2006/main">
               <a:ext uri="{FF2B5EF4-FFF2-40B4-BE49-F238E27FC236}">
-                <a16:creationId xmlns:a16="http://schemas.microsoft.com/office/drawing/2014/main" id="{7653C0F5-8783-4E51-90AB-8FDA80A37F8C}"/>
+                <a16:creationId xmlns:a16="http://schemas.microsoft.com/office/drawing/2014/main" id="{0194A16F-78E8-40D4-8580-B54E4FD3AA13}"/>
               </a:ext>
             </a:extLst>
           </p:cNvPr>
@@ -7265,7 +6440,7 @@
           <p:cNvPr id="9" name="">
             <a:extLst xmlns:a="http://schemas.openxmlformats.org/drawingml/2006/main">
               <a:ext uri="{FF2B5EF4-FFF2-40B4-BE49-F238E27FC236}">
-                <a16:creationId xmlns:a16="http://schemas.microsoft.com/office/drawing/2014/main" id="{CB64823E-6519-416F-A38B-44AE05668A9B}"/>
+                <a16:creationId xmlns:a16="http://schemas.microsoft.com/office/drawing/2014/main" id="{10CA95E4-6439-48E4-B5D6-D8CD684351AF}"/>
               </a:ext>
             </a:extLst>
           </p:cNvPr>
@@ -7333,7 +6508,7 @@
           <p:cNvPr id="10" name="">
             <a:extLst xmlns:a="http://schemas.openxmlformats.org/drawingml/2006/main">
               <a:ext uri="{FF2B5EF4-FFF2-40B4-BE49-F238E27FC236}">
-                <a16:creationId xmlns:a16="http://schemas.microsoft.com/office/drawing/2014/main" id="{39722C97-D291-4291-A178-8AF13229E0C5}"/>
+                <a16:creationId xmlns:a16="http://schemas.microsoft.com/office/drawing/2014/main" id="{74003981-F337-45CD-82FA-727D8D51A18B}"/>
               </a:ext>
             </a:extLst>
           </p:cNvPr>
@@ -7401,7 +6576,7 @@
           <p:cNvPr id="11" name="">
             <a:extLst xmlns:a="http://schemas.openxmlformats.org/drawingml/2006/main">
               <a:ext uri="{FF2B5EF4-FFF2-40B4-BE49-F238E27FC236}">
-                <a16:creationId xmlns:a16="http://schemas.microsoft.com/office/drawing/2014/main" id="{DA01BEE3-0649-4CD7-8509-A0ECA4476593}"/>
+                <a16:creationId xmlns:a16="http://schemas.microsoft.com/office/drawing/2014/main" id="{253CF544-C2D2-461F-BEF6-6B90EE217144}"/>
               </a:ext>
             </a:extLst>
           </p:cNvPr>
@@ -7469,7 +6644,7 @@
           <p:cNvPr id="12" name="">
             <a:extLst xmlns:a="http://schemas.openxmlformats.org/drawingml/2006/main">
               <a:ext uri="{FF2B5EF4-FFF2-40B4-BE49-F238E27FC236}">
-                <a16:creationId xmlns:a16="http://schemas.microsoft.com/office/drawing/2014/main" id="{8425F3D8-BED8-4031-AE87-A5377D8F093F}"/>
+                <a16:creationId xmlns:a16="http://schemas.microsoft.com/office/drawing/2014/main" id="{7F1660CB-E159-47AE-8871-41604EF20E15}"/>
               </a:ext>
             </a:extLst>
           </p:cNvPr>
@@ -7537,7 +6712,7 @@
           <p:cNvPr id="13" name="">
             <a:extLst xmlns:a="http://schemas.openxmlformats.org/drawingml/2006/main">
               <a:ext uri="{FF2B5EF4-FFF2-40B4-BE49-F238E27FC236}">
-                <a16:creationId xmlns:a16="http://schemas.microsoft.com/office/drawing/2014/main" id="{B9AC4E39-A5AF-4274-BD95-0B42AD0BEDD6}"/>
+                <a16:creationId xmlns:a16="http://schemas.microsoft.com/office/drawing/2014/main" id="{A32BBCD7-92A9-44FB-8D4E-664900D056C9}"/>
               </a:ext>
             </a:extLst>
           </p:cNvPr>
@@ -7605,7 +6780,7 @@
           <p:cNvPr id="14" name="">
             <a:extLst xmlns:a="http://schemas.openxmlformats.org/drawingml/2006/main">
               <a:ext uri="{FF2B5EF4-FFF2-40B4-BE49-F238E27FC236}">
-                <a16:creationId xmlns:a16="http://schemas.microsoft.com/office/drawing/2014/main" id="{61201C22-FF19-4046-A1CC-52A2E45F1F54}"/>
+                <a16:creationId xmlns:a16="http://schemas.microsoft.com/office/drawing/2014/main" id="{52EA2AAA-F1E4-4F7C-BD57-D5B6C6A70AC3}"/>
               </a:ext>
             </a:extLst>
           </p:cNvPr>
@@ -7673,7 +6848,7 @@
           <p:cNvPr id="15" name="">
             <a:extLst xmlns:a="http://schemas.openxmlformats.org/drawingml/2006/main">
               <a:ext uri="{FF2B5EF4-FFF2-40B4-BE49-F238E27FC236}">
-                <a16:creationId xmlns:a16="http://schemas.microsoft.com/office/drawing/2014/main" id="{2DE25EAB-976D-4629-8A8A-7C3C2BD0F976}"/>
+                <a16:creationId xmlns:a16="http://schemas.microsoft.com/office/drawing/2014/main" id="{06E3D25C-1F59-416E-9A41-818A01A4DB4B}"/>
               </a:ext>
             </a:extLst>
           </p:cNvPr>
@@ -7741,7 +6916,7 @@
           <p:cNvPr id="16" name="">
             <a:extLst xmlns:a="http://schemas.openxmlformats.org/drawingml/2006/main">
               <a:ext uri="{FF2B5EF4-FFF2-40B4-BE49-F238E27FC236}">
-                <a16:creationId xmlns:a16="http://schemas.microsoft.com/office/drawing/2014/main" id="{79FEBADD-7DD2-43D7-9875-DF118EB27E53}"/>
+                <a16:creationId xmlns:a16="http://schemas.microsoft.com/office/drawing/2014/main" id="{9C3D33AE-C429-439A-A464-350A022DCF6A}"/>
               </a:ext>
             </a:extLst>
           </p:cNvPr>
@@ -7809,7 +6984,7 @@
           <p:cNvPr id="17" name="">
             <a:extLst xmlns:a="http://schemas.openxmlformats.org/drawingml/2006/main">
               <a:ext uri="{FF2B5EF4-FFF2-40B4-BE49-F238E27FC236}">
-                <a16:creationId xmlns:a16="http://schemas.microsoft.com/office/drawing/2014/main" id="{CD131FA3-B7FE-4378-BB22-BCA7A4AF4B9F}"/>
+                <a16:creationId xmlns:a16="http://schemas.microsoft.com/office/drawing/2014/main" id="{6433CD06-84BE-4882-9340-0804FDBFF60A}"/>
               </a:ext>
             </a:extLst>
           </p:cNvPr>
@@ -7877,7 +7052,7 @@
           <p:cNvPr id="18" name="">
             <a:extLst xmlns:a="http://schemas.openxmlformats.org/drawingml/2006/main">
               <a:ext uri="{FF2B5EF4-FFF2-40B4-BE49-F238E27FC236}">
-                <a16:creationId xmlns:a16="http://schemas.microsoft.com/office/drawing/2014/main" id="{0E3526C3-7CCC-48EA-8B72-9646B567C76F}"/>
+                <a16:creationId xmlns:a16="http://schemas.microsoft.com/office/drawing/2014/main" id="{64448834-0592-456D-8800-00CAC21010D3}"/>
               </a:ext>
             </a:extLst>
           </p:cNvPr>
@@ -7945,7 +7120,7 @@
           <p:cNvPr id="19" name="">
             <a:extLst xmlns:a="http://schemas.openxmlformats.org/drawingml/2006/main">
               <a:ext uri="{FF2B5EF4-FFF2-40B4-BE49-F238E27FC236}">
-                <a16:creationId xmlns:a16="http://schemas.microsoft.com/office/drawing/2014/main" id="{D7D46E8E-283B-4C12-AEF8-B7B7B796D5CC}"/>
+                <a16:creationId xmlns:a16="http://schemas.microsoft.com/office/drawing/2014/main" id="{79C543EF-CF3E-4BC5-ACD7-CAA859FF3632}"/>
               </a:ext>
             </a:extLst>
           </p:cNvPr>
@@ -8013,7 +7188,7 @@
           <p:cNvPr id="20" name="">
             <a:extLst xmlns:a="http://schemas.openxmlformats.org/drawingml/2006/main">
               <a:ext uri="{FF2B5EF4-FFF2-40B4-BE49-F238E27FC236}">
-                <a16:creationId xmlns:a16="http://schemas.microsoft.com/office/drawing/2014/main" id="{9AC2A519-7A3A-4E77-A9FB-9D553398E797}"/>
+                <a16:creationId xmlns:a16="http://schemas.microsoft.com/office/drawing/2014/main" id="{C34D10FD-8383-4A98-996D-6193C626DC06}"/>
               </a:ext>
             </a:extLst>
           </p:cNvPr>
@@ -8081,7 +7256,7 @@
           <p:cNvPr id="21" name="">
             <a:extLst xmlns:a="http://schemas.openxmlformats.org/drawingml/2006/main">
               <a:ext uri="{FF2B5EF4-FFF2-40B4-BE49-F238E27FC236}">
-                <a16:creationId xmlns:a16="http://schemas.microsoft.com/office/drawing/2014/main" id="{9EAB77B3-B1B2-4FAF-99B3-C0050E8D7565}"/>
+                <a16:creationId xmlns:a16="http://schemas.microsoft.com/office/drawing/2014/main" id="{17154E91-31A1-467C-9854-816A7D04458E}"/>
               </a:ext>
             </a:extLst>
           </p:cNvPr>
@@ -8149,7 +7324,7 @@
           <p:cNvPr id="22" name="">
             <a:extLst xmlns:a="http://schemas.openxmlformats.org/drawingml/2006/main">
               <a:ext uri="{FF2B5EF4-FFF2-40B4-BE49-F238E27FC236}">
-                <a16:creationId xmlns:a16="http://schemas.microsoft.com/office/drawing/2014/main" id="{B4FECC2C-FEA9-4248-AF48-C14A091F8E01}"/>
+                <a16:creationId xmlns:a16="http://schemas.microsoft.com/office/drawing/2014/main" id="{B96BAAF9-0BE8-4BE5-B5E4-6579C2BAD340}"/>
               </a:ext>
             </a:extLst>
           </p:cNvPr>
@@ -8217,7 +7392,7 @@
           <p:cNvPr id="23" name="">
             <a:extLst xmlns:a="http://schemas.openxmlformats.org/drawingml/2006/main">
               <a:ext uri="{FF2B5EF4-FFF2-40B4-BE49-F238E27FC236}">
-                <a16:creationId xmlns:a16="http://schemas.microsoft.com/office/drawing/2014/main" id="{94D014AE-29AF-460F-B326-A86EEB281CC0}"/>
+                <a16:creationId xmlns:a16="http://schemas.microsoft.com/office/drawing/2014/main" id="{FE2FD9D9-0FE9-4963-BC1B-0E32D648BEA3}"/>
               </a:ext>
             </a:extLst>
           </p:cNvPr>
@@ -8285,7 +7460,7 @@
           <p:cNvPr id="24" name="">
             <a:extLst xmlns:a="http://schemas.openxmlformats.org/drawingml/2006/main">
               <a:ext uri="{FF2B5EF4-FFF2-40B4-BE49-F238E27FC236}">
-                <a16:creationId xmlns:a16="http://schemas.microsoft.com/office/drawing/2014/main" id="{8ED7B6D7-FD9B-421E-A15E-A9408C10B494}"/>
+                <a16:creationId xmlns:a16="http://schemas.microsoft.com/office/drawing/2014/main" id="{E3A0E869-8F91-4E5B-A377-0DA6410C6854}"/>
               </a:ext>
             </a:extLst>
           </p:cNvPr>
@@ -8353,7 +7528,7 @@
           <p:cNvPr id="25" name="">
             <a:extLst xmlns:a="http://schemas.openxmlformats.org/drawingml/2006/main">
               <a:ext uri="{FF2B5EF4-FFF2-40B4-BE49-F238E27FC236}">
-                <a16:creationId xmlns:a16="http://schemas.microsoft.com/office/drawing/2014/main" id="{A9F3F7E7-399A-4877-905C-89E01E948911}"/>
+                <a16:creationId xmlns:a16="http://schemas.microsoft.com/office/drawing/2014/main" id="{02FCDEE1-F359-482F-AEEC-B87EA9892C38}"/>
               </a:ext>
             </a:extLst>
           </p:cNvPr>
@@ -8421,7 +7596,7 @@
           <p:cNvPr id="26" name="">
             <a:extLst xmlns:a="http://schemas.openxmlformats.org/drawingml/2006/main">
               <a:ext uri="{FF2B5EF4-FFF2-40B4-BE49-F238E27FC236}">
-                <a16:creationId xmlns:a16="http://schemas.microsoft.com/office/drawing/2014/main" id="{D03352B4-A759-408A-B466-A24BAE948B0A}"/>
+                <a16:creationId xmlns:a16="http://schemas.microsoft.com/office/drawing/2014/main" id="{F695E841-C616-4144-95CE-ECAEB2E4A27D}"/>
               </a:ext>
             </a:extLst>
           </p:cNvPr>
@@ -8489,7 +7664,7 @@
           <p:cNvPr id="27" name="">
             <a:extLst xmlns:a="http://schemas.openxmlformats.org/drawingml/2006/main">
               <a:ext uri="{FF2B5EF4-FFF2-40B4-BE49-F238E27FC236}">
-                <a16:creationId xmlns:a16="http://schemas.microsoft.com/office/drawing/2014/main" id="{E39BA2D2-EE6F-4C9C-8B60-CCF3BB8E6FD2}"/>
+                <a16:creationId xmlns:a16="http://schemas.microsoft.com/office/drawing/2014/main" id="{7D5BCE21-B111-4371-91CE-45E03D8AC578}"/>
               </a:ext>
             </a:extLst>
           </p:cNvPr>
@@ -8555,7 +7730,7 @@
     </p:spTree>
     <p:extLst>
       <p:ext uri="{BB962C8B-B14F-4D97-AF65-F5344CB8AC3E}">
-        <p14:creationId xmlns:p14="http://schemas.microsoft.com/office/powerpoint/2010/main" val="1730114855"/>
+        <p14:creationId xmlns:p14="http://schemas.microsoft.com/office/powerpoint/2010/main" val="1966129995"/>
       </p:ext>
     </p:extLst>
   </p:cSld>
@@ -8586,7 +7761,7 @@
           <p:cNvPr id="14" name="">
             <a:extLst xmlns:a="http://schemas.openxmlformats.org/drawingml/2006/main">
               <a:ext uri="{FF2B5EF4-FFF2-40B4-BE49-F238E27FC236}">
-                <a16:creationId xmlns:a16="http://schemas.microsoft.com/office/drawing/2014/main" id="{9EDB460E-23BA-443B-B96C-78BAF57945A8}"/>
+                <a16:creationId xmlns:a16="http://schemas.microsoft.com/office/drawing/2014/main" id="{AE0A146D-503A-4F31-AE68-70C5C1126918}"/>
               </a:ext>
             </a:extLst>
           </p:cNvPr>
@@ -8654,7 +7829,7 @@
           <p:cNvPr id="2" name="">
             <a:extLst xmlns:a="http://schemas.openxmlformats.org/drawingml/2006/main">
               <a:ext uri="{FF2B5EF4-FFF2-40B4-BE49-F238E27FC236}">
-                <a16:creationId xmlns:a16="http://schemas.microsoft.com/office/drawing/2014/main" id="{2EA0FEBC-5F59-4461-A09C-1F475AA5CBC0}"/>
+                <a16:creationId xmlns:a16="http://schemas.microsoft.com/office/drawing/2014/main" id="{484739DC-00A7-487B-A6C0-3AEA5E1ED155}"/>
               </a:ext>
             </a:extLst>
           </p:cNvPr>
@@ -8664,7 +7839,7 @@
           <p:nvPr/>
         </p:nvPicPr>
         <p:blipFill>
-          <a:blip xmlns:r="http://schemas.openxmlformats.org/officeDocument/2006/relationships" xmlns:a="http://schemas.openxmlformats.org/drawingml/2006/main" r:embed="Rea2ca80944844ecd"/>
+          <a:blip xmlns:r="http://schemas.openxmlformats.org/officeDocument/2006/relationships" xmlns:a="http://schemas.openxmlformats.org/drawingml/2006/main" r:embed="R96e20ec8a92e4add"/>
           <a:stretch xmlns:a="http://schemas.openxmlformats.org/drawingml/2006/main"/>
         </p:blipFill>
         <p:spPr>
@@ -8682,7 +7857,7 @@
           <p:cNvPr id="3" name="">
             <a:extLst xmlns:a="http://schemas.openxmlformats.org/drawingml/2006/main">
               <a:ext uri="{FF2B5EF4-FFF2-40B4-BE49-F238E27FC236}">
-                <a16:creationId xmlns:a16="http://schemas.microsoft.com/office/drawing/2014/main" id="{738F9CDD-8B66-421F-A6CF-529744B0ED86}"/>
+                <a16:creationId xmlns:a16="http://schemas.microsoft.com/office/drawing/2014/main" id="{7E47CA90-ED40-4950-8277-78751164B326}"/>
               </a:ext>
             </a:extLst>
           </p:cNvPr>
@@ -8712,7 +7887,7 @@
           <p:cNvPr id="4" name="">
             <a:extLst xmlns:a="http://schemas.openxmlformats.org/drawingml/2006/main">
               <a:ext uri="{FF2B5EF4-FFF2-40B4-BE49-F238E27FC236}">
-                <a16:creationId xmlns:a16="http://schemas.microsoft.com/office/drawing/2014/main" id="{F51DB3B7-2788-469D-B235-9C8C55FF02AB}"/>
+                <a16:creationId xmlns:a16="http://schemas.microsoft.com/office/drawing/2014/main" id="{55BCAE30-5693-452A-A416-A88EB2BBC684}"/>
               </a:ext>
             </a:extLst>
           </p:cNvPr>
@@ -8780,7 +7955,7 @@
           <p:cNvPr id="5" name="">
             <a:extLst xmlns:a="http://schemas.openxmlformats.org/drawingml/2006/main">
               <a:ext uri="{FF2B5EF4-FFF2-40B4-BE49-F238E27FC236}">
-                <a16:creationId xmlns:a16="http://schemas.microsoft.com/office/drawing/2014/main" id="{E58A7C24-F914-4A26-817F-A0B26063C682}"/>
+                <a16:creationId xmlns:a16="http://schemas.microsoft.com/office/drawing/2014/main" id="{D6E1EE50-9784-4471-9B7D-21214CCCA662}"/>
               </a:ext>
             </a:extLst>
           </p:cNvPr>
@@ -8848,7 +8023,7 @@
           <p:cNvPr id="6" name="">
             <a:extLst xmlns:a="http://schemas.openxmlformats.org/drawingml/2006/main">
               <a:ext uri="{FF2B5EF4-FFF2-40B4-BE49-F238E27FC236}">
-                <a16:creationId xmlns:a16="http://schemas.microsoft.com/office/drawing/2014/main" id="{1D45C206-34D5-4D8E-A77D-32C41D4F9B3B}"/>
+                <a16:creationId xmlns:a16="http://schemas.microsoft.com/office/drawing/2014/main" id="{23B7C2C0-12E0-4906-98A5-D2755DBF7350}"/>
               </a:ext>
             </a:extLst>
           </p:cNvPr>
@@ -8916,7 +8091,7 @@
           <p:cNvPr id="7" name="">
             <a:extLst xmlns:a="http://schemas.openxmlformats.org/drawingml/2006/main">
               <a:ext uri="{FF2B5EF4-FFF2-40B4-BE49-F238E27FC236}">
-                <a16:creationId xmlns:a16="http://schemas.microsoft.com/office/drawing/2014/main" id="{EE35CD8F-25F0-44CA-9809-FC81679AA4F5}"/>
+                <a16:creationId xmlns:a16="http://schemas.microsoft.com/office/drawing/2014/main" id="{EE6F0B2E-0FA6-4F4D-8066-DB149A441CBA}"/>
               </a:ext>
             </a:extLst>
           </p:cNvPr>
@@ -8984,7 +8159,7 @@
           <p:cNvPr id="8" name="">
             <a:extLst xmlns:a="http://schemas.openxmlformats.org/drawingml/2006/main">
               <a:ext uri="{FF2B5EF4-FFF2-40B4-BE49-F238E27FC236}">
-                <a16:creationId xmlns:a16="http://schemas.microsoft.com/office/drawing/2014/main" id="{C0D3C98A-F440-4EEB-B3A5-7B82D1CC1E74}"/>
+                <a16:creationId xmlns:a16="http://schemas.microsoft.com/office/drawing/2014/main" id="{E93AC9BE-292C-4EE7-8D63-A38891BBCA76}"/>
               </a:ext>
             </a:extLst>
           </p:cNvPr>
@@ -9052,7 +8227,7 @@
           <p:cNvPr id="9" name="">
             <a:extLst xmlns:a="http://schemas.openxmlformats.org/drawingml/2006/main">
               <a:ext uri="{FF2B5EF4-FFF2-40B4-BE49-F238E27FC236}">
-                <a16:creationId xmlns:a16="http://schemas.microsoft.com/office/drawing/2014/main" id="{FBBD4AA2-CFC6-4241-9C37-E2247D01A59F}"/>
+                <a16:creationId xmlns:a16="http://schemas.microsoft.com/office/drawing/2014/main" id="{082DC61D-3EE4-41F1-A7B6-B966AC9970B6}"/>
               </a:ext>
             </a:extLst>
           </p:cNvPr>
@@ -9062,7 +8237,7 @@
           <p:nvPr/>
         </p:nvPicPr>
         <p:blipFill>
-          <a:blip xmlns:r="http://schemas.openxmlformats.org/officeDocument/2006/relationships" xmlns:a="http://schemas.openxmlformats.org/drawingml/2006/main" r:embed="R78d509a739164644"/>
+          <a:blip xmlns:r="http://schemas.openxmlformats.org/officeDocument/2006/relationships" xmlns:a="http://schemas.openxmlformats.org/drawingml/2006/main" r:embed="R5d4a048dc97f4179"/>
           <a:stretch xmlns:a="http://schemas.openxmlformats.org/drawingml/2006/main"/>
         </p:blipFill>
         <p:spPr>
@@ -9080,7 +8255,7 @@
           <p:cNvPr id="10" name="">
             <a:extLst xmlns:a="http://schemas.openxmlformats.org/drawingml/2006/main">
               <a:ext uri="{FF2B5EF4-FFF2-40B4-BE49-F238E27FC236}">
-                <a16:creationId xmlns:a16="http://schemas.microsoft.com/office/drawing/2014/main" id="{B96A5C54-A0CF-447F-99B7-F43F1D7B69D3}"/>
+                <a16:creationId xmlns:a16="http://schemas.microsoft.com/office/drawing/2014/main" id="{F8B9E43D-46D2-426E-BCE3-BF73563573BC}"/>
               </a:ext>
             </a:extLst>
           </p:cNvPr>
@@ -9148,7 +8323,7 @@
           <p:cNvPr id="11" name="">
             <a:extLst xmlns:a="http://schemas.openxmlformats.org/drawingml/2006/main">
               <a:ext uri="{FF2B5EF4-FFF2-40B4-BE49-F238E27FC236}">
-                <a16:creationId xmlns:a16="http://schemas.microsoft.com/office/drawing/2014/main" id="{3ADC01FD-BEA4-4537-97D0-598307F4CB90}"/>
+                <a16:creationId xmlns:a16="http://schemas.microsoft.com/office/drawing/2014/main" id="{2B023758-E83C-490B-B751-A77724DE7D3E}"/>
               </a:ext>
             </a:extLst>
           </p:cNvPr>
@@ -9216,7 +8391,7 @@
           <p:cNvPr id="12" name="">
             <a:extLst xmlns:a="http://schemas.openxmlformats.org/drawingml/2006/main">
               <a:ext uri="{FF2B5EF4-FFF2-40B4-BE49-F238E27FC236}">
-                <a16:creationId xmlns:a16="http://schemas.microsoft.com/office/drawing/2014/main" id="{74B6B796-B7E7-4C71-AB03-8F6145B0FCD1}"/>
+                <a16:creationId xmlns:a16="http://schemas.microsoft.com/office/drawing/2014/main" id="{0837B190-E5B9-4799-BBE9-8A3C338EEFE3}"/>
               </a:ext>
             </a:extLst>
           </p:cNvPr>
@@ -9284,7 +8459,7 @@
           <p:cNvPr id="13" name="">
             <a:extLst xmlns:a="http://schemas.openxmlformats.org/drawingml/2006/main">
               <a:ext uri="{FF2B5EF4-FFF2-40B4-BE49-F238E27FC236}">
-                <a16:creationId xmlns:a16="http://schemas.microsoft.com/office/drawing/2014/main" id="{81040C28-C012-4F6F-BA63-E70D4A98BD15}"/>
+                <a16:creationId xmlns:a16="http://schemas.microsoft.com/office/drawing/2014/main" id="{E7E0A851-AE81-4B5B-AF67-8F1C85E64439}"/>
               </a:ext>
             </a:extLst>
           </p:cNvPr>
@@ -9350,7 +8525,7 @@
     </p:spTree>
     <p:extLst>
       <p:ext uri="{BB962C8B-B14F-4D97-AF65-F5344CB8AC3E}">
-        <p14:creationId xmlns:p14="http://schemas.microsoft.com/office/powerpoint/2010/main" val="419368492"/>
+        <p14:creationId xmlns:p14="http://schemas.microsoft.com/office/powerpoint/2010/main" val="2072865134"/>
       </p:ext>
     </p:extLst>
   </p:cSld>
@@ -9381,7 +8556,7 @@
           <p:cNvPr id="27" name="">
             <a:extLst xmlns:a="http://schemas.openxmlformats.org/drawingml/2006/main">
               <a:ext uri="{FF2B5EF4-FFF2-40B4-BE49-F238E27FC236}">
-                <a16:creationId xmlns:a16="http://schemas.microsoft.com/office/drawing/2014/main" id="{A9F3087A-EBF5-42E9-9E42-0A55CD71A0BC}"/>
+                <a16:creationId xmlns:a16="http://schemas.microsoft.com/office/drawing/2014/main" id="{20DABB0F-1054-45FE-A386-ABC8943C0834}"/>
               </a:ext>
             </a:extLst>
           </p:cNvPr>
@@ -9449,7 +8624,7 @@
           <p:cNvPr id="2" name="">
             <a:extLst xmlns:a="http://schemas.openxmlformats.org/drawingml/2006/main">
               <a:ext uri="{FF2B5EF4-FFF2-40B4-BE49-F238E27FC236}">
-                <a16:creationId xmlns:a16="http://schemas.microsoft.com/office/drawing/2014/main" id="{46301F1F-963C-4CE6-A2AB-C4A62814BED0}"/>
+                <a16:creationId xmlns:a16="http://schemas.microsoft.com/office/drawing/2014/main" id="{E7807610-0E65-42A7-9E81-20B4FF953D40}"/>
               </a:ext>
             </a:extLst>
           </p:cNvPr>
@@ -9459,7 +8634,7 @@
           <p:nvPr/>
         </p:nvPicPr>
         <p:blipFill>
-          <a:blip xmlns:r="http://schemas.openxmlformats.org/officeDocument/2006/relationships" xmlns:a="http://schemas.openxmlformats.org/drawingml/2006/main" r:embed="Rbba9081c54554a87"/>
+          <a:blip xmlns:r="http://schemas.openxmlformats.org/officeDocument/2006/relationships" xmlns:a="http://schemas.openxmlformats.org/drawingml/2006/main" r:embed="R201f43f578034ad9"/>
           <a:stretch xmlns:a="http://schemas.openxmlformats.org/drawingml/2006/main"/>
         </p:blipFill>
         <p:spPr>
@@ -9477,7 +8652,7 @@
           <p:cNvPr id="3" name="">
             <a:extLst xmlns:a="http://schemas.openxmlformats.org/drawingml/2006/main">
               <a:ext uri="{FF2B5EF4-FFF2-40B4-BE49-F238E27FC236}">
-                <a16:creationId xmlns:a16="http://schemas.microsoft.com/office/drawing/2014/main" id="{045A961E-F221-4535-BC45-41002EA1E1CB}"/>
+                <a16:creationId xmlns:a16="http://schemas.microsoft.com/office/drawing/2014/main" id="{7B677DDC-589B-4034-A322-3B5E3B85C018}"/>
               </a:ext>
             </a:extLst>
           </p:cNvPr>
@@ -9507,7 +8682,7 @@
           <p:cNvPr id="4" name="">
             <a:extLst xmlns:a="http://schemas.openxmlformats.org/drawingml/2006/main">
               <a:ext uri="{FF2B5EF4-FFF2-40B4-BE49-F238E27FC236}">
-                <a16:creationId xmlns:a16="http://schemas.microsoft.com/office/drawing/2014/main" id="{C41B0539-B458-4A20-AFF0-8D10422DA087}"/>
+                <a16:creationId xmlns:a16="http://schemas.microsoft.com/office/drawing/2014/main" id="{D8A320B2-90C1-4B84-9C35-F4E391B70126}"/>
               </a:ext>
             </a:extLst>
           </p:cNvPr>
@@ -9575,7 +8750,7 @@
           <p:cNvPr id="5" name="">
             <a:extLst xmlns:a="http://schemas.openxmlformats.org/drawingml/2006/main">
               <a:ext uri="{FF2B5EF4-FFF2-40B4-BE49-F238E27FC236}">
-                <a16:creationId xmlns:a16="http://schemas.microsoft.com/office/drawing/2014/main" id="{7E3A240D-085A-4C5F-AA84-D67CAC23A35C}"/>
+                <a16:creationId xmlns:a16="http://schemas.microsoft.com/office/drawing/2014/main" id="{4640AA00-E6CB-47E0-BD77-14062B03B7C7}"/>
               </a:ext>
             </a:extLst>
           </p:cNvPr>
@@ -9643,7 +8818,7 @@
           <p:cNvPr id="6" name="">
             <a:extLst xmlns:a="http://schemas.openxmlformats.org/drawingml/2006/main">
               <a:ext uri="{FF2B5EF4-FFF2-40B4-BE49-F238E27FC236}">
-                <a16:creationId xmlns:a16="http://schemas.microsoft.com/office/drawing/2014/main" id="{E0C2E65A-7BA5-4576-8DC9-BA372DA66CE6}"/>
+                <a16:creationId xmlns:a16="http://schemas.microsoft.com/office/drawing/2014/main" id="{86CF7857-3E02-4FCB-89C0-FCF5E0F2F730}"/>
               </a:ext>
             </a:extLst>
           </p:cNvPr>
@@ -9711,7 +8886,7 @@
           <p:cNvPr id="7" name="">
             <a:extLst xmlns:a="http://schemas.openxmlformats.org/drawingml/2006/main">
               <a:ext uri="{FF2B5EF4-FFF2-40B4-BE49-F238E27FC236}">
-                <a16:creationId xmlns:a16="http://schemas.microsoft.com/office/drawing/2014/main" id="{E644C3B5-1827-464D-993D-30EED6A96D34}"/>
+                <a16:creationId xmlns:a16="http://schemas.microsoft.com/office/drawing/2014/main" id="{5604620F-CFE5-478D-8C6F-B3CD506D6805}"/>
               </a:ext>
             </a:extLst>
           </p:cNvPr>
@@ -9779,7 +8954,7 @@
           <p:cNvPr id="8" name="">
             <a:extLst xmlns:a="http://schemas.openxmlformats.org/drawingml/2006/main">
               <a:ext uri="{FF2B5EF4-FFF2-40B4-BE49-F238E27FC236}">
-                <a16:creationId xmlns:a16="http://schemas.microsoft.com/office/drawing/2014/main" id="{7CF20F5C-40B4-4F99-963C-2F1C36FDF99A}"/>
+                <a16:creationId xmlns:a16="http://schemas.microsoft.com/office/drawing/2014/main" id="{64F5D4A1-E721-416F-AD2E-2362F1783F71}"/>
               </a:ext>
             </a:extLst>
           </p:cNvPr>
@@ -9847,7 +9022,7 @@
           <p:cNvPr id="9" name="">
             <a:extLst xmlns:a="http://schemas.openxmlformats.org/drawingml/2006/main">
               <a:ext uri="{FF2B5EF4-FFF2-40B4-BE49-F238E27FC236}">
-                <a16:creationId xmlns:a16="http://schemas.microsoft.com/office/drawing/2014/main" id="{9910DA49-BC08-4C81-AC67-486706D2FB35}"/>
+                <a16:creationId xmlns:a16="http://schemas.microsoft.com/office/drawing/2014/main" id="{51B2AD54-830B-44D0-BD3E-21A1ED60F75D}"/>
               </a:ext>
             </a:extLst>
           </p:cNvPr>
@@ -9915,7 +9090,7 @@
           <p:cNvPr id="10" name="">
             <a:extLst xmlns:a="http://schemas.openxmlformats.org/drawingml/2006/main">
               <a:ext uri="{FF2B5EF4-FFF2-40B4-BE49-F238E27FC236}">
-                <a16:creationId xmlns:a16="http://schemas.microsoft.com/office/drawing/2014/main" id="{E96DD434-C599-4ECC-A6F0-EF89A7B6494D}"/>
+                <a16:creationId xmlns:a16="http://schemas.microsoft.com/office/drawing/2014/main" id="{00226C23-A2A2-4D43-BB1F-30B0EB799570}"/>
               </a:ext>
             </a:extLst>
           </p:cNvPr>
@@ -9983,7 +9158,7 @@
           <p:cNvPr id="11" name="">
             <a:extLst xmlns:a="http://schemas.openxmlformats.org/drawingml/2006/main">
               <a:ext uri="{FF2B5EF4-FFF2-40B4-BE49-F238E27FC236}">
-                <a16:creationId xmlns:a16="http://schemas.microsoft.com/office/drawing/2014/main" id="{52E34FC9-6886-43E5-A29F-389FFAA0EDAD}"/>
+                <a16:creationId xmlns:a16="http://schemas.microsoft.com/office/drawing/2014/main" id="{FA98C101-7FC2-427F-95D6-02B35DDEC59D}"/>
               </a:ext>
             </a:extLst>
           </p:cNvPr>
@@ -10051,7 +9226,7 @@
           <p:cNvPr id="12" name="">
             <a:extLst xmlns:a="http://schemas.openxmlformats.org/drawingml/2006/main">
               <a:ext uri="{FF2B5EF4-FFF2-40B4-BE49-F238E27FC236}">
-                <a16:creationId xmlns:a16="http://schemas.microsoft.com/office/drawing/2014/main" id="{62FDFA93-057A-4347-849F-4D0600AFDD23}"/>
+                <a16:creationId xmlns:a16="http://schemas.microsoft.com/office/drawing/2014/main" id="{276927AC-694D-4CBA-973C-F2A7CEF5B39E}"/>
               </a:ext>
             </a:extLst>
           </p:cNvPr>
@@ -10119,7 +9294,7 @@
           <p:cNvPr id="13" name="">
             <a:extLst xmlns:a="http://schemas.openxmlformats.org/drawingml/2006/main">
               <a:ext uri="{FF2B5EF4-FFF2-40B4-BE49-F238E27FC236}">
-                <a16:creationId xmlns:a16="http://schemas.microsoft.com/office/drawing/2014/main" id="{A7AC09BC-04B9-4559-8F5A-1ADDEE7BD031}"/>
+                <a16:creationId xmlns:a16="http://schemas.microsoft.com/office/drawing/2014/main" id="{07568F18-9FB0-48DE-A8C0-19DCF7E641EE}"/>
               </a:ext>
             </a:extLst>
           </p:cNvPr>
@@ -10149,7 +9324,7 @@
           <p:cNvPr id="14" name="">
             <a:extLst xmlns:a="http://schemas.openxmlformats.org/drawingml/2006/main">
               <a:ext uri="{FF2B5EF4-FFF2-40B4-BE49-F238E27FC236}">
-                <a16:creationId xmlns:a16="http://schemas.microsoft.com/office/drawing/2014/main" id="{0274EF11-E764-4DBC-A248-59782E0A5DFA}"/>
+                <a16:creationId xmlns:a16="http://schemas.microsoft.com/office/drawing/2014/main" id="{6CE17CEB-463E-4964-B13D-567D08F4B1D5}"/>
               </a:ext>
             </a:extLst>
           </p:cNvPr>
@@ -10217,7 +9392,7 @@
           <p:cNvPr id="15" name="">
             <a:extLst xmlns:a="http://schemas.openxmlformats.org/drawingml/2006/main">
               <a:ext uri="{FF2B5EF4-FFF2-40B4-BE49-F238E27FC236}">
-                <a16:creationId xmlns:a16="http://schemas.microsoft.com/office/drawing/2014/main" id="{D646AFB0-748F-4818-A5DA-0AC1C64A9B02}"/>
+                <a16:creationId xmlns:a16="http://schemas.microsoft.com/office/drawing/2014/main" id="{DB766E4B-FBC9-4F8E-A34C-6BF34CEE59F4}"/>
               </a:ext>
             </a:extLst>
           </p:cNvPr>
@@ -10285,7 +9460,7 @@
           <p:cNvPr id="16" name="">
             <a:extLst xmlns:a="http://schemas.openxmlformats.org/drawingml/2006/main">
               <a:ext uri="{FF2B5EF4-FFF2-40B4-BE49-F238E27FC236}">
-                <a16:creationId xmlns:a16="http://schemas.microsoft.com/office/drawing/2014/main" id="{4572127D-5224-4988-81EC-F464098C6B48}"/>
+                <a16:creationId xmlns:a16="http://schemas.microsoft.com/office/drawing/2014/main" id="{9D4572E4-C0D4-47B0-88BD-D6965D830833}"/>
               </a:ext>
             </a:extLst>
           </p:cNvPr>
@@ -10353,7 +9528,7 @@
           <p:cNvPr id="17" name="">
             <a:extLst xmlns:a="http://schemas.openxmlformats.org/drawingml/2006/main">
               <a:ext uri="{FF2B5EF4-FFF2-40B4-BE49-F238E27FC236}">
-                <a16:creationId xmlns:a16="http://schemas.microsoft.com/office/drawing/2014/main" id="{D8885DF0-7083-4683-8DDB-36E4D7831D42}"/>
+                <a16:creationId xmlns:a16="http://schemas.microsoft.com/office/drawing/2014/main" id="{B4D0E842-F06A-4300-96E9-999D4A3CD75F}"/>
               </a:ext>
             </a:extLst>
           </p:cNvPr>
@@ -10421,7 +9596,7 @@
           <p:cNvPr id="18" name="">
             <a:extLst xmlns:a="http://schemas.openxmlformats.org/drawingml/2006/main">
               <a:ext uri="{FF2B5EF4-FFF2-40B4-BE49-F238E27FC236}">
-                <a16:creationId xmlns:a16="http://schemas.microsoft.com/office/drawing/2014/main" id="{8E70D519-64A3-4420-8763-EC075D8C8742}"/>
+                <a16:creationId xmlns:a16="http://schemas.microsoft.com/office/drawing/2014/main" id="{78DBC677-5B2C-4C23-AEB1-64EEADB4C896}"/>
               </a:ext>
             </a:extLst>
           </p:cNvPr>
@@ -10489,7 +9664,7 @@
           <p:cNvPr id="19" name="">
             <a:extLst xmlns:a="http://schemas.openxmlformats.org/drawingml/2006/main">
               <a:ext uri="{FF2B5EF4-FFF2-40B4-BE49-F238E27FC236}">
-                <a16:creationId xmlns:a16="http://schemas.microsoft.com/office/drawing/2014/main" id="{8348EAC8-A711-45FA-8D95-F16FEA685E1E}"/>
+                <a16:creationId xmlns:a16="http://schemas.microsoft.com/office/drawing/2014/main" id="{DF7AA688-6CDE-481A-990A-3393D19B2F7C}"/>
               </a:ext>
             </a:extLst>
           </p:cNvPr>
@@ -10557,7 +9732,7 @@
           <p:cNvPr id="20" name="">
             <a:extLst xmlns:a="http://schemas.openxmlformats.org/drawingml/2006/main">
               <a:ext uri="{FF2B5EF4-FFF2-40B4-BE49-F238E27FC236}">
-                <a16:creationId xmlns:a16="http://schemas.microsoft.com/office/drawing/2014/main" id="{6F8C8ECC-E7D2-4AE6-BA76-773FDD53EC75}"/>
+                <a16:creationId xmlns:a16="http://schemas.microsoft.com/office/drawing/2014/main" id="{A2792210-B62C-4F9B-B391-3BD025C6AF3B}"/>
               </a:ext>
             </a:extLst>
           </p:cNvPr>
@@ -10625,7 +9800,7 @@
           <p:cNvPr id="21" name="">
             <a:extLst xmlns:a="http://schemas.openxmlformats.org/drawingml/2006/main">
               <a:ext uri="{FF2B5EF4-FFF2-40B4-BE49-F238E27FC236}">
-                <a16:creationId xmlns:a16="http://schemas.microsoft.com/office/drawing/2014/main" id="{9DFE3FAA-6786-46D1-A152-6DB09E894A80}"/>
+                <a16:creationId xmlns:a16="http://schemas.microsoft.com/office/drawing/2014/main" id="{955F5D27-90E1-4C2C-B669-77650748EEEE}"/>
               </a:ext>
             </a:extLst>
           </p:cNvPr>
@@ -10693,7 +9868,7 @@
           <p:cNvPr id="22" name="">
             <a:extLst xmlns:a="http://schemas.openxmlformats.org/drawingml/2006/main">
               <a:ext uri="{FF2B5EF4-FFF2-40B4-BE49-F238E27FC236}">
-                <a16:creationId xmlns:a16="http://schemas.microsoft.com/office/drawing/2014/main" id="{4EE96B60-A34A-4F28-9930-59938805EA7B}"/>
+                <a16:creationId xmlns:a16="http://schemas.microsoft.com/office/drawing/2014/main" id="{FF3286E7-AC0F-4E3E-9B5B-901E9D16E122}"/>
               </a:ext>
             </a:extLst>
           </p:cNvPr>
@@ -10761,7 +9936,7 @@
           <p:cNvPr id="23" name="">
             <a:extLst xmlns:a="http://schemas.openxmlformats.org/drawingml/2006/main">
               <a:ext uri="{FF2B5EF4-FFF2-40B4-BE49-F238E27FC236}">
-                <a16:creationId xmlns:a16="http://schemas.microsoft.com/office/drawing/2014/main" id="{C3C3EDF9-26AF-437C-99EF-CEDC79F07F8B}"/>
+                <a16:creationId xmlns:a16="http://schemas.microsoft.com/office/drawing/2014/main" id="{367D45AB-E605-4CF6-97AC-CFD785154BF7}"/>
               </a:ext>
             </a:extLst>
           </p:cNvPr>
@@ -10829,7 +10004,7 @@
           <p:cNvPr id="24" name="">
             <a:extLst xmlns:a="http://schemas.openxmlformats.org/drawingml/2006/main">
               <a:ext uri="{FF2B5EF4-FFF2-40B4-BE49-F238E27FC236}">
-                <a16:creationId xmlns:a16="http://schemas.microsoft.com/office/drawing/2014/main" id="{B2892F91-C133-4502-9E75-EF0A6426979F}"/>
+                <a16:creationId xmlns:a16="http://schemas.microsoft.com/office/drawing/2014/main" id="{13A55BF0-3D99-4B32-A17F-932300492597}"/>
               </a:ext>
             </a:extLst>
           </p:cNvPr>
@@ -10897,7 +10072,7 @@
           <p:cNvPr id="25" name="">
             <a:extLst xmlns:a="http://schemas.openxmlformats.org/drawingml/2006/main">
               <a:ext uri="{FF2B5EF4-FFF2-40B4-BE49-F238E27FC236}">
-                <a16:creationId xmlns:a16="http://schemas.microsoft.com/office/drawing/2014/main" id="{033DF740-109A-4633-887E-C589301DC08E}"/>
+                <a16:creationId xmlns:a16="http://schemas.microsoft.com/office/drawing/2014/main" id="{F8F2EACC-ABF7-405F-884A-2B6DEDBD83ED}"/>
               </a:ext>
             </a:extLst>
           </p:cNvPr>
@@ -10965,7 +10140,7 @@
           <p:cNvPr id="26" name="">
             <a:extLst xmlns:a="http://schemas.openxmlformats.org/drawingml/2006/main">
               <a:ext uri="{FF2B5EF4-FFF2-40B4-BE49-F238E27FC236}">
-                <a16:creationId xmlns:a16="http://schemas.microsoft.com/office/drawing/2014/main" id="{7B7FEAD0-9BB7-4087-9437-BC1B1BEEA4EE}"/>
+                <a16:creationId xmlns:a16="http://schemas.microsoft.com/office/drawing/2014/main" id="{38EA73F5-AD5F-44F7-968F-88A7FBB26ABA}"/>
               </a:ext>
             </a:extLst>
           </p:cNvPr>
@@ -11031,7 +10206,7 @@
     </p:spTree>
     <p:extLst>
       <p:ext uri="{BB962C8B-B14F-4D97-AF65-F5344CB8AC3E}">
-        <p14:creationId xmlns:p14="http://schemas.microsoft.com/office/powerpoint/2010/main" val="161805036"/>
+        <p14:creationId xmlns:p14="http://schemas.microsoft.com/office/powerpoint/2010/main" val="1286080387"/>
       </p:ext>
     </p:extLst>
   </p:cSld>
@@ -11062,7 +10237,7 @@
           <p:cNvPr id="7" name="">
             <a:extLst xmlns:a="http://schemas.openxmlformats.org/drawingml/2006/main">
               <a:ext uri="{FF2B5EF4-FFF2-40B4-BE49-F238E27FC236}">
-                <a16:creationId xmlns:a16="http://schemas.microsoft.com/office/drawing/2014/main" id="{871F1DC7-0711-4FD8-8222-E755C521248E}"/>
+                <a16:creationId xmlns:a16="http://schemas.microsoft.com/office/drawing/2014/main" id="{A2A7FABA-BADA-4509-B3DC-C94031DEDA99}"/>
               </a:ext>
             </a:extLst>
           </p:cNvPr>
@@ -11130,7 +10305,7 @@
           <p:cNvPr id="2" name="">
             <a:extLst xmlns:a="http://schemas.openxmlformats.org/drawingml/2006/main">
               <a:ext uri="{FF2B5EF4-FFF2-40B4-BE49-F238E27FC236}">
-                <a16:creationId xmlns:a16="http://schemas.microsoft.com/office/drawing/2014/main" id="{83E559EE-89AD-4476-8EE1-B2180305B0FA}"/>
+                <a16:creationId xmlns:a16="http://schemas.microsoft.com/office/drawing/2014/main" id="{2D62A64F-C44C-4E0B-B772-0A923CF86E94}"/>
               </a:ext>
             </a:extLst>
           </p:cNvPr>
@@ -11198,7 +10373,7 @@
           <p:cNvPr id="3" name="">
             <a:extLst xmlns:a="http://schemas.openxmlformats.org/drawingml/2006/main">
               <a:ext uri="{FF2B5EF4-FFF2-40B4-BE49-F238E27FC236}">
-                <a16:creationId xmlns:a16="http://schemas.microsoft.com/office/drawing/2014/main" id="{92E8407A-0E67-44DC-8298-5ABD475938D9}"/>
+                <a16:creationId xmlns:a16="http://schemas.microsoft.com/office/drawing/2014/main" id="{D2304E05-3E13-470B-A72B-F1A8C208A58E}"/>
               </a:ext>
             </a:extLst>
           </p:cNvPr>
@@ -11208,7 +10383,7 @@
           <p:nvPr/>
         </p:nvPicPr>
         <p:blipFill>
-          <a:blip xmlns:r="http://schemas.openxmlformats.org/officeDocument/2006/relationships" xmlns:a="http://schemas.openxmlformats.org/drawingml/2006/main" r:embed="R82245ccac42848b4"/>
+          <a:blip xmlns:r="http://schemas.openxmlformats.org/officeDocument/2006/relationships" xmlns:a="http://schemas.openxmlformats.org/drawingml/2006/main" r:embed="R4eb85cda61de4076"/>
           <a:stretch xmlns:a="http://schemas.openxmlformats.org/drawingml/2006/main"/>
         </p:blipFill>
         <p:spPr>
@@ -11226,7 +10401,7 @@
           <p:cNvPr id="4" name="">
             <a:extLst xmlns:a="http://schemas.openxmlformats.org/drawingml/2006/main">
               <a:ext uri="{FF2B5EF4-FFF2-40B4-BE49-F238E27FC236}">
-                <a16:creationId xmlns:a16="http://schemas.microsoft.com/office/drawing/2014/main" id="{442BCE9A-4E69-4BA2-98A7-705C5956A18A}"/>
+                <a16:creationId xmlns:a16="http://schemas.microsoft.com/office/drawing/2014/main" id="{6A52B39B-6D6F-4A8F-A449-E80F80D0D9FF}"/>
               </a:ext>
             </a:extLst>
           </p:cNvPr>
@@ -11256,7 +10431,7 @@
           <p:cNvPr id="5" name="">
             <a:extLst xmlns:a="http://schemas.openxmlformats.org/drawingml/2006/main">
               <a:ext uri="{FF2B5EF4-FFF2-40B4-BE49-F238E27FC236}">
-                <a16:creationId xmlns:a16="http://schemas.microsoft.com/office/drawing/2014/main" id="{118997D5-4AB6-4172-8A7B-1F37BCF98B64}"/>
+                <a16:creationId xmlns:a16="http://schemas.microsoft.com/office/drawing/2014/main" id="{5B52C28A-87EB-4A6F-A3B7-9F2263FDEAF2}"/>
               </a:ext>
             </a:extLst>
           </p:cNvPr>
@@ -11324,7 +10499,7 @@
           <p:cNvPr id="6" name="">
             <a:extLst xmlns:a="http://schemas.openxmlformats.org/drawingml/2006/main">
               <a:ext uri="{FF2B5EF4-FFF2-40B4-BE49-F238E27FC236}">
-                <a16:creationId xmlns:a16="http://schemas.microsoft.com/office/drawing/2014/main" id="{C9D78242-349D-45E8-BDF6-E930311E9A50}"/>
+                <a16:creationId xmlns:a16="http://schemas.microsoft.com/office/drawing/2014/main" id="{11F62AE3-8968-4D56-B397-3034DAA8FF39}"/>
               </a:ext>
             </a:extLst>
           </p:cNvPr>
@@ -11390,7 +10565,7 @@
     </p:spTree>
     <p:extLst>
       <p:ext uri="{BB962C8B-B14F-4D97-AF65-F5344CB8AC3E}">
-        <p14:creationId xmlns:p14="http://schemas.microsoft.com/office/powerpoint/2010/main" val="964826449"/>
+        <p14:creationId xmlns:p14="http://schemas.microsoft.com/office/powerpoint/2010/main" val="942930205"/>
       </p:ext>
     </p:extLst>
   </p:cSld>
@@ -11421,7 +10596,7 @@
           <p:cNvPr id="7" name="">
             <a:extLst xmlns:a="http://schemas.openxmlformats.org/drawingml/2006/main">
               <a:ext uri="{FF2B5EF4-FFF2-40B4-BE49-F238E27FC236}">
-                <a16:creationId xmlns:a16="http://schemas.microsoft.com/office/drawing/2014/main" id="{2C8D0742-AD12-4E59-A4AC-F5DCE09CCABD}"/>
+                <a16:creationId xmlns:a16="http://schemas.microsoft.com/office/drawing/2014/main" id="{D75C4A1C-9E17-46C3-90F0-FD14B2AD733B}"/>
               </a:ext>
             </a:extLst>
           </p:cNvPr>
@@ -11489,7 +10664,7 @@
           <p:cNvPr id="2" name="">
             <a:extLst xmlns:a="http://schemas.openxmlformats.org/drawingml/2006/main">
               <a:ext uri="{FF2B5EF4-FFF2-40B4-BE49-F238E27FC236}">
-                <a16:creationId xmlns:a16="http://schemas.microsoft.com/office/drawing/2014/main" id="{341A5E4A-0A7B-406A-B212-4994C49CAD29}"/>
+                <a16:creationId xmlns:a16="http://schemas.microsoft.com/office/drawing/2014/main" id="{A53AA946-BBC0-4830-931C-7B052E4784CD}"/>
               </a:ext>
             </a:extLst>
           </p:cNvPr>
@@ -11557,7 +10732,7 @@
           <p:cNvPr id="3" name="">
             <a:extLst xmlns:a="http://schemas.openxmlformats.org/drawingml/2006/main">
               <a:ext uri="{FF2B5EF4-FFF2-40B4-BE49-F238E27FC236}">
-                <a16:creationId xmlns:a16="http://schemas.microsoft.com/office/drawing/2014/main" id="{637E1D12-415C-49EA-8564-DE54F21B58FC}"/>
+                <a16:creationId xmlns:a16="http://schemas.microsoft.com/office/drawing/2014/main" id="{E78FA552-0D12-4D73-B734-F204F76DB6C3}"/>
               </a:ext>
             </a:extLst>
           </p:cNvPr>
@@ -11567,7 +10742,7 @@
           <p:nvPr/>
         </p:nvPicPr>
         <p:blipFill>
-          <a:blip xmlns:r="http://schemas.openxmlformats.org/officeDocument/2006/relationships" xmlns:a="http://schemas.openxmlformats.org/drawingml/2006/main" r:embed="R7361408f9a654f87"/>
+          <a:blip xmlns:r="http://schemas.openxmlformats.org/officeDocument/2006/relationships" xmlns:a="http://schemas.openxmlformats.org/drawingml/2006/main" r:embed="R681c88229aad4e76"/>
           <a:stretch xmlns:a="http://schemas.openxmlformats.org/drawingml/2006/main"/>
         </p:blipFill>
         <p:spPr>
@@ -11585,7 +10760,7 @@
           <p:cNvPr id="4" name="">
             <a:extLst xmlns:a="http://schemas.openxmlformats.org/drawingml/2006/main">
               <a:ext uri="{FF2B5EF4-FFF2-40B4-BE49-F238E27FC236}">
-                <a16:creationId xmlns:a16="http://schemas.microsoft.com/office/drawing/2014/main" id="{9C10178B-BE7E-49E8-A596-21D046CEBBFC}"/>
+                <a16:creationId xmlns:a16="http://schemas.microsoft.com/office/drawing/2014/main" id="{167E2704-524A-4519-86EA-B0AF2F4581B5}"/>
               </a:ext>
             </a:extLst>
           </p:cNvPr>
@@ -11615,7 +10790,7 @@
           <p:cNvPr id="5" name="">
             <a:extLst xmlns:a="http://schemas.openxmlformats.org/drawingml/2006/main">
               <a:ext uri="{FF2B5EF4-FFF2-40B4-BE49-F238E27FC236}">
-                <a16:creationId xmlns:a16="http://schemas.microsoft.com/office/drawing/2014/main" id="{417CB957-964D-40E8-9861-358265BEE2CB}"/>
+                <a16:creationId xmlns:a16="http://schemas.microsoft.com/office/drawing/2014/main" id="{139E30B7-0B8D-4E94-A8A8-C386EB70A4AF}"/>
               </a:ext>
             </a:extLst>
           </p:cNvPr>
@@ -11683,7 +10858,7 @@
           <p:cNvPr id="6" name="">
             <a:extLst xmlns:a="http://schemas.openxmlformats.org/drawingml/2006/main">
               <a:ext uri="{FF2B5EF4-FFF2-40B4-BE49-F238E27FC236}">
-                <a16:creationId xmlns:a16="http://schemas.microsoft.com/office/drawing/2014/main" id="{D6E9E2F8-813D-463B-971B-74CBBD6E0B5B}"/>
+                <a16:creationId xmlns:a16="http://schemas.microsoft.com/office/drawing/2014/main" id="{2957890D-AD50-4574-BE39-6F86CC98F092}"/>
               </a:ext>
             </a:extLst>
           </p:cNvPr>
@@ -11749,7 +10924,7 @@
     </p:spTree>
     <p:extLst>
       <p:ext uri="{BB962C8B-B14F-4D97-AF65-F5344CB8AC3E}">
-        <p14:creationId xmlns:p14="http://schemas.microsoft.com/office/powerpoint/2010/main" val="562962979"/>
+        <p14:creationId xmlns:p14="http://schemas.microsoft.com/office/powerpoint/2010/main" val="2103642898"/>
       </p:ext>
     </p:extLst>
   </p:cSld>
@@ -11780,7 +10955,7 @@
           <p:cNvPr id="7" name="">
             <a:extLst xmlns:a="http://schemas.openxmlformats.org/drawingml/2006/main">
               <a:ext uri="{FF2B5EF4-FFF2-40B4-BE49-F238E27FC236}">
-                <a16:creationId xmlns:a16="http://schemas.microsoft.com/office/drawing/2014/main" id="{BDCB4C41-E973-4B04-82A8-7E787910F437}"/>
+                <a16:creationId xmlns:a16="http://schemas.microsoft.com/office/drawing/2014/main" id="{611730C1-D488-419D-BB89-9C3D8A1E686E}"/>
               </a:ext>
             </a:extLst>
           </p:cNvPr>
@@ -11848,7 +11023,7 @@
           <p:cNvPr id="2" name="">
             <a:extLst xmlns:a="http://schemas.openxmlformats.org/drawingml/2006/main">
               <a:ext uri="{FF2B5EF4-FFF2-40B4-BE49-F238E27FC236}">
-                <a16:creationId xmlns:a16="http://schemas.microsoft.com/office/drawing/2014/main" id="{D6483EEA-D620-4C0E-973B-714571A4DAD8}"/>
+                <a16:creationId xmlns:a16="http://schemas.microsoft.com/office/drawing/2014/main" id="{55D586EF-8F22-46B6-AD28-CD61D1AF4F02}"/>
               </a:ext>
             </a:extLst>
           </p:cNvPr>
@@ -11916,7 +11091,7 @@
           <p:cNvPr id="3" name="">
             <a:extLst xmlns:a="http://schemas.openxmlformats.org/drawingml/2006/main">
               <a:ext uri="{FF2B5EF4-FFF2-40B4-BE49-F238E27FC236}">
-                <a16:creationId xmlns:a16="http://schemas.microsoft.com/office/drawing/2014/main" id="{8C621C21-92D0-4AF3-AEFE-32A680B94CFC}"/>
+                <a16:creationId xmlns:a16="http://schemas.microsoft.com/office/drawing/2014/main" id="{F4E5B5F0-DECA-4810-996D-7B8355020243}"/>
               </a:ext>
             </a:extLst>
           </p:cNvPr>
@@ -11926,7 +11101,7 @@
           <p:nvPr/>
         </p:nvPicPr>
         <p:blipFill>
-          <a:blip xmlns:r="http://schemas.openxmlformats.org/officeDocument/2006/relationships" xmlns:a="http://schemas.openxmlformats.org/drawingml/2006/main" r:embed="Rf84f5926fd584d12"/>
+          <a:blip xmlns:r="http://schemas.openxmlformats.org/officeDocument/2006/relationships" xmlns:a="http://schemas.openxmlformats.org/drawingml/2006/main" r:embed="Rc2441ce8996540fe"/>
           <a:stretch xmlns:a="http://schemas.openxmlformats.org/drawingml/2006/main"/>
         </p:blipFill>
         <p:spPr>
@@ -11944,7 +11119,7 @@
           <p:cNvPr id="4" name="">
             <a:extLst xmlns:a="http://schemas.openxmlformats.org/drawingml/2006/main">
               <a:ext uri="{FF2B5EF4-FFF2-40B4-BE49-F238E27FC236}">
-                <a16:creationId xmlns:a16="http://schemas.microsoft.com/office/drawing/2014/main" id="{1C51E2C9-1B2F-4EEE-A561-4CB0B476F295}"/>
+                <a16:creationId xmlns:a16="http://schemas.microsoft.com/office/drawing/2014/main" id="{CC8B25A8-2838-406F-9D0F-CB4CDE4DBDC0}"/>
               </a:ext>
             </a:extLst>
           </p:cNvPr>
@@ -11974,7 +11149,7 @@
           <p:cNvPr id="5" name="">
             <a:extLst xmlns:a="http://schemas.openxmlformats.org/drawingml/2006/main">
               <a:ext uri="{FF2B5EF4-FFF2-40B4-BE49-F238E27FC236}">
-                <a16:creationId xmlns:a16="http://schemas.microsoft.com/office/drawing/2014/main" id="{BB2D8F1C-3430-4124-9CC1-A373707B3FAC}"/>
+                <a16:creationId xmlns:a16="http://schemas.microsoft.com/office/drawing/2014/main" id="{40FC0994-0A2E-4271-9166-DB2150C232BD}"/>
               </a:ext>
             </a:extLst>
           </p:cNvPr>
@@ -12042,7 +11217,7 @@
           <p:cNvPr id="6" name="">
             <a:extLst xmlns:a="http://schemas.openxmlformats.org/drawingml/2006/main">
               <a:ext uri="{FF2B5EF4-FFF2-40B4-BE49-F238E27FC236}">
-                <a16:creationId xmlns:a16="http://schemas.microsoft.com/office/drawing/2014/main" id="{3419E3DB-FD25-4058-AA93-D83D152C2615}"/>
+                <a16:creationId xmlns:a16="http://schemas.microsoft.com/office/drawing/2014/main" id="{FAE08A5B-9A7E-47AE-B106-D7418383A6A5}"/>
               </a:ext>
             </a:extLst>
           </p:cNvPr>
@@ -12108,7 +11283,7 @@
     </p:spTree>
     <p:extLst>
       <p:ext uri="{BB962C8B-B14F-4D97-AF65-F5344CB8AC3E}">
-        <p14:creationId xmlns:p14="http://schemas.microsoft.com/office/powerpoint/2010/main" val="1230044322"/>
+        <p14:creationId xmlns:p14="http://schemas.microsoft.com/office/powerpoint/2010/main" val="723729628"/>
       </p:ext>
     </p:extLst>
   </p:cSld>
@@ -12139,7 +11314,7 @@
           <p:cNvPr id="7" name="">
             <a:extLst xmlns:a="http://schemas.openxmlformats.org/drawingml/2006/main">
               <a:ext uri="{FF2B5EF4-FFF2-40B4-BE49-F238E27FC236}">
-                <a16:creationId xmlns:a16="http://schemas.microsoft.com/office/drawing/2014/main" id="{013B8CFE-AFAC-4F29-BAE2-22E42E93959B}"/>
+                <a16:creationId xmlns:a16="http://schemas.microsoft.com/office/drawing/2014/main" id="{83F56CB7-4330-4A77-BBAD-DFDF8D43C7F1}"/>
               </a:ext>
             </a:extLst>
           </p:cNvPr>
@@ -12207,7 +11382,7 @@
           <p:cNvPr id="2" name="">
             <a:extLst xmlns:a="http://schemas.openxmlformats.org/drawingml/2006/main">
               <a:ext uri="{FF2B5EF4-FFF2-40B4-BE49-F238E27FC236}">
-                <a16:creationId xmlns:a16="http://schemas.microsoft.com/office/drawing/2014/main" id="{34B3691A-77AB-415A-AC36-367285055C12}"/>
+                <a16:creationId xmlns:a16="http://schemas.microsoft.com/office/drawing/2014/main" id="{313A6450-A489-4E8C-AE52-DEFB0648E46E}"/>
               </a:ext>
             </a:extLst>
           </p:cNvPr>
@@ -12275,7 +11450,7 @@
           <p:cNvPr id="3" name="">
             <a:extLst xmlns:a="http://schemas.openxmlformats.org/drawingml/2006/main">
               <a:ext uri="{FF2B5EF4-FFF2-40B4-BE49-F238E27FC236}">
-                <a16:creationId xmlns:a16="http://schemas.microsoft.com/office/drawing/2014/main" id="{0F80B87A-A315-446F-80F9-1AB3A3EC42C6}"/>
+                <a16:creationId xmlns:a16="http://schemas.microsoft.com/office/drawing/2014/main" id="{87723898-3173-4631-AFD6-50D50DCCB37A}"/>
               </a:ext>
             </a:extLst>
           </p:cNvPr>
@@ -12285,7 +11460,7 @@
           <p:nvPr/>
         </p:nvPicPr>
         <p:blipFill>
-          <a:blip xmlns:r="http://schemas.openxmlformats.org/officeDocument/2006/relationships" xmlns:a="http://schemas.openxmlformats.org/drawingml/2006/main" r:embed="Rf8b0d752d97c42c2"/>
+          <a:blip xmlns:r="http://schemas.openxmlformats.org/officeDocument/2006/relationships" xmlns:a="http://schemas.openxmlformats.org/drawingml/2006/main" r:embed="R6f09ccd82f074301"/>
           <a:stretch xmlns:a="http://schemas.openxmlformats.org/drawingml/2006/main"/>
         </p:blipFill>
         <p:spPr>
@@ -12303,7 +11478,7 @@
           <p:cNvPr id="4" name="">
             <a:extLst xmlns:a="http://schemas.openxmlformats.org/drawingml/2006/main">
               <a:ext uri="{FF2B5EF4-FFF2-40B4-BE49-F238E27FC236}">
-                <a16:creationId xmlns:a16="http://schemas.microsoft.com/office/drawing/2014/main" id="{F9E7166F-FAE2-491B-B7C1-9DB1CE2BE20E}"/>
+                <a16:creationId xmlns:a16="http://schemas.microsoft.com/office/drawing/2014/main" id="{18C57B05-4616-4758-A817-F62EE60FA349}"/>
               </a:ext>
             </a:extLst>
           </p:cNvPr>
@@ -12333,7 +11508,7 @@
           <p:cNvPr id="5" name="">
             <a:extLst xmlns:a="http://schemas.openxmlformats.org/drawingml/2006/main">
               <a:ext uri="{FF2B5EF4-FFF2-40B4-BE49-F238E27FC236}">
-                <a16:creationId xmlns:a16="http://schemas.microsoft.com/office/drawing/2014/main" id="{11736035-198A-4DD5-956C-AA1AA059B4C8}"/>
+                <a16:creationId xmlns:a16="http://schemas.microsoft.com/office/drawing/2014/main" id="{D22A738D-06A6-4BEB-A06E-2339628C525A}"/>
               </a:ext>
             </a:extLst>
           </p:cNvPr>
@@ -12401,7 +11576,7 @@
           <p:cNvPr id="6" name="">
             <a:extLst xmlns:a="http://schemas.openxmlformats.org/drawingml/2006/main">
               <a:ext uri="{FF2B5EF4-FFF2-40B4-BE49-F238E27FC236}">
-                <a16:creationId xmlns:a16="http://schemas.microsoft.com/office/drawing/2014/main" id="{52D42E1C-28E5-4F7B-83B9-9C67936654A5}"/>
+                <a16:creationId xmlns:a16="http://schemas.microsoft.com/office/drawing/2014/main" id="{3F77A491-E667-4B07-925D-87189FA0DA8F}"/>
               </a:ext>
             </a:extLst>
           </p:cNvPr>
@@ -12467,7 +11642,7 @@
     </p:spTree>
     <p:extLst>
       <p:ext uri="{BB962C8B-B14F-4D97-AF65-F5344CB8AC3E}">
-        <p14:creationId xmlns:p14="http://schemas.microsoft.com/office/powerpoint/2010/main" val="1796714502"/>
+        <p14:creationId xmlns:p14="http://schemas.microsoft.com/office/powerpoint/2010/main" val="91226534"/>
       </p:ext>
     </p:extLst>
   </p:cSld>
@@ -12498,7 +11673,7 @@
           <p:cNvPr id="7" name="">
             <a:extLst xmlns:a="http://schemas.openxmlformats.org/drawingml/2006/main">
               <a:ext uri="{FF2B5EF4-FFF2-40B4-BE49-F238E27FC236}">
-                <a16:creationId xmlns:a16="http://schemas.microsoft.com/office/drawing/2014/main" id="{30B38F70-727C-4F05-AA52-804227A197EA}"/>
+                <a16:creationId xmlns:a16="http://schemas.microsoft.com/office/drawing/2014/main" id="{1E2E4CFB-0326-4725-BA3D-582EAA1AADE6}"/>
               </a:ext>
             </a:extLst>
           </p:cNvPr>
@@ -12566,7 +11741,7 @@
           <p:cNvPr id="2" name="">
             <a:extLst xmlns:a="http://schemas.openxmlformats.org/drawingml/2006/main">
               <a:ext uri="{FF2B5EF4-FFF2-40B4-BE49-F238E27FC236}">
-                <a16:creationId xmlns:a16="http://schemas.microsoft.com/office/drawing/2014/main" id="{D14034BC-B393-42B6-BBC2-6CCF0240FBD9}"/>
+                <a16:creationId xmlns:a16="http://schemas.microsoft.com/office/drawing/2014/main" id="{C33039DC-7525-497D-B6D9-32439C1D764B}"/>
               </a:ext>
             </a:extLst>
           </p:cNvPr>
@@ -12634,7 +11809,7 @@
           <p:cNvPr id="3" name="">
             <a:extLst xmlns:a="http://schemas.openxmlformats.org/drawingml/2006/main">
               <a:ext uri="{FF2B5EF4-FFF2-40B4-BE49-F238E27FC236}">
-                <a16:creationId xmlns:a16="http://schemas.microsoft.com/office/drawing/2014/main" id="{8F244830-DA4D-4636-83B9-149D9F68E373}"/>
+                <a16:creationId xmlns:a16="http://schemas.microsoft.com/office/drawing/2014/main" id="{97D43DF2-FEAF-4348-83CF-4E7B5EEE23FE}"/>
               </a:ext>
             </a:extLst>
           </p:cNvPr>
@@ -12644,7 +11819,7 @@
           <p:nvPr/>
         </p:nvPicPr>
         <p:blipFill>
-          <a:blip xmlns:r="http://schemas.openxmlformats.org/officeDocument/2006/relationships" xmlns:a="http://schemas.openxmlformats.org/drawingml/2006/main" r:embed="R8e8f5a2ce3b44bf3"/>
+          <a:blip xmlns:r="http://schemas.openxmlformats.org/officeDocument/2006/relationships" xmlns:a="http://schemas.openxmlformats.org/drawingml/2006/main" r:embed="Rf608218fa8ea46d5"/>
           <a:stretch xmlns:a="http://schemas.openxmlformats.org/drawingml/2006/main"/>
         </p:blipFill>
         <p:spPr>
@@ -12662,7 +11837,7 @@
           <p:cNvPr id="4" name="">
             <a:extLst xmlns:a="http://schemas.openxmlformats.org/drawingml/2006/main">
               <a:ext uri="{FF2B5EF4-FFF2-40B4-BE49-F238E27FC236}">
-                <a16:creationId xmlns:a16="http://schemas.microsoft.com/office/drawing/2014/main" id="{A8992244-DA3A-4CF9-8EBD-BA2FDA08E421}"/>
+                <a16:creationId xmlns:a16="http://schemas.microsoft.com/office/drawing/2014/main" id="{C7728A1D-AB78-44A1-B5E2-397CD62F6A18}"/>
               </a:ext>
             </a:extLst>
           </p:cNvPr>
@@ -12692,7 +11867,7 @@
           <p:cNvPr id="5" name="">
             <a:extLst xmlns:a="http://schemas.openxmlformats.org/drawingml/2006/main">
               <a:ext uri="{FF2B5EF4-FFF2-40B4-BE49-F238E27FC236}">
-                <a16:creationId xmlns:a16="http://schemas.microsoft.com/office/drawing/2014/main" id="{AD26CD87-9580-4ABB-AAB2-8688D99C3A45}"/>
+                <a16:creationId xmlns:a16="http://schemas.microsoft.com/office/drawing/2014/main" id="{57855402-7162-457B-AB16-588A1758FA7D}"/>
               </a:ext>
             </a:extLst>
           </p:cNvPr>
@@ -12760,7 +11935,7 @@
           <p:cNvPr id="6" name="">
             <a:extLst xmlns:a="http://schemas.openxmlformats.org/drawingml/2006/main">
               <a:ext uri="{FF2B5EF4-FFF2-40B4-BE49-F238E27FC236}">
-                <a16:creationId xmlns:a16="http://schemas.microsoft.com/office/drawing/2014/main" id="{5CAB2392-F8FE-46B6-BF4C-00BE773AC863}"/>
+                <a16:creationId xmlns:a16="http://schemas.microsoft.com/office/drawing/2014/main" id="{4E78FFD5-22D6-453B-A108-3460DF919499}"/>
               </a:ext>
             </a:extLst>
           </p:cNvPr>
@@ -12826,7 +12001,7 @@
     </p:spTree>
     <p:extLst>
       <p:ext uri="{BB962C8B-B14F-4D97-AF65-F5344CB8AC3E}">
-        <p14:creationId xmlns:p14="http://schemas.microsoft.com/office/powerpoint/2010/main" val="1990357416"/>
+        <p14:creationId xmlns:p14="http://schemas.microsoft.com/office/powerpoint/2010/main" val="1175891919"/>
       </p:ext>
     </p:extLst>
   </p:cSld>

</xml_diff>